<commit_message>
Made changes to the Methods section
Signed-off-by: Abdon Morales <abdonm@cs.utexas.edu>
</commit_message>
<xml_diff>
--- a/Final Project/FinalProject.pptx
+++ b/Final Project/FinalProject.pptx
@@ -117,6 +117,7 @@
 <p1510:revInfo xmlns:a="http://schemas.openxmlformats.org/drawingml/2006/main" xmlns:r="http://schemas.openxmlformats.org/officeDocument/2006/relationships" xmlns:p1510="http://schemas.microsoft.com/office/powerpoint/2015/10/main">
   <p1510:revLst>
     <p1510:client id="{60DCBEB9-452B-42DA-B7D1-E4A5A7FC6C10}" v="1749" dt="2025-12-03T17:44:14.992"/>
+    <p1510:client id="{80BA49D0-6376-CB48-B3C3-F4708D789340}" v="223" dt="2025-12-04T04:11:19.332"/>
   </p1510:revLst>
 </p1510:revInfo>
 </file>
@@ -124,132 +125,84 @@
 <file path=ppt/changesInfos/changesInfo1.xml><?xml version="1.0" encoding="utf-8"?>
 <pc:chgInfo xmlns:a="http://schemas.openxmlformats.org/drawingml/2006/main" xmlns:r="http://schemas.openxmlformats.org/officeDocument/2006/relationships" xmlns:ac="http://schemas.microsoft.com/office/drawing/2013/main/command" xmlns:pc="http://schemas.microsoft.com/office/powerpoint/2013/main/command">
   <pc:docChgLst>
-    <pc:chgData name="Morales, Abdon" userId="b8e72fca-89fa-40b2-95f0-bdb26e6d8c1d" providerId="ADAL" clId="{D6E4417C-859A-4BAF-A446-455E9918AB5F}"/>
-    <pc:docChg chg="undo custSel addSld delSld modSld">
-      <pc:chgData name="Morales, Abdon" userId="b8e72fca-89fa-40b2-95f0-bdb26e6d8c1d" providerId="ADAL" clId="{D6E4417C-859A-4BAF-A446-455E9918AB5F}" dt="2025-12-03T17:44:14.992" v="5567" actId="20577"/>
+    <pc:chgData name="Morales, Abdon" userId="b8e72fca-89fa-40b2-95f0-bdb26e6d8c1d" providerId="ADAL" clId="{F77E3D6D-613B-5030-A384-37FA661628F6}"/>
+    <pc:docChg chg="undo custSel modSld">
+      <pc:chgData name="Morales, Abdon" userId="b8e72fca-89fa-40b2-95f0-bdb26e6d8c1d" providerId="ADAL" clId="{F77E3D6D-613B-5030-A384-37FA661628F6}" dt="2025-12-04T04:20:15.339" v="1088" actId="164"/>
       <pc:docMkLst>
         <pc:docMk/>
       </pc:docMkLst>
-      <pc:sldChg chg="addSp delSp modSp add del mod">
-        <pc:chgData name="Morales, Abdon" userId="b8e72fca-89fa-40b2-95f0-bdb26e6d8c1d" providerId="ADAL" clId="{D6E4417C-859A-4BAF-A446-455E9918AB5F}" dt="2025-12-03T17:44:14.992" v="5567" actId="20577"/>
+      <pc:sldChg chg="addSp delSp modSp mod">
+        <pc:chgData name="Morales, Abdon" userId="b8e72fca-89fa-40b2-95f0-bdb26e6d8c1d" providerId="ADAL" clId="{F77E3D6D-613B-5030-A384-37FA661628F6}" dt="2025-12-04T04:20:15.339" v="1088" actId="164"/>
         <pc:sldMkLst>
           <pc:docMk/>
           <pc:sldMk cId="4152292366" sldId="268"/>
         </pc:sldMkLst>
-        <pc:spChg chg="mod">
-          <ac:chgData name="Morales, Abdon" userId="b8e72fca-89fa-40b2-95f0-bdb26e6d8c1d" providerId="ADAL" clId="{D6E4417C-859A-4BAF-A446-455E9918AB5F}" dt="2025-12-03T17:40:32.096" v="5286" actId="1076"/>
+        <pc:spChg chg="add mod">
+          <ac:chgData name="Morales, Abdon" userId="b8e72fca-89fa-40b2-95f0-bdb26e6d8c1d" providerId="ADAL" clId="{F77E3D6D-613B-5030-A384-37FA661628F6}" dt="2025-12-04T04:04:24.376" v="1037" actId="1076"/>
           <ac:spMkLst>
             <pc:docMk/>
             <pc:sldMk cId="4152292366" sldId="268"/>
-            <ac:spMk id="33" creationId="{7418BA6E-2677-B748-A162-8B83DCDBD8E6}"/>
+            <ac:spMk id="2" creationId="{B78BFC16-B0AF-8B41-829D-20E46F0F3C5B}"/>
+          </ac:spMkLst>
+        </pc:spChg>
+        <pc:spChg chg="add mod">
+          <ac:chgData name="Morales, Abdon" userId="b8e72fca-89fa-40b2-95f0-bdb26e6d8c1d" providerId="ADAL" clId="{F77E3D6D-613B-5030-A384-37FA661628F6}" dt="2025-12-04T04:05:25.467" v="1063" actId="1076"/>
+          <ac:spMkLst>
+            <pc:docMk/>
+            <pc:sldMk cId="4152292366" sldId="268"/>
+            <ac:spMk id="3" creationId="{1342CD79-1432-E499-29FA-C0F48653707F}"/>
           </ac:spMkLst>
         </pc:spChg>
         <pc:spChg chg="mod">
-          <ac:chgData name="Morales, Abdon" userId="b8e72fca-89fa-40b2-95f0-bdb26e6d8c1d" providerId="ADAL" clId="{D6E4417C-859A-4BAF-A446-455E9918AB5F}" dt="2025-11-27T11:30:14.469" v="301" actId="20577"/>
+          <ac:chgData name="Morales, Abdon" userId="b8e72fca-89fa-40b2-95f0-bdb26e6d8c1d" providerId="ADAL" clId="{F77E3D6D-613B-5030-A384-37FA661628F6}" dt="2025-12-04T04:19:55.037" v="1086" actId="14100"/>
           <ac:spMkLst>
             <pc:docMk/>
             <pc:sldMk cId="4152292366" sldId="268"/>
-            <ac:spMk id="37" creationId="{1CB2525F-971E-E941-B2D3-728BCEFFCCFB}"/>
+            <ac:spMk id="4" creationId="{C2642BAB-3737-CE4C-874C-5EA986C6E360}"/>
+          </ac:spMkLst>
+        </pc:spChg>
+        <pc:spChg chg="del">
+          <ac:chgData name="Morales, Abdon" userId="b8e72fca-89fa-40b2-95f0-bdb26e6d8c1d" providerId="ADAL" clId="{F77E3D6D-613B-5030-A384-37FA661628F6}" dt="2025-12-04T04:12:05.673" v="1083" actId="478"/>
+          <ac:spMkLst>
+            <pc:docMk/>
+            <pc:sldMk cId="4152292366" sldId="268"/>
+            <ac:spMk id="46" creationId="{D903B466-646C-2D4A-BD19-7AA4D5AE665B}"/>
           </ac:spMkLst>
         </pc:spChg>
         <pc:spChg chg="mod">
-          <ac:chgData name="Morales, Abdon" userId="b8e72fca-89fa-40b2-95f0-bdb26e6d8c1d" providerId="ADAL" clId="{D6E4417C-859A-4BAF-A446-455E9918AB5F}" dt="2025-11-27T11:13:44.407" v="215" actId="20577"/>
-          <ac:spMkLst>
-            <pc:docMk/>
-            <pc:sldMk cId="4152292366" sldId="268"/>
-            <ac:spMk id="40" creationId="{5B415905-C185-1D48-A064-6465FD424184}"/>
-          </ac:spMkLst>
-        </pc:spChg>
-        <pc:spChg chg="mod">
-          <ac:chgData name="Morales, Abdon" userId="b8e72fca-89fa-40b2-95f0-bdb26e6d8c1d" providerId="ADAL" clId="{D6E4417C-859A-4BAF-A446-455E9918AB5F}" dt="2025-12-01T15:05:50.099" v="3837" actId="1035"/>
-          <ac:spMkLst>
-            <pc:docMk/>
-            <pc:sldMk cId="4152292366" sldId="268"/>
-            <ac:spMk id="47" creationId="{5B1CB227-8D1C-E348-84AD-06F18B6E4815}"/>
-          </ac:spMkLst>
-        </pc:spChg>
-        <pc:spChg chg="mod">
-          <ac:chgData name="Morales, Abdon" userId="b8e72fca-89fa-40b2-95f0-bdb26e6d8c1d" providerId="ADAL" clId="{D6E4417C-859A-4BAF-A446-455E9918AB5F}" dt="2025-12-01T16:13:36.212" v="4800" actId="20577"/>
-          <ac:spMkLst>
-            <pc:docMk/>
-            <pc:sldMk cId="4152292366" sldId="268"/>
-            <ac:spMk id="48" creationId="{2EA8601F-31F3-C14A-BF17-B9C6854CA5E3}"/>
-          </ac:spMkLst>
-        </pc:spChg>
-        <pc:spChg chg="mod">
-          <ac:chgData name="Morales, Abdon" userId="b8e72fca-89fa-40b2-95f0-bdb26e6d8c1d" providerId="ADAL" clId="{D6E4417C-859A-4BAF-A446-455E9918AB5F}" dt="2025-12-03T17:44:14.992" v="5567" actId="20577"/>
-          <ac:spMkLst>
-            <pc:docMk/>
-            <pc:sldMk cId="4152292366" sldId="268"/>
-            <ac:spMk id="49" creationId="{9D66091E-E47C-CF42-A22A-669CB4253806}"/>
-          </ac:spMkLst>
-        </pc:spChg>
-        <pc:spChg chg="mod">
-          <ac:chgData name="Morales, Abdon" userId="b8e72fca-89fa-40b2-95f0-bdb26e6d8c1d" providerId="ADAL" clId="{D6E4417C-859A-4BAF-A446-455E9918AB5F}" dt="2025-12-03T17:42:17.528" v="5299" actId="1076"/>
+          <ac:chgData name="Morales, Abdon" userId="b8e72fca-89fa-40b2-95f0-bdb26e6d8c1d" providerId="ADAL" clId="{F77E3D6D-613B-5030-A384-37FA661628F6}" dt="2025-12-04T04:04:32.036" v="1038" actId="1076"/>
           <ac:spMkLst>
             <pc:docMk/>
             <pc:sldMk cId="4152292366" sldId="268"/>
             <ac:spMk id="51" creationId="{E1CD2C2A-F064-084C-B9FF-1CE5B53E4E32}"/>
           </ac:spMkLst>
         </pc:spChg>
-        <pc:spChg chg="del mod">
-          <ac:chgData name="Morales, Abdon" userId="b8e72fca-89fa-40b2-95f0-bdb26e6d8c1d" providerId="ADAL" clId="{D6E4417C-859A-4BAF-A446-455E9918AB5F}" dt="2025-12-03T17:32:54.343" v="4829" actId="478"/>
+        <pc:spChg chg="del">
+          <ac:chgData name="Morales, Abdon" userId="b8e72fca-89fa-40b2-95f0-bdb26e6d8c1d" providerId="ADAL" clId="{F77E3D6D-613B-5030-A384-37FA661628F6}" dt="2025-12-04T04:12:09.898" v="1084" actId="478"/>
           <ac:spMkLst>
             <pc:docMk/>
             <pc:sldMk cId="4152292366" sldId="268"/>
-            <ac:spMk id="52" creationId="{4B05A019-717D-A648-A8DE-E62A37015CA2}"/>
+            <ac:spMk id="59" creationId="{887E75FA-C034-2447-9AFA-253A4A8F5217}"/>
           </ac:spMkLst>
         </pc:spChg>
-        <pc:spChg chg="del mod">
-          <ac:chgData name="Morales, Abdon" userId="b8e72fca-89fa-40b2-95f0-bdb26e6d8c1d" providerId="ADAL" clId="{D6E4417C-859A-4BAF-A446-455E9918AB5F}" dt="2025-12-03T17:41:42.509" v="5294" actId="478"/>
-          <ac:spMkLst>
+        <pc:grpChg chg="add">
+          <ac:chgData name="Morales, Abdon" userId="b8e72fca-89fa-40b2-95f0-bdb26e6d8c1d" providerId="ADAL" clId="{F77E3D6D-613B-5030-A384-37FA661628F6}" dt="2025-12-04T04:20:08.114" v="1087" actId="164"/>
+          <ac:grpSpMkLst>
             <pc:docMk/>
             <pc:sldMk cId="4152292366" sldId="268"/>
-            <ac:spMk id="53" creationId="{868D2662-CE1B-CA4E-9C45-7BFADD8B478E}"/>
-          </ac:spMkLst>
-        </pc:spChg>
-        <pc:spChg chg="mod">
-          <ac:chgData name="Morales, Abdon" userId="b8e72fca-89fa-40b2-95f0-bdb26e6d8c1d" providerId="ADAL" clId="{D6E4417C-859A-4BAF-A446-455E9918AB5F}" dt="2025-12-03T17:42:29.545" v="5300" actId="1076"/>
-          <ac:spMkLst>
+            <ac:grpSpMk id="10" creationId="{8B87BA69-F4CB-DBF5-4676-B393D1F8A96A}"/>
+          </ac:grpSpMkLst>
+        </pc:grpChg>
+        <pc:grpChg chg="add">
+          <ac:chgData name="Morales, Abdon" userId="b8e72fca-89fa-40b2-95f0-bdb26e6d8c1d" providerId="ADAL" clId="{F77E3D6D-613B-5030-A384-37FA661628F6}" dt="2025-12-04T04:20:15.339" v="1088" actId="164"/>
+          <ac:grpSpMkLst>
             <pc:docMk/>
             <pc:sldMk cId="4152292366" sldId="268"/>
-            <ac:spMk id="54" creationId="{F8C7482B-E913-3C49-AF7C-0ACF650610EA}"/>
-          </ac:spMkLst>
-        </pc:spChg>
-        <pc:spChg chg="del">
-          <ac:chgData name="Morales, Abdon" userId="b8e72fca-89fa-40b2-95f0-bdb26e6d8c1d" providerId="ADAL" clId="{D6E4417C-859A-4BAF-A446-455E9918AB5F}" dt="2025-12-03T17:31:04.535" v="4811" actId="478"/>
-          <ac:spMkLst>
-            <pc:docMk/>
-            <pc:sldMk cId="4152292366" sldId="268"/>
-            <ac:spMk id="56" creationId="{BB2032AF-3003-B24B-9A68-7D70AAA8A35C}"/>
-          </ac:spMkLst>
-        </pc:spChg>
-        <pc:spChg chg="del">
-          <ac:chgData name="Morales, Abdon" userId="b8e72fca-89fa-40b2-95f0-bdb26e6d8c1d" providerId="ADAL" clId="{D6E4417C-859A-4BAF-A446-455E9918AB5F}" dt="2025-12-03T17:33:02.162" v="4831" actId="478"/>
-          <ac:spMkLst>
-            <pc:docMk/>
-            <pc:sldMk cId="4152292366" sldId="268"/>
-            <ac:spMk id="57" creationId="{1FED97EB-3F99-4046-B146-88CF814D5474}"/>
-          </ac:spMkLst>
-        </pc:spChg>
-        <pc:spChg chg="del">
-          <ac:chgData name="Morales, Abdon" userId="b8e72fca-89fa-40b2-95f0-bdb26e6d8c1d" providerId="ADAL" clId="{D6E4417C-859A-4BAF-A446-455E9918AB5F}" dt="2025-12-03T17:32:48.990" v="4827" actId="478"/>
-          <ac:spMkLst>
-            <pc:docMk/>
-            <pc:sldMk cId="4152292366" sldId="268"/>
-            <ac:spMk id="58" creationId="{9A716952-6964-FF4F-943E-A4CCA63175C7}"/>
-          </ac:spMkLst>
-        </pc:spChg>
-        <pc:graphicFrameChg chg="add del mod modGraphic">
-          <ac:chgData name="Morales, Abdon" userId="b8e72fca-89fa-40b2-95f0-bdb26e6d8c1d" providerId="ADAL" clId="{D6E4417C-859A-4BAF-A446-455E9918AB5F}" dt="2025-12-03T17:01:57.937" v="4806" actId="478"/>
-          <ac:graphicFrameMkLst>
-            <pc:docMk/>
-            <pc:sldMk cId="4152292366" sldId="268"/>
-            <ac:graphicFrameMk id="2" creationId="{4CFD5E63-87CB-3D3B-59A6-F5461C4DA834}"/>
-          </ac:graphicFrameMkLst>
-        </pc:graphicFrameChg>
-        <pc:picChg chg="add mod">
-          <ac:chgData name="Morales, Abdon" userId="b8e72fca-89fa-40b2-95f0-bdb26e6d8c1d" providerId="ADAL" clId="{D6E4417C-859A-4BAF-A446-455E9918AB5F}" dt="2025-12-03T17:42:11.661" v="5298" actId="14100"/>
+            <ac:grpSpMk id="11" creationId="{E4C589B7-4B88-CC58-6898-2E7425307E9A}"/>
+          </ac:grpSpMkLst>
+        </pc:grpChg>
+        <pc:picChg chg="mod">
+          <ac:chgData name="Morales, Abdon" userId="b8e72fca-89fa-40b2-95f0-bdb26e6d8c1d" providerId="ADAL" clId="{F77E3D6D-613B-5030-A384-37FA661628F6}" dt="2025-12-04T04:01:10.443" v="983" actId="1076"/>
           <ac:picMkLst>
             <pc:docMk/>
             <pc:sldMk cId="4152292366" sldId="268"/>
@@ -257,21 +210,38 @@
           </ac:picMkLst>
         </pc:picChg>
         <pc:picChg chg="add mod">
-          <ac:chgData name="Morales, Abdon" userId="b8e72fca-89fa-40b2-95f0-bdb26e6d8c1d" providerId="ADAL" clId="{D6E4417C-859A-4BAF-A446-455E9918AB5F}" dt="2025-12-03T17:33:10.449" v="4832" actId="1076"/>
+          <ac:chgData name="Morales, Abdon" userId="b8e72fca-89fa-40b2-95f0-bdb26e6d8c1d" providerId="ADAL" clId="{F77E3D6D-613B-5030-A384-37FA661628F6}" dt="2025-12-04T04:08:01.170" v="1064"/>
+          <ac:picMkLst>
+            <pc:docMk/>
+            <pc:sldMk cId="4152292366" sldId="268"/>
+            <ac:picMk id="6" creationId="{6408B6EF-FEDB-CD66-BA45-B016490FC750}"/>
+          </ac:picMkLst>
+        </pc:picChg>
+        <pc:picChg chg="mod">
+          <ac:chgData name="Morales, Abdon" userId="b8e72fca-89fa-40b2-95f0-bdb26e6d8c1d" providerId="ADAL" clId="{F77E3D6D-613B-5030-A384-37FA661628F6}" dt="2025-12-04T04:04:42.913" v="1039" actId="1076"/>
           <ac:picMkLst>
             <pc:docMk/>
             <pc:sldMk cId="4152292366" sldId="268"/>
             <ac:picMk id="7" creationId="{56CDAAF2-1818-9EB6-09DE-0325CCB12502}"/>
           </ac:picMkLst>
         </pc:picChg>
+        <pc:picChg chg="add del mod">
+          <ac:chgData name="Morales, Abdon" userId="b8e72fca-89fa-40b2-95f0-bdb26e6d8c1d" providerId="ADAL" clId="{F77E3D6D-613B-5030-A384-37FA661628F6}" dt="2025-12-04T04:08:55.938" v="1074" actId="478"/>
+          <ac:picMkLst>
+            <pc:docMk/>
+            <pc:sldMk cId="4152292366" sldId="268"/>
+            <ac:picMk id="8" creationId="{6740F724-754B-FD30-2AC9-4F6671BEBCC8}"/>
+          </ac:picMkLst>
+        </pc:picChg>
+        <pc:picChg chg="add mod">
+          <ac:chgData name="Morales, Abdon" userId="b8e72fca-89fa-40b2-95f0-bdb26e6d8c1d" providerId="ADAL" clId="{F77E3D6D-613B-5030-A384-37FA661628F6}" dt="2025-12-04T04:11:56.480" v="1082" actId="1076"/>
+          <ac:picMkLst>
+            <pc:docMk/>
+            <pc:sldMk cId="4152292366" sldId="268"/>
+            <ac:picMk id="9" creationId="{1F6FF982-84D1-D5B7-2672-EEB42FF7BB88}"/>
+          </ac:picMkLst>
+        </pc:picChg>
       </pc:sldChg>
-      <pc:sldMasterChg chg="delSldLayout">
-        <pc:chgData name="Morales, Abdon" userId="b8e72fca-89fa-40b2-95f0-bdb26e6d8c1d" providerId="ADAL" clId="{D6E4417C-859A-4BAF-A446-455E9918AB5F}" dt="2025-11-27T11:11:17.187" v="3" actId="47"/>
-        <pc:sldMasterMkLst>
-          <pc:docMk/>
-          <pc:sldMasterMk cId="2666359474" sldId="2147483648"/>
-        </pc:sldMasterMkLst>
-      </pc:sldMasterChg>
     </pc:docChg>
   </pc:docChgLst>
 </pc:chgInfo>
@@ -424,7 +394,7 @@
           <a:p>
             <a:fld id="{722949B6-FD26-4F0A-B27E-95AA34CFB7B6}" type="datetimeFigureOut">
               <a:rPr lang="en-US" smtClean="0"/>
-              <a:t>12/1/2025</a:t>
+              <a:t>12/3/25</a:t>
             </a:fld>
             <a:endParaRPr lang="en-US"/>
           </a:p>
@@ -478,7 +448,7 @@
           <a:p>
             <a:fld id="{F528ECA1-1E0E-45AA-9354-4925D9A91E67}" type="slidenum">
               <a:rPr lang="en-US" smtClean="0"/>
-              <a:t>‹#›</a:t>
+              <a:t>‹Nº›</a:t>
             </a:fld>
             <a:endParaRPr lang="en-US"/>
           </a:p>
@@ -622,7 +592,7 @@
           <a:p>
             <a:fld id="{722949B6-FD26-4F0A-B27E-95AA34CFB7B6}" type="datetimeFigureOut">
               <a:rPr lang="en-US" smtClean="0"/>
-              <a:t>12/1/2025</a:t>
+              <a:t>12/3/25</a:t>
             </a:fld>
             <a:endParaRPr lang="en-US"/>
           </a:p>
@@ -676,7 +646,7 @@
           <a:p>
             <a:fld id="{F528ECA1-1E0E-45AA-9354-4925D9A91E67}" type="slidenum">
               <a:rPr lang="en-US" smtClean="0"/>
-              <a:t>‹#›</a:t>
+              <a:t>‹Nº›</a:t>
             </a:fld>
             <a:endParaRPr lang="en-US"/>
           </a:p>
@@ -830,7 +800,7 @@
           <a:p>
             <a:fld id="{722949B6-FD26-4F0A-B27E-95AA34CFB7B6}" type="datetimeFigureOut">
               <a:rPr lang="en-US" smtClean="0"/>
-              <a:t>12/1/2025</a:t>
+              <a:t>12/3/25</a:t>
             </a:fld>
             <a:endParaRPr lang="en-US"/>
           </a:p>
@@ -884,7 +854,7 @@
           <a:p>
             <a:fld id="{F528ECA1-1E0E-45AA-9354-4925D9A91E67}" type="slidenum">
               <a:rPr lang="en-US" smtClean="0"/>
-              <a:t>‹#›</a:t>
+              <a:t>‹Nº›</a:t>
             </a:fld>
             <a:endParaRPr lang="en-US"/>
           </a:p>
@@ -1034,7 +1004,7 @@
           <a:p>
             <a:fld id="{C764DE79-268F-4C1A-8933-263129D2AF90}" type="datetimeFigureOut">
               <a:rPr lang="en-US" dirty="0"/>
-              <a:t>12/1/2025</a:t>
+              <a:t>12/3/25</a:t>
             </a:fld>
             <a:endParaRPr lang="en-US" dirty="0"/>
           </a:p>
@@ -1076,7 +1046,7 @@
           <a:p>
             <a:fld id="{48F63A3B-78C7-47BE-AE5E-E10140E04643}" type="slidenum">
               <a:rPr lang="en-US" dirty="0"/>
-              <a:t>‹#›</a:t>
+              <a:t>‹Nº›</a:t>
             </a:fld>
             <a:endParaRPr lang="en-US" dirty="0"/>
           </a:p>
@@ -1204,7 +1174,7 @@
           <a:p>
             <a:fld id="{C764DE79-268F-4C1A-8933-263129D2AF90}" type="datetimeFigureOut">
               <a:rPr lang="en-US" dirty="0"/>
-              <a:t>12/1/2025</a:t>
+              <a:t>12/3/25</a:t>
             </a:fld>
             <a:endParaRPr lang="en-US" dirty="0"/>
           </a:p>
@@ -1246,7 +1216,7 @@
           <a:p>
             <a:fld id="{48F63A3B-78C7-47BE-AE5E-E10140E04643}" type="slidenum">
               <a:rPr lang="en-US" dirty="0"/>
-              <a:t>‹#›</a:t>
+              <a:t>‹Nº›</a:t>
             </a:fld>
             <a:endParaRPr lang="en-US" dirty="0"/>
           </a:p>
@@ -1448,7 +1418,7 @@
           <a:p>
             <a:fld id="{C764DE79-268F-4C1A-8933-263129D2AF90}" type="datetimeFigureOut">
               <a:rPr lang="en-US" dirty="0"/>
-              <a:t>12/1/2025</a:t>
+              <a:t>12/3/25</a:t>
             </a:fld>
             <a:endParaRPr lang="en-US" dirty="0"/>
           </a:p>
@@ -1490,7 +1460,7 @@
           <a:p>
             <a:fld id="{48F63A3B-78C7-47BE-AE5E-E10140E04643}" type="slidenum">
               <a:rPr lang="en-US" dirty="0"/>
-              <a:t>‹#›</a:t>
+              <a:t>‹Nº›</a:t>
             </a:fld>
             <a:endParaRPr lang="en-US" dirty="0"/>
           </a:p>
@@ -1680,7 +1650,7 @@
           <a:p>
             <a:fld id="{C764DE79-268F-4C1A-8933-263129D2AF90}" type="datetimeFigureOut">
               <a:rPr lang="en-US" dirty="0"/>
-              <a:t>12/1/2025</a:t>
+              <a:t>12/3/25</a:t>
             </a:fld>
             <a:endParaRPr lang="en-US" dirty="0"/>
           </a:p>
@@ -1722,7 +1692,7 @@
           <a:p>
             <a:fld id="{48F63A3B-78C7-47BE-AE5E-E10140E04643}" type="slidenum">
               <a:rPr lang="en-US" dirty="0"/>
-              <a:t>‹#›</a:t>
+              <a:t>‹Nº›</a:t>
             </a:fld>
             <a:endParaRPr lang="en-US" dirty="0"/>
           </a:p>
@@ -2047,7 +2017,7 @@
           <a:p>
             <a:fld id="{C764DE79-268F-4C1A-8933-263129D2AF90}" type="datetimeFigureOut">
               <a:rPr lang="en-US" dirty="0"/>
-              <a:t>12/1/2025</a:t>
+              <a:t>12/3/25</a:t>
             </a:fld>
             <a:endParaRPr lang="en-US" dirty="0"/>
           </a:p>
@@ -2089,7 +2059,7 @@
           <a:p>
             <a:fld id="{48F63A3B-78C7-47BE-AE5E-E10140E04643}" type="slidenum">
               <a:rPr lang="en-US" dirty="0"/>
-              <a:t>‹#›</a:t>
+              <a:t>‹Nº›</a:t>
             </a:fld>
             <a:endParaRPr lang="en-US" dirty="0"/>
           </a:p>
@@ -2165,7 +2135,7 @@
           <a:p>
             <a:fld id="{C764DE79-268F-4C1A-8933-263129D2AF90}" type="datetimeFigureOut">
               <a:rPr lang="en-US" dirty="0"/>
-              <a:t>12/1/2025</a:t>
+              <a:t>12/3/25</a:t>
             </a:fld>
             <a:endParaRPr lang="en-US" dirty="0"/>
           </a:p>
@@ -2207,7 +2177,7 @@
           <a:p>
             <a:fld id="{48F63A3B-78C7-47BE-AE5E-E10140E04643}" type="slidenum">
               <a:rPr lang="en-US" dirty="0"/>
-              <a:t>‹#›</a:t>
+              <a:t>‹Nº›</a:t>
             </a:fld>
             <a:endParaRPr lang="en-US" dirty="0"/>
           </a:p>
@@ -2260,7 +2230,7 @@
           <a:p>
             <a:fld id="{C764DE79-268F-4C1A-8933-263129D2AF90}" type="datetimeFigureOut">
               <a:rPr lang="en-US" dirty="0"/>
-              <a:t>12/1/2025</a:t>
+              <a:t>12/3/25</a:t>
             </a:fld>
             <a:endParaRPr lang="en-US" dirty="0"/>
           </a:p>
@@ -2302,7 +2272,7 @@
           <a:p>
             <a:fld id="{48F63A3B-78C7-47BE-AE5E-E10140E04643}" type="slidenum">
               <a:rPr lang="en-US" dirty="0"/>
-              <a:t>‹#›</a:t>
+              <a:t>‹Nº›</a:t>
             </a:fld>
             <a:endParaRPr lang="en-US" dirty="0"/>
           </a:p>
@@ -2537,7 +2507,7 @@
           <a:p>
             <a:fld id="{C764DE79-268F-4C1A-8933-263129D2AF90}" type="datetimeFigureOut">
               <a:rPr lang="en-US" dirty="0"/>
-              <a:t>12/1/2025</a:t>
+              <a:t>12/3/25</a:t>
             </a:fld>
             <a:endParaRPr lang="en-US" dirty="0"/>
           </a:p>
@@ -2579,7 +2549,7 @@
           <a:p>
             <a:fld id="{48F63A3B-78C7-47BE-AE5E-E10140E04643}" type="slidenum">
               <a:rPr lang="en-US" dirty="0"/>
-              <a:t>‹#›</a:t>
+              <a:t>‹Nº›</a:t>
             </a:fld>
             <a:endParaRPr lang="en-US" dirty="0"/>
           </a:p>
@@ -2723,7 +2693,7 @@
           <a:p>
             <a:fld id="{722949B6-FD26-4F0A-B27E-95AA34CFB7B6}" type="datetimeFigureOut">
               <a:rPr lang="en-US" smtClean="0"/>
-              <a:t>12/1/2025</a:t>
+              <a:t>12/3/25</a:t>
             </a:fld>
             <a:endParaRPr lang="en-US"/>
           </a:p>
@@ -2777,7 +2747,7 @@
           <a:p>
             <a:fld id="{F528ECA1-1E0E-45AA-9354-4925D9A91E67}" type="slidenum">
               <a:rPr lang="en-US" smtClean="0"/>
-              <a:t>‹#›</a:t>
+              <a:t>‹Nº›</a:t>
             </a:fld>
             <a:endParaRPr lang="en-US"/>
           </a:p>
@@ -2992,7 +2962,7 @@
           <a:p>
             <a:fld id="{C764DE79-268F-4C1A-8933-263129D2AF90}" type="datetimeFigureOut">
               <a:rPr lang="en-US" dirty="0"/>
-              <a:t>12/1/2025</a:t>
+              <a:t>12/3/25</a:t>
             </a:fld>
             <a:endParaRPr lang="en-US" dirty="0"/>
           </a:p>
@@ -3034,7 +3004,7 @@
           <a:p>
             <a:fld id="{48F63A3B-78C7-47BE-AE5E-E10140E04643}" type="slidenum">
               <a:rPr lang="en-US" dirty="0"/>
-              <a:t>‹#›</a:t>
+              <a:t>‹Nº›</a:t>
             </a:fld>
             <a:endParaRPr lang="en-US" dirty="0"/>
           </a:p>
@@ -3162,7 +3132,7 @@
           <a:p>
             <a:fld id="{C764DE79-268F-4C1A-8933-263129D2AF90}" type="datetimeFigureOut">
               <a:rPr lang="en-US" dirty="0"/>
-              <a:t>12/1/2025</a:t>
+              <a:t>12/3/25</a:t>
             </a:fld>
             <a:endParaRPr lang="en-US" dirty="0"/>
           </a:p>
@@ -3204,7 +3174,7 @@
           <a:p>
             <a:fld id="{48F63A3B-78C7-47BE-AE5E-E10140E04643}" type="slidenum">
               <a:rPr lang="en-US" dirty="0"/>
-              <a:t>‹#›</a:t>
+              <a:t>‹Nº›</a:t>
             </a:fld>
             <a:endParaRPr lang="en-US" dirty="0"/>
           </a:p>
@@ -3342,7 +3312,7 @@
           <a:p>
             <a:fld id="{C764DE79-268F-4C1A-8933-263129D2AF90}" type="datetimeFigureOut">
               <a:rPr lang="en-US" dirty="0"/>
-              <a:t>12/1/2025</a:t>
+              <a:t>12/3/25</a:t>
             </a:fld>
             <a:endParaRPr lang="en-US" dirty="0"/>
           </a:p>
@@ -3384,7 +3354,7 @@
           <a:p>
             <a:fld id="{48F63A3B-78C7-47BE-AE5E-E10140E04643}" type="slidenum">
               <a:rPr lang="en-US" dirty="0"/>
-              <a:t>‹#›</a:t>
+              <a:t>‹Nº›</a:t>
             </a:fld>
             <a:endParaRPr lang="en-US" dirty="0"/>
           </a:p>
@@ -3635,7 +3605,7 @@
           <a:p>
             <a:fld id="{722949B6-FD26-4F0A-B27E-95AA34CFB7B6}" type="datetimeFigureOut">
               <a:rPr lang="en-US" smtClean="0"/>
-              <a:t>12/1/2025</a:t>
+              <a:t>12/3/25</a:t>
             </a:fld>
             <a:endParaRPr lang="en-US"/>
           </a:p>
@@ -3689,7 +3659,7 @@
           <a:p>
             <a:fld id="{F528ECA1-1E0E-45AA-9354-4925D9A91E67}" type="slidenum">
               <a:rPr lang="en-US" smtClean="0"/>
-              <a:t>‹#›</a:t>
+              <a:t>‹Nº›</a:t>
             </a:fld>
             <a:endParaRPr lang="en-US"/>
           </a:p>
@@ -3900,7 +3870,7 @@
           <a:p>
             <a:fld id="{722949B6-FD26-4F0A-B27E-95AA34CFB7B6}" type="datetimeFigureOut">
               <a:rPr lang="en-US" smtClean="0"/>
-              <a:t>12/1/2025</a:t>
+              <a:t>12/3/25</a:t>
             </a:fld>
             <a:endParaRPr lang="en-US"/>
           </a:p>
@@ -3954,7 +3924,7 @@
           <a:p>
             <a:fld id="{F528ECA1-1E0E-45AA-9354-4925D9A91E67}" type="slidenum">
               <a:rPr lang="en-US" smtClean="0"/>
-              <a:t>‹#›</a:t>
+              <a:t>‹Nº›</a:t>
             </a:fld>
             <a:endParaRPr lang="en-US"/>
           </a:p>
@@ -4312,7 +4282,7 @@
           <a:p>
             <a:fld id="{722949B6-FD26-4F0A-B27E-95AA34CFB7B6}" type="datetimeFigureOut">
               <a:rPr lang="en-US" smtClean="0"/>
-              <a:t>12/1/2025</a:t>
+              <a:t>12/3/25</a:t>
             </a:fld>
             <a:endParaRPr lang="en-US"/>
           </a:p>
@@ -4366,7 +4336,7 @@
           <a:p>
             <a:fld id="{F528ECA1-1E0E-45AA-9354-4925D9A91E67}" type="slidenum">
               <a:rPr lang="en-US" smtClean="0"/>
-              <a:t>‹#›</a:t>
+              <a:t>‹Nº›</a:t>
             </a:fld>
             <a:endParaRPr lang="en-US"/>
           </a:p>
@@ -4453,7 +4423,7 @@
           <a:p>
             <a:fld id="{722949B6-FD26-4F0A-B27E-95AA34CFB7B6}" type="datetimeFigureOut">
               <a:rPr lang="en-US" smtClean="0"/>
-              <a:t>12/1/2025</a:t>
+              <a:t>12/3/25</a:t>
             </a:fld>
             <a:endParaRPr lang="en-US"/>
           </a:p>
@@ -4507,7 +4477,7 @@
           <a:p>
             <a:fld id="{F528ECA1-1E0E-45AA-9354-4925D9A91E67}" type="slidenum">
               <a:rPr lang="en-US" smtClean="0"/>
-              <a:t>‹#›</a:t>
+              <a:t>‹Nº›</a:t>
             </a:fld>
             <a:endParaRPr lang="en-US"/>
           </a:p>
@@ -4566,7 +4536,7 @@
           <a:p>
             <a:fld id="{722949B6-FD26-4F0A-B27E-95AA34CFB7B6}" type="datetimeFigureOut">
               <a:rPr lang="en-US" smtClean="0"/>
-              <a:t>12/1/2025</a:t>
+              <a:t>12/3/25</a:t>
             </a:fld>
             <a:endParaRPr lang="en-US"/>
           </a:p>
@@ -4620,7 +4590,7 @@
           <a:p>
             <a:fld id="{F528ECA1-1E0E-45AA-9354-4925D9A91E67}" type="slidenum">
               <a:rPr lang="en-US" smtClean="0"/>
-              <a:t>‹#›</a:t>
+              <a:t>‹Nº›</a:t>
             </a:fld>
             <a:endParaRPr lang="en-US"/>
           </a:p>
@@ -4877,7 +4847,7 @@
           <a:p>
             <a:fld id="{722949B6-FD26-4F0A-B27E-95AA34CFB7B6}" type="datetimeFigureOut">
               <a:rPr lang="en-US" smtClean="0"/>
-              <a:t>12/1/2025</a:t>
+              <a:t>12/3/25</a:t>
             </a:fld>
             <a:endParaRPr lang="en-US"/>
           </a:p>
@@ -4931,7 +4901,7 @@
           <a:p>
             <a:fld id="{F528ECA1-1E0E-45AA-9354-4925D9A91E67}" type="slidenum">
               <a:rPr lang="en-US" smtClean="0"/>
-              <a:t>‹#›</a:t>
+              <a:t>‹Nº›</a:t>
             </a:fld>
             <a:endParaRPr lang="en-US"/>
           </a:p>
@@ -5165,7 +5135,7 @@
           <a:p>
             <a:fld id="{722949B6-FD26-4F0A-B27E-95AA34CFB7B6}" type="datetimeFigureOut">
               <a:rPr lang="en-US" smtClean="0"/>
-              <a:t>12/1/2025</a:t>
+              <a:t>12/3/25</a:t>
             </a:fld>
             <a:endParaRPr lang="en-US"/>
           </a:p>
@@ -5219,7 +5189,7 @@
           <a:p>
             <a:fld id="{F528ECA1-1E0E-45AA-9354-4925D9A91E67}" type="slidenum">
               <a:rPr lang="en-US" smtClean="0"/>
-              <a:t>‹#›</a:t>
+              <a:t>‹Nº›</a:t>
             </a:fld>
             <a:endParaRPr lang="en-US"/>
           </a:p>
@@ -5406,7 +5376,7 @@
           <a:p>
             <a:fld id="{722949B6-FD26-4F0A-B27E-95AA34CFB7B6}" type="datetimeFigureOut">
               <a:rPr lang="en-US" smtClean="0"/>
-              <a:t>12/1/2025</a:t>
+              <a:t>12/3/25</a:t>
             </a:fld>
             <a:endParaRPr lang="en-US"/>
           </a:p>
@@ -5496,7 +5466,7 @@
           <a:p>
             <a:fld id="{F528ECA1-1E0E-45AA-9354-4925D9A91E67}" type="slidenum">
               <a:rPr lang="en-US" smtClean="0"/>
-              <a:t>‹#›</a:t>
+              <a:t>‹Nº›</a:t>
             </a:fld>
             <a:endParaRPr lang="en-US"/>
           </a:p>
@@ -5958,7 +5928,7 @@
           <a:p>
             <a:fld id="{C764DE79-268F-4C1A-8933-263129D2AF90}" type="datetimeFigureOut">
               <a:rPr lang="en-US" dirty="0"/>
-              <a:t>12/1/2025</a:t>
+              <a:t>12/3/25</a:t>
             </a:fld>
             <a:endParaRPr lang="en-US" dirty="0"/>
           </a:p>
@@ -6036,7 +6006,7 @@
           <a:p>
             <a:fld id="{48F63A3B-78C7-47BE-AE5E-E10140E04643}" type="slidenum">
               <a:rPr lang="en-US" dirty="0"/>
-              <a:t>‹#›</a:t>
+              <a:t>‹Nº›</a:t>
             </a:fld>
             <a:endParaRPr lang="en-US" dirty="0"/>
           </a:p>
@@ -9175,7 +9145,7 @@
         </p:nvSpPr>
         <p:spPr>
           <a:xfrm>
-            <a:off x="1771310" y="4239936"/>
+            <a:off x="1771310" y="4192539"/>
             <a:ext cx="2452736" cy="257315"/>
           </a:xfrm>
           <a:prstGeom prst="rect">
@@ -9618,8 +9588,8 @@
           </a:p>
         </p:txBody>
       </p:sp>
-      <mc:AlternateContent xmlns:mc="http://schemas.openxmlformats.org/markup-compatibility/2006">
-        <mc:Choice xmlns:a14="http://schemas.microsoft.com/office/drawing/2010/main" Requires="a14">
+      <mc:AlternateContent xmlns:mc="http://schemas.openxmlformats.org/markup-compatibility/2006" xmlns:a14="http://schemas.microsoft.com/office/drawing/2010/main">
+        <mc:Choice Requires="a14">
           <p:sp>
             <p:nvSpPr>
               <p:cNvPr id="47" name="TextBox 46">
@@ -9784,7 +9754,7 @@
             </p:txBody>
           </p:sp>
         </mc:Choice>
-        <mc:Fallback>
+        <mc:Fallback xmlns="">
           <p:sp>
             <p:nvSpPr>
               <p:cNvPr id="47" name="TextBox 46">
@@ -9829,8 +9799,8 @@
           </p:sp>
         </mc:Fallback>
       </mc:AlternateContent>
-      <mc:AlternateContent xmlns:mc="http://schemas.openxmlformats.org/markup-compatibility/2006">
-        <mc:Choice xmlns:a14="http://schemas.microsoft.com/office/drawing/2010/main" Requires="a14">
+      <mc:AlternateContent xmlns:mc="http://schemas.openxmlformats.org/markup-compatibility/2006" xmlns:a14="http://schemas.microsoft.com/office/drawing/2010/main">
+        <mc:Choice Requires="a14">
           <p:sp>
             <p:nvSpPr>
               <p:cNvPr id="48" name="TextBox 47">
@@ -9982,7 +9952,7 @@
             </p:txBody>
           </p:sp>
         </mc:Choice>
-        <mc:Fallback>
+        <mc:Fallback xmlns="">
           <p:sp>
             <p:nvSpPr>
               <p:cNvPr id="48" name="TextBox 47">
@@ -10027,8 +9997,8 @@
           </p:sp>
         </mc:Fallback>
       </mc:AlternateContent>
-      <mc:AlternateContent xmlns:mc="http://schemas.openxmlformats.org/markup-compatibility/2006">
-        <mc:Choice xmlns:a14="http://schemas.microsoft.com/office/drawing/2010/main" Requires="a14">
+      <mc:AlternateContent xmlns:mc="http://schemas.openxmlformats.org/markup-compatibility/2006" xmlns:a14="http://schemas.microsoft.com/office/drawing/2010/main">
+        <mc:Choice Requires="a14">
           <p:sp>
             <p:nvSpPr>
               <p:cNvPr id="49" name="TextBox 48">
@@ -10043,8 +10013,8 @@
             </p:nvSpPr>
             <p:spPr>
               <a:xfrm>
-                <a:off x="1773209" y="4427397"/>
-                <a:ext cx="2594684" cy="920573"/>
+                <a:off x="1771310" y="4332107"/>
+                <a:ext cx="2594684" cy="2278188"/>
               </a:xfrm>
               <a:prstGeom prst="rect">
                 <a:avLst/>
@@ -10066,7 +10036,182 @@
                     <a:latin typeface="Arial" panose="020B0604020202020204" pitchFamily="34" charset="0"/>
                     <a:cs typeface="Arial" panose="020B0604020202020204" pitchFamily="34" charset="0"/>
                   </a:rPr>
-                  <a:t>I conducted an experiment to measure how plate area and plate separation affect the capacitance of a parallel-plate capacitor. The setup included two adjustable metal plates, a fixed voltage source, and a digital capacitance meter. For the first set of trials (N=1 to N=6), plate separation was kept constant while plate area was varied in increments. For the second set, plate area was fixed while plate separation was adjusted; at each configuration, capacitance was recorded, and energy was calculated using </a:t>
+                  <a:t>To investigate the effect of plate area and plate separation on the capacitance of a parallel-plate capacitor, I designed an experiment using adjustable metal plates, a regulated DC voltage source, and a digital capacitance meter. The plates were mounted on a frame that allowed precise control of both their surface area and the distance between them. A micrometer screw gauge was used to measure and adjust the separation with millimeter accuracy, while interchangeable plates of varying sizes were employed to modify the area. The voltage source was set to a constant value throughout the experiment to ensure that changes in capacitance were solely due to geometric variations.</a:t>
+                </a:r>
+              </a:p>
+              <a:p>
+                <a:pPr defTabSz="780653"/>
+                <a:r>
+                  <a:rPr lang="en-US" sz="572" dirty="0">
+                    <a:solidFill>
+                      <a:prstClr val="black"/>
+                    </a:solidFill>
+                    <a:latin typeface="Arial" panose="020B0604020202020204" pitchFamily="34" charset="0"/>
+                    <a:cs typeface="Arial" panose="020B0604020202020204" pitchFamily="34" charset="0"/>
+                  </a:rPr>
+                  <a:t>The experiment was conducted in two parts. In the first part, the plate separation was fixed at 6mm, and the plate area was systemically increased in increments from </a:t>
+                </a:r>
+                <a14:m>
+                  <m:oMath xmlns:m="http://schemas.openxmlformats.org/officeDocument/2006/math">
+                    <m:r>
+                      <a:rPr lang="en-US" sz="572" b="0" i="1" smtClean="0">
+                        <a:solidFill>
+                          <a:prstClr val="black"/>
+                        </a:solidFill>
+                        <a:latin typeface="Cambria Math" panose="02040503050406030204" pitchFamily="18" charset="0"/>
+                        <a:cs typeface="Arial" panose="020B0604020202020204" pitchFamily="34" charset="0"/>
+                      </a:rPr>
+                      <m:t>100 </m:t>
+                    </m:r>
+                    <m:r>
+                      <a:rPr lang="en-US" sz="572" b="0" i="1" smtClean="0">
+                        <a:solidFill>
+                          <a:prstClr val="black"/>
+                        </a:solidFill>
+                        <a:latin typeface="Cambria Math" panose="02040503050406030204" pitchFamily="18" charset="0"/>
+                        <a:cs typeface="Arial" panose="020B0604020202020204" pitchFamily="34" charset="0"/>
+                      </a:rPr>
+                      <m:t>𝑚</m:t>
+                    </m:r>
+                    <m:sSup>
+                      <m:sSupPr>
+                        <m:ctrlPr>
+                          <a:rPr lang="en-US" sz="572" b="0" i="1" smtClean="0">
+                            <a:solidFill>
+                              <a:prstClr val="black"/>
+                            </a:solidFill>
+                            <a:latin typeface="Cambria Math" panose="02040503050406030204" pitchFamily="18" charset="0"/>
+                            <a:cs typeface="Arial" panose="020B0604020202020204" pitchFamily="34" charset="0"/>
+                          </a:rPr>
+                        </m:ctrlPr>
+                      </m:sSupPr>
+                      <m:e>
+                        <m:r>
+                          <a:rPr lang="en-US" sz="572" b="0" i="1" smtClean="0">
+                            <a:solidFill>
+                              <a:prstClr val="black"/>
+                            </a:solidFill>
+                            <a:latin typeface="Cambria Math" panose="02040503050406030204" pitchFamily="18" charset="0"/>
+                            <a:cs typeface="Arial" panose="020B0604020202020204" pitchFamily="34" charset="0"/>
+                          </a:rPr>
+                          <m:t>𝑚</m:t>
+                        </m:r>
+                      </m:e>
+                      <m:sup>
+                        <m:r>
+                          <a:rPr lang="en-US" sz="572" b="0" i="1" smtClean="0">
+                            <a:solidFill>
+                              <a:prstClr val="black"/>
+                            </a:solidFill>
+                            <a:latin typeface="Cambria Math" panose="02040503050406030204" pitchFamily="18" charset="0"/>
+                            <a:cs typeface="Arial" panose="020B0604020202020204" pitchFamily="34" charset="0"/>
+                          </a:rPr>
+                          <m:t>2</m:t>
+                        </m:r>
+                      </m:sup>
+                    </m:sSup>
+                  </m:oMath>
+                </a14:m>
+                <a:r>
+                  <a:rPr lang="en-US" sz="572" dirty="0">
+                    <a:solidFill>
+                      <a:prstClr val="black"/>
+                    </a:solidFill>
+                    <a:latin typeface="Arial" panose="020B0604020202020204" pitchFamily="34" charset="0"/>
+                    <a:cs typeface="Arial" panose="020B0604020202020204" pitchFamily="34" charset="0"/>
+                  </a:rPr>
+                  <a:t> to </a:t>
+                </a:r>
+                <a14:m>
+                  <m:oMath xmlns:m="http://schemas.openxmlformats.org/officeDocument/2006/math">
+                    <m:r>
+                      <a:rPr lang="en-US" sz="572" i="1" dirty="0" smtClean="0">
+                        <a:solidFill>
+                          <a:prstClr val="black"/>
+                        </a:solidFill>
+                        <a:latin typeface="Cambria Math" panose="02040503050406030204" pitchFamily="18" charset="0"/>
+                        <a:cs typeface="Arial" panose="020B0604020202020204" pitchFamily="34" charset="0"/>
+                      </a:rPr>
+                      <m:t>1</m:t>
+                    </m:r>
+                    <m:r>
+                      <a:rPr lang="en-US" sz="572" b="0" i="1" dirty="0" smtClean="0">
+                        <a:solidFill>
+                          <a:prstClr val="black"/>
+                        </a:solidFill>
+                        <a:latin typeface="Cambria Math" panose="02040503050406030204" pitchFamily="18" charset="0"/>
+                        <a:cs typeface="Arial" panose="020B0604020202020204" pitchFamily="34" charset="0"/>
+                      </a:rPr>
+                      <m:t>50</m:t>
+                    </m:r>
+                    <m:r>
+                      <a:rPr lang="en-US" sz="572" i="1">
+                        <a:solidFill>
+                          <a:prstClr val="black"/>
+                        </a:solidFill>
+                        <a:latin typeface="Cambria Math" panose="02040503050406030204" pitchFamily="18" charset="0"/>
+                        <a:cs typeface="Arial" panose="020B0604020202020204" pitchFamily="34" charset="0"/>
+                      </a:rPr>
+                      <m:t> </m:t>
+                    </m:r>
+                    <m:r>
+                      <a:rPr lang="en-US" sz="572" i="1">
+                        <a:solidFill>
+                          <a:prstClr val="black"/>
+                        </a:solidFill>
+                        <a:latin typeface="Cambria Math" panose="02040503050406030204" pitchFamily="18" charset="0"/>
+                        <a:cs typeface="Arial" panose="020B0604020202020204" pitchFamily="34" charset="0"/>
+                      </a:rPr>
+                      <m:t>𝑚</m:t>
+                    </m:r>
+                    <m:sSup>
+                      <m:sSupPr>
+                        <m:ctrlPr>
+                          <a:rPr lang="en-US" sz="572" i="1">
+                            <a:solidFill>
+                              <a:prstClr val="black"/>
+                            </a:solidFill>
+                            <a:latin typeface="Cambria Math" panose="02040503050406030204" pitchFamily="18" charset="0"/>
+                            <a:cs typeface="Arial" panose="020B0604020202020204" pitchFamily="34" charset="0"/>
+                          </a:rPr>
+                        </m:ctrlPr>
+                      </m:sSupPr>
+                      <m:e>
+                        <m:r>
+                          <a:rPr lang="en-US" sz="572" i="1">
+                            <a:solidFill>
+                              <a:prstClr val="black"/>
+                            </a:solidFill>
+                            <a:latin typeface="Cambria Math" panose="02040503050406030204" pitchFamily="18" charset="0"/>
+                            <a:cs typeface="Arial" panose="020B0604020202020204" pitchFamily="34" charset="0"/>
+                          </a:rPr>
+                          <m:t>𝑚</m:t>
+                        </m:r>
+                      </m:e>
+                      <m:sup>
+                        <m:r>
+                          <a:rPr lang="en-US" sz="572" i="1">
+                            <a:solidFill>
+                              <a:prstClr val="black"/>
+                            </a:solidFill>
+                            <a:latin typeface="Cambria Math" panose="02040503050406030204" pitchFamily="18" charset="0"/>
+                            <a:cs typeface="Arial" panose="020B0604020202020204" pitchFamily="34" charset="0"/>
+                          </a:rPr>
+                          <m:t>2</m:t>
+                        </m:r>
+                      </m:sup>
+                    </m:sSup>
+                  </m:oMath>
+                </a14:m>
+                <a:r>
+                  <a:rPr lang="en-US" sz="572" dirty="0">
+                    <a:solidFill>
+                      <a:prstClr val="black"/>
+                    </a:solidFill>
+                    <a:latin typeface="Arial" panose="020B0604020202020204" pitchFamily="34" charset="0"/>
+                    <a:cs typeface="Arial" panose="020B0604020202020204" pitchFamily="34" charset="0"/>
+                  </a:rPr>
+                  <a:t>. For each configuration, the capacitance was measured using the digital meter, and the corresponding energy stored in the capacitor was calculated using the formula </a:t>
                 </a:r>
                 <a14:m>
                   <m:oMath xmlns:m="http://schemas.openxmlformats.org/officeDocument/2006/math">
@@ -10184,13 +10329,189 @@
                     <a:latin typeface="Arial" panose="020B0604020202020204" pitchFamily="34" charset="0"/>
                     <a:cs typeface="Arial" panose="020B0604020202020204" pitchFamily="34" charset="0"/>
                   </a:rPr>
-                  <a:t>. All measurements were repeated to ensure consistency and accuracy.</a:t>
+                  <a:t>. In the second phase, the plate are was held constant to </a:t>
                 </a:r>
+                <a14:m>
+                  <m:oMath xmlns:m="http://schemas.openxmlformats.org/officeDocument/2006/math">
+                    <m:r>
+                      <a:rPr lang="en-US" sz="572" b="0" i="1" smtClean="0">
+                        <a:solidFill>
+                          <a:prstClr val="black"/>
+                        </a:solidFill>
+                        <a:latin typeface="Cambria Math" panose="02040503050406030204" pitchFamily="18" charset="0"/>
+                        <a:cs typeface="Arial" panose="020B0604020202020204" pitchFamily="34" charset="0"/>
+                      </a:rPr>
+                      <m:t>100 </m:t>
+                    </m:r>
+                    <m:r>
+                      <a:rPr lang="en-US" sz="572" b="0" i="1" smtClean="0">
+                        <a:solidFill>
+                          <a:prstClr val="black"/>
+                        </a:solidFill>
+                        <a:latin typeface="Cambria Math" panose="02040503050406030204" pitchFamily="18" charset="0"/>
+                        <a:cs typeface="Arial" panose="020B0604020202020204" pitchFamily="34" charset="0"/>
+                      </a:rPr>
+                      <m:t>𝑚</m:t>
+                    </m:r>
+                    <m:sSup>
+                      <m:sSupPr>
+                        <m:ctrlPr>
+                          <a:rPr lang="en-US" sz="572" b="0" i="1" smtClean="0">
+                            <a:solidFill>
+                              <a:prstClr val="black"/>
+                            </a:solidFill>
+                            <a:latin typeface="Cambria Math" panose="02040503050406030204" pitchFamily="18" charset="0"/>
+                            <a:cs typeface="Arial" panose="020B0604020202020204" pitchFamily="34" charset="0"/>
+                          </a:rPr>
+                        </m:ctrlPr>
+                      </m:sSupPr>
+                      <m:e>
+                        <m:r>
+                          <a:rPr lang="en-US" sz="572" b="0" i="1" smtClean="0">
+                            <a:solidFill>
+                              <a:prstClr val="black"/>
+                            </a:solidFill>
+                            <a:latin typeface="Cambria Math" panose="02040503050406030204" pitchFamily="18" charset="0"/>
+                            <a:cs typeface="Arial" panose="020B0604020202020204" pitchFamily="34" charset="0"/>
+                          </a:rPr>
+                          <m:t>𝑚</m:t>
+                        </m:r>
+                      </m:e>
+                      <m:sup>
+                        <m:r>
+                          <a:rPr lang="en-US" sz="572" b="0" i="1" smtClean="0">
+                            <a:solidFill>
+                              <a:prstClr val="black"/>
+                            </a:solidFill>
+                            <a:latin typeface="Cambria Math" panose="02040503050406030204" pitchFamily="18" charset="0"/>
+                            <a:cs typeface="Arial" panose="020B0604020202020204" pitchFamily="34" charset="0"/>
+                          </a:rPr>
+                          <m:t>2</m:t>
+                        </m:r>
+                      </m:sup>
+                    </m:sSup>
+                  </m:oMath>
+                </a14:m>
+                <a:r>
+                  <a:rPr lang="en-US" sz="572" dirty="0">
+                    <a:solidFill>
+                      <a:prstClr val="black"/>
+                    </a:solidFill>
+                    <a:latin typeface="Arial" panose="020B0604020202020204" pitchFamily="34" charset="0"/>
+                    <a:cs typeface="Arial" panose="020B0604020202020204" pitchFamily="34" charset="0"/>
+                  </a:rPr>
+                  <a:t>, while the separation was varied from 2 mm to 7mm in steps of 1 mm. In addition, capacitance readings were recorded for each setting, and energy values were computed; all measurements were repeated to confirm consistency, and the data was organized into two sets: one for capacitance versus plate area and another for capacitance versus plate separation. These datasets were late analyzed to identify trends and compare experimental results with theoretical predictions based on the equation </a:t>
+                </a:r>
+                <a14:m>
+                  <m:oMath xmlns:m="http://schemas.openxmlformats.org/officeDocument/2006/math">
+                    <m:r>
+                      <a:rPr lang="en-US" sz="572" b="0" i="1" smtClean="0">
+                        <a:solidFill>
+                          <a:prstClr val="black"/>
+                        </a:solidFill>
+                        <a:latin typeface="Cambria Math" panose="02040503050406030204" pitchFamily="18" charset="0"/>
+                        <a:cs typeface="Arial" panose="020B0604020202020204" pitchFamily="34" charset="0"/>
+                      </a:rPr>
+                      <m:t>𝐶</m:t>
+                    </m:r>
+                    <m:r>
+                      <a:rPr lang="en-US" sz="572" b="0" i="1" smtClean="0">
+                        <a:solidFill>
+                          <a:prstClr val="black"/>
+                        </a:solidFill>
+                        <a:latin typeface="Cambria Math" panose="02040503050406030204" pitchFamily="18" charset="0"/>
+                        <a:cs typeface="Arial" panose="020B0604020202020204" pitchFamily="34" charset="0"/>
+                      </a:rPr>
+                      <m:t>=</m:t>
+                    </m:r>
+                    <m:sSub>
+                      <m:sSubPr>
+                        <m:ctrlPr>
+                          <a:rPr lang="en-US" sz="572" b="0" i="1" smtClean="0">
+                            <a:solidFill>
+                              <a:prstClr val="black"/>
+                            </a:solidFill>
+                            <a:latin typeface="Cambria Math" panose="02040503050406030204" pitchFamily="18" charset="0"/>
+                            <a:cs typeface="Arial" panose="020B0604020202020204" pitchFamily="34" charset="0"/>
+                          </a:rPr>
+                        </m:ctrlPr>
+                      </m:sSubPr>
+                      <m:e>
+                        <m:r>
+                          <a:rPr lang="en-US" sz="572" b="0" i="1" smtClean="0">
+                            <a:solidFill>
+                              <a:prstClr val="black"/>
+                            </a:solidFill>
+                            <a:latin typeface="Cambria Math" panose="02040503050406030204" pitchFamily="18" charset="0"/>
+                            <a:cs typeface="Arial" panose="020B0604020202020204" pitchFamily="34" charset="0"/>
+                          </a:rPr>
+                          <m:t>𝜖</m:t>
+                        </m:r>
+                      </m:e>
+                      <m:sub>
+                        <m:r>
+                          <a:rPr lang="en-US" sz="572" b="0" i="1" smtClean="0">
+                            <a:solidFill>
+                              <a:prstClr val="black"/>
+                            </a:solidFill>
+                            <a:latin typeface="Cambria Math" panose="02040503050406030204" pitchFamily="18" charset="0"/>
+                            <a:cs typeface="Arial" panose="020B0604020202020204" pitchFamily="34" charset="0"/>
+                          </a:rPr>
+                          <m:t>0</m:t>
+                        </m:r>
+                      </m:sub>
+                    </m:sSub>
+                    <m:f>
+                      <m:fPr>
+                        <m:ctrlPr>
+                          <a:rPr lang="en-US" sz="572" b="0" i="1" smtClean="0">
+                            <a:solidFill>
+                              <a:prstClr val="black"/>
+                            </a:solidFill>
+                            <a:latin typeface="Cambria Math" panose="02040503050406030204" pitchFamily="18" charset="0"/>
+                            <a:cs typeface="Arial" panose="020B0604020202020204" pitchFamily="34" charset="0"/>
+                          </a:rPr>
+                        </m:ctrlPr>
+                      </m:fPr>
+                      <m:num>
+                        <m:r>
+                          <a:rPr lang="en-US" sz="572" b="0" i="1" smtClean="0">
+                            <a:solidFill>
+                              <a:prstClr val="black"/>
+                            </a:solidFill>
+                            <a:latin typeface="Cambria Math" panose="02040503050406030204" pitchFamily="18" charset="0"/>
+                            <a:cs typeface="Arial" panose="020B0604020202020204" pitchFamily="34" charset="0"/>
+                          </a:rPr>
+                          <m:t>𝐴</m:t>
+                        </m:r>
+                      </m:num>
+                      <m:den>
+                        <m:r>
+                          <a:rPr lang="en-US" sz="572" b="0" i="1" smtClean="0">
+                            <a:solidFill>
+                              <a:prstClr val="black"/>
+                            </a:solidFill>
+                            <a:latin typeface="Cambria Math" panose="02040503050406030204" pitchFamily="18" charset="0"/>
+                            <a:cs typeface="Arial" panose="020B0604020202020204" pitchFamily="34" charset="0"/>
+                          </a:rPr>
+                          <m:t>𝑑</m:t>
+                        </m:r>
+                      </m:den>
+                    </m:f>
+                  </m:oMath>
+                </a14:m>
+                <a:endParaRPr lang="en-US" sz="572" dirty="0">
+                  <a:solidFill>
+                    <a:prstClr val="black"/>
+                  </a:solidFill>
+                  <a:latin typeface="Arial" panose="020B0604020202020204" pitchFamily="34" charset="0"/>
+                  <a:cs typeface="Arial" panose="020B0604020202020204" pitchFamily="34" charset="0"/>
+                </a:endParaRPr>
               </a:p>
             </p:txBody>
           </p:sp>
         </mc:Choice>
-        <mc:Fallback>
+        <mc:Fallback xmlns="">
           <p:sp>
             <p:nvSpPr>
               <p:cNvPr id="49" name="TextBox 48">
@@ -10207,8 +10528,8 @@
             </p:nvSpPr>
             <p:spPr>
               <a:xfrm>
-                <a:off x="1773209" y="4427397"/>
-                <a:ext cx="2594684" cy="920573"/>
+                <a:off x="1771310" y="4332107"/>
+                <a:ext cx="2594684" cy="2278188"/>
               </a:xfrm>
               <a:prstGeom prst="rect">
                 <a:avLst/>
@@ -10225,7 +10546,7 @@
               <a:lstStyle/>
               <a:p>
                 <a:r>
-                  <a:rPr lang="en-US">
+                  <a:rPr lang="es-ES">
                     <a:noFill/>
                   </a:rPr>
                   <a:t> </a:t>
@@ -10737,2437 +11058,251 @@
           </a:p>
         </p:txBody>
       </p:sp>
-      <p:sp>
-        <p:nvSpPr>
-          <p:cNvPr id="51" name="TextBox 50">
-            <a:extLst>
-              <a:ext uri="{FF2B5EF4-FFF2-40B4-BE49-F238E27FC236}">
-                <a16:creationId xmlns:a16="http://schemas.microsoft.com/office/drawing/2014/main" id="{E1CD2C2A-F064-084C-B9FF-1CE5B53E4E32}"/>
-              </a:ext>
-            </a:extLst>
-          </p:cNvPr>
-          <p:cNvSpPr txBox="1"/>
-          <p:nvPr/>
-        </p:nvSpPr>
-        <p:spPr>
-          <a:xfrm>
-            <a:off x="4805279" y="5787291"/>
-            <a:ext cx="2581433" cy="708592"/>
-          </a:xfrm>
-          <a:prstGeom prst="rect">
-            <a:avLst/>
-          </a:prstGeom>
-          <a:noFill/>
-        </p:spPr>
-        <p:txBody>
-          <a:bodyPr wrap="square" rtlCol="0">
-            <a:spAutoFit/>
-          </a:bodyPr>
-          <a:lstStyle/>
-          <a:p>
-            <a:pPr defTabSz="780653"/>
-            <a:r>
-              <a:rPr lang="en-US" sz="572" dirty="0">
-                <a:solidFill>
-                  <a:prstClr val="black"/>
-                </a:solidFill>
-                <a:latin typeface="Arial" panose="020B0604020202020204" pitchFamily="34" charset="0"/>
-                <a:cs typeface="Arial" panose="020B0604020202020204" pitchFamily="34" charset="0"/>
-              </a:rPr>
-              <a:t>As </a:t>
-            </a:r>
-            <a:r>
-              <a:rPr lang="en-US" sz="572" dirty="0" err="1">
-                <a:solidFill>
-                  <a:prstClr val="black"/>
-                </a:solidFill>
-                <a:latin typeface="Arial" panose="020B0604020202020204" pitchFamily="34" charset="0"/>
-                <a:cs typeface="Arial" panose="020B0604020202020204" pitchFamily="34" charset="0"/>
-              </a:rPr>
-              <a:t>verepe</a:t>
-            </a:r>
-            <a:r>
-              <a:rPr lang="en-US" sz="572" dirty="0">
-                <a:solidFill>
-                  <a:prstClr val="black"/>
-                </a:solidFill>
-                <a:latin typeface="Arial" panose="020B0604020202020204" pitchFamily="34" charset="0"/>
-                <a:cs typeface="Arial" panose="020B0604020202020204" pitchFamily="34" charset="0"/>
-              </a:rPr>
-              <a:t> </a:t>
-            </a:r>
-            <a:r>
-              <a:rPr lang="en-US" sz="572" dirty="0" err="1">
-                <a:solidFill>
-                  <a:prstClr val="black"/>
-                </a:solidFill>
-                <a:latin typeface="Arial" panose="020B0604020202020204" pitchFamily="34" charset="0"/>
-                <a:cs typeface="Arial" panose="020B0604020202020204" pitchFamily="34" charset="0"/>
-              </a:rPr>
-              <a:t>sectis</a:t>
-            </a:r>
-            <a:r>
-              <a:rPr lang="en-US" sz="572" dirty="0">
-                <a:solidFill>
-                  <a:prstClr val="black"/>
-                </a:solidFill>
-                <a:latin typeface="Arial" panose="020B0604020202020204" pitchFamily="34" charset="0"/>
-                <a:cs typeface="Arial" panose="020B0604020202020204" pitchFamily="34" charset="0"/>
-              </a:rPr>
-              <a:t> </a:t>
-            </a:r>
-            <a:r>
-              <a:rPr lang="en-US" sz="572" dirty="0" err="1">
-                <a:solidFill>
-                  <a:prstClr val="black"/>
-                </a:solidFill>
-                <a:latin typeface="Arial" panose="020B0604020202020204" pitchFamily="34" charset="0"/>
-                <a:cs typeface="Arial" panose="020B0604020202020204" pitchFamily="34" charset="0"/>
-              </a:rPr>
-              <a:t>enda</a:t>
-            </a:r>
-            <a:r>
-              <a:rPr lang="en-US" sz="572" dirty="0">
-                <a:solidFill>
-                  <a:prstClr val="black"/>
-                </a:solidFill>
-                <a:latin typeface="Arial" panose="020B0604020202020204" pitchFamily="34" charset="0"/>
-                <a:cs typeface="Arial" panose="020B0604020202020204" pitchFamily="34" charset="0"/>
-              </a:rPr>
-              <a:t> di </a:t>
-            </a:r>
-            <a:r>
-              <a:rPr lang="en-US" sz="572" dirty="0" err="1">
-                <a:solidFill>
-                  <a:prstClr val="black"/>
-                </a:solidFill>
-                <a:latin typeface="Arial" panose="020B0604020202020204" pitchFamily="34" charset="0"/>
-                <a:cs typeface="Arial" panose="020B0604020202020204" pitchFamily="34" charset="0"/>
-              </a:rPr>
-              <a:t>incto</a:t>
-            </a:r>
-            <a:r>
-              <a:rPr lang="en-US" sz="572" dirty="0">
-                <a:solidFill>
-                  <a:prstClr val="black"/>
-                </a:solidFill>
-                <a:latin typeface="Arial" panose="020B0604020202020204" pitchFamily="34" charset="0"/>
-                <a:cs typeface="Arial" panose="020B0604020202020204" pitchFamily="34" charset="0"/>
-              </a:rPr>
-              <a:t> </a:t>
-            </a:r>
-            <a:r>
-              <a:rPr lang="en-US" sz="572" dirty="0" err="1">
-                <a:solidFill>
-                  <a:prstClr val="black"/>
-                </a:solidFill>
-                <a:latin typeface="Arial" panose="020B0604020202020204" pitchFamily="34" charset="0"/>
-                <a:cs typeface="Arial" panose="020B0604020202020204" pitchFamily="34" charset="0"/>
-              </a:rPr>
-              <a:t>etusda</a:t>
-            </a:r>
-            <a:r>
-              <a:rPr lang="en-US" sz="572" dirty="0">
-                <a:solidFill>
-                  <a:prstClr val="black"/>
-                </a:solidFill>
-                <a:latin typeface="Arial" panose="020B0604020202020204" pitchFamily="34" charset="0"/>
-                <a:cs typeface="Arial" panose="020B0604020202020204" pitchFamily="34" charset="0"/>
-              </a:rPr>
-              <a:t> </a:t>
-            </a:r>
-            <a:r>
-              <a:rPr lang="en-US" sz="572" dirty="0" err="1">
-                <a:solidFill>
-                  <a:prstClr val="black"/>
-                </a:solidFill>
-                <a:latin typeface="Arial" panose="020B0604020202020204" pitchFamily="34" charset="0"/>
-                <a:cs typeface="Arial" panose="020B0604020202020204" pitchFamily="34" charset="0"/>
-              </a:rPr>
-              <a:t>delectet</a:t>
-            </a:r>
-            <a:r>
-              <a:rPr lang="en-US" sz="572" dirty="0">
-                <a:solidFill>
-                  <a:prstClr val="black"/>
-                </a:solidFill>
-                <a:latin typeface="Arial" panose="020B0604020202020204" pitchFamily="34" charset="0"/>
-                <a:cs typeface="Arial" panose="020B0604020202020204" pitchFamily="34" charset="0"/>
-              </a:rPr>
-              <a:t> </a:t>
-            </a:r>
-            <a:r>
-              <a:rPr lang="en-US" sz="572" dirty="0" err="1">
-                <a:solidFill>
-                  <a:prstClr val="black"/>
-                </a:solidFill>
-                <a:latin typeface="Arial" panose="020B0604020202020204" pitchFamily="34" charset="0"/>
-                <a:cs typeface="Arial" panose="020B0604020202020204" pitchFamily="34" charset="0"/>
-              </a:rPr>
-              <a:t>eaque</a:t>
-            </a:r>
-            <a:r>
-              <a:rPr lang="en-US" sz="572" dirty="0">
-                <a:solidFill>
-                  <a:prstClr val="black"/>
-                </a:solidFill>
-                <a:latin typeface="Arial" panose="020B0604020202020204" pitchFamily="34" charset="0"/>
-                <a:cs typeface="Arial" panose="020B0604020202020204" pitchFamily="34" charset="0"/>
-              </a:rPr>
-              <a:t> </a:t>
-            </a:r>
-            <a:r>
-              <a:rPr lang="en-US" sz="572" dirty="0" err="1">
-                <a:solidFill>
-                  <a:prstClr val="black"/>
-                </a:solidFill>
-                <a:latin typeface="Arial" panose="020B0604020202020204" pitchFamily="34" charset="0"/>
-                <a:cs typeface="Arial" panose="020B0604020202020204" pitchFamily="34" charset="0"/>
-              </a:rPr>
-              <a:t>simusda</a:t>
-            </a:r>
-            <a:r>
-              <a:rPr lang="en-US" sz="572" dirty="0">
-                <a:solidFill>
-                  <a:prstClr val="black"/>
-                </a:solidFill>
-                <a:latin typeface="Arial" panose="020B0604020202020204" pitchFamily="34" charset="0"/>
-                <a:cs typeface="Arial" panose="020B0604020202020204" pitchFamily="34" charset="0"/>
-              </a:rPr>
-              <a:t> </a:t>
-            </a:r>
-            <a:r>
-              <a:rPr lang="en-US" sz="572" dirty="0" err="1">
-                <a:solidFill>
-                  <a:prstClr val="black"/>
-                </a:solidFill>
-                <a:latin typeface="Arial" panose="020B0604020202020204" pitchFamily="34" charset="0"/>
-                <a:cs typeface="Arial" panose="020B0604020202020204" pitchFamily="34" charset="0"/>
-              </a:rPr>
-              <a:t>ndanimus</a:t>
-            </a:r>
-            <a:r>
-              <a:rPr lang="en-US" sz="572" dirty="0">
-                <a:solidFill>
-                  <a:prstClr val="black"/>
-                </a:solidFill>
-                <a:latin typeface="Arial" panose="020B0604020202020204" pitchFamily="34" charset="0"/>
-                <a:cs typeface="Arial" panose="020B0604020202020204" pitchFamily="34" charset="0"/>
-              </a:rPr>
-              <a:t>, sin </a:t>
-            </a:r>
-            <a:r>
-              <a:rPr lang="en-US" sz="572" dirty="0" err="1">
-                <a:solidFill>
-                  <a:prstClr val="black"/>
-                </a:solidFill>
-                <a:latin typeface="Arial" panose="020B0604020202020204" pitchFamily="34" charset="0"/>
-                <a:cs typeface="Arial" panose="020B0604020202020204" pitchFamily="34" charset="0"/>
-              </a:rPr>
-              <a:t>cori</a:t>
-            </a:r>
-            <a:r>
-              <a:rPr lang="en-US" sz="572" dirty="0">
-                <a:solidFill>
-                  <a:prstClr val="black"/>
-                </a:solidFill>
-                <a:latin typeface="Arial" panose="020B0604020202020204" pitchFamily="34" charset="0"/>
-                <a:cs typeface="Arial" panose="020B0604020202020204" pitchFamily="34" charset="0"/>
-              </a:rPr>
-              <a:t> rem id </a:t>
-            </a:r>
-            <a:r>
-              <a:rPr lang="en-US" sz="572" dirty="0" err="1">
-                <a:solidFill>
-                  <a:prstClr val="black"/>
-                </a:solidFill>
-                <a:latin typeface="Arial" panose="020B0604020202020204" pitchFamily="34" charset="0"/>
-                <a:cs typeface="Arial" panose="020B0604020202020204" pitchFamily="34" charset="0"/>
-              </a:rPr>
-              <a:t>maximillut</a:t>
-            </a:r>
-            <a:r>
-              <a:rPr lang="en-US" sz="572" dirty="0">
-                <a:solidFill>
-                  <a:prstClr val="black"/>
-                </a:solidFill>
-                <a:latin typeface="Arial" panose="020B0604020202020204" pitchFamily="34" charset="0"/>
-                <a:cs typeface="Arial" panose="020B0604020202020204" pitchFamily="34" charset="0"/>
-              </a:rPr>
-              <a:t> </a:t>
-            </a:r>
-            <a:r>
-              <a:rPr lang="en-US" sz="572" dirty="0" err="1">
-                <a:solidFill>
-                  <a:prstClr val="black"/>
-                </a:solidFill>
-                <a:latin typeface="Arial" panose="020B0604020202020204" pitchFamily="34" charset="0"/>
-                <a:cs typeface="Arial" panose="020B0604020202020204" pitchFamily="34" charset="0"/>
-              </a:rPr>
-              <a:t>hari</a:t>
-            </a:r>
-            <a:r>
-              <a:rPr lang="en-US" sz="572" dirty="0">
-                <a:solidFill>
-                  <a:prstClr val="black"/>
-                </a:solidFill>
-                <a:latin typeface="Arial" panose="020B0604020202020204" pitchFamily="34" charset="0"/>
-                <a:cs typeface="Arial" panose="020B0604020202020204" pitchFamily="34" charset="0"/>
-              </a:rPr>
-              <a:t> con </a:t>
-            </a:r>
-            <a:r>
-              <a:rPr lang="en-US" sz="572" dirty="0" err="1">
-                <a:solidFill>
-                  <a:prstClr val="black"/>
-                </a:solidFill>
-                <a:latin typeface="Arial" panose="020B0604020202020204" pitchFamily="34" charset="0"/>
-                <a:cs typeface="Arial" panose="020B0604020202020204" pitchFamily="34" charset="0"/>
-              </a:rPr>
-              <a:t>ea</a:t>
-            </a:r>
-            <a:r>
-              <a:rPr lang="en-US" sz="572" dirty="0">
-                <a:solidFill>
-                  <a:prstClr val="black"/>
-                </a:solidFill>
-                <a:latin typeface="Arial" panose="020B0604020202020204" pitchFamily="34" charset="0"/>
-                <a:cs typeface="Arial" panose="020B0604020202020204" pitchFamily="34" charset="0"/>
-              </a:rPr>
-              <a:t> </a:t>
-            </a:r>
-            <a:r>
-              <a:rPr lang="en-US" sz="572" dirty="0" err="1">
-                <a:solidFill>
-                  <a:prstClr val="black"/>
-                </a:solidFill>
-                <a:latin typeface="Arial" panose="020B0604020202020204" pitchFamily="34" charset="0"/>
-                <a:cs typeface="Arial" panose="020B0604020202020204" pitchFamily="34" charset="0"/>
-              </a:rPr>
-              <a:t>quiam</a:t>
-            </a:r>
-            <a:r>
-              <a:rPr lang="en-US" sz="572" dirty="0">
-                <a:solidFill>
-                  <a:prstClr val="black"/>
-                </a:solidFill>
-                <a:latin typeface="Arial" panose="020B0604020202020204" pitchFamily="34" charset="0"/>
-                <a:cs typeface="Arial" panose="020B0604020202020204" pitchFamily="34" charset="0"/>
-              </a:rPr>
-              <a:t> </a:t>
-            </a:r>
-            <a:r>
-              <a:rPr lang="en-US" sz="572" dirty="0" err="1">
-                <a:solidFill>
-                  <a:prstClr val="black"/>
-                </a:solidFill>
-                <a:latin typeface="Arial" panose="020B0604020202020204" pitchFamily="34" charset="0"/>
-                <a:cs typeface="Arial" panose="020B0604020202020204" pitchFamily="34" charset="0"/>
-              </a:rPr>
-              <a:t>quam</a:t>
-            </a:r>
-            <a:r>
-              <a:rPr lang="en-US" sz="572" dirty="0">
-                <a:solidFill>
-                  <a:prstClr val="black"/>
-                </a:solidFill>
-                <a:latin typeface="Arial" panose="020B0604020202020204" pitchFamily="34" charset="0"/>
-                <a:cs typeface="Arial" panose="020B0604020202020204" pitchFamily="34" charset="0"/>
-              </a:rPr>
-              <a:t> et </a:t>
-            </a:r>
-            <a:r>
-              <a:rPr lang="en-US" sz="572" dirty="0" err="1">
-                <a:solidFill>
-                  <a:prstClr val="black"/>
-                </a:solidFill>
-                <a:latin typeface="Arial" panose="020B0604020202020204" pitchFamily="34" charset="0"/>
-                <a:cs typeface="Arial" panose="020B0604020202020204" pitchFamily="34" charset="0"/>
-              </a:rPr>
-              <a:t>enduci</a:t>
-            </a:r>
-            <a:r>
-              <a:rPr lang="en-US" sz="572" dirty="0">
-                <a:solidFill>
-                  <a:prstClr val="black"/>
-                </a:solidFill>
-                <a:latin typeface="Arial" panose="020B0604020202020204" pitchFamily="34" charset="0"/>
-                <a:cs typeface="Arial" panose="020B0604020202020204" pitchFamily="34" charset="0"/>
-              </a:rPr>
-              <a:t> </a:t>
-            </a:r>
-            <a:r>
-              <a:rPr lang="en-US" sz="572" dirty="0" err="1">
-                <a:solidFill>
-                  <a:prstClr val="black"/>
-                </a:solidFill>
-                <a:latin typeface="Arial" panose="020B0604020202020204" pitchFamily="34" charset="0"/>
-                <a:cs typeface="Arial" panose="020B0604020202020204" pitchFamily="34" charset="0"/>
-              </a:rPr>
-              <a:t>idunt</a:t>
-            </a:r>
-            <a:r>
-              <a:rPr lang="en-US" sz="572" dirty="0">
-                <a:solidFill>
-                  <a:prstClr val="black"/>
-                </a:solidFill>
-                <a:latin typeface="Arial" panose="020B0604020202020204" pitchFamily="34" charset="0"/>
-                <a:cs typeface="Arial" panose="020B0604020202020204" pitchFamily="34" charset="0"/>
-              </a:rPr>
-              <a:t>, </a:t>
-            </a:r>
-            <a:r>
-              <a:rPr lang="en-US" sz="572" dirty="0" err="1">
-                <a:solidFill>
-                  <a:prstClr val="black"/>
-                </a:solidFill>
-                <a:latin typeface="Arial" panose="020B0604020202020204" pitchFamily="34" charset="0"/>
-                <a:cs typeface="Arial" panose="020B0604020202020204" pitchFamily="34" charset="0"/>
-              </a:rPr>
-              <a:t>corecta</a:t>
-            </a:r>
-            <a:r>
-              <a:rPr lang="en-US" sz="572" dirty="0">
-                <a:solidFill>
-                  <a:prstClr val="black"/>
-                </a:solidFill>
-                <a:latin typeface="Arial" panose="020B0604020202020204" pitchFamily="34" charset="0"/>
-                <a:cs typeface="Arial" panose="020B0604020202020204" pitchFamily="34" charset="0"/>
-              </a:rPr>
-              <a:t> </a:t>
-            </a:r>
-            <a:r>
-              <a:rPr lang="en-US" sz="572" dirty="0" err="1">
-                <a:solidFill>
-                  <a:prstClr val="black"/>
-                </a:solidFill>
-                <a:latin typeface="Arial" panose="020B0604020202020204" pitchFamily="34" charset="0"/>
-                <a:cs typeface="Arial" panose="020B0604020202020204" pitchFamily="34" charset="0"/>
-              </a:rPr>
-              <a:t>alicimp</a:t>
-            </a:r>
-            <a:r>
-              <a:rPr lang="en-US" sz="572" dirty="0">
-                <a:solidFill>
-                  <a:prstClr val="black"/>
-                </a:solidFill>
-                <a:latin typeface="Arial" panose="020B0604020202020204" pitchFamily="34" charset="0"/>
-                <a:cs typeface="Arial" panose="020B0604020202020204" pitchFamily="34" charset="0"/>
-              </a:rPr>
-              <a:t> </a:t>
-            </a:r>
-            <a:r>
-              <a:rPr lang="en-US" sz="572" dirty="0" err="1">
-                <a:solidFill>
-                  <a:prstClr val="black"/>
-                </a:solidFill>
-                <a:latin typeface="Arial" panose="020B0604020202020204" pitchFamily="34" charset="0"/>
-                <a:cs typeface="Arial" panose="020B0604020202020204" pitchFamily="34" charset="0"/>
-              </a:rPr>
-              <a:t>oriaeperum</a:t>
-            </a:r>
-            <a:r>
-              <a:rPr lang="en-US" sz="572" dirty="0">
-                <a:solidFill>
-                  <a:prstClr val="black"/>
-                </a:solidFill>
-                <a:latin typeface="Arial" panose="020B0604020202020204" pitchFamily="34" charset="0"/>
-                <a:cs typeface="Arial" panose="020B0604020202020204" pitchFamily="34" charset="0"/>
-              </a:rPr>
-              <a:t> </a:t>
-            </a:r>
-            <a:r>
-              <a:rPr lang="en-US" sz="572" dirty="0" err="1">
-                <a:solidFill>
-                  <a:prstClr val="black"/>
-                </a:solidFill>
-                <a:latin typeface="Arial" panose="020B0604020202020204" pitchFamily="34" charset="0"/>
-                <a:cs typeface="Arial" panose="020B0604020202020204" pitchFamily="34" charset="0"/>
-              </a:rPr>
-              <a:t>iusaeped</a:t>
-            </a:r>
-            <a:r>
-              <a:rPr lang="en-US" sz="572" dirty="0">
-                <a:solidFill>
-                  <a:prstClr val="black"/>
-                </a:solidFill>
-                <a:latin typeface="Arial" panose="020B0604020202020204" pitchFamily="34" charset="0"/>
-                <a:cs typeface="Arial" panose="020B0604020202020204" pitchFamily="34" charset="0"/>
-              </a:rPr>
-              <a:t> </a:t>
-            </a:r>
-            <a:r>
-              <a:rPr lang="en-US" sz="572" dirty="0" err="1">
-                <a:solidFill>
-                  <a:prstClr val="black"/>
-                </a:solidFill>
-                <a:latin typeface="Arial" panose="020B0604020202020204" pitchFamily="34" charset="0"/>
-                <a:cs typeface="Arial" panose="020B0604020202020204" pitchFamily="34" charset="0"/>
-              </a:rPr>
-              <a:t>unt</a:t>
-            </a:r>
-            <a:r>
-              <a:rPr lang="en-US" sz="572" dirty="0">
-                <a:solidFill>
-                  <a:prstClr val="black"/>
-                </a:solidFill>
-                <a:latin typeface="Arial" panose="020B0604020202020204" pitchFamily="34" charset="0"/>
-                <a:cs typeface="Arial" panose="020B0604020202020204" pitchFamily="34" charset="0"/>
-              </a:rPr>
-              <a:t> </a:t>
-            </a:r>
-            <a:r>
-              <a:rPr lang="en-US" sz="572" dirty="0" err="1">
-                <a:solidFill>
-                  <a:prstClr val="black"/>
-                </a:solidFill>
-                <a:latin typeface="Arial" panose="020B0604020202020204" pitchFamily="34" charset="0"/>
-                <a:cs typeface="Arial" panose="020B0604020202020204" pitchFamily="34" charset="0"/>
-              </a:rPr>
-              <a:t>quis</a:t>
-            </a:r>
-            <a:r>
-              <a:rPr lang="en-US" sz="572" dirty="0">
-                <a:solidFill>
-                  <a:prstClr val="black"/>
-                </a:solidFill>
-                <a:latin typeface="Arial" panose="020B0604020202020204" pitchFamily="34" charset="0"/>
-                <a:cs typeface="Arial" panose="020B0604020202020204" pitchFamily="34" charset="0"/>
-              </a:rPr>
-              <a:t> et </a:t>
-            </a:r>
-            <a:r>
-              <a:rPr lang="en-US" sz="572" dirty="0" err="1">
-                <a:solidFill>
-                  <a:prstClr val="black"/>
-                </a:solidFill>
-                <a:latin typeface="Arial" panose="020B0604020202020204" pitchFamily="34" charset="0"/>
-                <a:cs typeface="Arial" panose="020B0604020202020204" pitchFamily="34" charset="0"/>
-              </a:rPr>
-              <a:t>ut</a:t>
-            </a:r>
-            <a:r>
-              <a:rPr lang="en-US" sz="572" dirty="0">
-                <a:solidFill>
-                  <a:prstClr val="black"/>
-                </a:solidFill>
-                <a:latin typeface="Arial" panose="020B0604020202020204" pitchFamily="34" charset="0"/>
-                <a:cs typeface="Arial" panose="020B0604020202020204" pitchFamily="34" charset="0"/>
-              </a:rPr>
-              <a:t> </a:t>
-            </a:r>
-            <a:r>
-              <a:rPr lang="en-US" sz="572" dirty="0" err="1">
-                <a:solidFill>
-                  <a:prstClr val="black"/>
-                </a:solidFill>
-                <a:latin typeface="Arial" panose="020B0604020202020204" pitchFamily="34" charset="0"/>
-                <a:cs typeface="Arial" panose="020B0604020202020204" pitchFamily="34" charset="0"/>
-              </a:rPr>
-              <a:t>abor</a:t>
-            </a:r>
-            <a:r>
-              <a:rPr lang="en-US" sz="572" dirty="0">
-                <a:solidFill>
-                  <a:prstClr val="black"/>
-                </a:solidFill>
-                <a:latin typeface="Arial" panose="020B0604020202020204" pitchFamily="34" charset="0"/>
-                <a:cs typeface="Arial" panose="020B0604020202020204" pitchFamily="34" charset="0"/>
-              </a:rPr>
-              <a:t> </a:t>
-            </a:r>
-            <a:r>
-              <a:rPr lang="en-US" sz="572" dirty="0" err="1">
-                <a:solidFill>
-                  <a:prstClr val="black"/>
-                </a:solidFill>
-                <a:latin typeface="Arial" panose="020B0604020202020204" pitchFamily="34" charset="0"/>
-                <a:cs typeface="Arial" panose="020B0604020202020204" pitchFamily="34" charset="0"/>
-              </a:rPr>
-              <a:t>ame</a:t>
-            </a:r>
-            <a:r>
-              <a:rPr lang="en-US" sz="572" dirty="0">
-                <a:solidFill>
-                  <a:prstClr val="black"/>
-                </a:solidFill>
-                <a:latin typeface="Arial" panose="020B0604020202020204" pitchFamily="34" charset="0"/>
-                <a:cs typeface="Arial" panose="020B0604020202020204" pitchFamily="34" charset="0"/>
-              </a:rPr>
-              <a:t> </a:t>
-            </a:r>
-            <a:r>
-              <a:rPr lang="en-US" sz="572" dirty="0" err="1">
-                <a:solidFill>
-                  <a:prstClr val="black"/>
-                </a:solidFill>
-                <a:latin typeface="Arial" panose="020B0604020202020204" pitchFamily="34" charset="0"/>
-                <a:cs typeface="Arial" panose="020B0604020202020204" pitchFamily="34" charset="0"/>
-              </a:rPr>
-              <a:t>alis</a:t>
-            </a:r>
-            <a:r>
-              <a:rPr lang="en-US" sz="572" dirty="0">
-                <a:solidFill>
-                  <a:prstClr val="black"/>
-                </a:solidFill>
-                <a:latin typeface="Arial" panose="020B0604020202020204" pitchFamily="34" charset="0"/>
-                <a:cs typeface="Arial" panose="020B0604020202020204" pitchFamily="34" charset="0"/>
-              </a:rPr>
-              <a:t> </a:t>
-            </a:r>
-            <a:r>
-              <a:rPr lang="en-US" sz="572" dirty="0" err="1">
-                <a:solidFill>
-                  <a:prstClr val="black"/>
-                </a:solidFill>
-                <a:latin typeface="Arial" panose="020B0604020202020204" pitchFamily="34" charset="0"/>
-                <a:cs typeface="Arial" panose="020B0604020202020204" pitchFamily="34" charset="0"/>
-              </a:rPr>
-              <a:t>utatur</a:t>
-            </a:r>
-            <a:r>
-              <a:rPr lang="en-US" sz="572" dirty="0">
-                <a:solidFill>
-                  <a:prstClr val="black"/>
-                </a:solidFill>
-                <a:latin typeface="Arial" panose="020B0604020202020204" pitchFamily="34" charset="0"/>
-                <a:cs typeface="Arial" panose="020B0604020202020204" pitchFamily="34" charset="0"/>
-              </a:rPr>
-              <a:t> as senet a </a:t>
-            </a:r>
-            <a:r>
-              <a:rPr lang="en-US" sz="572" dirty="0" err="1">
-                <a:solidFill>
-                  <a:prstClr val="black"/>
-                </a:solidFill>
-                <a:latin typeface="Arial" panose="020B0604020202020204" pitchFamily="34" charset="0"/>
-                <a:cs typeface="Arial" panose="020B0604020202020204" pitchFamily="34" charset="0"/>
-              </a:rPr>
-              <a:t>quibus</a:t>
-            </a:r>
-            <a:r>
-              <a:rPr lang="en-US" sz="572" dirty="0">
-                <a:solidFill>
-                  <a:prstClr val="black"/>
-                </a:solidFill>
-                <a:latin typeface="Arial" panose="020B0604020202020204" pitchFamily="34" charset="0"/>
-                <a:cs typeface="Arial" panose="020B0604020202020204" pitchFamily="34" charset="0"/>
-              </a:rPr>
-              <a:t> </a:t>
-            </a:r>
-            <a:r>
-              <a:rPr lang="en-US" sz="572" dirty="0" err="1">
-                <a:solidFill>
-                  <a:prstClr val="black"/>
-                </a:solidFill>
-                <a:latin typeface="Arial" panose="020B0604020202020204" pitchFamily="34" charset="0"/>
-                <a:cs typeface="Arial" panose="020B0604020202020204" pitchFamily="34" charset="0"/>
-              </a:rPr>
-              <a:t>dolutatur</a:t>
-            </a:r>
-            <a:r>
-              <a:rPr lang="en-US" sz="572" dirty="0">
-                <a:solidFill>
-                  <a:prstClr val="black"/>
-                </a:solidFill>
-                <a:latin typeface="Arial" panose="020B0604020202020204" pitchFamily="34" charset="0"/>
-                <a:cs typeface="Arial" panose="020B0604020202020204" pitchFamily="34" charset="0"/>
-              </a:rPr>
-              <a:t> </a:t>
-            </a:r>
-            <a:r>
-              <a:rPr lang="en-US" sz="572" dirty="0" err="1">
-                <a:solidFill>
-                  <a:prstClr val="black"/>
-                </a:solidFill>
-                <a:latin typeface="Arial" panose="020B0604020202020204" pitchFamily="34" charset="0"/>
-                <a:cs typeface="Arial" panose="020B0604020202020204" pitchFamily="34" charset="0"/>
-              </a:rPr>
-              <a:t>sedit</a:t>
-            </a:r>
-            <a:r>
-              <a:rPr lang="en-US" sz="572" dirty="0">
-                <a:solidFill>
-                  <a:prstClr val="black"/>
-                </a:solidFill>
-                <a:latin typeface="Arial" panose="020B0604020202020204" pitchFamily="34" charset="0"/>
-                <a:cs typeface="Arial" panose="020B0604020202020204" pitchFamily="34" charset="0"/>
-              </a:rPr>
-              <a:t> </a:t>
-            </a:r>
-            <a:r>
-              <a:rPr lang="en-US" sz="572" dirty="0" err="1">
-                <a:solidFill>
-                  <a:prstClr val="black"/>
-                </a:solidFill>
-                <a:latin typeface="Arial" panose="020B0604020202020204" pitchFamily="34" charset="0"/>
-                <a:cs typeface="Arial" panose="020B0604020202020204" pitchFamily="34" charset="0"/>
-              </a:rPr>
-              <a:t>aliam</a:t>
-            </a:r>
-            <a:r>
-              <a:rPr lang="en-US" sz="572" dirty="0">
-                <a:solidFill>
-                  <a:prstClr val="black"/>
-                </a:solidFill>
-                <a:latin typeface="Arial" panose="020B0604020202020204" pitchFamily="34" charset="0"/>
-                <a:cs typeface="Arial" panose="020B0604020202020204" pitchFamily="34" charset="0"/>
-              </a:rPr>
-              <a:t> </a:t>
-            </a:r>
-            <a:r>
-              <a:rPr lang="en-US" sz="572" dirty="0" err="1">
-                <a:solidFill>
-                  <a:prstClr val="black"/>
-                </a:solidFill>
-                <a:latin typeface="Arial" panose="020B0604020202020204" pitchFamily="34" charset="0"/>
-                <a:cs typeface="Arial" panose="020B0604020202020204" pitchFamily="34" charset="0"/>
-              </a:rPr>
-              <a:t>apienda</a:t>
-            </a:r>
-            <a:r>
-              <a:rPr lang="en-US" sz="572" dirty="0">
-                <a:solidFill>
-                  <a:prstClr val="black"/>
-                </a:solidFill>
-                <a:latin typeface="Arial" panose="020B0604020202020204" pitchFamily="34" charset="0"/>
-                <a:cs typeface="Arial" panose="020B0604020202020204" pitchFamily="34" charset="0"/>
-              </a:rPr>
-              <a:t> </a:t>
-            </a:r>
-            <a:r>
-              <a:rPr lang="en-US" sz="572" dirty="0" err="1">
-                <a:solidFill>
-                  <a:prstClr val="black"/>
-                </a:solidFill>
-                <a:latin typeface="Arial" panose="020B0604020202020204" pitchFamily="34" charset="0"/>
-                <a:cs typeface="Arial" panose="020B0604020202020204" pitchFamily="34" charset="0"/>
-              </a:rPr>
-              <a:t>versper</a:t>
-            </a:r>
-            <a:r>
-              <a:rPr lang="en-US" sz="572" dirty="0">
-                <a:solidFill>
-                  <a:prstClr val="black"/>
-                </a:solidFill>
-                <a:latin typeface="Arial" panose="020B0604020202020204" pitchFamily="34" charset="0"/>
-                <a:cs typeface="Arial" panose="020B0604020202020204" pitchFamily="34" charset="0"/>
-              </a:rPr>
-              <a:t> </a:t>
-            </a:r>
-            <a:r>
-              <a:rPr lang="en-US" sz="572" dirty="0" err="1">
-                <a:solidFill>
-                  <a:prstClr val="black"/>
-                </a:solidFill>
-                <a:latin typeface="Arial" panose="020B0604020202020204" pitchFamily="34" charset="0"/>
-                <a:cs typeface="Arial" panose="020B0604020202020204" pitchFamily="34" charset="0"/>
-              </a:rPr>
-              <a:t>feriti</a:t>
-            </a:r>
-            <a:r>
-              <a:rPr lang="en-US" sz="572" dirty="0">
-                <a:solidFill>
-                  <a:prstClr val="black"/>
-                </a:solidFill>
-                <a:latin typeface="Arial" panose="020B0604020202020204" pitchFamily="34" charset="0"/>
-                <a:cs typeface="Arial" panose="020B0604020202020204" pitchFamily="34" charset="0"/>
-              </a:rPr>
-              <a:t> </a:t>
-            </a:r>
-            <a:r>
-              <a:rPr lang="en-US" sz="572" dirty="0" err="1">
-                <a:solidFill>
-                  <a:prstClr val="black"/>
-                </a:solidFill>
-                <a:latin typeface="Arial" panose="020B0604020202020204" pitchFamily="34" charset="0"/>
-                <a:cs typeface="Arial" panose="020B0604020202020204" pitchFamily="34" charset="0"/>
-              </a:rPr>
-              <a:t>delia</a:t>
-            </a:r>
-            <a:r>
-              <a:rPr lang="en-US" sz="572" dirty="0">
-                <a:solidFill>
-                  <a:prstClr val="black"/>
-                </a:solidFill>
-                <a:latin typeface="Arial" panose="020B0604020202020204" pitchFamily="34" charset="0"/>
-                <a:cs typeface="Arial" panose="020B0604020202020204" pitchFamily="34" charset="0"/>
-              </a:rPr>
-              <a:t> pa </a:t>
-            </a:r>
-            <a:r>
-              <a:rPr lang="en-US" sz="572" dirty="0" err="1">
-                <a:solidFill>
-                  <a:prstClr val="black"/>
-                </a:solidFill>
-                <a:latin typeface="Arial" panose="020B0604020202020204" pitchFamily="34" charset="0"/>
-                <a:cs typeface="Arial" panose="020B0604020202020204" pitchFamily="34" charset="0"/>
-              </a:rPr>
-              <a:t>dolo</a:t>
-            </a:r>
-            <a:r>
-              <a:rPr lang="en-US" sz="572" dirty="0">
-                <a:solidFill>
-                  <a:prstClr val="black"/>
-                </a:solidFill>
-                <a:latin typeface="Arial" panose="020B0604020202020204" pitchFamily="34" charset="0"/>
-                <a:cs typeface="Arial" panose="020B0604020202020204" pitchFamily="34" charset="0"/>
-              </a:rPr>
-              <a:t> </a:t>
-            </a:r>
-            <a:r>
-              <a:rPr lang="en-US" sz="572" dirty="0" err="1">
-                <a:solidFill>
-                  <a:prstClr val="black"/>
-                </a:solidFill>
-                <a:latin typeface="Arial" panose="020B0604020202020204" pitchFamily="34" charset="0"/>
-                <a:cs typeface="Arial" panose="020B0604020202020204" pitchFamily="34" charset="0"/>
-              </a:rPr>
-              <a:t>quamus</a:t>
-            </a:r>
-            <a:r>
-              <a:rPr lang="en-US" sz="572" dirty="0">
-                <a:solidFill>
-                  <a:prstClr val="black"/>
-                </a:solidFill>
-                <a:latin typeface="Arial" panose="020B0604020202020204" pitchFamily="34" charset="0"/>
-                <a:cs typeface="Arial" panose="020B0604020202020204" pitchFamily="34" charset="0"/>
-              </a:rPr>
-              <a:t> arum es </a:t>
-            </a:r>
-            <a:r>
-              <a:rPr lang="en-US" sz="572" dirty="0" err="1">
-                <a:solidFill>
-                  <a:prstClr val="black"/>
-                </a:solidFill>
-                <a:latin typeface="Arial" panose="020B0604020202020204" pitchFamily="34" charset="0"/>
-                <a:cs typeface="Arial" panose="020B0604020202020204" pitchFamily="34" charset="0"/>
-              </a:rPr>
-              <a:t>endellu</a:t>
-            </a:r>
-            <a:r>
-              <a:rPr lang="en-US" sz="572" dirty="0">
-                <a:solidFill>
-                  <a:prstClr val="black"/>
-                </a:solidFill>
-                <a:latin typeface="Arial" panose="020B0604020202020204" pitchFamily="34" charset="0"/>
-                <a:cs typeface="Arial" panose="020B0604020202020204" pitchFamily="34" charset="0"/>
-              </a:rPr>
-              <a:t> </a:t>
-            </a:r>
-            <a:r>
-              <a:rPr lang="en-US" sz="572" dirty="0" err="1">
-                <a:solidFill>
-                  <a:prstClr val="black"/>
-                </a:solidFill>
-                <a:latin typeface="Arial" panose="020B0604020202020204" pitchFamily="34" charset="0"/>
-                <a:cs typeface="Arial" panose="020B0604020202020204" pitchFamily="34" charset="0"/>
-              </a:rPr>
-              <a:t>pisquia</a:t>
-            </a:r>
-            <a:r>
-              <a:rPr lang="en-US" sz="572" dirty="0">
-                <a:solidFill>
-                  <a:prstClr val="black"/>
-                </a:solidFill>
-                <a:latin typeface="Arial" panose="020B0604020202020204" pitchFamily="34" charset="0"/>
-                <a:cs typeface="Arial" panose="020B0604020202020204" pitchFamily="34" charset="0"/>
-              </a:rPr>
-              <a:t> </a:t>
-            </a:r>
-            <a:r>
-              <a:rPr lang="en-US" sz="572" dirty="0" err="1">
-                <a:solidFill>
-                  <a:prstClr val="black"/>
-                </a:solidFill>
-                <a:latin typeface="Arial" panose="020B0604020202020204" pitchFamily="34" charset="0"/>
-                <a:cs typeface="Arial" panose="020B0604020202020204" pitchFamily="34" charset="0"/>
-              </a:rPr>
-              <a:t>aditatur</a:t>
-            </a:r>
-            <a:r>
-              <a:rPr lang="en-US" sz="572" dirty="0">
-                <a:solidFill>
-                  <a:prstClr val="black"/>
-                </a:solidFill>
-                <a:latin typeface="Arial" panose="020B0604020202020204" pitchFamily="34" charset="0"/>
-                <a:cs typeface="Arial" panose="020B0604020202020204" pitchFamily="34" charset="0"/>
-              </a:rPr>
-              <a:t> </a:t>
-            </a:r>
-            <a:r>
-              <a:rPr lang="en-US" sz="572" dirty="0" err="1">
-                <a:solidFill>
-                  <a:prstClr val="black"/>
-                </a:solidFill>
-                <a:latin typeface="Arial" panose="020B0604020202020204" pitchFamily="34" charset="0"/>
-                <a:cs typeface="Arial" panose="020B0604020202020204" pitchFamily="34" charset="0"/>
-              </a:rPr>
-              <a:t>audam</a:t>
-            </a:r>
-            <a:r>
-              <a:rPr lang="en-US" sz="572" dirty="0">
-                <a:solidFill>
-                  <a:prstClr val="black"/>
-                </a:solidFill>
-                <a:latin typeface="Arial" panose="020B0604020202020204" pitchFamily="34" charset="0"/>
-                <a:cs typeface="Arial" panose="020B0604020202020204" pitchFamily="34" charset="0"/>
-              </a:rPr>
-              <a:t> </a:t>
-            </a:r>
-            <a:r>
-              <a:rPr lang="en-US" sz="572" dirty="0" err="1">
-                <a:solidFill>
-                  <a:prstClr val="black"/>
-                </a:solidFill>
-                <a:latin typeface="Arial" panose="020B0604020202020204" pitchFamily="34" charset="0"/>
-                <a:cs typeface="Arial" panose="020B0604020202020204" pitchFamily="34" charset="0"/>
-              </a:rPr>
-              <a:t>earupid</a:t>
-            </a:r>
-            <a:r>
-              <a:rPr lang="en-US" sz="572" dirty="0">
-                <a:solidFill>
-                  <a:prstClr val="black"/>
-                </a:solidFill>
-                <a:latin typeface="Arial" panose="020B0604020202020204" pitchFamily="34" charset="0"/>
-                <a:cs typeface="Arial" panose="020B0604020202020204" pitchFamily="34" charset="0"/>
-              </a:rPr>
-              <a:t> quo </a:t>
-            </a:r>
-            <a:r>
-              <a:rPr lang="en-US" sz="572" dirty="0" err="1">
-                <a:solidFill>
-                  <a:prstClr val="black"/>
-                </a:solidFill>
-                <a:latin typeface="Arial" panose="020B0604020202020204" pitchFamily="34" charset="0"/>
-                <a:cs typeface="Arial" panose="020B0604020202020204" pitchFamily="34" charset="0"/>
-              </a:rPr>
-              <a:t>quunt</a:t>
-            </a:r>
-            <a:r>
-              <a:rPr lang="en-US" sz="572" dirty="0">
-                <a:solidFill>
-                  <a:prstClr val="black"/>
-                </a:solidFill>
-                <a:latin typeface="Arial" panose="020B0604020202020204" pitchFamily="34" charset="0"/>
-                <a:cs typeface="Arial" panose="020B0604020202020204" pitchFamily="34" charset="0"/>
-              </a:rPr>
-              <a:t> </a:t>
-            </a:r>
-            <a:r>
-              <a:rPr lang="en-US" sz="572" dirty="0" err="1">
-                <a:solidFill>
-                  <a:prstClr val="black"/>
-                </a:solidFill>
-                <a:latin typeface="Arial" panose="020B0604020202020204" pitchFamily="34" charset="0"/>
-                <a:cs typeface="Arial" panose="020B0604020202020204" pitchFamily="34" charset="0"/>
-              </a:rPr>
-              <a:t>odigniscil</a:t>
-            </a:r>
-            <a:r>
-              <a:rPr lang="en-US" sz="572" dirty="0">
-                <a:solidFill>
-                  <a:prstClr val="black"/>
-                </a:solidFill>
-                <a:latin typeface="Arial" panose="020B0604020202020204" pitchFamily="34" charset="0"/>
-                <a:cs typeface="Arial" panose="020B0604020202020204" pitchFamily="34" charset="0"/>
-              </a:rPr>
-              <a:t> </a:t>
-            </a:r>
-            <a:r>
-              <a:rPr lang="en-US" sz="572" dirty="0" err="1">
-                <a:solidFill>
-                  <a:prstClr val="black"/>
-                </a:solidFill>
-                <a:latin typeface="Arial" panose="020B0604020202020204" pitchFamily="34" charset="0"/>
-                <a:cs typeface="Arial" panose="020B0604020202020204" pitchFamily="34" charset="0"/>
-              </a:rPr>
-              <a:t>earum</a:t>
-            </a:r>
-            <a:r>
-              <a:rPr lang="en-US" sz="572" dirty="0">
-                <a:solidFill>
-                  <a:prstClr val="black"/>
-                </a:solidFill>
-                <a:latin typeface="Arial" panose="020B0604020202020204" pitchFamily="34" charset="0"/>
-                <a:cs typeface="Arial" panose="020B0604020202020204" pitchFamily="34" charset="0"/>
-              </a:rPr>
-              <a:t> </a:t>
-            </a:r>
-            <a:r>
-              <a:rPr lang="en-US" sz="572" dirty="0" err="1">
-                <a:solidFill>
-                  <a:prstClr val="black"/>
-                </a:solidFill>
-                <a:latin typeface="Arial" panose="020B0604020202020204" pitchFamily="34" charset="0"/>
-                <a:cs typeface="Arial" panose="020B0604020202020204" pitchFamily="34" charset="0"/>
-              </a:rPr>
-              <a:t>verios</a:t>
-            </a:r>
-            <a:r>
-              <a:rPr lang="en-US" sz="572" dirty="0">
-                <a:solidFill>
-                  <a:prstClr val="black"/>
-                </a:solidFill>
-                <a:latin typeface="Arial" panose="020B0604020202020204" pitchFamily="34" charset="0"/>
-                <a:cs typeface="Arial" panose="020B0604020202020204" pitchFamily="34" charset="0"/>
-              </a:rPr>
-              <a:t> </a:t>
-            </a:r>
-            <a:r>
-              <a:rPr lang="en-US" sz="572" dirty="0" err="1">
-                <a:solidFill>
-                  <a:prstClr val="black"/>
-                </a:solidFill>
-                <a:latin typeface="Arial" panose="020B0604020202020204" pitchFamily="34" charset="0"/>
-                <a:cs typeface="Arial" panose="020B0604020202020204" pitchFamily="34" charset="0"/>
-              </a:rPr>
-              <a:t>nonsequam</a:t>
-            </a:r>
-            <a:r>
-              <a:rPr lang="en-US" sz="572" dirty="0">
-                <a:solidFill>
-                  <a:prstClr val="black"/>
-                </a:solidFill>
-                <a:latin typeface="Arial" panose="020B0604020202020204" pitchFamily="34" charset="0"/>
-                <a:cs typeface="Arial" panose="020B0604020202020204" pitchFamily="34" charset="0"/>
-              </a:rPr>
-              <a:t> </a:t>
-            </a:r>
-            <a:r>
-              <a:rPr lang="en-US" sz="572" dirty="0" err="1">
-                <a:solidFill>
-                  <a:prstClr val="black"/>
-                </a:solidFill>
-                <a:latin typeface="Arial" panose="020B0604020202020204" pitchFamily="34" charset="0"/>
-                <a:cs typeface="Arial" panose="020B0604020202020204" pitchFamily="34" charset="0"/>
-              </a:rPr>
-              <a:t>duciis</a:t>
-            </a:r>
-            <a:r>
-              <a:rPr lang="en-US" sz="572" dirty="0">
-                <a:solidFill>
-                  <a:prstClr val="black"/>
-                </a:solidFill>
-                <a:latin typeface="Arial" panose="020B0604020202020204" pitchFamily="34" charset="0"/>
-                <a:cs typeface="Arial" panose="020B0604020202020204" pitchFamily="34" charset="0"/>
-              </a:rPr>
-              <a:t> et</a:t>
-            </a:r>
-          </a:p>
-          <a:p>
-            <a:pPr defTabSz="780653"/>
-            <a:endParaRPr lang="en-US" sz="572" dirty="0">
-              <a:solidFill>
-                <a:prstClr val="black"/>
-              </a:solidFill>
-              <a:latin typeface="Arial" panose="020B0604020202020204" pitchFamily="34" charset="0"/>
-              <a:cs typeface="Arial" panose="020B0604020202020204" pitchFamily="34" charset="0"/>
-            </a:endParaRPr>
-          </a:p>
-        </p:txBody>
-      </p:sp>
-      <p:sp>
-        <p:nvSpPr>
-          <p:cNvPr id="54" name="TextBox 53">
-            <a:extLst>
-              <a:ext uri="{FF2B5EF4-FFF2-40B4-BE49-F238E27FC236}">
-                <a16:creationId xmlns:a16="http://schemas.microsoft.com/office/drawing/2014/main" id="{F8C7482B-E913-3C49-AF7C-0ACF650610EA}"/>
-              </a:ext>
-            </a:extLst>
-          </p:cNvPr>
-          <p:cNvSpPr txBox="1"/>
-          <p:nvPr/>
-        </p:nvSpPr>
-        <p:spPr>
-          <a:xfrm>
-            <a:off x="4805279" y="4974783"/>
-            <a:ext cx="2581433" cy="796628"/>
-          </a:xfrm>
-          <a:prstGeom prst="rect">
-            <a:avLst/>
-          </a:prstGeom>
-          <a:noFill/>
-        </p:spPr>
-        <p:txBody>
-          <a:bodyPr wrap="square" rtlCol="0">
-            <a:spAutoFit/>
-          </a:bodyPr>
-          <a:lstStyle/>
-          <a:p>
-            <a:pPr defTabSz="780653"/>
-            <a:r>
-              <a:rPr lang="en-US" sz="572" dirty="0">
-                <a:solidFill>
-                  <a:prstClr val="black"/>
-                </a:solidFill>
-                <a:latin typeface="Arial" panose="020B0604020202020204" pitchFamily="34" charset="0"/>
-                <a:cs typeface="Arial" panose="020B0604020202020204" pitchFamily="34" charset="0"/>
-              </a:rPr>
-              <a:t>As </a:t>
-            </a:r>
-            <a:r>
-              <a:rPr lang="en-US" sz="572" dirty="0" err="1">
-                <a:solidFill>
-                  <a:prstClr val="black"/>
-                </a:solidFill>
-                <a:latin typeface="Arial" panose="020B0604020202020204" pitchFamily="34" charset="0"/>
-                <a:cs typeface="Arial" panose="020B0604020202020204" pitchFamily="34" charset="0"/>
-              </a:rPr>
-              <a:t>verepe</a:t>
-            </a:r>
-            <a:r>
-              <a:rPr lang="en-US" sz="572" dirty="0">
-                <a:solidFill>
-                  <a:prstClr val="black"/>
-                </a:solidFill>
-                <a:latin typeface="Arial" panose="020B0604020202020204" pitchFamily="34" charset="0"/>
-                <a:cs typeface="Arial" panose="020B0604020202020204" pitchFamily="34" charset="0"/>
-              </a:rPr>
-              <a:t> </a:t>
-            </a:r>
-            <a:r>
-              <a:rPr lang="en-US" sz="572" dirty="0" err="1">
-                <a:solidFill>
-                  <a:prstClr val="black"/>
-                </a:solidFill>
-                <a:latin typeface="Arial" panose="020B0604020202020204" pitchFamily="34" charset="0"/>
-                <a:cs typeface="Arial" panose="020B0604020202020204" pitchFamily="34" charset="0"/>
-              </a:rPr>
-              <a:t>sectis</a:t>
-            </a:r>
-            <a:r>
-              <a:rPr lang="en-US" sz="572" dirty="0">
-                <a:solidFill>
-                  <a:prstClr val="black"/>
-                </a:solidFill>
-                <a:latin typeface="Arial" panose="020B0604020202020204" pitchFamily="34" charset="0"/>
-                <a:cs typeface="Arial" panose="020B0604020202020204" pitchFamily="34" charset="0"/>
-              </a:rPr>
-              <a:t> </a:t>
-            </a:r>
-            <a:r>
-              <a:rPr lang="en-US" sz="572" dirty="0" err="1">
-                <a:solidFill>
-                  <a:prstClr val="black"/>
-                </a:solidFill>
-                <a:latin typeface="Arial" panose="020B0604020202020204" pitchFamily="34" charset="0"/>
-                <a:cs typeface="Arial" panose="020B0604020202020204" pitchFamily="34" charset="0"/>
-              </a:rPr>
-              <a:t>enda</a:t>
-            </a:r>
-            <a:r>
-              <a:rPr lang="en-US" sz="572" dirty="0">
-                <a:solidFill>
-                  <a:prstClr val="black"/>
-                </a:solidFill>
-                <a:latin typeface="Arial" panose="020B0604020202020204" pitchFamily="34" charset="0"/>
-                <a:cs typeface="Arial" panose="020B0604020202020204" pitchFamily="34" charset="0"/>
-              </a:rPr>
-              <a:t> di </a:t>
-            </a:r>
-            <a:r>
-              <a:rPr lang="en-US" sz="572" dirty="0" err="1">
-                <a:solidFill>
-                  <a:prstClr val="black"/>
-                </a:solidFill>
-                <a:latin typeface="Arial" panose="020B0604020202020204" pitchFamily="34" charset="0"/>
-                <a:cs typeface="Arial" panose="020B0604020202020204" pitchFamily="34" charset="0"/>
-              </a:rPr>
-              <a:t>incto</a:t>
-            </a:r>
-            <a:r>
-              <a:rPr lang="en-US" sz="572" dirty="0">
-                <a:solidFill>
-                  <a:prstClr val="black"/>
-                </a:solidFill>
-                <a:latin typeface="Arial" panose="020B0604020202020204" pitchFamily="34" charset="0"/>
-                <a:cs typeface="Arial" panose="020B0604020202020204" pitchFamily="34" charset="0"/>
-              </a:rPr>
-              <a:t> </a:t>
-            </a:r>
-            <a:r>
-              <a:rPr lang="en-US" sz="572" dirty="0" err="1">
-                <a:solidFill>
-                  <a:prstClr val="black"/>
-                </a:solidFill>
-                <a:latin typeface="Arial" panose="020B0604020202020204" pitchFamily="34" charset="0"/>
-                <a:cs typeface="Arial" panose="020B0604020202020204" pitchFamily="34" charset="0"/>
-              </a:rPr>
-              <a:t>etusda</a:t>
-            </a:r>
-            <a:r>
-              <a:rPr lang="en-US" sz="572" dirty="0">
-                <a:solidFill>
-                  <a:prstClr val="black"/>
-                </a:solidFill>
-                <a:latin typeface="Arial" panose="020B0604020202020204" pitchFamily="34" charset="0"/>
-                <a:cs typeface="Arial" panose="020B0604020202020204" pitchFamily="34" charset="0"/>
-              </a:rPr>
-              <a:t> </a:t>
-            </a:r>
-            <a:r>
-              <a:rPr lang="en-US" sz="572" dirty="0" err="1">
-                <a:solidFill>
-                  <a:prstClr val="black"/>
-                </a:solidFill>
-                <a:latin typeface="Arial" panose="020B0604020202020204" pitchFamily="34" charset="0"/>
-                <a:cs typeface="Arial" panose="020B0604020202020204" pitchFamily="34" charset="0"/>
-              </a:rPr>
-              <a:t>delectet</a:t>
-            </a:r>
-            <a:r>
-              <a:rPr lang="en-US" sz="572" dirty="0">
-                <a:solidFill>
-                  <a:prstClr val="black"/>
-                </a:solidFill>
-                <a:latin typeface="Arial" panose="020B0604020202020204" pitchFamily="34" charset="0"/>
-                <a:cs typeface="Arial" panose="020B0604020202020204" pitchFamily="34" charset="0"/>
-              </a:rPr>
-              <a:t> </a:t>
-            </a:r>
-            <a:r>
-              <a:rPr lang="en-US" sz="572" dirty="0" err="1">
-                <a:solidFill>
-                  <a:prstClr val="black"/>
-                </a:solidFill>
-                <a:latin typeface="Arial" panose="020B0604020202020204" pitchFamily="34" charset="0"/>
-                <a:cs typeface="Arial" panose="020B0604020202020204" pitchFamily="34" charset="0"/>
-              </a:rPr>
-              <a:t>eaque</a:t>
-            </a:r>
-            <a:r>
-              <a:rPr lang="en-US" sz="572" dirty="0">
-                <a:solidFill>
-                  <a:prstClr val="black"/>
-                </a:solidFill>
-                <a:latin typeface="Arial" panose="020B0604020202020204" pitchFamily="34" charset="0"/>
-                <a:cs typeface="Arial" panose="020B0604020202020204" pitchFamily="34" charset="0"/>
-              </a:rPr>
-              <a:t> </a:t>
-            </a:r>
-            <a:r>
-              <a:rPr lang="en-US" sz="572" dirty="0" err="1">
-                <a:solidFill>
-                  <a:prstClr val="black"/>
-                </a:solidFill>
-                <a:latin typeface="Arial" panose="020B0604020202020204" pitchFamily="34" charset="0"/>
-                <a:cs typeface="Arial" panose="020B0604020202020204" pitchFamily="34" charset="0"/>
-              </a:rPr>
-              <a:t>simusda</a:t>
-            </a:r>
-            <a:r>
-              <a:rPr lang="en-US" sz="572" dirty="0">
-                <a:solidFill>
-                  <a:prstClr val="black"/>
-                </a:solidFill>
-                <a:latin typeface="Arial" panose="020B0604020202020204" pitchFamily="34" charset="0"/>
-                <a:cs typeface="Arial" panose="020B0604020202020204" pitchFamily="34" charset="0"/>
-              </a:rPr>
-              <a:t> </a:t>
-            </a:r>
-            <a:r>
-              <a:rPr lang="en-US" sz="572" dirty="0" err="1">
-                <a:solidFill>
-                  <a:prstClr val="black"/>
-                </a:solidFill>
-                <a:latin typeface="Arial" panose="020B0604020202020204" pitchFamily="34" charset="0"/>
-                <a:cs typeface="Arial" panose="020B0604020202020204" pitchFamily="34" charset="0"/>
-              </a:rPr>
-              <a:t>ndanimus</a:t>
-            </a:r>
-            <a:r>
-              <a:rPr lang="en-US" sz="572" dirty="0">
-                <a:solidFill>
-                  <a:prstClr val="black"/>
-                </a:solidFill>
-                <a:latin typeface="Arial" panose="020B0604020202020204" pitchFamily="34" charset="0"/>
-                <a:cs typeface="Arial" panose="020B0604020202020204" pitchFamily="34" charset="0"/>
-              </a:rPr>
-              <a:t>, sin </a:t>
-            </a:r>
-            <a:r>
-              <a:rPr lang="en-US" sz="572" dirty="0" err="1">
-                <a:solidFill>
-                  <a:prstClr val="black"/>
-                </a:solidFill>
-                <a:latin typeface="Arial" panose="020B0604020202020204" pitchFamily="34" charset="0"/>
-                <a:cs typeface="Arial" panose="020B0604020202020204" pitchFamily="34" charset="0"/>
-              </a:rPr>
-              <a:t>cori</a:t>
-            </a:r>
-            <a:r>
-              <a:rPr lang="en-US" sz="572" dirty="0">
-                <a:solidFill>
-                  <a:prstClr val="black"/>
-                </a:solidFill>
-                <a:latin typeface="Arial" panose="020B0604020202020204" pitchFamily="34" charset="0"/>
-                <a:cs typeface="Arial" panose="020B0604020202020204" pitchFamily="34" charset="0"/>
-              </a:rPr>
-              <a:t> rem id </a:t>
-            </a:r>
-            <a:r>
-              <a:rPr lang="en-US" sz="572" dirty="0" err="1">
-                <a:solidFill>
-                  <a:prstClr val="black"/>
-                </a:solidFill>
-                <a:latin typeface="Arial" panose="020B0604020202020204" pitchFamily="34" charset="0"/>
-                <a:cs typeface="Arial" panose="020B0604020202020204" pitchFamily="34" charset="0"/>
-              </a:rPr>
-              <a:t>maximillut</a:t>
-            </a:r>
-            <a:r>
-              <a:rPr lang="en-US" sz="572" dirty="0">
-                <a:solidFill>
-                  <a:prstClr val="black"/>
-                </a:solidFill>
-                <a:latin typeface="Arial" panose="020B0604020202020204" pitchFamily="34" charset="0"/>
-                <a:cs typeface="Arial" panose="020B0604020202020204" pitchFamily="34" charset="0"/>
-              </a:rPr>
-              <a:t> </a:t>
-            </a:r>
-            <a:r>
-              <a:rPr lang="en-US" sz="572" dirty="0" err="1">
-                <a:solidFill>
-                  <a:prstClr val="black"/>
-                </a:solidFill>
-                <a:latin typeface="Arial" panose="020B0604020202020204" pitchFamily="34" charset="0"/>
-                <a:cs typeface="Arial" panose="020B0604020202020204" pitchFamily="34" charset="0"/>
-              </a:rPr>
-              <a:t>hari</a:t>
-            </a:r>
-            <a:r>
-              <a:rPr lang="en-US" sz="572" dirty="0">
-                <a:solidFill>
-                  <a:prstClr val="black"/>
-                </a:solidFill>
-                <a:latin typeface="Arial" panose="020B0604020202020204" pitchFamily="34" charset="0"/>
-                <a:cs typeface="Arial" panose="020B0604020202020204" pitchFamily="34" charset="0"/>
-              </a:rPr>
-              <a:t> con </a:t>
-            </a:r>
-            <a:r>
-              <a:rPr lang="en-US" sz="572" dirty="0" err="1">
-                <a:solidFill>
-                  <a:prstClr val="black"/>
-                </a:solidFill>
-                <a:latin typeface="Arial" panose="020B0604020202020204" pitchFamily="34" charset="0"/>
-                <a:cs typeface="Arial" panose="020B0604020202020204" pitchFamily="34" charset="0"/>
-              </a:rPr>
-              <a:t>ea</a:t>
-            </a:r>
-            <a:r>
-              <a:rPr lang="en-US" sz="572" dirty="0">
-                <a:solidFill>
-                  <a:prstClr val="black"/>
-                </a:solidFill>
-                <a:latin typeface="Arial" panose="020B0604020202020204" pitchFamily="34" charset="0"/>
-                <a:cs typeface="Arial" panose="020B0604020202020204" pitchFamily="34" charset="0"/>
-              </a:rPr>
-              <a:t> </a:t>
-            </a:r>
-            <a:r>
-              <a:rPr lang="en-US" sz="572" dirty="0" err="1">
-                <a:solidFill>
-                  <a:prstClr val="black"/>
-                </a:solidFill>
-                <a:latin typeface="Arial" panose="020B0604020202020204" pitchFamily="34" charset="0"/>
-                <a:cs typeface="Arial" panose="020B0604020202020204" pitchFamily="34" charset="0"/>
-              </a:rPr>
-              <a:t>quiam</a:t>
-            </a:r>
-            <a:r>
-              <a:rPr lang="en-US" sz="572" dirty="0">
-                <a:solidFill>
-                  <a:prstClr val="black"/>
-                </a:solidFill>
-                <a:latin typeface="Arial" panose="020B0604020202020204" pitchFamily="34" charset="0"/>
-                <a:cs typeface="Arial" panose="020B0604020202020204" pitchFamily="34" charset="0"/>
-              </a:rPr>
-              <a:t> </a:t>
-            </a:r>
-            <a:r>
-              <a:rPr lang="en-US" sz="572" dirty="0" err="1">
-                <a:solidFill>
-                  <a:prstClr val="black"/>
-                </a:solidFill>
-                <a:latin typeface="Arial" panose="020B0604020202020204" pitchFamily="34" charset="0"/>
-                <a:cs typeface="Arial" panose="020B0604020202020204" pitchFamily="34" charset="0"/>
-              </a:rPr>
-              <a:t>quam</a:t>
-            </a:r>
-            <a:r>
-              <a:rPr lang="en-US" sz="572" dirty="0">
-                <a:solidFill>
-                  <a:prstClr val="black"/>
-                </a:solidFill>
-                <a:latin typeface="Arial" panose="020B0604020202020204" pitchFamily="34" charset="0"/>
-                <a:cs typeface="Arial" panose="020B0604020202020204" pitchFamily="34" charset="0"/>
-              </a:rPr>
-              <a:t> et </a:t>
-            </a:r>
-            <a:r>
-              <a:rPr lang="en-US" sz="572" dirty="0" err="1">
-                <a:solidFill>
-                  <a:prstClr val="black"/>
-                </a:solidFill>
-                <a:latin typeface="Arial" panose="020B0604020202020204" pitchFamily="34" charset="0"/>
-                <a:cs typeface="Arial" panose="020B0604020202020204" pitchFamily="34" charset="0"/>
-              </a:rPr>
-              <a:t>enduci</a:t>
-            </a:r>
-            <a:r>
-              <a:rPr lang="en-US" sz="572" dirty="0">
-                <a:solidFill>
-                  <a:prstClr val="black"/>
-                </a:solidFill>
-                <a:latin typeface="Arial" panose="020B0604020202020204" pitchFamily="34" charset="0"/>
-                <a:cs typeface="Arial" panose="020B0604020202020204" pitchFamily="34" charset="0"/>
-              </a:rPr>
-              <a:t> </a:t>
-            </a:r>
-            <a:r>
-              <a:rPr lang="en-US" sz="572" dirty="0" err="1">
-                <a:solidFill>
-                  <a:prstClr val="black"/>
-                </a:solidFill>
-                <a:latin typeface="Arial" panose="020B0604020202020204" pitchFamily="34" charset="0"/>
-                <a:cs typeface="Arial" panose="020B0604020202020204" pitchFamily="34" charset="0"/>
-              </a:rPr>
-              <a:t>idunt</a:t>
-            </a:r>
-            <a:r>
-              <a:rPr lang="en-US" sz="572" dirty="0">
-                <a:solidFill>
-                  <a:prstClr val="black"/>
-                </a:solidFill>
-                <a:latin typeface="Arial" panose="020B0604020202020204" pitchFamily="34" charset="0"/>
-                <a:cs typeface="Arial" panose="020B0604020202020204" pitchFamily="34" charset="0"/>
-              </a:rPr>
-              <a:t>, </a:t>
-            </a:r>
-            <a:r>
-              <a:rPr lang="en-US" sz="572" dirty="0" err="1">
-                <a:solidFill>
-                  <a:prstClr val="black"/>
-                </a:solidFill>
-                <a:latin typeface="Arial" panose="020B0604020202020204" pitchFamily="34" charset="0"/>
-                <a:cs typeface="Arial" panose="020B0604020202020204" pitchFamily="34" charset="0"/>
-              </a:rPr>
-              <a:t>corecta</a:t>
-            </a:r>
-            <a:r>
-              <a:rPr lang="en-US" sz="572" dirty="0">
-                <a:solidFill>
-                  <a:prstClr val="black"/>
-                </a:solidFill>
-                <a:latin typeface="Arial" panose="020B0604020202020204" pitchFamily="34" charset="0"/>
-                <a:cs typeface="Arial" panose="020B0604020202020204" pitchFamily="34" charset="0"/>
-              </a:rPr>
-              <a:t> </a:t>
-            </a:r>
-            <a:r>
-              <a:rPr lang="en-US" sz="572" dirty="0" err="1">
-                <a:solidFill>
-                  <a:prstClr val="black"/>
-                </a:solidFill>
-                <a:latin typeface="Arial" panose="020B0604020202020204" pitchFamily="34" charset="0"/>
-                <a:cs typeface="Arial" panose="020B0604020202020204" pitchFamily="34" charset="0"/>
-              </a:rPr>
-              <a:t>alicimp</a:t>
-            </a:r>
-            <a:r>
-              <a:rPr lang="en-US" sz="572" dirty="0">
-                <a:solidFill>
-                  <a:prstClr val="black"/>
-                </a:solidFill>
-                <a:latin typeface="Arial" panose="020B0604020202020204" pitchFamily="34" charset="0"/>
-                <a:cs typeface="Arial" panose="020B0604020202020204" pitchFamily="34" charset="0"/>
-              </a:rPr>
-              <a:t> </a:t>
-            </a:r>
-            <a:r>
-              <a:rPr lang="en-US" sz="572" dirty="0" err="1">
-                <a:solidFill>
-                  <a:prstClr val="black"/>
-                </a:solidFill>
-                <a:latin typeface="Arial" panose="020B0604020202020204" pitchFamily="34" charset="0"/>
-                <a:cs typeface="Arial" panose="020B0604020202020204" pitchFamily="34" charset="0"/>
-              </a:rPr>
-              <a:t>oriaeperum</a:t>
-            </a:r>
-            <a:r>
-              <a:rPr lang="en-US" sz="572" dirty="0">
-                <a:solidFill>
-                  <a:prstClr val="black"/>
-                </a:solidFill>
-                <a:latin typeface="Arial" panose="020B0604020202020204" pitchFamily="34" charset="0"/>
-                <a:cs typeface="Arial" panose="020B0604020202020204" pitchFamily="34" charset="0"/>
-              </a:rPr>
-              <a:t> </a:t>
-            </a:r>
-            <a:r>
-              <a:rPr lang="en-US" sz="572" dirty="0" err="1">
-                <a:solidFill>
-                  <a:prstClr val="black"/>
-                </a:solidFill>
-                <a:latin typeface="Arial" panose="020B0604020202020204" pitchFamily="34" charset="0"/>
-                <a:cs typeface="Arial" panose="020B0604020202020204" pitchFamily="34" charset="0"/>
-              </a:rPr>
-              <a:t>iusaeped</a:t>
-            </a:r>
-            <a:r>
-              <a:rPr lang="en-US" sz="572" dirty="0">
-                <a:solidFill>
-                  <a:prstClr val="black"/>
-                </a:solidFill>
-                <a:latin typeface="Arial" panose="020B0604020202020204" pitchFamily="34" charset="0"/>
-                <a:cs typeface="Arial" panose="020B0604020202020204" pitchFamily="34" charset="0"/>
-              </a:rPr>
-              <a:t> </a:t>
-            </a:r>
-            <a:r>
-              <a:rPr lang="en-US" sz="572" dirty="0" err="1">
-                <a:solidFill>
-                  <a:prstClr val="black"/>
-                </a:solidFill>
-                <a:latin typeface="Arial" panose="020B0604020202020204" pitchFamily="34" charset="0"/>
-                <a:cs typeface="Arial" panose="020B0604020202020204" pitchFamily="34" charset="0"/>
-              </a:rPr>
-              <a:t>unt</a:t>
-            </a:r>
-            <a:r>
-              <a:rPr lang="en-US" sz="572" dirty="0">
-                <a:solidFill>
-                  <a:prstClr val="black"/>
-                </a:solidFill>
-                <a:latin typeface="Arial" panose="020B0604020202020204" pitchFamily="34" charset="0"/>
-                <a:cs typeface="Arial" panose="020B0604020202020204" pitchFamily="34" charset="0"/>
-              </a:rPr>
-              <a:t> </a:t>
-            </a:r>
-            <a:r>
-              <a:rPr lang="en-US" sz="572" dirty="0" err="1">
-                <a:solidFill>
-                  <a:prstClr val="black"/>
-                </a:solidFill>
-                <a:latin typeface="Arial" panose="020B0604020202020204" pitchFamily="34" charset="0"/>
-                <a:cs typeface="Arial" panose="020B0604020202020204" pitchFamily="34" charset="0"/>
-              </a:rPr>
-              <a:t>quis</a:t>
-            </a:r>
-            <a:r>
-              <a:rPr lang="en-US" sz="572" dirty="0">
-                <a:solidFill>
-                  <a:prstClr val="black"/>
-                </a:solidFill>
-                <a:latin typeface="Arial" panose="020B0604020202020204" pitchFamily="34" charset="0"/>
-                <a:cs typeface="Arial" panose="020B0604020202020204" pitchFamily="34" charset="0"/>
-              </a:rPr>
-              <a:t> et </a:t>
-            </a:r>
-            <a:r>
-              <a:rPr lang="en-US" sz="572" dirty="0" err="1">
-                <a:solidFill>
-                  <a:prstClr val="black"/>
-                </a:solidFill>
-                <a:latin typeface="Arial" panose="020B0604020202020204" pitchFamily="34" charset="0"/>
-                <a:cs typeface="Arial" panose="020B0604020202020204" pitchFamily="34" charset="0"/>
-              </a:rPr>
-              <a:t>ut</a:t>
-            </a:r>
-            <a:r>
-              <a:rPr lang="en-US" sz="572" dirty="0">
-                <a:solidFill>
-                  <a:prstClr val="black"/>
-                </a:solidFill>
-                <a:latin typeface="Arial" panose="020B0604020202020204" pitchFamily="34" charset="0"/>
-                <a:cs typeface="Arial" panose="020B0604020202020204" pitchFamily="34" charset="0"/>
-              </a:rPr>
-              <a:t> </a:t>
-            </a:r>
-            <a:r>
-              <a:rPr lang="en-US" sz="572" dirty="0" err="1">
-                <a:solidFill>
-                  <a:prstClr val="black"/>
-                </a:solidFill>
-                <a:latin typeface="Arial" panose="020B0604020202020204" pitchFamily="34" charset="0"/>
-                <a:cs typeface="Arial" panose="020B0604020202020204" pitchFamily="34" charset="0"/>
-              </a:rPr>
-              <a:t>abor</a:t>
-            </a:r>
-            <a:r>
-              <a:rPr lang="en-US" sz="572" dirty="0">
-                <a:solidFill>
-                  <a:prstClr val="black"/>
-                </a:solidFill>
-                <a:latin typeface="Arial" panose="020B0604020202020204" pitchFamily="34" charset="0"/>
-                <a:cs typeface="Arial" panose="020B0604020202020204" pitchFamily="34" charset="0"/>
-              </a:rPr>
-              <a:t> </a:t>
-            </a:r>
-            <a:r>
-              <a:rPr lang="en-US" sz="572" dirty="0" err="1">
-                <a:solidFill>
-                  <a:prstClr val="black"/>
-                </a:solidFill>
-                <a:latin typeface="Arial" panose="020B0604020202020204" pitchFamily="34" charset="0"/>
-                <a:cs typeface="Arial" panose="020B0604020202020204" pitchFamily="34" charset="0"/>
-              </a:rPr>
-              <a:t>ame</a:t>
-            </a:r>
-            <a:r>
-              <a:rPr lang="en-US" sz="572" dirty="0">
-                <a:solidFill>
-                  <a:prstClr val="black"/>
-                </a:solidFill>
-                <a:latin typeface="Arial" panose="020B0604020202020204" pitchFamily="34" charset="0"/>
-                <a:cs typeface="Arial" panose="020B0604020202020204" pitchFamily="34" charset="0"/>
-              </a:rPr>
-              <a:t> </a:t>
-            </a:r>
-            <a:r>
-              <a:rPr lang="en-US" sz="572" dirty="0" err="1">
-                <a:solidFill>
-                  <a:prstClr val="black"/>
-                </a:solidFill>
-                <a:latin typeface="Arial" panose="020B0604020202020204" pitchFamily="34" charset="0"/>
-                <a:cs typeface="Arial" panose="020B0604020202020204" pitchFamily="34" charset="0"/>
-              </a:rPr>
-              <a:t>alis</a:t>
-            </a:r>
-            <a:r>
-              <a:rPr lang="en-US" sz="572" dirty="0">
-                <a:solidFill>
-                  <a:prstClr val="black"/>
-                </a:solidFill>
-                <a:latin typeface="Arial" panose="020B0604020202020204" pitchFamily="34" charset="0"/>
-                <a:cs typeface="Arial" panose="020B0604020202020204" pitchFamily="34" charset="0"/>
-              </a:rPr>
-              <a:t> </a:t>
-            </a:r>
-            <a:r>
-              <a:rPr lang="en-US" sz="572" dirty="0" err="1">
-                <a:solidFill>
-                  <a:prstClr val="black"/>
-                </a:solidFill>
-                <a:latin typeface="Arial" panose="020B0604020202020204" pitchFamily="34" charset="0"/>
-                <a:cs typeface="Arial" panose="020B0604020202020204" pitchFamily="34" charset="0"/>
-              </a:rPr>
-              <a:t>utatur</a:t>
-            </a:r>
-            <a:r>
-              <a:rPr lang="en-US" sz="572" dirty="0">
-                <a:solidFill>
-                  <a:prstClr val="black"/>
-                </a:solidFill>
-                <a:latin typeface="Arial" panose="020B0604020202020204" pitchFamily="34" charset="0"/>
-                <a:cs typeface="Arial" panose="020B0604020202020204" pitchFamily="34" charset="0"/>
-              </a:rPr>
-              <a:t> as </a:t>
-            </a:r>
-            <a:r>
-              <a:rPr lang="en-US" sz="572" dirty="0" err="1">
-                <a:solidFill>
-                  <a:prstClr val="black"/>
-                </a:solidFill>
-                <a:latin typeface="Arial" panose="020B0604020202020204" pitchFamily="34" charset="0"/>
-                <a:cs typeface="Arial" panose="020B0604020202020204" pitchFamily="34" charset="0"/>
-              </a:rPr>
-              <a:t>senet</a:t>
-            </a:r>
-            <a:r>
-              <a:rPr lang="en-US" sz="572" dirty="0">
-                <a:solidFill>
-                  <a:prstClr val="black"/>
-                </a:solidFill>
-                <a:latin typeface="Arial" panose="020B0604020202020204" pitchFamily="34" charset="0"/>
-                <a:cs typeface="Arial" panose="020B0604020202020204" pitchFamily="34" charset="0"/>
-              </a:rPr>
-              <a:t> a </a:t>
-            </a:r>
-            <a:r>
-              <a:rPr lang="en-US" sz="572" dirty="0" err="1">
-                <a:solidFill>
-                  <a:prstClr val="black"/>
-                </a:solidFill>
-                <a:latin typeface="Arial" panose="020B0604020202020204" pitchFamily="34" charset="0"/>
-                <a:cs typeface="Arial" panose="020B0604020202020204" pitchFamily="34" charset="0"/>
-              </a:rPr>
-              <a:t>quibus</a:t>
-            </a:r>
-            <a:r>
-              <a:rPr lang="en-US" sz="572" dirty="0">
-                <a:solidFill>
-                  <a:prstClr val="black"/>
-                </a:solidFill>
-                <a:latin typeface="Arial" panose="020B0604020202020204" pitchFamily="34" charset="0"/>
-                <a:cs typeface="Arial" panose="020B0604020202020204" pitchFamily="34" charset="0"/>
-              </a:rPr>
-              <a:t> </a:t>
-            </a:r>
-            <a:r>
-              <a:rPr lang="en-US" sz="572" dirty="0" err="1">
-                <a:solidFill>
-                  <a:prstClr val="black"/>
-                </a:solidFill>
-                <a:latin typeface="Arial" panose="020B0604020202020204" pitchFamily="34" charset="0"/>
-                <a:cs typeface="Arial" panose="020B0604020202020204" pitchFamily="34" charset="0"/>
-              </a:rPr>
-              <a:t>dolutatur</a:t>
-            </a:r>
-            <a:r>
-              <a:rPr lang="en-US" sz="572" dirty="0">
-                <a:solidFill>
-                  <a:prstClr val="black"/>
-                </a:solidFill>
-                <a:latin typeface="Arial" panose="020B0604020202020204" pitchFamily="34" charset="0"/>
-                <a:cs typeface="Arial" panose="020B0604020202020204" pitchFamily="34" charset="0"/>
-              </a:rPr>
-              <a:t> </a:t>
-            </a:r>
-            <a:r>
-              <a:rPr lang="en-US" sz="572" dirty="0" err="1">
-                <a:solidFill>
-                  <a:prstClr val="black"/>
-                </a:solidFill>
-                <a:latin typeface="Arial" panose="020B0604020202020204" pitchFamily="34" charset="0"/>
-                <a:cs typeface="Arial" panose="020B0604020202020204" pitchFamily="34" charset="0"/>
-              </a:rPr>
-              <a:t>sedit</a:t>
-            </a:r>
-            <a:r>
-              <a:rPr lang="en-US" sz="572" dirty="0">
-                <a:solidFill>
-                  <a:prstClr val="black"/>
-                </a:solidFill>
-                <a:latin typeface="Arial" panose="020B0604020202020204" pitchFamily="34" charset="0"/>
-                <a:cs typeface="Arial" panose="020B0604020202020204" pitchFamily="34" charset="0"/>
-              </a:rPr>
-              <a:t> </a:t>
-            </a:r>
-            <a:r>
-              <a:rPr lang="en-US" sz="572" dirty="0" err="1">
-                <a:solidFill>
-                  <a:prstClr val="black"/>
-                </a:solidFill>
-                <a:latin typeface="Arial" panose="020B0604020202020204" pitchFamily="34" charset="0"/>
-                <a:cs typeface="Arial" panose="020B0604020202020204" pitchFamily="34" charset="0"/>
-              </a:rPr>
-              <a:t>aliam</a:t>
-            </a:r>
-            <a:r>
-              <a:rPr lang="en-US" sz="572" dirty="0">
-                <a:solidFill>
-                  <a:prstClr val="black"/>
-                </a:solidFill>
-                <a:latin typeface="Arial" panose="020B0604020202020204" pitchFamily="34" charset="0"/>
-                <a:cs typeface="Arial" panose="020B0604020202020204" pitchFamily="34" charset="0"/>
-              </a:rPr>
-              <a:t> </a:t>
-            </a:r>
-            <a:r>
-              <a:rPr lang="en-US" sz="572" dirty="0" err="1">
-                <a:solidFill>
-                  <a:prstClr val="black"/>
-                </a:solidFill>
-                <a:latin typeface="Arial" panose="020B0604020202020204" pitchFamily="34" charset="0"/>
-                <a:cs typeface="Arial" panose="020B0604020202020204" pitchFamily="34" charset="0"/>
-              </a:rPr>
-              <a:t>apienda</a:t>
-            </a:r>
-            <a:r>
-              <a:rPr lang="en-US" sz="572" dirty="0">
-                <a:solidFill>
-                  <a:prstClr val="black"/>
-                </a:solidFill>
-                <a:latin typeface="Arial" panose="020B0604020202020204" pitchFamily="34" charset="0"/>
-                <a:cs typeface="Arial" panose="020B0604020202020204" pitchFamily="34" charset="0"/>
-              </a:rPr>
-              <a:t> </a:t>
-            </a:r>
-            <a:r>
-              <a:rPr lang="en-US" sz="572" dirty="0" err="1">
-                <a:solidFill>
-                  <a:prstClr val="black"/>
-                </a:solidFill>
-                <a:latin typeface="Arial" panose="020B0604020202020204" pitchFamily="34" charset="0"/>
-                <a:cs typeface="Arial" panose="020B0604020202020204" pitchFamily="34" charset="0"/>
-              </a:rPr>
-              <a:t>versper</a:t>
-            </a:r>
-            <a:r>
-              <a:rPr lang="en-US" sz="572" dirty="0">
-                <a:solidFill>
-                  <a:prstClr val="black"/>
-                </a:solidFill>
-                <a:latin typeface="Arial" panose="020B0604020202020204" pitchFamily="34" charset="0"/>
-                <a:cs typeface="Arial" panose="020B0604020202020204" pitchFamily="34" charset="0"/>
-              </a:rPr>
-              <a:t> </a:t>
-            </a:r>
-            <a:r>
-              <a:rPr lang="en-US" sz="572" dirty="0" err="1">
-                <a:solidFill>
-                  <a:prstClr val="black"/>
-                </a:solidFill>
-                <a:latin typeface="Arial" panose="020B0604020202020204" pitchFamily="34" charset="0"/>
-                <a:cs typeface="Arial" panose="020B0604020202020204" pitchFamily="34" charset="0"/>
-              </a:rPr>
-              <a:t>feriti</a:t>
-            </a:r>
-            <a:r>
-              <a:rPr lang="en-US" sz="572" dirty="0">
-                <a:solidFill>
-                  <a:prstClr val="black"/>
-                </a:solidFill>
-                <a:latin typeface="Arial" panose="020B0604020202020204" pitchFamily="34" charset="0"/>
-                <a:cs typeface="Arial" panose="020B0604020202020204" pitchFamily="34" charset="0"/>
-              </a:rPr>
-              <a:t> </a:t>
-            </a:r>
-            <a:r>
-              <a:rPr lang="en-US" sz="572" dirty="0" err="1">
-                <a:solidFill>
-                  <a:prstClr val="black"/>
-                </a:solidFill>
-                <a:latin typeface="Arial" panose="020B0604020202020204" pitchFamily="34" charset="0"/>
-                <a:cs typeface="Arial" panose="020B0604020202020204" pitchFamily="34" charset="0"/>
-              </a:rPr>
-              <a:t>delia</a:t>
-            </a:r>
-            <a:r>
-              <a:rPr lang="en-US" sz="572" dirty="0">
-                <a:solidFill>
-                  <a:prstClr val="black"/>
-                </a:solidFill>
-                <a:latin typeface="Arial" panose="020B0604020202020204" pitchFamily="34" charset="0"/>
-                <a:cs typeface="Arial" panose="020B0604020202020204" pitchFamily="34" charset="0"/>
-              </a:rPr>
-              <a:t> pa </a:t>
-            </a:r>
-            <a:r>
-              <a:rPr lang="en-US" sz="572" dirty="0" err="1">
-                <a:solidFill>
-                  <a:prstClr val="black"/>
-                </a:solidFill>
-                <a:latin typeface="Arial" panose="020B0604020202020204" pitchFamily="34" charset="0"/>
-                <a:cs typeface="Arial" panose="020B0604020202020204" pitchFamily="34" charset="0"/>
-              </a:rPr>
-              <a:t>dolo</a:t>
-            </a:r>
-            <a:r>
-              <a:rPr lang="en-US" sz="572" dirty="0">
-                <a:solidFill>
-                  <a:prstClr val="black"/>
-                </a:solidFill>
-                <a:latin typeface="Arial" panose="020B0604020202020204" pitchFamily="34" charset="0"/>
-                <a:cs typeface="Arial" panose="020B0604020202020204" pitchFamily="34" charset="0"/>
-              </a:rPr>
-              <a:t> </a:t>
-            </a:r>
-            <a:r>
-              <a:rPr lang="en-US" sz="572" dirty="0" err="1">
-                <a:solidFill>
-                  <a:prstClr val="black"/>
-                </a:solidFill>
-                <a:latin typeface="Arial" panose="020B0604020202020204" pitchFamily="34" charset="0"/>
-                <a:cs typeface="Arial" panose="020B0604020202020204" pitchFamily="34" charset="0"/>
-              </a:rPr>
-              <a:t>quamus</a:t>
-            </a:r>
-            <a:r>
-              <a:rPr lang="en-US" sz="572" dirty="0">
-                <a:solidFill>
-                  <a:prstClr val="black"/>
-                </a:solidFill>
-                <a:latin typeface="Arial" panose="020B0604020202020204" pitchFamily="34" charset="0"/>
-                <a:cs typeface="Arial" panose="020B0604020202020204" pitchFamily="34" charset="0"/>
-              </a:rPr>
-              <a:t> arum </a:t>
-            </a:r>
-            <a:r>
-              <a:rPr lang="en-US" sz="572" dirty="0" err="1">
-                <a:solidFill>
-                  <a:prstClr val="black"/>
-                </a:solidFill>
-                <a:latin typeface="Arial" panose="020B0604020202020204" pitchFamily="34" charset="0"/>
-                <a:cs typeface="Arial" panose="020B0604020202020204" pitchFamily="34" charset="0"/>
-              </a:rPr>
-              <a:t>es</a:t>
-            </a:r>
-            <a:r>
-              <a:rPr lang="en-US" sz="572" dirty="0">
-                <a:solidFill>
-                  <a:prstClr val="black"/>
-                </a:solidFill>
-                <a:latin typeface="Arial" panose="020B0604020202020204" pitchFamily="34" charset="0"/>
-                <a:cs typeface="Arial" panose="020B0604020202020204" pitchFamily="34" charset="0"/>
-              </a:rPr>
-              <a:t> </a:t>
-            </a:r>
-            <a:r>
-              <a:rPr lang="en-US" sz="572" dirty="0" err="1">
-                <a:solidFill>
-                  <a:prstClr val="black"/>
-                </a:solidFill>
-                <a:latin typeface="Arial" panose="020B0604020202020204" pitchFamily="34" charset="0"/>
-                <a:cs typeface="Arial" panose="020B0604020202020204" pitchFamily="34" charset="0"/>
-              </a:rPr>
-              <a:t>endellu</a:t>
-            </a:r>
-            <a:r>
-              <a:rPr lang="en-US" sz="572" dirty="0">
-                <a:solidFill>
-                  <a:prstClr val="black"/>
-                </a:solidFill>
-                <a:latin typeface="Arial" panose="020B0604020202020204" pitchFamily="34" charset="0"/>
-                <a:cs typeface="Arial" panose="020B0604020202020204" pitchFamily="34" charset="0"/>
-              </a:rPr>
-              <a:t> </a:t>
-            </a:r>
-            <a:r>
-              <a:rPr lang="en-US" sz="572" dirty="0" err="1">
-                <a:solidFill>
-                  <a:prstClr val="black"/>
-                </a:solidFill>
-                <a:latin typeface="Arial" panose="020B0604020202020204" pitchFamily="34" charset="0"/>
-                <a:cs typeface="Arial" panose="020B0604020202020204" pitchFamily="34" charset="0"/>
-              </a:rPr>
-              <a:t>pisquia</a:t>
-            </a:r>
-            <a:r>
-              <a:rPr lang="en-US" sz="572" dirty="0">
-                <a:solidFill>
-                  <a:prstClr val="black"/>
-                </a:solidFill>
-                <a:latin typeface="Arial" panose="020B0604020202020204" pitchFamily="34" charset="0"/>
-                <a:cs typeface="Arial" panose="020B0604020202020204" pitchFamily="34" charset="0"/>
-              </a:rPr>
-              <a:t> </a:t>
-            </a:r>
-            <a:r>
-              <a:rPr lang="en-US" sz="572" dirty="0" err="1">
-                <a:solidFill>
-                  <a:prstClr val="black"/>
-                </a:solidFill>
-                <a:latin typeface="Arial" panose="020B0604020202020204" pitchFamily="34" charset="0"/>
-                <a:cs typeface="Arial" panose="020B0604020202020204" pitchFamily="34" charset="0"/>
-              </a:rPr>
-              <a:t>aditatur</a:t>
-            </a:r>
-            <a:r>
-              <a:rPr lang="en-US" sz="572" dirty="0">
-                <a:solidFill>
-                  <a:prstClr val="black"/>
-                </a:solidFill>
-                <a:latin typeface="Arial" panose="020B0604020202020204" pitchFamily="34" charset="0"/>
-                <a:cs typeface="Arial" panose="020B0604020202020204" pitchFamily="34" charset="0"/>
-              </a:rPr>
-              <a:t> </a:t>
-            </a:r>
-            <a:r>
-              <a:rPr lang="en-US" sz="572" dirty="0" err="1">
-                <a:solidFill>
-                  <a:prstClr val="black"/>
-                </a:solidFill>
-                <a:latin typeface="Arial" panose="020B0604020202020204" pitchFamily="34" charset="0"/>
-                <a:cs typeface="Arial" panose="020B0604020202020204" pitchFamily="34" charset="0"/>
-              </a:rPr>
-              <a:t>audam</a:t>
-            </a:r>
-            <a:r>
-              <a:rPr lang="en-US" sz="572" dirty="0">
-                <a:solidFill>
-                  <a:prstClr val="black"/>
-                </a:solidFill>
-                <a:latin typeface="Arial" panose="020B0604020202020204" pitchFamily="34" charset="0"/>
-                <a:cs typeface="Arial" panose="020B0604020202020204" pitchFamily="34" charset="0"/>
-              </a:rPr>
-              <a:t> </a:t>
-            </a:r>
-            <a:r>
-              <a:rPr lang="en-US" sz="572" dirty="0" err="1">
-                <a:solidFill>
-                  <a:prstClr val="black"/>
-                </a:solidFill>
-                <a:latin typeface="Arial" panose="020B0604020202020204" pitchFamily="34" charset="0"/>
-                <a:cs typeface="Arial" panose="020B0604020202020204" pitchFamily="34" charset="0"/>
-              </a:rPr>
-              <a:t>earupid</a:t>
-            </a:r>
-            <a:r>
-              <a:rPr lang="en-US" sz="572" dirty="0">
-                <a:solidFill>
-                  <a:prstClr val="black"/>
-                </a:solidFill>
-                <a:latin typeface="Arial" panose="020B0604020202020204" pitchFamily="34" charset="0"/>
-                <a:cs typeface="Arial" panose="020B0604020202020204" pitchFamily="34" charset="0"/>
-              </a:rPr>
-              <a:t> quo </a:t>
-            </a:r>
-            <a:r>
-              <a:rPr lang="en-US" sz="572" dirty="0" err="1">
-                <a:solidFill>
-                  <a:prstClr val="black"/>
-                </a:solidFill>
-                <a:latin typeface="Arial" panose="020B0604020202020204" pitchFamily="34" charset="0"/>
-                <a:cs typeface="Arial" panose="020B0604020202020204" pitchFamily="34" charset="0"/>
-              </a:rPr>
-              <a:t>quunt</a:t>
-            </a:r>
-            <a:r>
-              <a:rPr lang="en-US" sz="572" dirty="0">
-                <a:solidFill>
-                  <a:prstClr val="black"/>
-                </a:solidFill>
-                <a:latin typeface="Arial" panose="020B0604020202020204" pitchFamily="34" charset="0"/>
-                <a:cs typeface="Arial" panose="020B0604020202020204" pitchFamily="34" charset="0"/>
-              </a:rPr>
-              <a:t> </a:t>
-            </a:r>
-            <a:r>
-              <a:rPr lang="en-US" sz="572" dirty="0" err="1">
-                <a:solidFill>
-                  <a:prstClr val="black"/>
-                </a:solidFill>
-                <a:latin typeface="Arial" panose="020B0604020202020204" pitchFamily="34" charset="0"/>
-                <a:cs typeface="Arial" panose="020B0604020202020204" pitchFamily="34" charset="0"/>
-              </a:rPr>
-              <a:t>odigniscil</a:t>
-            </a:r>
-            <a:r>
-              <a:rPr lang="en-US" sz="572" dirty="0">
-                <a:solidFill>
-                  <a:prstClr val="black"/>
-                </a:solidFill>
-                <a:latin typeface="Arial" panose="020B0604020202020204" pitchFamily="34" charset="0"/>
-                <a:cs typeface="Arial" panose="020B0604020202020204" pitchFamily="34" charset="0"/>
-              </a:rPr>
-              <a:t> </a:t>
-            </a:r>
-            <a:r>
-              <a:rPr lang="en-US" sz="572" dirty="0" err="1">
-                <a:solidFill>
-                  <a:prstClr val="black"/>
-                </a:solidFill>
-                <a:latin typeface="Arial" panose="020B0604020202020204" pitchFamily="34" charset="0"/>
-                <a:cs typeface="Arial" panose="020B0604020202020204" pitchFamily="34" charset="0"/>
-              </a:rPr>
-              <a:t>earum</a:t>
-            </a:r>
-            <a:r>
-              <a:rPr lang="en-US" sz="572" dirty="0">
-                <a:solidFill>
-                  <a:prstClr val="black"/>
-                </a:solidFill>
-                <a:latin typeface="Arial" panose="020B0604020202020204" pitchFamily="34" charset="0"/>
-                <a:cs typeface="Arial" panose="020B0604020202020204" pitchFamily="34" charset="0"/>
-              </a:rPr>
-              <a:t> </a:t>
-            </a:r>
-            <a:r>
-              <a:rPr lang="en-US" sz="572" dirty="0" err="1">
-                <a:solidFill>
-                  <a:prstClr val="black"/>
-                </a:solidFill>
-                <a:latin typeface="Arial" panose="020B0604020202020204" pitchFamily="34" charset="0"/>
-                <a:cs typeface="Arial" panose="020B0604020202020204" pitchFamily="34" charset="0"/>
-              </a:rPr>
-              <a:t>verios</a:t>
-            </a:r>
-            <a:r>
-              <a:rPr lang="en-US" sz="572" dirty="0">
-                <a:solidFill>
-                  <a:prstClr val="black"/>
-                </a:solidFill>
-                <a:latin typeface="Arial" panose="020B0604020202020204" pitchFamily="34" charset="0"/>
-                <a:cs typeface="Arial" panose="020B0604020202020204" pitchFamily="34" charset="0"/>
-              </a:rPr>
-              <a:t> </a:t>
-            </a:r>
-            <a:r>
-              <a:rPr lang="en-US" sz="572" dirty="0" err="1">
-                <a:solidFill>
-                  <a:prstClr val="black"/>
-                </a:solidFill>
-                <a:latin typeface="Arial" panose="020B0604020202020204" pitchFamily="34" charset="0"/>
-                <a:cs typeface="Arial" panose="020B0604020202020204" pitchFamily="34" charset="0"/>
-              </a:rPr>
-              <a:t>nonsequam</a:t>
-            </a:r>
-            <a:r>
-              <a:rPr lang="en-US" sz="572" dirty="0">
-                <a:solidFill>
-                  <a:prstClr val="black"/>
-                </a:solidFill>
-                <a:latin typeface="Arial" panose="020B0604020202020204" pitchFamily="34" charset="0"/>
-                <a:cs typeface="Arial" panose="020B0604020202020204" pitchFamily="34" charset="0"/>
-              </a:rPr>
-              <a:t> </a:t>
-            </a:r>
-            <a:r>
-              <a:rPr lang="en-US" sz="572" dirty="0" err="1">
-                <a:solidFill>
-                  <a:prstClr val="black"/>
-                </a:solidFill>
-                <a:latin typeface="Arial" panose="020B0604020202020204" pitchFamily="34" charset="0"/>
-                <a:cs typeface="Arial" panose="020B0604020202020204" pitchFamily="34" charset="0"/>
-              </a:rPr>
-              <a:t>duciis</a:t>
-            </a:r>
-            <a:r>
-              <a:rPr lang="en-US" sz="572" dirty="0">
-                <a:solidFill>
-                  <a:prstClr val="black"/>
-                </a:solidFill>
-                <a:latin typeface="Arial" panose="020B0604020202020204" pitchFamily="34" charset="0"/>
-                <a:cs typeface="Arial" panose="020B0604020202020204" pitchFamily="34" charset="0"/>
-              </a:rPr>
-              <a:t> et </a:t>
-            </a:r>
-            <a:r>
-              <a:rPr lang="en-US" sz="572" dirty="0" err="1">
-                <a:solidFill>
-                  <a:prstClr val="black"/>
-                </a:solidFill>
-                <a:latin typeface="Arial" panose="020B0604020202020204" pitchFamily="34" charset="0"/>
-                <a:cs typeface="Arial" panose="020B0604020202020204" pitchFamily="34" charset="0"/>
-              </a:rPr>
-              <a:t>apienda</a:t>
-            </a:r>
-            <a:r>
-              <a:rPr lang="en-US" sz="572" dirty="0">
-                <a:solidFill>
-                  <a:prstClr val="black"/>
-                </a:solidFill>
-                <a:latin typeface="Arial" panose="020B0604020202020204" pitchFamily="34" charset="0"/>
-                <a:cs typeface="Arial" panose="020B0604020202020204" pitchFamily="34" charset="0"/>
-              </a:rPr>
-              <a:t> </a:t>
-            </a:r>
-            <a:r>
-              <a:rPr lang="en-US" sz="572" dirty="0" err="1">
-                <a:solidFill>
-                  <a:prstClr val="black"/>
-                </a:solidFill>
-                <a:latin typeface="Arial" panose="020B0604020202020204" pitchFamily="34" charset="0"/>
-                <a:cs typeface="Arial" panose="020B0604020202020204" pitchFamily="34" charset="0"/>
-              </a:rPr>
-              <a:t>versper</a:t>
-            </a:r>
-            <a:r>
-              <a:rPr lang="en-US" sz="572" dirty="0">
-                <a:solidFill>
-                  <a:prstClr val="black"/>
-                </a:solidFill>
-                <a:latin typeface="Arial" panose="020B0604020202020204" pitchFamily="34" charset="0"/>
-                <a:cs typeface="Arial" panose="020B0604020202020204" pitchFamily="34" charset="0"/>
-              </a:rPr>
-              <a:t> </a:t>
-            </a:r>
-            <a:r>
-              <a:rPr lang="en-US" sz="572" dirty="0" err="1">
-                <a:solidFill>
-                  <a:prstClr val="black"/>
-                </a:solidFill>
-                <a:latin typeface="Arial" panose="020B0604020202020204" pitchFamily="34" charset="0"/>
-                <a:cs typeface="Arial" panose="020B0604020202020204" pitchFamily="34" charset="0"/>
-              </a:rPr>
-              <a:t>feriti</a:t>
-            </a:r>
-            <a:r>
-              <a:rPr lang="en-US" sz="572" dirty="0">
-                <a:solidFill>
-                  <a:prstClr val="black"/>
-                </a:solidFill>
-                <a:latin typeface="Arial" panose="020B0604020202020204" pitchFamily="34" charset="0"/>
-                <a:cs typeface="Arial" panose="020B0604020202020204" pitchFamily="34" charset="0"/>
-              </a:rPr>
-              <a:t> </a:t>
-            </a:r>
-            <a:r>
-              <a:rPr lang="en-US" sz="572" dirty="0" err="1">
-                <a:solidFill>
-                  <a:prstClr val="black"/>
-                </a:solidFill>
-                <a:latin typeface="Arial" panose="020B0604020202020204" pitchFamily="34" charset="0"/>
-                <a:cs typeface="Arial" panose="020B0604020202020204" pitchFamily="34" charset="0"/>
-              </a:rPr>
-              <a:t>delia</a:t>
-            </a:r>
-            <a:r>
-              <a:rPr lang="en-US" sz="572" dirty="0">
-                <a:solidFill>
-                  <a:prstClr val="black"/>
-                </a:solidFill>
-                <a:latin typeface="Arial" panose="020B0604020202020204" pitchFamily="34" charset="0"/>
-                <a:cs typeface="Arial" panose="020B0604020202020204" pitchFamily="34" charset="0"/>
-              </a:rPr>
-              <a:t> pa </a:t>
-            </a:r>
-            <a:r>
-              <a:rPr lang="en-US" sz="572" dirty="0" err="1">
-                <a:solidFill>
-                  <a:prstClr val="black"/>
-                </a:solidFill>
-                <a:latin typeface="Arial" panose="020B0604020202020204" pitchFamily="34" charset="0"/>
-                <a:cs typeface="Arial" panose="020B0604020202020204" pitchFamily="34" charset="0"/>
-              </a:rPr>
-              <a:t>dolo</a:t>
-            </a:r>
-            <a:r>
-              <a:rPr lang="en-US" sz="572" dirty="0">
-                <a:solidFill>
-                  <a:prstClr val="black"/>
-                </a:solidFill>
-                <a:latin typeface="Arial" panose="020B0604020202020204" pitchFamily="34" charset="0"/>
-                <a:cs typeface="Arial" panose="020B0604020202020204" pitchFamily="34" charset="0"/>
-              </a:rPr>
-              <a:t> </a:t>
-            </a:r>
-            <a:r>
-              <a:rPr lang="en-US" sz="572" dirty="0" err="1">
-                <a:solidFill>
-                  <a:prstClr val="black"/>
-                </a:solidFill>
-                <a:latin typeface="Arial" panose="020B0604020202020204" pitchFamily="34" charset="0"/>
-                <a:cs typeface="Arial" panose="020B0604020202020204" pitchFamily="34" charset="0"/>
-              </a:rPr>
-              <a:t>quamus</a:t>
-            </a:r>
-            <a:r>
-              <a:rPr lang="en-US" sz="572" dirty="0">
-                <a:solidFill>
-                  <a:prstClr val="black"/>
-                </a:solidFill>
-                <a:latin typeface="Arial" panose="020B0604020202020204" pitchFamily="34" charset="0"/>
-                <a:cs typeface="Arial" panose="020B0604020202020204" pitchFamily="34" charset="0"/>
-              </a:rPr>
-              <a:t> arum </a:t>
-            </a:r>
-            <a:r>
-              <a:rPr lang="en-US" sz="572" dirty="0" err="1">
-                <a:solidFill>
-                  <a:prstClr val="black"/>
-                </a:solidFill>
-                <a:latin typeface="Arial" panose="020B0604020202020204" pitchFamily="34" charset="0"/>
-                <a:cs typeface="Arial" panose="020B0604020202020204" pitchFamily="34" charset="0"/>
-              </a:rPr>
-              <a:t>es</a:t>
-            </a:r>
-            <a:r>
-              <a:rPr lang="en-US" sz="572" dirty="0">
-                <a:solidFill>
-                  <a:prstClr val="black"/>
-                </a:solidFill>
-                <a:latin typeface="Arial" panose="020B0604020202020204" pitchFamily="34" charset="0"/>
-                <a:cs typeface="Arial" panose="020B0604020202020204" pitchFamily="34" charset="0"/>
-              </a:rPr>
-              <a:t> </a:t>
-            </a:r>
-            <a:r>
-              <a:rPr lang="en-US" sz="572" dirty="0" err="1">
-                <a:solidFill>
-                  <a:prstClr val="black"/>
-                </a:solidFill>
-                <a:latin typeface="Arial" panose="020B0604020202020204" pitchFamily="34" charset="0"/>
-                <a:cs typeface="Arial" panose="020B0604020202020204" pitchFamily="34" charset="0"/>
-              </a:rPr>
-              <a:t>endellu</a:t>
-            </a:r>
-            <a:r>
-              <a:rPr lang="en-US" sz="572" dirty="0">
-                <a:solidFill>
-                  <a:prstClr val="black"/>
-                </a:solidFill>
-                <a:latin typeface="Arial" panose="020B0604020202020204" pitchFamily="34" charset="0"/>
-                <a:cs typeface="Arial" panose="020B0604020202020204" pitchFamily="34" charset="0"/>
-              </a:rPr>
-              <a:t> </a:t>
-            </a:r>
-            <a:r>
-              <a:rPr lang="en-US" sz="572" dirty="0" err="1">
-                <a:solidFill>
-                  <a:prstClr val="black"/>
-                </a:solidFill>
-                <a:latin typeface="Arial" panose="020B0604020202020204" pitchFamily="34" charset="0"/>
-                <a:cs typeface="Arial" panose="020B0604020202020204" pitchFamily="34" charset="0"/>
-              </a:rPr>
-              <a:t>pisquia</a:t>
-            </a:r>
-            <a:r>
-              <a:rPr lang="en-US" sz="572" dirty="0">
-                <a:solidFill>
-                  <a:prstClr val="black"/>
-                </a:solidFill>
-                <a:latin typeface="Arial" panose="020B0604020202020204" pitchFamily="34" charset="0"/>
-                <a:cs typeface="Arial" panose="020B0604020202020204" pitchFamily="34" charset="0"/>
-              </a:rPr>
-              <a:t> </a:t>
-            </a:r>
-            <a:r>
-              <a:rPr lang="en-US" sz="572" dirty="0" err="1">
-                <a:solidFill>
-                  <a:prstClr val="black"/>
-                </a:solidFill>
-                <a:latin typeface="Arial" panose="020B0604020202020204" pitchFamily="34" charset="0"/>
-                <a:cs typeface="Arial" panose="020B0604020202020204" pitchFamily="34" charset="0"/>
-              </a:rPr>
-              <a:t>aditatur</a:t>
-            </a:r>
-            <a:r>
-              <a:rPr lang="en-US" sz="572" dirty="0">
-                <a:solidFill>
-                  <a:prstClr val="black"/>
-                </a:solidFill>
-                <a:latin typeface="Arial" panose="020B0604020202020204" pitchFamily="34" charset="0"/>
-                <a:cs typeface="Arial" panose="020B0604020202020204" pitchFamily="34" charset="0"/>
-              </a:rPr>
-              <a:t> </a:t>
-            </a:r>
-            <a:r>
-              <a:rPr lang="en-US" sz="572" dirty="0" err="1">
-                <a:solidFill>
-                  <a:prstClr val="black"/>
-                </a:solidFill>
-                <a:latin typeface="Arial" panose="020B0604020202020204" pitchFamily="34" charset="0"/>
-                <a:cs typeface="Arial" panose="020B0604020202020204" pitchFamily="34" charset="0"/>
-              </a:rPr>
-              <a:t>audam</a:t>
-            </a:r>
-            <a:r>
-              <a:rPr lang="en-US" sz="572" dirty="0">
-                <a:solidFill>
-                  <a:prstClr val="black"/>
-                </a:solidFill>
-                <a:latin typeface="Arial" panose="020B0604020202020204" pitchFamily="34" charset="0"/>
-                <a:cs typeface="Arial" panose="020B0604020202020204" pitchFamily="34" charset="0"/>
-              </a:rPr>
-              <a:t> </a:t>
-            </a:r>
-            <a:r>
-              <a:rPr lang="en-US" sz="572" dirty="0" err="1">
-                <a:solidFill>
-                  <a:prstClr val="black"/>
-                </a:solidFill>
-                <a:latin typeface="Arial" panose="020B0604020202020204" pitchFamily="34" charset="0"/>
-                <a:cs typeface="Arial" panose="020B0604020202020204" pitchFamily="34" charset="0"/>
-              </a:rPr>
-              <a:t>earupid</a:t>
-            </a:r>
-            <a:r>
-              <a:rPr lang="en-US" sz="572" dirty="0">
-                <a:solidFill>
-                  <a:prstClr val="black"/>
-                </a:solidFill>
-                <a:latin typeface="Arial" panose="020B0604020202020204" pitchFamily="34" charset="0"/>
-                <a:cs typeface="Arial" panose="020B0604020202020204" pitchFamily="34" charset="0"/>
-              </a:rPr>
-              <a:t> quo </a:t>
-            </a:r>
-            <a:r>
-              <a:rPr lang="en-US" sz="572" dirty="0" err="1">
-                <a:solidFill>
-                  <a:prstClr val="black"/>
-                </a:solidFill>
-                <a:latin typeface="Arial" panose="020B0604020202020204" pitchFamily="34" charset="0"/>
-                <a:cs typeface="Arial" panose="020B0604020202020204" pitchFamily="34" charset="0"/>
-              </a:rPr>
-              <a:t>quunt</a:t>
-            </a:r>
-            <a:r>
-              <a:rPr lang="en-US" sz="572" dirty="0">
-                <a:solidFill>
-                  <a:prstClr val="black"/>
-                </a:solidFill>
-                <a:latin typeface="Arial" panose="020B0604020202020204" pitchFamily="34" charset="0"/>
-                <a:cs typeface="Arial" panose="020B0604020202020204" pitchFamily="34" charset="0"/>
-              </a:rPr>
-              <a:t> </a:t>
-            </a:r>
-            <a:r>
-              <a:rPr lang="en-US" sz="572" dirty="0" err="1">
-                <a:solidFill>
-                  <a:prstClr val="black"/>
-                </a:solidFill>
-                <a:latin typeface="Arial" panose="020B0604020202020204" pitchFamily="34" charset="0"/>
-                <a:cs typeface="Arial" panose="020B0604020202020204" pitchFamily="34" charset="0"/>
-              </a:rPr>
-              <a:t>odigniscil</a:t>
-            </a:r>
-            <a:r>
-              <a:rPr lang="en-US" sz="572" dirty="0">
-                <a:solidFill>
-                  <a:prstClr val="black"/>
-                </a:solidFill>
-                <a:latin typeface="Arial" panose="020B0604020202020204" pitchFamily="34" charset="0"/>
-                <a:cs typeface="Arial" panose="020B0604020202020204" pitchFamily="34" charset="0"/>
-              </a:rPr>
-              <a:t> </a:t>
-            </a:r>
-            <a:r>
-              <a:rPr lang="en-US" sz="572" dirty="0" err="1">
-                <a:solidFill>
-                  <a:prstClr val="black"/>
-                </a:solidFill>
-                <a:latin typeface="Arial" panose="020B0604020202020204" pitchFamily="34" charset="0"/>
-                <a:cs typeface="Arial" panose="020B0604020202020204" pitchFamily="34" charset="0"/>
-              </a:rPr>
-              <a:t>earum</a:t>
-            </a:r>
-            <a:r>
-              <a:rPr lang="en-US" sz="572" dirty="0">
-                <a:solidFill>
-                  <a:prstClr val="black"/>
-                </a:solidFill>
-                <a:latin typeface="Arial" panose="020B0604020202020204" pitchFamily="34" charset="0"/>
-                <a:cs typeface="Arial" panose="020B0604020202020204" pitchFamily="34" charset="0"/>
-              </a:rPr>
-              <a:t> </a:t>
-            </a:r>
-            <a:r>
-              <a:rPr lang="en-US" sz="572" dirty="0" err="1">
-                <a:solidFill>
-                  <a:prstClr val="black"/>
-                </a:solidFill>
-                <a:latin typeface="Arial" panose="020B0604020202020204" pitchFamily="34" charset="0"/>
-                <a:cs typeface="Arial" panose="020B0604020202020204" pitchFamily="34" charset="0"/>
-              </a:rPr>
-              <a:t>verios</a:t>
-            </a:r>
-            <a:r>
-              <a:rPr lang="en-US" sz="572" dirty="0">
-                <a:solidFill>
-                  <a:prstClr val="black"/>
-                </a:solidFill>
-                <a:latin typeface="Arial" panose="020B0604020202020204" pitchFamily="34" charset="0"/>
-                <a:cs typeface="Arial" panose="020B0604020202020204" pitchFamily="34" charset="0"/>
-              </a:rPr>
-              <a:t> </a:t>
-            </a:r>
-            <a:r>
-              <a:rPr lang="en-US" sz="572" dirty="0" err="1">
-                <a:solidFill>
-                  <a:prstClr val="black"/>
-                </a:solidFill>
-                <a:latin typeface="Arial" panose="020B0604020202020204" pitchFamily="34" charset="0"/>
-                <a:cs typeface="Arial" panose="020B0604020202020204" pitchFamily="34" charset="0"/>
-              </a:rPr>
-              <a:t>nonsequam</a:t>
-            </a:r>
-            <a:endParaRPr lang="en-US" sz="572" dirty="0">
-              <a:solidFill>
-                <a:prstClr val="black"/>
-              </a:solidFill>
-              <a:latin typeface="Arial" panose="020B0604020202020204" pitchFamily="34" charset="0"/>
-              <a:cs typeface="Arial" panose="020B0604020202020204" pitchFamily="34" charset="0"/>
-            </a:endParaRPr>
-          </a:p>
-        </p:txBody>
-      </p:sp>
+      <mc:AlternateContent xmlns:mc="http://schemas.openxmlformats.org/markup-compatibility/2006">
+        <mc:Choice xmlns:a14="http://schemas.microsoft.com/office/drawing/2010/main" Requires="a14">
+          <p:sp>
+            <p:nvSpPr>
+              <p:cNvPr id="51" name="TextBox 50">
+                <a:extLst>
+                  <a:ext uri="{FF2B5EF4-FFF2-40B4-BE49-F238E27FC236}">
+                    <a16:creationId xmlns:a16="http://schemas.microsoft.com/office/drawing/2014/main" id="{E1CD2C2A-F064-084C-B9FF-1CE5B53E4E32}"/>
+                  </a:ext>
+                </a:extLst>
+              </p:cNvPr>
+              <p:cNvSpPr txBox="1"/>
+              <p:nvPr/>
+            </p:nvSpPr>
+            <p:spPr>
+              <a:xfrm>
+                <a:off x="4805278" y="5514244"/>
+                <a:ext cx="2581433" cy="1060740"/>
+              </a:xfrm>
+              <a:prstGeom prst="rect">
+                <a:avLst/>
+              </a:prstGeom>
+              <a:noFill/>
+            </p:spPr>
+            <p:txBody>
+              <a:bodyPr wrap="square" rtlCol="0">
+                <a:spAutoFit/>
+              </a:bodyPr>
+              <a:lstStyle/>
+              <a:p>
+                <a:pPr defTabSz="780653"/>
+                <a:r>
+                  <a:rPr lang="en-US" sz="572" dirty="0">
+                    <a:solidFill>
+                      <a:prstClr val="black"/>
+                    </a:solidFill>
+                    <a:latin typeface="Arial" panose="020B0604020202020204" pitchFamily="34" charset="0"/>
+                    <a:cs typeface="Arial" panose="020B0604020202020204" pitchFamily="34" charset="0"/>
+                  </a:rPr>
+                  <a:t>The experimental results demonstrate the relationship between capacitance and two key variables: plate separation and plate area. Shown in Figure 1, capacitance decreases as plate separation increases; following an inverse trend consistent with the theoretical prediction. Specifically, capacitance drops from approximately 0.44 pF at a 2 mm separation to about 0.13 pF at 7mm; indicating that greater distance between plates significantly reduces the ability to store charge.</a:t>
+                </a:r>
+              </a:p>
+              <a:p>
+                <a:pPr defTabSz="780653"/>
+                <a:r>
+                  <a:rPr lang="en-US" sz="572" dirty="0">
+                    <a:solidFill>
+                      <a:prstClr val="black"/>
+                    </a:solidFill>
+                    <a:latin typeface="Arial" panose="020B0604020202020204" pitchFamily="34" charset="0"/>
+                    <a:cs typeface="Arial" panose="020B0604020202020204" pitchFamily="34" charset="0"/>
+                  </a:rPr>
+                  <a:t>Conversely, Figure 2 illustrates that capacitance increases with plate area, rising from roughly 0.15 pF at </a:t>
+                </a:r>
+                <a14:m>
+                  <m:oMath xmlns:m="http://schemas.openxmlformats.org/officeDocument/2006/math">
+                    <m:r>
+                      <a:rPr lang="en-US" sz="572" b="0" i="1" smtClean="0">
+                        <a:solidFill>
+                          <a:prstClr val="black"/>
+                        </a:solidFill>
+                        <a:latin typeface="Cambria Math" panose="02040503050406030204" pitchFamily="18" charset="0"/>
+                        <a:cs typeface="Arial" panose="020B0604020202020204" pitchFamily="34" charset="0"/>
+                      </a:rPr>
+                      <m:t>100 </m:t>
+                    </m:r>
+                    <m:r>
+                      <a:rPr lang="en-US" sz="572" b="0" i="1" smtClean="0">
+                        <a:solidFill>
+                          <a:prstClr val="black"/>
+                        </a:solidFill>
+                        <a:latin typeface="Cambria Math" panose="02040503050406030204" pitchFamily="18" charset="0"/>
+                        <a:cs typeface="Arial" panose="020B0604020202020204" pitchFamily="34" charset="0"/>
+                      </a:rPr>
+                      <m:t>𝑚</m:t>
+                    </m:r>
+                    <m:sSup>
+                      <m:sSupPr>
+                        <m:ctrlPr>
+                          <a:rPr lang="en-US" sz="572" b="0" i="1" smtClean="0">
+                            <a:solidFill>
+                              <a:prstClr val="black"/>
+                            </a:solidFill>
+                            <a:latin typeface="Cambria Math" panose="02040503050406030204" pitchFamily="18" charset="0"/>
+                            <a:cs typeface="Arial" panose="020B0604020202020204" pitchFamily="34" charset="0"/>
+                          </a:rPr>
+                        </m:ctrlPr>
+                      </m:sSupPr>
+                      <m:e>
+                        <m:r>
+                          <a:rPr lang="en-US" sz="572" b="0" i="1" smtClean="0">
+                            <a:solidFill>
+                              <a:prstClr val="black"/>
+                            </a:solidFill>
+                            <a:latin typeface="Cambria Math" panose="02040503050406030204" pitchFamily="18" charset="0"/>
+                            <a:cs typeface="Arial" panose="020B0604020202020204" pitchFamily="34" charset="0"/>
+                          </a:rPr>
+                          <m:t>𝑚</m:t>
+                        </m:r>
+                      </m:e>
+                      <m:sup>
+                        <m:r>
+                          <a:rPr lang="en-US" sz="572" b="0" i="1" smtClean="0">
+                            <a:solidFill>
+                              <a:prstClr val="black"/>
+                            </a:solidFill>
+                            <a:latin typeface="Cambria Math" panose="02040503050406030204" pitchFamily="18" charset="0"/>
+                            <a:cs typeface="Arial" panose="020B0604020202020204" pitchFamily="34" charset="0"/>
+                          </a:rPr>
+                          <m:t>2</m:t>
+                        </m:r>
+                      </m:sup>
+                    </m:sSup>
+                  </m:oMath>
+                </a14:m>
+                <a:r>
+                  <a:rPr lang="en-US" sz="572" dirty="0">
+                    <a:solidFill>
+                      <a:prstClr val="black"/>
+                    </a:solidFill>
+                    <a:latin typeface="Arial" panose="020B0604020202020204" pitchFamily="34" charset="0"/>
+                    <a:cs typeface="Arial" panose="020B0604020202020204" pitchFamily="34" charset="0"/>
+                  </a:rPr>
+                  <a:t> to 0.22 pF at </a:t>
+                </a:r>
+                <a14:m>
+                  <m:oMath xmlns:m="http://schemas.openxmlformats.org/officeDocument/2006/math">
+                    <m:r>
+                      <a:rPr lang="en-US" sz="572" b="0" i="1" smtClean="0">
+                        <a:solidFill>
+                          <a:prstClr val="black"/>
+                        </a:solidFill>
+                        <a:latin typeface="Cambria Math" panose="02040503050406030204" pitchFamily="18" charset="0"/>
+                        <a:cs typeface="Arial" panose="020B0604020202020204" pitchFamily="34" charset="0"/>
+                      </a:rPr>
+                      <m:t>150 </m:t>
+                    </m:r>
+                    <m:r>
+                      <a:rPr lang="en-US" sz="572" b="0" i="1" smtClean="0">
+                        <a:solidFill>
+                          <a:prstClr val="black"/>
+                        </a:solidFill>
+                        <a:latin typeface="Cambria Math" panose="02040503050406030204" pitchFamily="18" charset="0"/>
+                        <a:cs typeface="Arial" panose="020B0604020202020204" pitchFamily="34" charset="0"/>
+                      </a:rPr>
+                      <m:t>𝑚</m:t>
+                    </m:r>
+                    <m:sSup>
+                      <m:sSupPr>
+                        <m:ctrlPr>
+                          <a:rPr lang="en-US" sz="572" b="0" i="1" smtClean="0">
+                            <a:solidFill>
+                              <a:prstClr val="black"/>
+                            </a:solidFill>
+                            <a:latin typeface="Cambria Math" panose="02040503050406030204" pitchFamily="18" charset="0"/>
+                            <a:cs typeface="Arial" panose="020B0604020202020204" pitchFamily="34" charset="0"/>
+                          </a:rPr>
+                        </m:ctrlPr>
+                      </m:sSupPr>
+                      <m:e>
+                        <m:r>
+                          <a:rPr lang="en-US" sz="572" b="0" i="1" smtClean="0">
+                            <a:solidFill>
+                              <a:prstClr val="black"/>
+                            </a:solidFill>
+                            <a:latin typeface="Cambria Math" panose="02040503050406030204" pitchFamily="18" charset="0"/>
+                            <a:cs typeface="Arial" panose="020B0604020202020204" pitchFamily="34" charset="0"/>
+                          </a:rPr>
+                          <m:t>𝑚</m:t>
+                        </m:r>
+                      </m:e>
+                      <m:sup>
+                        <m:r>
+                          <a:rPr lang="en-US" sz="572" b="0" i="1" smtClean="0">
+                            <a:solidFill>
+                              <a:prstClr val="black"/>
+                            </a:solidFill>
+                            <a:latin typeface="Cambria Math" panose="02040503050406030204" pitchFamily="18" charset="0"/>
+                            <a:cs typeface="Arial" panose="020B0604020202020204" pitchFamily="34" charset="0"/>
+                          </a:rPr>
+                          <m:t>2</m:t>
+                        </m:r>
+                      </m:sup>
+                    </m:sSup>
+                  </m:oMath>
+                </a14:m>
+                <a:r>
+                  <a:rPr lang="en-US" sz="572" dirty="0">
+                    <a:solidFill>
+                      <a:prstClr val="black"/>
+                    </a:solidFill>
+                    <a:latin typeface="Arial" panose="020B0604020202020204" pitchFamily="34" charset="0"/>
+                    <a:cs typeface="Arial" panose="020B0604020202020204" pitchFamily="34" charset="0"/>
+                  </a:rPr>
+                  <a:t>. This positive correlation aligns with the expectation that larger plate surfaces enhance charge storage capacity.</a:t>
+                </a:r>
+              </a:p>
+            </p:txBody>
+          </p:sp>
+        </mc:Choice>
+        <mc:Fallback>
+          <p:sp>
+            <p:nvSpPr>
+              <p:cNvPr id="51" name="TextBox 50">
+                <a:extLst>
+                  <a:ext uri="{FF2B5EF4-FFF2-40B4-BE49-F238E27FC236}">
+                    <a16:creationId xmlns:a16="http://schemas.microsoft.com/office/drawing/2014/main" id="{E1CD2C2A-F064-084C-B9FF-1CE5B53E4E32}"/>
+                  </a:ext>
+                </a:extLst>
+              </p:cNvPr>
+              <p:cNvSpPr txBox="1">
+                <a:spLocks noRot="1" noChangeAspect="1" noMove="1" noResize="1" noEditPoints="1" noAdjustHandles="1" noChangeArrowheads="1" noChangeShapeType="1" noTextEdit="1"/>
+              </p:cNvSpPr>
+              <p:nvPr/>
+            </p:nvSpPr>
+            <p:spPr>
+              <a:xfrm>
+                <a:off x="4805278" y="5514244"/>
+                <a:ext cx="2581433" cy="1060740"/>
+              </a:xfrm>
+              <a:prstGeom prst="rect">
+                <a:avLst/>
+              </a:prstGeom>
+              <a:blipFill>
+                <a:blip r:embed="rId5"/>
+                <a:stretch>
+                  <a:fillRect/>
+                </a:stretch>
+              </a:blipFill>
+            </p:spPr>
+            <p:txBody>
+              <a:bodyPr/>
+              <a:lstStyle/>
+              <a:p>
+                <a:r>
+                  <a:rPr lang="es-ES">
+                    <a:noFill/>
+                  </a:rPr>
+                  <a:t> </a:t>
+                </a:r>
+              </a:p>
+            </p:txBody>
+          </p:sp>
+        </mc:Fallback>
+      </mc:AlternateContent>
       <p:sp>
         <p:nvSpPr>
           <p:cNvPr id="55" name="Rectangle 54">
@@ -13390,7 +11525,7 @@
           <p:nvPr/>
         </p:nvPicPr>
         <p:blipFill>
-          <a:blip r:embed="rId5"/>
+          <a:blip r:embed="rId6"/>
           <a:stretch>
             <a:fillRect/>
           </a:stretch>
@@ -13405,140 +11540,240 @@
           </a:prstGeom>
         </p:spPr>
       </p:pic>
-      <p:sp>
-        <p:nvSpPr>
-          <p:cNvPr id="46" name="Rectangle 45">
+      <p:grpSp>
+        <p:nvGrpSpPr>
+          <p:cNvPr id="10" name="Grupo 9">
             <a:extLst>
               <a:ext uri="{FF2B5EF4-FFF2-40B4-BE49-F238E27FC236}">
-                <a16:creationId xmlns:a16="http://schemas.microsoft.com/office/drawing/2014/main" id="{D903B466-646C-2D4A-BD19-7AA4D5AE665B}"/>
+                <a16:creationId xmlns:a16="http://schemas.microsoft.com/office/drawing/2014/main" id="{8B87BA69-F4CB-DBF5-4676-B393D1F8A96A}"/>
               </a:ext>
             </a:extLst>
           </p:cNvPr>
-          <p:cNvSpPr/>
+          <p:cNvGrpSpPr/>
           <p:nvPr/>
-        </p:nvSpPr>
-        <p:spPr>
+        </p:nvGrpSpPr>
+        <p:grpSpPr>
           <a:xfrm>
-            <a:off x="7747567" y="634289"/>
-            <a:ext cx="1887651" cy="596757"/>
+            <a:off x="4823707" y="3637807"/>
+            <a:ext cx="2547253" cy="1876437"/>
+            <a:chOff x="4823707" y="3637807"/>
+            <a:chExt cx="2547253" cy="1876437"/>
           </a:xfrm>
-          <a:prstGeom prst="rect">
-            <a:avLst/>
-          </a:prstGeom>
-          <a:solidFill>
-            <a:schemeClr val="accent3">
-              <a:lumMod val="40000"/>
-              <a:lumOff val="60000"/>
-            </a:schemeClr>
-          </a:solidFill>
-          <a:ln>
+        </p:grpSpPr>
+        <p:pic>
+          <p:nvPicPr>
+            <p:cNvPr id="5" name="Picture 4" descr="A graph with a line going up&#10;&#10;AI-generated content may be incorrect.">
+              <a:extLst>
+                <a:ext uri="{FF2B5EF4-FFF2-40B4-BE49-F238E27FC236}">
+                  <a16:creationId xmlns:a16="http://schemas.microsoft.com/office/drawing/2014/main" id="{C498A840-B2C8-4383-7568-2620CE9B6494}"/>
+                </a:ext>
+              </a:extLst>
+            </p:cNvPr>
+            <p:cNvPicPr>
+              <a:picLocks noChangeAspect="1"/>
+            </p:cNvPicPr>
+            <p:nvPr/>
+          </p:nvPicPr>
+          <p:blipFill>
+            <a:blip r:embed="rId7">
+              <a:extLst>
+                <a:ext uri="{28A0092B-C50C-407E-A947-70E740481C1C}">
+                  <a14:useLocalDpi xmlns:a14="http://schemas.microsoft.com/office/drawing/2010/main" val="0"/>
+                </a:ext>
+              </a:extLst>
+            </a:blip>
+            <a:stretch>
+              <a:fillRect/>
+            </a:stretch>
+          </p:blipFill>
+          <p:spPr>
+            <a:xfrm>
+              <a:off x="4823707" y="3637807"/>
+              <a:ext cx="2547253" cy="1678218"/>
+            </a:xfrm>
+            <a:prstGeom prst="rect">
+              <a:avLst/>
+            </a:prstGeom>
+          </p:spPr>
+        </p:pic>
+        <p:sp>
+          <p:nvSpPr>
+            <p:cNvPr id="2" name="CuadroTexto 1">
+              <a:extLst>
+                <a:ext uri="{FF2B5EF4-FFF2-40B4-BE49-F238E27FC236}">
+                  <a16:creationId xmlns:a16="http://schemas.microsoft.com/office/drawing/2014/main" id="{B78BFC16-B0AF-8B41-829D-20E46F0F3C5B}"/>
+                </a:ext>
+              </a:extLst>
+            </p:cNvPr>
+            <p:cNvSpPr txBox="1"/>
+            <p:nvPr/>
+          </p:nvSpPr>
+          <p:spPr>
+            <a:xfrm>
+              <a:off x="5408444" y="5321884"/>
+              <a:ext cx="1375102" cy="192360"/>
+            </a:xfrm>
+            <a:prstGeom prst="rect">
+              <a:avLst/>
+            </a:prstGeom>
             <a:noFill/>
-          </a:ln>
-        </p:spPr>
-        <p:style>
-          <a:lnRef idx="2">
-            <a:schemeClr val="accent1">
-              <a:shade val="50000"/>
-            </a:schemeClr>
-          </a:lnRef>
-          <a:fillRef idx="1">
-            <a:schemeClr val="accent1"/>
-          </a:fillRef>
-          <a:effectRef idx="0">
-            <a:schemeClr val="accent1"/>
-          </a:effectRef>
-          <a:fontRef idx="minor">
-            <a:schemeClr val="lt1"/>
-          </a:fontRef>
-        </p:style>
-        <p:txBody>
-          <a:bodyPr rtlCol="0" anchor="ctr"/>
-          <a:lstStyle/>
-          <a:p>
-            <a:pPr algn="ctr" defTabSz="780653"/>
-            <a:r>
-              <a:rPr lang="en-US" sz="1281" dirty="0">
-                <a:solidFill>
-                  <a:prstClr val="white"/>
-                </a:solidFill>
-                <a:latin typeface="Arial" panose="020B0604020202020204" pitchFamily="34" charset="0"/>
-                <a:cs typeface="Arial" panose="020B0604020202020204" pitchFamily="34" charset="0"/>
-              </a:rPr>
-              <a:t>logo</a:t>
-            </a:r>
-          </a:p>
-        </p:txBody>
-      </p:sp>
-      <p:sp>
-        <p:nvSpPr>
-          <p:cNvPr id="59" name="Oval 58">
+          </p:spPr>
+          <p:txBody>
+            <a:bodyPr wrap="square" rtlCol="0">
+              <a:spAutoFit/>
+            </a:bodyPr>
+            <a:lstStyle/>
+            <a:p>
+              <a:pPr algn="ctr"/>
+              <a:r>
+                <a:rPr lang="es-ES" sz="650" dirty="0"/>
+                <a:t>Figure 2: </a:t>
+              </a:r>
+              <a:r>
+                <a:rPr lang="es-ES" sz="650" dirty="0" err="1"/>
+                <a:t>Capacitance</a:t>
+              </a:r>
+              <a:r>
+                <a:rPr lang="es-ES" sz="650" dirty="0"/>
+                <a:t> vs. </a:t>
+              </a:r>
+              <a:r>
+                <a:rPr lang="es-ES" sz="650" dirty="0" err="1"/>
+                <a:t>Plate</a:t>
+              </a:r>
+              <a:r>
+                <a:rPr lang="es-ES" sz="650" dirty="0"/>
+                <a:t> </a:t>
+              </a:r>
+              <a:r>
+                <a:rPr lang="es-ES" sz="650" dirty="0" err="1"/>
+                <a:t>Area</a:t>
+              </a:r>
+              <a:endParaRPr lang="es-ES" sz="650" dirty="0"/>
+            </a:p>
+          </p:txBody>
+        </p:sp>
+      </p:grpSp>
+      <p:grpSp>
+        <p:nvGrpSpPr>
+          <p:cNvPr id="11" name="Grupo 10">
             <a:extLst>
               <a:ext uri="{FF2B5EF4-FFF2-40B4-BE49-F238E27FC236}">
-                <a16:creationId xmlns:a16="http://schemas.microsoft.com/office/drawing/2014/main" id="{887E75FA-C034-2447-9AFA-253A4A8F5217}"/>
+                <a16:creationId xmlns:a16="http://schemas.microsoft.com/office/drawing/2014/main" id="{E4C589B7-4B88-CC58-6898-2E7425307E9A}"/>
               </a:ext>
             </a:extLst>
           </p:cNvPr>
-          <p:cNvSpPr/>
+          <p:cNvGrpSpPr/>
           <p:nvPr/>
-        </p:nvSpPr>
-        <p:spPr>
+        </p:nvGrpSpPr>
+        <p:grpSpPr>
           <a:xfrm>
-            <a:off x="9751559" y="634289"/>
-            <a:ext cx="794997" cy="590354"/>
+            <a:off x="4823703" y="1748673"/>
+            <a:ext cx="2547257" cy="1881983"/>
+            <a:chOff x="4823703" y="1748673"/>
+            <a:chExt cx="2547257" cy="1881983"/>
           </a:xfrm>
-          <a:prstGeom prst="ellipse">
-            <a:avLst/>
-          </a:prstGeom>
-          <a:solidFill>
-            <a:schemeClr val="accent3">
-              <a:lumMod val="40000"/>
-              <a:lumOff val="60000"/>
-            </a:schemeClr>
-          </a:solidFill>
-          <a:ln>
+        </p:grpSpPr>
+        <p:pic>
+          <p:nvPicPr>
+            <p:cNvPr id="7" name="Picture 6" descr="A graph with a red line&#10;&#10;AI-generated content may be incorrect.">
+              <a:extLst>
+                <a:ext uri="{FF2B5EF4-FFF2-40B4-BE49-F238E27FC236}">
+                  <a16:creationId xmlns:a16="http://schemas.microsoft.com/office/drawing/2014/main" id="{56CDAAF2-1818-9EB6-09DE-0325CCB12502}"/>
+                </a:ext>
+              </a:extLst>
+            </p:cNvPr>
+            <p:cNvPicPr>
+              <a:picLocks noChangeAspect="1"/>
+            </p:cNvPicPr>
+            <p:nvPr/>
+          </p:nvPicPr>
+          <p:blipFill>
+            <a:blip r:embed="rId8">
+              <a:extLst>
+                <a:ext uri="{28A0092B-C50C-407E-A947-70E740481C1C}">
+                  <a14:useLocalDpi xmlns:a14="http://schemas.microsoft.com/office/drawing/2010/main" val="0"/>
+                </a:ext>
+              </a:extLst>
+            </a:blip>
+            <a:stretch>
+              <a:fillRect/>
+            </a:stretch>
+          </p:blipFill>
+          <p:spPr>
+            <a:xfrm>
+              <a:off x="4823703" y="1748673"/>
+              <a:ext cx="2547257" cy="1690915"/>
+            </a:xfrm>
+            <a:prstGeom prst="rect">
+              <a:avLst/>
+            </a:prstGeom>
+          </p:spPr>
+        </p:pic>
+        <p:sp>
+          <p:nvSpPr>
+            <p:cNvPr id="3" name="CuadroTexto 2">
+              <a:extLst>
+                <a:ext uri="{FF2B5EF4-FFF2-40B4-BE49-F238E27FC236}">
+                  <a16:creationId xmlns:a16="http://schemas.microsoft.com/office/drawing/2014/main" id="{1342CD79-1432-E499-29FA-C0F48653707F}"/>
+                </a:ext>
+              </a:extLst>
+            </p:cNvPr>
+            <p:cNvSpPr txBox="1"/>
+            <p:nvPr/>
+          </p:nvSpPr>
+          <p:spPr>
+            <a:xfrm>
+              <a:off x="5300057" y="3438296"/>
+              <a:ext cx="1584097" cy="192360"/>
+            </a:xfrm>
+            <a:prstGeom prst="rect">
+              <a:avLst/>
+            </a:prstGeom>
             <a:noFill/>
-          </a:ln>
-        </p:spPr>
-        <p:style>
-          <a:lnRef idx="2">
-            <a:schemeClr val="accent1">
-              <a:shade val="50000"/>
-            </a:schemeClr>
-          </a:lnRef>
-          <a:fillRef idx="1">
-            <a:schemeClr val="accent1"/>
-          </a:fillRef>
-          <a:effectRef idx="0">
-            <a:schemeClr val="accent1"/>
-          </a:effectRef>
-          <a:fontRef idx="minor">
-            <a:schemeClr val="lt1"/>
-          </a:fontRef>
-        </p:style>
-        <p:txBody>
-          <a:bodyPr rtlCol="0" anchor="ctr"/>
-          <a:lstStyle/>
-          <a:p>
-            <a:pPr algn="ctr" defTabSz="780653"/>
-            <a:r>
-              <a:rPr lang="en-US" sz="1281" dirty="0">
-                <a:solidFill>
-                  <a:prstClr val="white"/>
-                </a:solidFill>
-                <a:latin typeface="Arial" panose="020B0604020202020204" pitchFamily="34" charset="0"/>
-                <a:cs typeface="Arial" panose="020B0604020202020204" pitchFamily="34" charset="0"/>
-              </a:rPr>
-              <a:t>logo</a:t>
-            </a:r>
-          </a:p>
-        </p:txBody>
-      </p:sp>
+          </p:spPr>
+          <p:txBody>
+            <a:bodyPr wrap="square" rtlCol="0">
+              <a:spAutoFit/>
+            </a:bodyPr>
+            <a:lstStyle/>
+            <a:p>
+              <a:pPr algn="ctr"/>
+              <a:r>
+                <a:rPr lang="es-ES" sz="650" dirty="0"/>
+                <a:t>Figure 1: </a:t>
+              </a:r>
+              <a:r>
+                <a:rPr lang="es-ES" sz="650" dirty="0" err="1"/>
+                <a:t>Capacitance</a:t>
+              </a:r>
+              <a:r>
+                <a:rPr lang="es-ES" sz="650" dirty="0"/>
+                <a:t> vs. </a:t>
+              </a:r>
+              <a:r>
+                <a:rPr lang="es-ES" sz="650" dirty="0" err="1"/>
+                <a:t>Plate</a:t>
+              </a:r>
+              <a:r>
+                <a:rPr lang="es-ES" sz="650" dirty="0"/>
+                <a:t> </a:t>
+              </a:r>
+              <a:r>
+                <a:rPr lang="es-ES" sz="650" dirty="0" err="1"/>
+                <a:t>Separation</a:t>
+              </a:r>
+              <a:endParaRPr lang="es-ES" sz="650" dirty="0"/>
+            </a:p>
+          </p:txBody>
+        </p:sp>
+      </p:grpSp>
       <p:pic>
         <p:nvPicPr>
-          <p:cNvPr id="5" name="Picture 4" descr="A graph with a line going up&#10;&#10;AI-generated content may be incorrect.">
+          <p:cNvPr id="9" name="Picture 26">
             <a:extLst>
               <a:ext uri="{FF2B5EF4-FFF2-40B4-BE49-F238E27FC236}">
-                <a16:creationId xmlns:a16="http://schemas.microsoft.com/office/drawing/2014/main" id="{C498A840-B2C8-4383-7568-2620CE9B6494}"/>
+                <a16:creationId xmlns:a16="http://schemas.microsoft.com/office/drawing/2014/main" id="{1F6FF982-84D1-D5B7-2672-EEB42FF7BB88}"/>
               </a:ext>
             </a:extLst>
           </p:cNvPr>
@@ -13548,57 +11783,15 @@
           <p:nvPr/>
         </p:nvPicPr>
         <p:blipFill>
-          <a:blip r:embed="rId6">
-            <a:extLst>
-              <a:ext uri="{28A0092B-C50C-407E-A947-70E740481C1C}">
-                <a14:useLocalDpi xmlns:a14="http://schemas.microsoft.com/office/drawing/2010/main" val="0"/>
-              </a:ext>
-            </a:extLst>
-          </a:blip>
+          <a:blip r:embed="rId9"/>
           <a:stretch>
             <a:fillRect/>
           </a:stretch>
         </p:blipFill>
         <p:spPr>
           <a:xfrm>
-            <a:off x="4839459" y="3560934"/>
-            <a:ext cx="2547253" cy="1678218"/>
-          </a:xfrm>
-          <a:prstGeom prst="rect">
-            <a:avLst/>
-          </a:prstGeom>
-        </p:spPr>
-      </p:pic>
-      <p:pic>
-        <p:nvPicPr>
-          <p:cNvPr id="7" name="Picture 6" descr="A graph with a red line&#10;&#10;AI-generated content may be incorrect.">
-            <a:extLst>
-              <a:ext uri="{FF2B5EF4-FFF2-40B4-BE49-F238E27FC236}">
-                <a16:creationId xmlns:a16="http://schemas.microsoft.com/office/drawing/2014/main" id="{56CDAAF2-1818-9EB6-09DE-0325CCB12502}"/>
-              </a:ext>
-            </a:extLst>
-          </p:cNvPr>
-          <p:cNvPicPr>
-            <a:picLocks noChangeAspect="1"/>
-          </p:cNvPicPr>
-          <p:nvPr/>
-        </p:nvPicPr>
-        <p:blipFill>
-          <a:blip r:embed="rId7">
-            <a:extLst>
-              <a:ext uri="{28A0092B-C50C-407E-A947-70E740481C1C}">
-                <a14:useLocalDpi xmlns:a14="http://schemas.microsoft.com/office/drawing/2010/main" val="0"/>
-              </a:ext>
-            </a:extLst>
-          </a:blip>
-          <a:stretch>
-            <a:fillRect/>
-          </a:stretch>
-        </p:blipFill>
-        <p:spPr>
-          <a:xfrm>
-            <a:off x="4839459" y="1826242"/>
-            <a:ext cx="2547257" cy="1690915"/>
+            <a:off x="7747567" y="695165"/>
+            <a:ext cx="1887651" cy="409173"/>
           </a:xfrm>
           <a:prstGeom prst="rect">
             <a:avLst/>

</xml_diff>

<commit_message>
Adding code for statistical testing and changes to the poster.
Made changes to the results and added statistical dump/output.

Signed-off-by: Abdon Morales <abdonm@cs.utexas.edu>
</commit_message>
<xml_diff>
--- a/Final Project/FinalProject.pptx
+++ b/Final Project/FinalProject.pptx
@@ -5,6 +5,9 @@
     <p:sldMasterId id="2147483648" r:id="rId1"/>
     <p:sldMasterId id="2147483660" r:id="rId2"/>
   </p:sldMasterIdLst>
+  <p:notesMasterIdLst>
+    <p:notesMasterId r:id="rId4"/>
+  </p:notesMasterIdLst>
   <p:sldIdLst>
     <p:sldId id="268" r:id="rId3"/>
   </p:sldIdLst>
@@ -116,8 +119,7 @@
 <file path=ppt/revisionInfo.xml><?xml version="1.0" encoding="utf-8"?>
 <p1510:revInfo xmlns:a="http://schemas.openxmlformats.org/drawingml/2006/main" xmlns:r="http://schemas.openxmlformats.org/officeDocument/2006/relationships" xmlns:p1510="http://schemas.microsoft.com/office/powerpoint/2015/10/main">
   <p1510:revLst>
-    <p1510:client id="{60DCBEB9-452B-42DA-B7D1-E4A5A7FC6C10}" v="1749" dt="2025-12-03T17:44:14.992"/>
-    <p1510:client id="{80BA49D0-6376-CB48-B3C3-F4708D789340}" v="223" dt="2025-12-04T04:11:19.332"/>
+    <p1510:client id="{80BA49D0-6376-CB48-B3C3-F4708D789340}" v="992" dt="2025-12-04T22:49:57.117"/>
   </p1510:revLst>
 </p1510:revInfo>
 </file>
@@ -127,12 +129,12 @@
   <pc:docChgLst>
     <pc:chgData name="Morales, Abdon" userId="b8e72fca-89fa-40b2-95f0-bdb26e6d8c1d" providerId="ADAL" clId="{F77E3D6D-613B-5030-A384-37FA661628F6}"/>
     <pc:docChg chg="undo custSel modSld">
-      <pc:chgData name="Morales, Abdon" userId="b8e72fca-89fa-40b2-95f0-bdb26e6d8c1d" providerId="ADAL" clId="{F77E3D6D-613B-5030-A384-37FA661628F6}" dt="2025-12-04T04:20:15.339" v="1088" actId="164"/>
+      <pc:chgData name="Morales, Abdon" userId="b8e72fca-89fa-40b2-95f0-bdb26e6d8c1d" providerId="ADAL" clId="{F77E3D6D-613B-5030-A384-37FA661628F6}" dt="2025-12-04T22:49:57.117" v="2265" actId="313"/>
       <pc:docMkLst>
         <pc:docMk/>
       </pc:docMkLst>
       <pc:sldChg chg="addSp delSp modSp mod">
-        <pc:chgData name="Morales, Abdon" userId="b8e72fca-89fa-40b2-95f0-bdb26e6d8c1d" providerId="ADAL" clId="{F77E3D6D-613B-5030-A384-37FA661628F6}" dt="2025-12-04T04:20:15.339" v="1088" actId="164"/>
+        <pc:chgData name="Morales, Abdon" userId="b8e72fca-89fa-40b2-95f0-bdb26e6d8c1d" providerId="ADAL" clId="{F77E3D6D-613B-5030-A384-37FA661628F6}" dt="2025-12-04T22:49:57.117" v="2265" actId="313"/>
         <pc:sldMkLst>
           <pc:docMk/>
           <pc:sldMk cId="4152292366" sldId="268"/>
@@ -161,6 +163,14 @@
             <ac:spMk id="4" creationId="{C2642BAB-3737-CE4C-874C-5EA986C6E360}"/>
           </ac:spMkLst>
         </pc:spChg>
+        <pc:spChg chg="add mod">
+          <ac:chgData name="Morales, Abdon" userId="b8e72fca-89fa-40b2-95f0-bdb26e6d8c1d" providerId="ADAL" clId="{F77E3D6D-613B-5030-A384-37FA661628F6}" dt="2025-12-04T22:48:23.119" v="2052" actId="255"/>
+          <ac:spMkLst>
+            <pc:docMk/>
+            <pc:sldMk cId="4152292366" sldId="268"/>
+            <ac:spMk id="12" creationId="{F99076AB-CD48-1D9C-24C3-8E5BC7671CED}"/>
+          </ac:spMkLst>
+        </pc:spChg>
         <pc:spChg chg="del">
           <ac:chgData name="Morales, Abdon" userId="b8e72fca-89fa-40b2-95f0-bdb26e6d8c1d" providerId="ADAL" clId="{F77E3D6D-613B-5030-A384-37FA661628F6}" dt="2025-12-04T04:12:05.673" v="1083" actId="478"/>
           <ac:spMkLst>
@@ -170,11 +180,27 @@
           </ac:spMkLst>
         </pc:spChg>
         <pc:spChg chg="mod">
+          <ac:chgData name="Morales, Abdon" userId="b8e72fca-89fa-40b2-95f0-bdb26e6d8c1d" providerId="ADAL" clId="{F77E3D6D-613B-5030-A384-37FA661628F6}" dt="2025-12-04T22:49:57.117" v="2265" actId="313"/>
+          <ac:spMkLst>
+            <pc:docMk/>
+            <pc:sldMk cId="4152292366" sldId="268"/>
+            <ac:spMk id="50" creationId="{79C029F1-D5E2-A842-A19B-DC4969111E24}"/>
+          </ac:spMkLst>
+        </pc:spChg>
+        <pc:spChg chg="mod">
           <ac:chgData name="Morales, Abdon" userId="b8e72fca-89fa-40b2-95f0-bdb26e6d8c1d" providerId="ADAL" clId="{F77E3D6D-613B-5030-A384-37FA661628F6}" dt="2025-12-04T04:04:32.036" v="1038" actId="1076"/>
           <ac:spMkLst>
             <pc:docMk/>
             <pc:sldMk cId="4152292366" sldId="268"/>
             <ac:spMk id="51" creationId="{E1CD2C2A-F064-084C-B9FF-1CE5B53E4E32}"/>
+          </ac:spMkLst>
+        </pc:spChg>
+        <pc:spChg chg="del">
+          <ac:chgData name="Morales, Abdon" userId="b8e72fca-89fa-40b2-95f0-bdb26e6d8c1d" providerId="ADAL" clId="{F77E3D6D-613B-5030-A384-37FA661628F6}" dt="2025-12-04T22:37:34.067" v="1108" actId="478"/>
+          <ac:spMkLst>
+            <pc:docMk/>
+            <pc:sldMk cId="4152292366" sldId="268"/>
+            <ac:spMk id="55" creationId="{932F4CD2-D53A-6945-A147-AA4161801A71}"/>
           </ac:spMkLst>
         </pc:spChg>
         <pc:spChg chg="del">
@@ -245,6 +271,439 @@
     </pc:docChg>
   </pc:docChgLst>
 </pc:chgInfo>
+</file>
+
+<file path=ppt/notesMasters/notesMaster1.xml><?xml version="1.0" encoding="utf-8"?>
+<p:notesMaster xmlns:a="http://schemas.openxmlformats.org/drawingml/2006/main" xmlns:r="http://schemas.openxmlformats.org/officeDocument/2006/relationships" xmlns:p="http://schemas.openxmlformats.org/presentationml/2006/main">
+  <p:cSld>
+    <p:bg>
+      <p:bgRef idx="1001">
+        <a:schemeClr val="bg1"/>
+      </p:bgRef>
+    </p:bg>
+    <p:spTree>
+      <p:nvGrpSpPr>
+        <p:cNvPr id="1" name=""/>
+        <p:cNvGrpSpPr/>
+        <p:nvPr/>
+      </p:nvGrpSpPr>
+      <p:grpSpPr>
+        <a:xfrm>
+          <a:off x="0" y="0"/>
+          <a:ext cx="0" cy="0"/>
+          <a:chOff x="0" y="0"/>
+          <a:chExt cx="0" cy="0"/>
+        </a:xfrm>
+      </p:grpSpPr>
+      <p:sp>
+        <p:nvSpPr>
+          <p:cNvPr id="2" name="Marcador de encabezado 1"/>
+          <p:cNvSpPr>
+            <a:spLocks noGrp="1"/>
+          </p:cNvSpPr>
+          <p:nvPr>
+            <p:ph type="hdr" sz="quarter"/>
+          </p:nvPr>
+        </p:nvSpPr>
+        <p:spPr>
+          <a:xfrm>
+            <a:off x="0" y="0"/>
+            <a:ext cx="2971800" cy="458788"/>
+          </a:xfrm>
+          <a:prstGeom prst="rect">
+            <a:avLst/>
+          </a:prstGeom>
+        </p:spPr>
+        <p:txBody>
+          <a:bodyPr vert="horz" lIns="91440" tIns="45720" rIns="91440" bIns="45720" rtlCol="0"/>
+          <a:lstStyle>
+            <a:lvl1pPr algn="l">
+              <a:defRPr sz="1200"/>
+            </a:lvl1pPr>
+          </a:lstStyle>
+          <a:p>
+            <a:endParaRPr lang="es-ES"/>
+          </a:p>
+        </p:txBody>
+      </p:sp>
+      <p:sp>
+        <p:nvSpPr>
+          <p:cNvPr id="3" name="Marcador de fecha 2"/>
+          <p:cNvSpPr>
+            <a:spLocks noGrp="1"/>
+          </p:cNvSpPr>
+          <p:nvPr>
+            <p:ph type="dt" idx="1"/>
+          </p:nvPr>
+        </p:nvSpPr>
+        <p:spPr>
+          <a:xfrm>
+            <a:off x="3884613" y="0"/>
+            <a:ext cx="2971800" cy="458788"/>
+          </a:xfrm>
+          <a:prstGeom prst="rect">
+            <a:avLst/>
+          </a:prstGeom>
+        </p:spPr>
+        <p:txBody>
+          <a:bodyPr vert="horz" lIns="91440" tIns="45720" rIns="91440" bIns="45720" rtlCol="0"/>
+          <a:lstStyle>
+            <a:lvl1pPr algn="r">
+              <a:defRPr sz="1200"/>
+            </a:lvl1pPr>
+          </a:lstStyle>
+          <a:p>
+            <a:fld id="{D353F5E4-024D-B04C-8649-02453A372B74}" type="datetimeFigureOut">
+              <a:rPr lang="es-ES" smtClean="0"/>
+              <a:t>4/12/25</a:t>
+            </a:fld>
+            <a:endParaRPr lang="es-ES"/>
+          </a:p>
+        </p:txBody>
+      </p:sp>
+      <p:sp>
+        <p:nvSpPr>
+          <p:cNvPr id="4" name="Marcador de imagen de diapositiva 3"/>
+          <p:cNvSpPr>
+            <a:spLocks noGrp="1" noRot="1" noChangeAspect="1"/>
+          </p:cNvSpPr>
+          <p:nvPr>
+            <p:ph type="sldImg" idx="2"/>
+          </p:nvPr>
+        </p:nvSpPr>
+        <p:spPr>
+          <a:xfrm>
+            <a:off x="685800" y="1143000"/>
+            <a:ext cx="5486400" cy="3086100"/>
+          </a:xfrm>
+          <a:prstGeom prst="rect">
+            <a:avLst/>
+          </a:prstGeom>
+          <a:noFill/>
+          <a:ln w="12700">
+            <a:solidFill>
+              <a:prstClr val="black"/>
+            </a:solidFill>
+          </a:ln>
+        </p:spPr>
+        <p:txBody>
+          <a:bodyPr vert="horz" lIns="91440" tIns="45720" rIns="91440" bIns="45720" rtlCol="0" anchor="ctr"/>
+          <a:lstStyle/>
+          <a:p>
+            <a:endParaRPr lang="es-ES"/>
+          </a:p>
+        </p:txBody>
+      </p:sp>
+      <p:sp>
+        <p:nvSpPr>
+          <p:cNvPr id="5" name="Marcador de notas 4"/>
+          <p:cNvSpPr>
+            <a:spLocks noGrp="1"/>
+          </p:cNvSpPr>
+          <p:nvPr>
+            <p:ph type="body" sz="quarter" idx="3"/>
+          </p:nvPr>
+        </p:nvSpPr>
+        <p:spPr>
+          <a:xfrm>
+            <a:off x="685800" y="4400550"/>
+            <a:ext cx="5486400" cy="3600450"/>
+          </a:xfrm>
+          <a:prstGeom prst="rect">
+            <a:avLst/>
+          </a:prstGeom>
+        </p:spPr>
+        <p:txBody>
+          <a:bodyPr vert="horz" lIns="91440" tIns="45720" rIns="91440" bIns="45720" rtlCol="0"/>
+          <a:lstStyle/>
+          <a:p>
+            <a:pPr lvl="0"/>
+            <a:r>
+              <a:rPr lang="es-ES"/>
+              <a:t>Haga clic para modificar los estilos de texto del patrón</a:t>
+            </a:r>
+          </a:p>
+          <a:p>
+            <a:pPr lvl="1"/>
+            <a:r>
+              <a:rPr lang="es-ES"/>
+              <a:t>Segundo nivel</a:t>
+            </a:r>
+          </a:p>
+          <a:p>
+            <a:pPr lvl="2"/>
+            <a:r>
+              <a:rPr lang="es-ES"/>
+              <a:t>Tercer nivel</a:t>
+            </a:r>
+          </a:p>
+          <a:p>
+            <a:pPr lvl="3"/>
+            <a:r>
+              <a:rPr lang="es-ES"/>
+              <a:t>Cuarto nivel</a:t>
+            </a:r>
+          </a:p>
+          <a:p>
+            <a:pPr lvl="4"/>
+            <a:r>
+              <a:rPr lang="es-ES"/>
+              <a:t>Quinto nivel</a:t>
+            </a:r>
+          </a:p>
+        </p:txBody>
+      </p:sp>
+      <p:sp>
+        <p:nvSpPr>
+          <p:cNvPr id="6" name="Marcador de pie de página 5"/>
+          <p:cNvSpPr>
+            <a:spLocks noGrp="1"/>
+          </p:cNvSpPr>
+          <p:nvPr>
+            <p:ph type="ftr" sz="quarter" idx="4"/>
+          </p:nvPr>
+        </p:nvSpPr>
+        <p:spPr>
+          <a:xfrm>
+            <a:off x="0" y="8685213"/>
+            <a:ext cx="2971800" cy="458787"/>
+          </a:xfrm>
+          <a:prstGeom prst="rect">
+            <a:avLst/>
+          </a:prstGeom>
+        </p:spPr>
+        <p:txBody>
+          <a:bodyPr vert="horz" lIns="91440" tIns="45720" rIns="91440" bIns="45720" rtlCol="0" anchor="b"/>
+          <a:lstStyle>
+            <a:lvl1pPr algn="l">
+              <a:defRPr sz="1200"/>
+            </a:lvl1pPr>
+          </a:lstStyle>
+          <a:p>
+            <a:endParaRPr lang="es-ES"/>
+          </a:p>
+        </p:txBody>
+      </p:sp>
+      <p:sp>
+        <p:nvSpPr>
+          <p:cNvPr id="7" name="Marcador de número de diapositiva 6"/>
+          <p:cNvSpPr>
+            <a:spLocks noGrp="1"/>
+          </p:cNvSpPr>
+          <p:nvPr>
+            <p:ph type="sldNum" sz="quarter" idx="5"/>
+          </p:nvPr>
+        </p:nvSpPr>
+        <p:spPr>
+          <a:xfrm>
+            <a:off x="3884613" y="8685213"/>
+            <a:ext cx="2971800" cy="458787"/>
+          </a:xfrm>
+          <a:prstGeom prst="rect">
+            <a:avLst/>
+          </a:prstGeom>
+        </p:spPr>
+        <p:txBody>
+          <a:bodyPr vert="horz" lIns="91440" tIns="45720" rIns="91440" bIns="45720" rtlCol="0" anchor="b"/>
+          <a:lstStyle>
+            <a:lvl1pPr algn="r">
+              <a:defRPr sz="1200"/>
+            </a:lvl1pPr>
+          </a:lstStyle>
+          <a:p>
+            <a:fld id="{8B8AD62F-FB3F-5643-A016-D6A8B7C9C1C4}" type="slidenum">
+              <a:rPr lang="es-ES" smtClean="0"/>
+              <a:t>‹Nº›</a:t>
+            </a:fld>
+            <a:endParaRPr lang="es-ES"/>
+          </a:p>
+        </p:txBody>
+      </p:sp>
+    </p:spTree>
+    <p:extLst>
+      <p:ext uri="{BB962C8B-B14F-4D97-AF65-F5344CB8AC3E}">
+        <p14:creationId xmlns:p14="http://schemas.microsoft.com/office/powerpoint/2010/main" val="3470198231"/>
+      </p:ext>
+    </p:extLst>
+  </p:cSld>
+  <p:clrMap bg1="lt1" tx1="dk1" bg2="lt2" tx2="dk2" accent1="accent1" accent2="accent2" accent3="accent3" accent4="accent4" accent5="accent5" accent6="accent6" hlink="hlink" folHlink="folHlink"/>
+  <p:notesStyle>
+    <a:lvl1pPr marL="0" algn="l" defTabSz="914400" rtl="0" eaLnBrk="1" latinLnBrk="0" hangingPunct="1">
+      <a:defRPr sz="1200" kern="1200">
+        <a:solidFill>
+          <a:schemeClr val="tx1"/>
+        </a:solidFill>
+        <a:latin typeface="+mn-lt"/>
+        <a:ea typeface="+mn-ea"/>
+        <a:cs typeface="+mn-cs"/>
+      </a:defRPr>
+    </a:lvl1pPr>
+    <a:lvl2pPr marL="457200" algn="l" defTabSz="914400" rtl="0" eaLnBrk="1" latinLnBrk="0" hangingPunct="1">
+      <a:defRPr sz="1200" kern="1200">
+        <a:solidFill>
+          <a:schemeClr val="tx1"/>
+        </a:solidFill>
+        <a:latin typeface="+mn-lt"/>
+        <a:ea typeface="+mn-ea"/>
+        <a:cs typeface="+mn-cs"/>
+      </a:defRPr>
+    </a:lvl2pPr>
+    <a:lvl3pPr marL="914400" algn="l" defTabSz="914400" rtl="0" eaLnBrk="1" latinLnBrk="0" hangingPunct="1">
+      <a:defRPr sz="1200" kern="1200">
+        <a:solidFill>
+          <a:schemeClr val="tx1"/>
+        </a:solidFill>
+        <a:latin typeface="+mn-lt"/>
+        <a:ea typeface="+mn-ea"/>
+        <a:cs typeface="+mn-cs"/>
+      </a:defRPr>
+    </a:lvl3pPr>
+    <a:lvl4pPr marL="1371600" algn="l" defTabSz="914400" rtl="0" eaLnBrk="1" latinLnBrk="0" hangingPunct="1">
+      <a:defRPr sz="1200" kern="1200">
+        <a:solidFill>
+          <a:schemeClr val="tx1"/>
+        </a:solidFill>
+        <a:latin typeface="+mn-lt"/>
+        <a:ea typeface="+mn-ea"/>
+        <a:cs typeface="+mn-cs"/>
+      </a:defRPr>
+    </a:lvl4pPr>
+    <a:lvl5pPr marL="1828800" algn="l" defTabSz="914400" rtl="0" eaLnBrk="1" latinLnBrk="0" hangingPunct="1">
+      <a:defRPr sz="1200" kern="1200">
+        <a:solidFill>
+          <a:schemeClr val="tx1"/>
+        </a:solidFill>
+        <a:latin typeface="+mn-lt"/>
+        <a:ea typeface="+mn-ea"/>
+        <a:cs typeface="+mn-cs"/>
+      </a:defRPr>
+    </a:lvl5pPr>
+    <a:lvl6pPr marL="2286000" algn="l" defTabSz="914400" rtl="0" eaLnBrk="1" latinLnBrk="0" hangingPunct="1">
+      <a:defRPr sz="1200" kern="1200">
+        <a:solidFill>
+          <a:schemeClr val="tx1"/>
+        </a:solidFill>
+        <a:latin typeface="+mn-lt"/>
+        <a:ea typeface="+mn-ea"/>
+        <a:cs typeface="+mn-cs"/>
+      </a:defRPr>
+    </a:lvl6pPr>
+    <a:lvl7pPr marL="2743200" algn="l" defTabSz="914400" rtl="0" eaLnBrk="1" latinLnBrk="0" hangingPunct="1">
+      <a:defRPr sz="1200" kern="1200">
+        <a:solidFill>
+          <a:schemeClr val="tx1"/>
+        </a:solidFill>
+        <a:latin typeface="+mn-lt"/>
+        <a:ea typeface="+mn-ea"/>
+        <a:cs typeface="+mn-cs"/>
+      </a:defRPr>
+    </a:lvl7pPr>
+    <a:lvl8pPr marL="3200400" algn="l" defTabSz="914400" rtl="0" eaLnBrk="1" latinLnBrk="0" hangingPunct="1">
+      <a:defRPr sz="1200" kern="1200">
+        <a:solidFill>
+          <a:schemeClr val="tx1"/>
+        </a:solidFill>
+        <a:latin typeface="+mn-lt"/>
+        <a:ea typeface="+mn-ea"/>
+        <a:cs typeface="+mn-cs"/>
+      </a:defRPr>
+    </a:lvl8pPr>
+    <a:lvl9pPr marL="3657600" algn="l" defTabSz="914400" rtl="0" eaLnBrk="1" latinLnBrk="0" hangingPunct="1">
+      <a:defRPr sz="1200" kern="1200">
+        <a:solidFill>
+          <a:schemeClr val="tx1"/>
+        </a:solidFill>
+        <a:latin typeface="+mn-lt"/>
+        <a:ea typeface="+mn-ea"/>
+        <a:cs typeface="+mn-cs"/>
+      </a:defRPr>
+    </a:lvl9pPr>
+  </p:notesStyle>
+</p:notesMaster>
+</file>
+
+<file path=ppt/notesSlides/notesSlide1.xml><?xml version="1.0" encoding="utf-8"?>
+<p:notes xmlns:a="http://schemas.openxmlformats.org/drawingml/2006/main" xmlns:r="http://schemas.openxmlformats.org/officeDocument/2006/relationships" xmlns:p="http://schemas.openxmlformats.org/presentationml/2006/main">
+  <p:cSld>
+    <p:spTree>
+      <p:nvGrpSpPr>
+        <p:cNvPr id="1" name=""/>
+        <p:cNvGrpSpPr/>
+        <p:nvPr/>
+      </p:nvGrpSpPr>
+      <p:grpSpPr>
+        <a:xfrm>
+          <a:off x="0" y="0"/>
+          <a:ext cx="0" cy="0"/>
+          <a:chOff x="0" y="0"/>
+          <a:chExt cx="0" cy="0"/>
+        </a:xfrm>
+      </p:grpSpPr>
+      <p:sp>
+        <p:nvSpPr>
+          <p:cNvPr id="2" name="Marcador de imagen de diapositiva 1"/>
+          <p:cNvSpPr>
+            <a:spLocks noGrp="1" noRot="1" noChangeAspect="1"/>
+          </p:cNvSpPr>
+          <p:nvPr>
+            <p:ph type="sldImg"/>
+          </p:nvPr>
+        </p:nvSpPr>
+        <p:spPr/>
+      </p:sp>
+      <p:sp>
+        <p:nvSpPr>
+          <p:cNvPr id="3" name="Marcador de notas 2"/>
+          <p:cNvSpPr>
+            <a:spLocks noGrp="1"/>
+          </p:cNvSpPr>
+          <p:nvPr>
+            <p:ph type="body" idx="1"/>
+          </p:nvPr>
+        </p:nvSpPr>
+        <p:spPr/>
+        <p:txBody>
+          <a:bodyPr/>
+          <a:lstStyle/>
+          <a:p>
+            <a:endParaRPr lang="es-ES" dirty="0"/>
+          </a:p>
+        </p:txBody>
+      </p:sp>
+      <p:sp>
+        <p:nvSpPr>
+          <p:cNvPr id="4" name="Marcador de número de diapositiva 3"/>
+          <p:cNvSpPr>
+            <a:spLocks noGrp="1"/>
+          </p:cNvSpPr>
+          <p:nvPr>
+            <p:ph type="sldNum" sz="quarter" idx="5"/>
+          </p:nvPr>
+        </p:nvSpPr>
+        <p:spPr/>
+        <p:txBody>
+          <a:bodyPr/>
+          <a:lstStyle/>
+          <a:p>
+            <a:fld id="{8B8AD62F-FB3F-5643-A016-D6A8B7C9C1C4}" type="slidenum">
+              <a:rPr lang="es-ES" smtClean="0"/>
+              <a:t>1</a:t>
+            </a:fld>
+            <a:endParaRPr lang="es-ES"/>
+          </a:p>
+        </p:txBody>
+      </p:sp>
+    </p:spTree>
+    <p:extLst>
+      <p:ext uri="{BB962C8B-B14F-4D97-AF65-F5344CB8AC3E}">
+        <p14:creationId xmlns:p14="http://schemas.microsoft.com/office/powerpoint/2010/main" val="1924924292"/>
+      </p:ext>
+    </p:extLst>
+  </p:cSld>
+  <p:clrMapOvr>
+    <a:masterClrMapping/>
+  </p:clrMapOvr>
+</p:notes>
 </file>
 
 <file path=ppt/slideLayouts/slideLayout1.xml><?xml version="1.0" encoding="utf-8"?>
@@ -9778,7 +10237,7 @@
                 <a:avLst/>
               </a:prstGeom>
               <a:blipFill>
-                <a:blip r:embed="rId2"/>
+                <a:blip r:embed="rId3"/>
                 <a:stretch>
                   <a:fillRect/>
                 </a:stretch>
@@ -9976,7 +10435,7 @@
                 <a:avLst/>
               </a:prstGeom>
               <a:blipFill>
-                <a:blip r:embed="rId3"/>
+                <a:blip r:embed="rId4"/>
                 <a:stretch>
                   <a:fillRect/>
                 </a:stretch>
@@ -10535,7 +10994,7 @@
                 <a:avLst/>
               </a:prstGeom>
               <a:blipFill>
-                <a:blip r:embed="rId4"/>
+                <a:blip r:embed="rId5"/>
                 <a:stretch>
                   <a:fillRect/>
                 </a:stretch>
@@ -10556,508 +11015,346 @@
           </p:sp>
         </mc:Fallback>
       </mc:AlternateContent>
-      <p:sp>
-        <p:nvSpPr>
-          <p:cNvPr id="50" name="TextBox 49">
-            <a:extLst>
-              <a:ext uri="{FF2B5EF4-FFF2-40B4-BE49-F238E27FC236}">
-                <a16:creationId xmlns:a16="http://schemas.microsoft.com/office/drawing/2014/main" id="{79C029F1-D5E2-A842-A19B-DC4969111E24}"/>
-              </a:ext>
-            </a:extLst>
-          </p:cNvPr>
-          <p:cNvSpPr txBox="1"/>
-          <p:nvPr/>
-        </p:nvSpPr>
-        <p:spPr>
-          <a:xfrm>
-            <a:off x="7873433" y="3596455"/>
-            <a:ext cx="2597105" cy="356444"/>
-          </a:xfrm>
-          <a:prstGeom prst="rect">
-            <a:avLst/>
-          </a:prstGeom>
-          <a:noFill/>
-        </p:spPr>
-        <p:txBody>
-          <a:bodyPr wrap="square" rtlCol="0">
-            <a:spAutoFit/>
-          </a:bodyPr>
-          <a:lstStyle/>
-          <a:p>
-            <a:pPr defTabSz="780653"/>
-            <a:r>
-              <a:rPr lang="en-US" sz="572" dirty="0">
-                <a:solidFill>
-                  <a:prstClr val="black"/>
-                </a:solidFill>
-                <a:latin typeface="Arial" panose="020B0604020202020204" pitchFamily="34" charset="0"/>
-                <a:cs typeface="Arial" panose="020B0604020202020204" pitchFamily="34" charset="0"/>
-              </a:rPr>
-              <a:t>Ga. Ro </a:t>
-            </a:r>
-            <a:r>
-              <a:rPr lang="en-US" sz="572" dirty="0" err="1">
-                <a:solidFill>
-                  <a:prstClr val="black"/>
-                </a:solidFill>
-                <a:latin typeface="Arial" panose="020B0604020202020204" pitchFamily="34" charset="0"/>
-                <a:cs typeface="Arial" panose="020B0604020202020204" pitchFamily="34" charset="0"/>
-              </a:rPr>
-              <a:t>ium</a:t>
-            </a:r>
-            <a:r>
-              <a:rPr lang="en-US" sz="572" dirty="0">
-                <a:solidFill>
-                  <a:prstClr val="black"/>
-                </a:solidFill>
-                <a:latin typeface="Arial" panose="020B0604020202020204" pitchFamily="34" charset="0"/>
-                <a:cs typeface="Arial" panose="020B0604020202020204" pitchFamily="34" charset="0"/>
-              </a:rPr>
-              <a:t> </a:t>
-            </a:r>
-            <a:r>
-              <a:rPr lang="en-US" sz="572" dirty="0" err="1">
-                <a:solidFill>
-                  <a:prstClr val="black"/>
-                </a:solidFill>
-                <a:latin typeface="Arial" panose="020B0604020202020204" pitchFamily="34" charset="0"/>
-                <a:cs typeface="Arial" panose="020B0604020202020204" pitchFamily="34" charset="0"/>
-              </a:rPr>
-              <a:t>versperum</a:t>
-            </a:r>
-            <a:r>
-              <a:rPr lang="en-US" sz="572" dirty="0">
-                <a:solidFill>
-                  <a:prstClr val="black"/>
-                </a:solidFill>
-                <a:latin typeface="Arial" panose="020B0604020202020204" pitchFamily="34" charset="0"/>
-                <a:cs typeface="Arial" panose="020B0604020202020204" pitchFamily="34" charset="0"/>
-              </a:rPr>
-              <a:t> re </a:t>
-            </a:r>
-            <a:r>
-              <a:rPr lang="en-US" sz="572" dirty="0" err="1">
-                <a:solidFill>
-                  <a:prstClr val="black"/>
-                </a:solidFill>
-                <a:latin typeface="Arial" panose="020B0604020202020204" pitchFamily="34" charset="0"/>
-                <a:cs typeface="Arial" panose="020B0604020202020204" pitchFamily="34" charset="0"/>
-              </a:rPr>
-              <a:t>aut</a:t>
-            </a:r>
-            <a:r>
-              <a:rPr lang="en-US" sz="572" dirty="0">
-                <a:solidFill>
-                  <a:prstClr val="black"/>
-                </a:solidFill>
-                <a:latin typeface="Arial" panose="020B0604020202020204" pitchFamily="34" charset="0"/>
-                <a:cs typeface="Arial" panose="020B0604020202020204" pitchFamily="34" charset="0"/>
-              </a:rPr>
-              <a:t> </a:t>
-            </a:r>
-            <a:r>
-              <a:rPr lang="en-US" sz="572" dirty="0" err="1">
-                <a:solidFill>
-                  <a:prstClr val="black"/>
-                </a:solidFill>
-                <a:latin typeface="Arial" panose="020B0604020202020204" pitchFamily="34" charset="0"/>
-                <a:cs typeface="Arial" panose="020B0604020202020204" pitchFamily="34" charset="0"/>
-              </a:rPr>
-              <a:t>omnienderi</a:t>
-            </a:r>
-            <a:r>
-              <a:rPr lang="en-US" sz="572" dirty="0">
-                <a:solidFill>
-                  <a:prstClr val="black"/>
-                </a:solidFill>
-                <a:latin typeface="Arial" panose="020B0604020202020204" pitchFamily="34" charset="0"/>
-                <a:cs typeface="Arial" panose="020B0604020202020204" pitchFamily="34" charset="0"/>
-              </a:rPr>
-              <a:t> </a:t>
-            </a:r>
-            <a:r>
-              <a:rPr lang="en-US" sz="572" dirty="0" err="1">
-                <a:solidFill>
-                  <a:prstClr val="black"/>
-                </a:solidFill>
-                <a:latin typeface="Arial" panose="020B0604020202020204" pitchFamily="34" charset="0"/>
-                <a:cs typeface="Arial" panose="020B0604020202020204" pitchFamily="34" charset="0"/>
-              </a:rPr>
-              <a:t>sinvele</a:t>
-            </a:r>
-            <a:r>
-              <a:rPr lang="en-US" sz="572" dirty="0">
-                <a:solidFill>
-                  <a:prstClr val="black"/>
-                </a:solidFill>
-                <a:latin typeface="Arial" panose="020B0604020202020204" pitchFamily="34" charset="0"/>
-                <a:cs typeface="Arial" panose="020B0604020202020204" pitchFamily="34" charset="0"/>
-              </a:rPr>
-              <a:t> </a:t>
-            </a:r>
-            <a:r>
-              <a:rPr lang="en-US" sz="572" dirty="0" err="1">
-                <a:solidFill>
-                  <a:prstClr val="black"/>
-                </a:solidFill>
-                <a:latin typeface="Arial" panose="020B0604020202020204" pitchFamily="34" charset="0"/>
-                <a:cs typeface="Arial" panose="020B0604020202020204" pitchFamily="34" charset="0"/>
-              </a:rPr>
-              <a:t>stiam</a:t>
-            </a:r>
-            <a:r>
-              <a:rPr lang="en-US" sz="572" dirty="0">
-                <a:solidFill>
-                  <a:prstClr val="black"/>
-                </a:solidFill>
-                <a:latin typeface="Arial" panose="020B0604020202020204" pitchFamily="34" charset="0"/>
-                <a:cs typeface="Arial" panose="020B0604020202020204" pitchFamily="34" charset="0"/>
-              </a:rPr>
-              <a:t>, </a:t>
-            </a:r>
-            <a:r>
-              <a:rPr lang="en-US" sz="572" dirty="0" err="1">
-                <a:solidFill>
-                  <a:prstClr val="black"/>
-                </a:solidFill>
-                <a:latin typeface="Arial" panose="020B0604020202020204" pitchFamily="34" charset="0"/>
-                <a:cs typeface="Arial" panose="020B0604020202020204" pitchFamily="34" charset="0"/>
-              </a:rPr>
-              <a:t>cus</a:t>
-            </a:r>
-            <a:r>
-              <a:rPr lang="en-US" sz="572" dirty="0">
-                <a:solidFill>
-                  <a:prstClr val="black"/>
-                </a:solidFill>
-                <a:latin typeface="Arial" panose="020B0604020202020204" pitchFamily="34" charset="0"/>
-                <a:cs typeface="Arial" panose="020B0604020202020204" pitchFamily="34" charset="0"/>
-              </a:rPr>
-              <a:t> </a:t>
-            </a:r>
-            <a:r>
-              <a:rPr lang="en-US" sz="572" dirty="0" err="1">
-                <a:solidFill>
-                  <a:prstClr val="black"/>
-                </a:solidFill>
-                <a:latin typeface="Arial" panose="020B0604020202020204" pitchFamily="34" charset="0"/>
-                <a:cs typeface="Arial" panose="020B0604020202020204" pitchFamily="34" charset="0"/>
-              </a:rPr>
-              <a:t>eos</a:t>
-            </a:r>
-            <a:r>
-              <a:rPr lang="en-US" sz="572" dirty="0">
-                <a:solidFill>
-                  <a:prstClr val="black"/>
-                </a:solidFill>
-                <a:latin typeface="Arial" panose="020B0604020202020204" pitchFamily="34" charset="0"/>
-                <a:cs typeface="Arial" panose="020B0604020202020204" pitchFamily="34" charset="0"/>
-              </a:rPr>
-              <a:t> </a:t>
-            </a:r>
-            <a:r>
-              <a:rPr lang="en-US" sz="572" dirty="0" err="1">
-                <a:solidFill>
-                  <a:prstClr val="black"/>
-                </a:solidFill>
-                <a:latin typeface="Arial" panose="020B0604020202020204" pitchFamily="34" charset="0"/>
-                <a:cs typeface="Arial" panose="020B0604020202020204" pitchFamily="34" charset="0"/>
-              </a:rPr>
-              <a:t>sime</a:t>
-            </a:r>
-            <a:r>
-              <a:rPr lang="en-US" sz="572" dirty="0">
-                <a:solidFill>
-                  <a:prstClr val="black"/>
-                </a:solidFill>
-                <a:latin typeface="Arial" panose="020B0604020202020204" pitchFamily="34" charset="0"/>
-                <a:cs typeface="Arial" panose="020B0604020202020204" pitchFamily="34" charset="0"/>
-              </a:rPr>
-              <a:t> </a:t>
-            </a:r>
-            <a:r>
-              <a:rPr lang="en-US" sz="572" dirty="0" err="1">
-                <a:solidFill>
-                  <a:prstClr val="black"/>
-                </a:solidFill>
-                <a:latin typeface="Arial" panose="020B0604020202020204" pitchFamily="34" charset="0"/>
-                <a:cs typeface="Arial" panose="020B0604020202020204" pitchFamily="34" charset="0"/>
-              </a:rPr>
-              <a:t>sed</a:t>
-            </a:r>
-            <a:r>
-              <a:rPr lang="en-US" sz="572" dirty="0">
-                <a:solidFill>
-                  <a:prstClr val="black"/>
-                </a:solidFill>
-                <a:latin typeface="Arial" panose="020B0604020202020204" pitchFamily="34" charset="0"/>
-                <a:cs typeface="Arial" panose="020B0604020202020204" pitchFamily="34" charset="0"/>
-              </a:rPr>
-              <a:t> que </a:t>
-            </a:r>
-            <a:r>
-              <a:rPr lang="en-US" sz="572" dirty="0" err="1">
-                <a:solidFill>
-                  <a:prstClr val="black"/>
-                </a:solidFill>
-                <a:latin typeface="Arial" panose="020B0604020202020204" pitchFamily="34" charset="0"/>
-                <a:cs typeface="Arial" panose="020B0604020202020204" pitchFamily="34" charset="0"/>
-              </a:rPr>
-              <a:t>occupta</a:t>
-            </a:r>
-            <a:r>
-              <a:rPr lang="en-US" sz="572" dirty="0">
-                <a:solidFill>
-                  <a:prstClr val="black"/>
-                </a:solidFill>
-                <a:latin typeface="Arial" panose="020B0604020202020204" pitchFamily="34" charset="0"/>
-                <a:cs typeface="Arial" panose="020B0604020202020204" pitchFamily="34" charset="0"/>
-              </a:rPr>
-              <a:t> </a:t>
-            </a:r>
-            <a:r>
-              <a:rPr lang="en-US" sz="572" dirty="0" err="1">
-                <a:solidFill>
-                  <a:prstClr val="black"/>
-                </a:solidFill>
-                <a:latin typeface="Arial" panose="020B0604020202020204" pitchFamily="34" charset="0"/>
-                <a:cs typeface="Arial" panose="020B0604020202020204" pitchFamily="34" charset="0"/>
-              </a:rPr>
-              <a:t>temquia</a:t>
-            </a:r>
-            <a:r>
-              <a:rPr lang="en-US" sz="572" dirty="0">
-                <a:solidFill>
-                  <a:prstClr val="black"/>
-                </a:solidFill>
-                <a:latin typeface="Arial" panose="020B0604020202020204" pitchFamily="34" charset="0"/>
-                <a:cs typeface="Arial" panose="020B0604020202020204" pitchFamily="34" charset="0"/>
-              </a:rPr>
-              <a:t> </a:t>
-            </a:r>
-            <a:r>
-              <a:rPr lang="en-US" sz="572" dirty="0" err="1">
-                <a:solidFill>
-                  <a:prstClr val="black"/>
-                </a:solidFill>
-                <a:latin typeface="Arial" panose="020B0604020202020204" pitchFamily="34" charset="0"/>
-                <a:cs typeface="Arial" panose="020B0604020202020204" pitchFamily="34" charset="0"/>
-              </a:rPr>
-              <a:t>nobisciur</a:t>
-            </a:r>
-            <a:r>
-              <a:rPr lang="en-US" sz="572" dirty="0">
-                <a:solidFill>
-                  <a:prstClr val="black"/>
-                </a:solidFill>
-                <a:latin typeface="Arial" panose="020B0604020202020204" pitchFamily="34" charset="0"/>
-                <a:cs typeface="Arial" panose="020B0604020202020204" pitchFamily="34" charset="0"/>
-              </a:rPr>
-              <a:t>? </a:t>
-            </a:r>
-            <a:r>
-              <a:rPr lang="en-US" sz="572" dirty="0" err="1">
-                <a:solidFill>
-                  <a:prstClr val="black"/>
-                </a:solidFill>
-                <a:latin typeface="Arial" panose="020B0604020202020204" pitchFamily="34" charset="0"/>
-                <a:cs typeface="Arial" panose="020B0604020202020204" pitchFamily="34" charset="0"/>
-              </a:rPr>
-              <a:t>Quis</a:t>
-            </a:r>
-            <a:r>
-              <a:rPr lang="en-US" sz="572" dirty="0">
-                <a:solidFill>
-                  <a:prstClr val="black"/>
-                </a:solidFill>
-                <a:latin typeface="Arial" panose="020B0604020202020204" pitchFamily="34" charset="0"/>
-                <a:cs typeface="Arial" panose="020B0604020202020204" pitchFamily="34" charset="0"/>
-              </a:rPr>
-              <a:t> </a:t>
-            </a:r>
-            <a:r>
-              <a:rPr lang="en-US" sz="572" dirty="0" err="1">
-                <a:solidFill>
-                  <a:prstClr val="black"/>
-                </a:solidFill>
-                <a:latin typeface="Arial" panose="020B0604020202020204" pitchFamily="34" charset="0"/>
-                <a:cs typeface="Arial" panose="020B0604020202020204" pitchFamily="34" charset="0"/>
-              </a:rPr>
-              <a:t>dolenem</a:t>
-            </a:r>
-            <a:r>
-              <a:rPr lang="en-US" sz="572" dirty="0">
-                <a:solidFill>
-                  <a:prstClr val="black"/>
-                </a:solidFill>
-                <a:latin typeface="Arial" panose="020B0604020202020204" pitchFamily="34" charset="0"/>
-                <a:cs typeface="Arial" panose="020B0604020202020204" pitchFamily="34" charset="0"/>
-              </a:rPr>
-              <a:t> </a:t>
-            </a:r>
-            <a:r>
-              <a:rPr lang="en-US" sz="572" dirty="0" err="1">
-                <a:solidFill>
-                  <a:prstClr val="black"/>
-                </a:solidFill>
-                <a:latin typeface="Arial" panose="020B0604020202020204" pitchFamily="34" charset="0"/>
-                <a:cs typeface="Arial" panose="020B0604020202020204" pitchFamily="34" charset="0"/>
-              </a:rPr>
-              <a:t>oluptam</a:t>
-            </a:r>
-            <a:r>
-              <a:rPr lang="en-US" sz="572" dirty="0">
-                <a:solidFill>
-                  <a:prstClr val="black"/>
-                </a:solidFill>
-                <a:latin typeface="Arial" panose="020B0604020202020204" pitchFamily="34" charset="0"/>
-                <a:cs typeface="Arial" panose="020B0604020202020204" pitchFamily="34" charset="0"/>
-              </a:rPr>
-              <a:t> ne </a:t>
-            </a:r>
-            <a:r>
-              <a:rPr lang="en-US" sz="572" dirty="0" err="1">
-                <a:solidFill>
-                  <a:prstClr val="black"/>
-                </a:solidFill>
-                <a:latin typeface="Arial" panose="020B0604020202020204" pitchFamily="34" charset="0"/>
-                <a:cs typeface="Arial" panose="020B0604020202020204" pitchFamily="34" charset="0"/>
-              </a:rPr>
-              <a:t>nonessumqui</a:t>
-            </a:r>
-            <a:r>
-              <a:rPr lang="en-US" sz="572" dirty="0">
-                <a:solidFill>
-                  <a:prstClr val="black"/>
-                </a:solidFill>
-                <a:latin typeface="Arial" panose="020B0604020202020204" pitchFamily="34" charset="0"/>
-                <a:cs typeface="Arial" panose="020B0604020202020204" pitchFamily="34" charset="0"/>
-              </a:rPr>
-              <a:t> </a:t>
-            </a:r>
-            <a:r>
-              <a:rPr lang="en-US" sz="572" dirty="0" err="1">
-                <a:solidFill>
-                  <a:prstClr val="black"/>
-                </a:solidFill>
-                <a:latin typeface="Arial" panose="020B0604020202020204" pitchFamily="34" charset="0"/>
-                <a:cs typeface="Arial" panose="020B0604020202020204" pitchFamily="34" charset="0"/>
-              </a:rPr>
-              <a:t>doluptatem</a:t>
-            </a:r>
-            <a:r>
-              <a:rPr lang="en-US" sz="572" dirty="0">
-                <a:solidFill>
-                  <a:prstClr val="black"/>
-                </a:solidFill>
-                <a:latin typeface="Arial" panose="020B0604020202020204" pitchFamily="34" charset="0"/>
-                <a:cs typeface="Arial" panose="020B0604020202020204" pitchFamily="34" charset="0"/>
-              </a:rPr>
-              <a:t> </a:t>
-            </a:r>
-            <a:r>
-              <a:rPr lang="en-US" sz="572" dirty="0" err="1">
-                <a:solidFill>
-                  <a:prstClr val="black"/>
-                </a:solidFill>
-                <a:latin typeface="Arial" panose="020B0604020202020204" pitchFamily="34" charset="0"/>
-                <a:cs typeface="Arial" panose="020B0604020202020204" pitchFamily="34" charset="0"/>
-              </a:rPr>
-              <a:t>exeribus</a:t>
-            </a:r>
-            <a:r>
-              <a:rPr lang="en-US" sz="572" dirty="0">
-                <a:solidFill>
-                  <a:prstClr val="black"/>
-                </a:solidFill>
-                <a:latin typeface="Arial" panose="020B0604020202020204" pitchFamily="34" charset="0"/>
-                <a:cs typeface="Arial" panose="020B0604020202020204" pitchFamily="34" charset="0"/>
-              </a:rPr>
-              <a:t> id </a:t>
-            </a:r>
-            <a:r>
-              <a:rPr lang="en-US" sz="572" dirty="0" err="1">
-                <a:solidFill>
-                  <a:prstClr val="black"/>
-                </a:solidFill>
-                <a:latin typeface="Arial" panose="020B0604020202020204" pitchFamily="34" charset="0"/>
-                <a:cs typeface="Arial" panose="020B0604020202020204" pitchFamily="34" charset="0"/>
-              </a:rPr>
-              <a:t>eveliquam</a:t>
-            </a:r>
-            <a:r>
-              <a:rPr lang="en-US" sz="572" dirty="0">
-                <a:solidFill>
-                  <a:prstClr val="black"/>
-                </a:solidFill>
-                <a:latin typeface="Arial" panose="020B0604020202020204" pitchFamily="34" charset="0"/>
-                <a:cs typeface="Arial" panose="020B0604020202020204" pitchFamily="34" charset="0"/>
-              </a:rPr>
-              <a:t> qui </a:t>
-            </a:r>
-            <a:r>
-              <a:rPr lang="en-US" sz="572" dirty="0" err="1">
-                <a:solidFill>
-                  <a:prstClr val="black"/>
-                </a:solidFill>
-                <a:latin typeface="Arial" panose="020B0604020202020204" pitchFamily="34" charset="0"/>
-                <a:cs typeface="Arial" panose="020B0604020202020204" pitchFamily="34" charset="0"/>
-              </a:rPr>
-              <a:t>nisqui</a:t>
-            </a:r>
-            <a:r>
-              <a:rPr lang="en-US" sz="572" dirty="0">
-                <a:solidFill>
-                  <a:prstClr val="black"/>
-                </a:solidFill>
-                <a:latin typeface="Arial" panose="020B0604020202020204" pitchFamily="34" charset="0"/>
-                <a:cs typeface="Arial" panose="020B0604020202020204" pitchFamily="34" charset="0"/>
-              </a:rPr>
-              <a:t> </a:t>
-            </a:r>
-            <a:r>
-              <a:rPr lang="en-US" sz="572" dirty="0" err="1">
-                <a:solidFill>
-                  <a:prstClr val="black"/>
-                </a:solidFill>
-                <a:latin typeface="Arial" panose="020B0604020202020204" pitchFamily="34" charset="0"/>
-                <a:cs typeface="Arial" panose="020B0604020202020204" pitchFamily="34" charset="0"/>
-              </a:rPr>
-              <a:t>atet</a:t>
-            </a:r>
-            <a:r>
-              <a:rPr lang="en-US" sz="572" dirty="0">
-                <a:solidFill>
-                  <a:prstClr val="black"/>
-                </a:solidFill>
-                <a:latin typeface="Arial" panose="020B0604020202020204" pitchFamily="34" charset="0"/>
-                <a:cs typeface="Arial" panose="020B0604020202020204" pitchFamily="34" charset="0"/>
-              </a:rPr>
-              <a:t> </a:t>
-            </a:r>
-            <a:r>
-              <a:rPr lang="en-US" sz="572" dirty="0" err="1">
-                <a:solidFill>
-                  <a:prstClr val="black"/>
-                </a:solidFill>
-                <a:latin typeface="Arial" panose="020B0604020202020204" pitchFamily="34" charset="0"/>
-                <a:cs typeface="Arial" panose="020B0604020202020204" pitchFamily="34" charset="0"/>
-              </a:rPr>
-              <a:t>eiciunt</a:t>
-            </a:r>
-            <a:r>
-              <a:rPr lang="en-US" sz="572" dirty="0">
-                <a:solidFill>
-                  <a:prstClr val="black"/>
-                </a:solidFill>
-                <a:latin typeface="Arial" panose="020B0604020202020204" pitchFamily="34" charset="0"/>
-                <a:cs typeface="Arial" panose="020B0604020202020204" pitchFamily="34" charset="0"/>
-              </a:rPr>
-              <a:t>.</a:t>
-            </a:r>
-          </a:p>
-        </p:txBody>
-      </p:sp>
+      <mc:AlternateContent xmlns:mc="http://schemas.openxmlformats.org/markup-compatibility/2006">
+        <mc:Choice xmlns:a14="http://schemas.microsoft.com/office/drawing/2010/main" Requires="a14">
+          <p:sp>
+            <p:nvSpPr>
+              <p:cNvPr id="50" name="TextBox 49">
+                <a:extLst>
+                  <a:ext uri="{FF2B5EF4-FFF2-40B4-BE49-F238E27FC236}">
+                    <a16:creationId xmlns:a16="http://schemas.microsoft.com/office/drawing/2014/main" id="{79C029F1-D5E2-A842-A19B-DC4969111E24}"/>
+                  </a:ext>
+                </a:extLst>
+              </p:cNvPr>
+              <p:cNvSpPr txBox="1"/>
+              <p:nvPr/>
+            </p:nvSpPr>
+            <p:spPr>
+              <a:xfrm>
+                <a:off x="7845698" y="2600046"/>
+                <a:ext cx="2597105" cy="1361911"/>
+              </a:xfrm>
+              <a:prstGeom prst="rect">
+                <a:avLst/>
+              </a:prstGeom>
+              <a:noFill/>
+            </p:spPr>
+            <p:txBody>
+              <a:bodyPr wrap="square" rtlCol="0">
+                <a:spAutoFit/>
+              </a:bodyPr>
+              <a:lstStyle/>
+              <a:p>
+                <a:pPr defTabSz="780653"/>
+                <a:r>
+                  <a:rPr lang="en-US" sz="572" dirty="0">
+                    <a:solidFill>
+                      <a:prstClr val="black"/>
+                    </a:solidFill>
+                    <a:latin typeface="Arial" panose="020B0604020202020204" pitchFamily="34" charset="0"/>
+                    <a:cs typeface="Arial" panose="020B0604020202020204" pitchFamily="34" charset="0"/>
+                  </a:rPr>
+                  <a:t>I concluded that the experimental results confirm the theoretical relationships governing capacitance in parallel plate capacitors. As plate separation increased from 2 mm to 7 mm, capacitance decreased significantly; demonstrating that the expected inverse dependence on distance. Conversely, increasing plate area from </a:t>
+                </a:r>
+                <a14:m>
+                  <m:oMath xmlns:m="http://schemas.openxmlformats.org/officeDocument/2006/math">
+                    <m:r>
+                      <a:rPr lang="en-US" sz="572" b="0" i="1" smtClean="0">
+                        <a:solidFill>
+                          <a:prstClr val="black"/>
+                        </a:solidFill>
+                        <a:latin typeface="Cambria Math" panose="02040503050406030204" pitchFamily="18" charset="0"/>
+                        <a:cs typeface="Arial" panose="020B0604020202020204" pitchFamily="34" charset="0"/>
+                      </a:rPr>
+                      <m:t>100 </m:t>
+                    </m:r>
+                    <m:r>
+                      <a:rPr lang="en-US" sz="572" b="0" i="1" smtClean="0">
+                        <a:solidFill>
+                          <a:prstClr val="black"/>
+                        </a:solidFill>
+                        <a:latin typeface="Cambria Math" panose="02040503050406030204" pitchFamily="18" charset="0"/>
+                        <a:cs typeface="Arial" panose="020B0604020202020204" pitchFamily="34" charset="0"/>
+                      </a:rPr>
+                      <m:t>𝑚</m:t>
+                    </m:r>
+                    <m:sSup>
+                      <m:sSupPr>
+                        <m:ctrlPr>
+                          <a:rPr lang="en-US" sz="572" b="0" i="1" smtClean="0">
+                            <a:solidFill>
+                              <a:prstClr val="black"/>
+                            </a:solidFill>
+                            <a:latin typeface="Cambria Math" panose="02040503050406030204" pitchFamily="18" charset="0"/>
+                            <a:cs typeface="Arial" panose="020B0604020202020204" pitchFamily="34" charset="0"/>
+                          </a:rPr>
+                        </m:ctrlPr>
+                      </m:sSupPr>
+                      <m:e>
+                        <m:r>
+                          <a:rPr lang="en-US" sz="572" b="0" i="1" smtClean="0">
+                            <a:solidFill>
+                              <a:prstClr val="black"/>
+                            </a:solidFill>
+                            <a:latin typeface="Cambria Math" panose="02040503050406030204" pitchFamily="18" charset="0"/>
+                            <a:cs typeface="Arial" panose="020B0604020202020204" pitchFamily="34" charset="0"/>
+                          </a:rPr>
+                          <m:t>𝑚</m:t>
+                        </m:r>
+                      </m:e>
+                      <m:sup>
+                        <m:r>
+                          <a:rPr lang="en-US" sz="572" b="0" i="1" smtClean="0">
+                            <a:solidFill>
+                              <a:prstClr val="black"/>
+                            </a:solidFill>
+                            <a:latin typeface="Cambria Math" panose="02040503050406030204" pitchFamily="18" charset="0"/>
+                            <a:cs typeface="Arial" panose="020B0604020202020204" pitchFamily="34" charset="0"/>
+                          </a:rPr>
+                          <m:t>2</m:t>
+                        </m:r>
+                      </m:sup>
+                    </m:sSup>
+                  </m:oMath>
+                </a14:m>
+                <a:r>
+                  <a:rPr lang="en-US" sz="572" dirty="0">
+                    <a:solidFill>
+                      <a:prstClr val="black"/>
+                    </a:solidFill>
+                    <a:latin typeface="Arial" panose="020B0604020202020204" pitchFamily="34" charset="0"/>
+                    <a:cs typeface="Arial" panose="020B0604020202020204" pitchFamily="34" charset="0"/>
+                  </a:rPr>
+                  <a:t> to </a:t>
+                </a:r>
+                <a14:m>
+                  <m:oMath xmlns:m="http://schemas.openxmlformats.org/officeDocument/2006/math">
+                    <m:r>
+                      <a:rPr lang="en-US" sz="572" b="0" i="1" smtClean="0">
+                        <a:solidFill>
+                          <a:prstClr val="black"/>
+                        </a:solidFill>
+                        <a:latin typeface="Cambria Math" panose="02040503050406030204" pitchFamily="18" charset="0"/>
+                        <a:cs typeface="Arial" panose="020B0604020202020204" pitchFamily="34" charset="0"/>
+                      </a:rPr>
+                      <m:t>150 </m:t>
+                    </m:r>
+                    <m:r>
+                      <a:rPr lang="en-US" sz="572" b="0" i="1" smtClean="0">
+                        <a:solidFill>
+                          <a:prstClr val="black"/>
+                        </a:solidFill>
+                        <a:latin typeface="Cambria Math" panose="02040503050406030204" pitchFamily="18" charset="0"/>
+                        <a:cs typeface="Arial" panose="020B0604020202020204" pitchFamily="34" charset="0"/>
+                      </a:rPr>
+                      <m:t>𝑚</m:t>
+                    </m:r>
+                    <m:sSup>
+                      <m:sSupPr>
+                        <m:ctrlPr>
+                          <a:rPr lang="en-US" sz="572" b="0" i="1" smtClean="0">
+                            <a:solidFill>
+                              <a:prstClr val="black"/>
+                            </a:solidFill>
+                            <a:latin typeface="Cambria Math" panose="02040503050406030204" pitchFamily="18" charset="0"/>
+                            <a:cs typeface="Arial" panose="020B0604020202020204" pitchFamily="34" charset="0"/>
+                          </a:rPr>
+                        </m:ctrlPr>
+                      </m:sSupPr>
+                      <m:e>
+                        <m:r>
+                          <a:rPr lang="en-US" sz="572" b="0" i="1" smtClean="0">
+                            <a:solidFill>
+                              <a:prstClr val="black"/>
+                            </a:solidFill>
+                            <a:latin typeface="Cambria Math" panose="02040503050406030204" pitchFamily="18" charset="0"/>
+                            <a:cs typeface="Arial" panose="020B0604020202020204" pitchFamily="34" charset="0"/>
+                          </a:rPr>
+                          <m:t>𝑚</m:t>
+                        </m:r>
+                      </m:e>
+                      <m:sup>
+                        <m:r>
+                          <a:rPr lang="en-US" sz="572" b="0" i="1" smtClean="0">
+                            <a:solidFill>
+                              <a:prstClr val="black"/>
+                            </a:solidFill>
+                            <a:latin typeface="Cambria Math" panose="02040503050406030204" pitchFamily="18" charset="0"/>
+                            <a:cs typeface="Arial" panose="020B0604020202020204" pitchFamily="34" charset="0"/>
+                          </a:rPr>
+                          <m:t>2</m:t>
+                        </m:r>
+                      </m:sup>
+                    </m:sSup>
+                  </m:oMath>
+                </a14:m>
+                <a:r>
+                  <a:rPr lang="en-US" sz="572" dirty="0">
+                    <a:solidFill>
+                      <a:prstClr val="black"/>
+                    </a:solidFill>
+                    <a:latin typeface="Arial" panose="020B0604020202020204" pitchFamily="34" charset="0"/>
+                    <a:cs typeface="Arial" panose="020B0604020202020204" pitchFamily="34" charset="0"/>
+                  </a:rPr>
+                  <a:t> produced a clear rise in capacitance, consistent with the direct proportionality predicted by the capacitance formula </a:t>
+                </a:r>
+                <a14:m>
+                  <m:oMath xmlns:m="http://schemas.openxmlformats.org/officeDocument/2006/math">
+                    <m:r>
+                      <a:rPr lang="en-US" sz="572" b="0" i="1" smtClean="0">
+                        <a:solidFill>
+                          <a:prstClr val="black"/>
+                        </a:solidFill>
+                        <a:latin typeface="Cambria Math" panose="02040503050406030204" pitchFamily="18" charset="0"/>
+                        <a:cs typeface="Arial" panose="020B0604020202020204" pitchFamily="34" charset="0"/>
+                      </a:rPr>
+                      <m:t>𝐶</m:t>
+                    </m:r>
+                    <m:r>
+                      <a:rPr lang="en-US" sz="572" b="0" i="1" smtClean="0">
+                        <a:solidFill>
+                          <a:prstClr val="black"/>
+                        </a:solidFill>
+                        <a:latin typeface="Cambria Math" panose="02040503050406030204" pitchFamily="18" charset="0"/>
+                        <a:cs typeface="Arial" panose="020B0604020202020204" pitchFamily="34" charset="0"/>
+                      </a:rPr>
+                      <m:t>=</m:t>
+                    </m:r>
+                    <m:sSub>
+                      <m:sSubPr>
+                        <m:ctrlPr>
+                          <a:rPr lang="en-US" sz="572" b="0" i="1" smtClean="0">
+                            <a:solidFill>
+                              <a:prstClr val="black"/>
+                            </a:solidFill>
+                            <a:latin typeface="Cambria Math" panose="02040503050406030204" pitchFamily="18" charset="0"/>
+                            <a:cs typeface="Arial" panose="020B0604020202020204" pitchFamily="34" charset="0"/>
+                          </a:rPr>
+                        </m:ctrlPr>
+                      </m:sSubPr>
+                      <m:e>
+                        <m:r>
+                          <a:rPr lang="en-US" sz="572" b="0" i="1" smtClean="0">
+                            <a:solidFill>
+                              <a:prstClr val="black"/>
+                            </a:solidFill>
+                            <a:latin typeface="Cambria Math" panose="02040503050406030204" pitchFamily="18" charset="0"/>
+                            <a:cs typeface="Arial" panose="020B0604020202020204" pitchFamily="34" charset="0"/>
+                          </a:rPr>
+                          <m:t>𝜖</m:t>
+                        </m:r>
+                      </m:e>
+                      <m:sub>
+                        <m:r>
+                          <a:rPr lang="en-US" sz="572" b="0" i="1" smtClean="0">
+                            <a:solidFill>
+                              <a:prstClr val="black"/>
+                            </a:solidFill>
+                            <a:latin typeface="Cambria Math" panose="02040503050406030204" pitchFamily="18" charset="0"/>
+                            <a:cs typeface="Arial" panose="020B0604020202020204" pitchFamily="34" charset="0"/>
+                          </a:rPr>
+                          <m:t>0</m:t>
+                        </m:r>
+                      </m:sub>
+                    </m:sSub>
+                    <m:f>
+                      <m:fPr>
+                        <m:ctrlPr>
+                          <a:rPr lang="en-US" sz="572" b="0" i="1" smtClean="0">
+                            <a:solidFill>
+                              <a:prstClr val="black"/>
+                            </a:solidFill>
+                            <a:latin typeface="Cambria Math" panose="02040503050406030204" pitchFamily="18" charset="0"/>
+                            <a:cs typeface="Arial" panose="020B0604020202020204" pitchFamily="34" charset="0"/>
+                          </a:rPr>
+                        </m:ctrlPr>
+                      </m:fPr>
+                      <m:num>
+                        <m:r>
+                          <a:rPr lang="en-US" sz="572" b="0" i="1" smtClean="0">
+                            <a:solidFill>
+                              <a:prstClr val="black"/>
+                            </a:solidFill>
+                            <a:latin typeface="Cambria Math" panose="02040503050406030204" pitchFamily="18" charset="0"/>
+                            <a:cs typeface="Arial" panose="020B0604020202020204" pitchFamily="34" charset="0"/>
+                          </a:rPr>
+                          <m:t>𝐴</m:t>
+                        </m:r>
+                      </m:num>
+                      <m:den>
+                        <m:r>
+                          <a:rPr lang="en-US" sz="572" b="0" i="1" smtClean="0">
+                            <a:solidFill>
+                              <a:prstClr val="black"/>
+                            </a:solidFill>
+                            <a:latin typeface="Cambria Math" panose="02040503050406030204" pitchFamily="18" charset="0"/>
+                            <a:cs typeface="Arial" panose="020B0604020202020204" pitchFamily="34" charset="0"/>
+                          </a:rPr>
+                          <m:t>𝑑</m:t>
+                        </m:r>
+                      </m:den>
+                    </m:f>
+                  </m:oMath>
+                </a14:m>
+                <a:r>
+                  <a:rPr lang="en-US" sz="572" dirty="0">
+                    <a:solidFill>
+                      <a:prstClr val="black"/>
+                    </a:solidFill>
+                    <a:latin typeface="Arial" panose="020B0604020202020204" pitchFamily="34" charset="0"/>
+                    <a:cs typeface="Arial" panose="020B0604020202020204" pitchFamily="34" charset="0"/>
+                  </a:rPr>
+                  <a:t>. Statistical analysis showed that both trends were highly significant, reinforcing the validity of the theoretical model. These findings highlight how geometric factors strongly influence energy storage in capacitors, with plate separation exerting a greater effect than plate area within the tested ranges. Overall, the experiment successfully verified the fundamental principles of electrostatics and demonstrated the practical importance of capacitor design parameters.</a:t>
+                </a:r>
+              </a:p>
+            </p:txBody>
+          </p:sp>
+        </mc:Choice>
+        <mc:Fallback>
+          <p:sp>
+            <p:nvSpPr>
+              <p:cNvPr id="50" name="TextBox 49">
+                <a:extLst>
+                  <a:ext uri="{FF2B5EF4-FFF2-40B4-BE49-F238E27FC236}">
+                    <a16:creationId xmlns:a16="http://schemas.microsoft.com/office/drawing/2014/main" id="{79C029F1-D5E2-A842-A19B-DC4969111E24}"/>
+                  </a:ext>
+                </a:extLst>
+              </p:cNvPr>
+              <p:cNvSpPr txBox="1">
+                <a:spLocks noRot="1" noChangeAspect="1" noMove="1" noResize="1" noEditPoints="1" noAdjustHandles="1" noChangeArrowheads="1" noChangeShapeType="1" noTextEdit="1"/>
+              </p:cNvSpPr>
+              <p:nvPr/>
+            </p:nvSpPr>
+            <p:spPr>
+              <a:xfrm>
+                <a:off x="7845698" y="2600046"/>
+                <a:ext cx="2597105" cy="1361911"/>
+              </a:xfrm>
+              <a:prstGeom prst="rect">
+                <a:avLst/>
+              </a:prstGeom>
+              <a:blipFill>
+                <a:blip r:embed="rId6"/>
+                <a:stretch>
+                  <a:fillRect/>
+                </a:stretch>
+              </a:blipFill>
+            </p:spPr>
+            <p:txBody>
+              <a:bodyPr/>
+              <a:lstStyle/>
+              <a:p>
+                <a:r>
+                  <a:rPr lang="es-ES">
+                    <a:noFill/>
+                  </a:rPr>
+                  <a:t> </a:t>
+                </a:r>
+              </a:p>
+            </p:txBody>
+          </p:sp>
+        </mc:Fallback>
+      </mc:AlternateContent>
       <mc:AlternateContent xmlns:mc="http://schemas.openxmlformats.org/markup-compatibility/2006">
         <mc:Choice xmlns:a14="http://schemas.microsoft.com/office/drawing/2010/main" Requires="a14">
           <p:sp>
@@ -11282,7 +11579,7 @@
                 <a:avLst/>
               </a:prstGeom>
               <a:blipFill>
-                <a:blip r:embed="rId5"/>
+                <a:blip r:embed="rId7"/>
                 <a:stretch>
                   <a:fillRect/>
                 </a:stretch>
@@ -11305,70 +11602,6 @@
       </mc:AlternateContent>
       <p:sp>
         <p:nvSpPr>
-          <p:cNvPr id="55" name="Rectangle 54">
-            <a:extLst>
-              <a:ext uri="{FF2B5EF4-FFF2-40B4-BE49-F238E27FC236}">
-                <a16:creationId xmlns:a16="http://schemas.microsoft.com/office/drawing/2014/main" id="{932F4CD2-D53A-6945-A147-AA4161801A71}"/>
-              </a:ext>
-            </a:extLst>
-          </p:cNvPr>
-          <p:cNvSpPr/>
-          <p:nvPr/>
-        </p:nvSpPr>
-        <p:spPr>
-          <a:xfrm>
-            <a:off x="7873433" y="1845712"/>
-            <a:ext cx="2547257" cy="1641003"/>
-          </a:xfrm>
-          <a:prstGeom prst="rect">
-            <a:avLst/>
-          </a:prstGeom>
-          <a:solidFill>
-            <a:schemeClr val="accent3">
-              <a:lumMod val="40000"/>
-              <a:lumOff val="60000"/>
-            </a:schemeClr>
-          </a:solidFill>
-          <a:ln>
-            <a:noFill/>
-          </a:ln>
-        </p:spPr>
-        <p:style>
-          <a:lnRef idx="2">
-            <a:schemeClr val="accent1">
-              <a:shade val="50000"/>
-            </a:schemeClr>
-          </a:lnRef>
-          <a:fillRef idx="1">
-            <a:schemeClr val="accent1"/>
-          </a:fillRef>
-          <a:effectRef idx="0">
-            <a:schemeClr val="accent1"/>
-          </a:effectRef>
-          <a:fontRef idx="minor">
-            <a:schemeClr val="lt1"/>
-          </a:fontRef>
-        </p:style>
-        <p:txBody>
-          <a:bodyPr rtlCol="0" anchor="ctr"/>
-          <a:lstStyle/>
-          <a:p>
-            <a:pPr algn="ctr" defTabSz="780653"/>
-            <a:r>
-              <a:rPr lang="en-US" sz="1281" dirty="0">
-                <a:solidFill>
-                  <a:prstClr val="white"/>
-                </a:solidFill>
-                <a:latin typeface="Arial" panose="020B0604020202020204" pitchFamily="34" charset="0"/>
-                <a:cs typeface="Arial" panose="020B0604020202020204" pitchFamily="34" charset="0"/>
-              </a:rPr>
-              <a:t>figures</a:t>
-            </a:r>
-          </a:p>
-        </p:txBody>
-      </p:sp>
-      <p:sp>
-        <p:nvSpPr>
           <p:cNvPr id="37" name="TextBox 36">
             <a:extLst>
               <a:ext uri="{FF2B5EF4-FFF2-40B4-BE49-F238E27FC236}">
@@ -11525,7 +11758,7 @@
           <p:nvPr/>
         </p:nvPicPr>
         <p:blipFill>
-          <a:blip r:embed="rId6"/>
+          <a:blip r:embed="rId8"/>
           <a:stretch>
             <a:fillRect/>
           </a:stretch>
@@ -11575,7 +11808,7 @@
             <p:nvPr/>
           </p:nvPicPr>
           <p:blipFill>
-            <a:blip r:embed="rId7">
+            <a:blip r:embed="rId9">
               <a:extLst>
                 <a:ext uri="{28A0092B-C50C-407E-A947-70E740481C1C}">
                   <a14:useLocalDpi xmlns:a14="http://schemas.microsoft.com/office/drawing/2010/main" val="0"/>
@@ -11689,7 +11922,7 @@
             <p:nvPr/>
           </p:nvPicPr>
           <p:blipFill>
-            <a:blip r:embed="rId8">
+            <a:blip r:embed="rId10">
               <a:extLst>
                 <a:ext uri="{28A0092B-C50C-407E-A947-70E740481C1C}">
                   <a14:useLocalDpi xmlns:a14="http://schemas.microsoft.com/office/drawing/2010/main" val="0"/>
@@ -11783,7 +12016,7 @@
           <p:nvPr/>
         </p:nvPicPr>
         <p:blipFill>
-          <a:blip r:embed="rId9"/>
+          <a:blip r:embed="rId11"/>
           <a:stretch>
             <a:fillRect/>
           </a:stretch>
@@ -11798,6 +12031,157 @@
           </a:prstGeom>
         </p:spPr>
       </p:pic>
+      <p:sp>
+        <p:nvSpPr>
+          <p:cNvPr id="12" name="CuadroTexto 11">
+            <a:extLst>
+              <a:ext uri="{FF2B5EF4-FFF2-40B4-BE49-F238E27FC236}">
+                <a16:creationId xmlns:a16="http://schemas.microsoft.com/office/drawing/2014/main" id="{F99076AB-CD48-1D9C-24C3-8E5BC7671CED}"/>
+              </a:ext>
+            </a:extLst>
+          </p:cNvPr>
+          <p:cNvSpPr txBox="1"/>
+          <p:nvPr/>
+        </p:nvSpPr>
+        <p:spPr>
+          <a:xfrm>
+            <a:off x="7983415" y="1777442"/>
+            <a:ext cx="2350477" cy="830997"/>
+          </a:xfrm>
+          <a:prstGeom prst="rect">
+            <a:avLst/>
+          </a:prstGeom>
+          <a:noFill/>
+        </p:spPr>
+        <p:txBody>
+          <a:bodyPr wrap="square" rtlCol="0">
+            <a:spAutoFit/>
+          </a:bodyPr>
+          <a:lstStyle/>
+          <a:p>
+            <a:r>
+              <a:rPr lang="es-ES" sz="600" dirty="0">
+                <a:latin typeface="Source Code Pro Light" panose="020B0409030403020204" pitchFamily="49" charset="0"/>
+                <a:ea typeface="Source Code Pro Light" panose="020B0409030403020204" pitchFamily="49" charset="0"/>
+              </a:rPr>
+              <a:t>&gt;&gt; </a:t>
+            </a:r>
+            <a:r>
+              <a:rPr lang="es-ES" sz="600" dirty="0" err="1">
+                <a:latin typeface="Source Code Pro Light" panose="020B0409030403020204" pitchFamily="49" charset="0"/>
+                <a:ea typeface="Source Code Pro Light" panose="020B0409030403020204" pitchFamily="49" charset="0"/>
+              </a:rPr>
+              <a:t>tscoreTesting</a:t>
+            </a:r>
+            <a:endParaRPr lang="es-ES" sz="600" dirty="0">
+              <a:latin typeface="Source Code Pro Light" panose="020B0409030403020204" pitchFamily="49" charset="0"/>
+              <a:ea typeface="Source Code Pro Light" panose="020B0409030403020204" pitchFamily="49" charset="0"/>
+            </a:endParaRPr>
+          </a:p>
+          <a:p>
+            <a:r>
+              <a:rPr lang="es-ES" sz="600" dirty="0" err="1">
+                <a:latin typeface="Source Code Pro Light" panose="020B0409030403020204" pitchFamily="49" charset="0"/>
+                <a:ea typeface="Source Code Pro Light" panose="020B0409030403020204" pitchFamily="49" charset="0"/>
+              </a:rPr>
+              <a:t>Seperation</a:t>
+            </a:r>
+            <a:r>
+              <a:rPr lang="es-ES" sz="600" dirty="0">
+                <a:latin typeface="Source Code Pro Light" panose="020B0409030403020204" pitchFamily="49" charset="0"/>
+                <a:ea typeface="Source Code Pro Light" panose="020B0409030403020204" pitchFamily="49" charset="0"/>
+              </a:rPr>
+              <a:t>: mean=0.2367, </a:t>
+            </a:r>
+            <a:r>
+              <a:rPr lang="es-ES" sz="600" dirty="0" err="1">
+                <a:latin typeface="Source Code Pro Light" panose="020B0409030403020204" pitchFamily="49" charset="0"/>
+                <a:ea typeface="Source Code Pro Light" panose="020B0409030403020204" pitchFamily="49" charset="0"/>
+              </a:rPr>
+              <a:t>sd</a:t>
+            </a:r>
+            <a:r>
+              <a:rPr lang="es-ES" sz="600" dirty="0">
+                <a:latin typeface="Source Code Pro Light" panose="020B0409030403020204" pitchFamily="49" charset="0"/>
+                <a:ea typeface="Source Code Pro Light" panose="020B0409030403020204" pitchFamily="49" charset="0"/>
+              </a:rPr>
+              <a:t>=0.1062, n=6, t=5.4562, p=0.0028</a:t>
+            </a:r>
+          </a:p>
+          <a:p>
+            <a:endParaRPr lang="es-ES" sz="600" dirty="0">
+              <a:latin typeface="Source Code Pro Light" panose="020B0409030403020204" pitchFamily="49" charset="0"/>
+              <a:ea typeface="Source Code Pro Light" panose="020B0409030403020204" pitchFamily="49" charset="0"/>
+            </a:endParaRPr>
+          </a:p>
+          <a:p>
+            <a:r>
+              <a:rPr lang="es-ES" sz="600" dirty="0" err="1">
+                <a:latin typeface="Source Code Pro Light" panose="020B0409030403020204" pitchFamily="49" charset="0"/>
+                <a:ea typeface="Source Code Pro Light" panose="020B0409030403020204" pitchFamily="49" charset="0"/>
+              </a:rPr>
+              <a:t>Area</a:t>
+            </a:r>
+            <a:r>
+              <a:rPr lang="es-ES" sz="600" dirty="0">
+                <a:latin typeface="Source Code Pro Light" panose="020B0409030403020204" pitchFamily="49" charset="0"/>
+                <a:ea typeface="Source Code Pro Light" panose="020B0409030403020204" pitchFamily="49" charset="0"/>
+              </a:rPr>
+              <a:t>: mean=0.1850, </a:t>
+            </a:r>
+            <a:r>
+              <a:rPr lang="es-ES" sz="600" dirty="0" err="1">
+                <a:latin typeface="Source Code Pro Light" panose="020B0409030403020204" pitchFamily="49" charset="0"/>
+                <a:ea typeface="Source Code Pro Light" panose="020B0409030403020204" pitchFamily="49" charset="0"/>
+              </a:rPr>
+              <a:t>sd</a:t>
+            </a:r>
+            <a:r>
+              <a:rPr lang="es-ES" sz="600" dirty="0">
+                <a:latin typeface="Source Code Pro Light" panose="020B0409030403020204" pitchFamily="49" charset="0"/>
+                <a:ea typeface="Source Code Pro Light" panose="020B0409030403020204" pitchFamily="49" charset="0"/>
+              </a:rPr>
+              <a:t>=0.0250, n=6, t=18.1262, p=0.0000</a:t>
+            </a:r>
+          </a:p>
+          <a:p>
+            <a:endParaRPr lang="es-ES" sz="600" dirty="0">
+              <a:latin typeface="Source Code Pro Light" panose="020B0409030403020204" pitchFamily="49" charset="0"/>
+              <a:ea typeface="Source Code Pro Light" panose="020B0409030403020204" pitchFamily="49" charset="0"/>
+            </a:endParaRPr>
+          </a:p>
+          <a:p>
+            <a:r>
+              <a:rPr lang="es-ES" sz="600" dirty="0" err="1">
+                <a:latin typeface="Source Code Pro Light" panose="020B0409030403020204" pitchFamily="49" charset="0"/>
+                <a:ea typeface="Source Code Pro Light" panose="020B0409030403020204" pitchFamily="49" charset="0"/>
+              </a:rPr>
+              <a:t>Two-sample</a:t>
+            </a:r>
+            <a:r>
+              <a:rPr lang="es-ES" sz="600" dirty="0">
+                <a:latin typeface="Source Code Pro Light" panose="020B0409030403020204" pitchFamily="49" charset="0"/>
+                <a:ea typeface="Source Code Pro Light" panose="020B0409030403020204" pitchFamily="49" charset="0"/>
+              </a:rPr>
+              <a:t> t-test: t=1.0584, </a:t>
+            </a:r>
+            <a:r>
+              <a:rPr lang="es-ES" sz="600" dirty="0" err="1">
+                <a:latin typeface="Source Code Pro Light" panose="020B0409030403020204" pitchFamily="49" charset="0"/>
+                <a:ea typeface="Source Code Pro Light" panose="020B0409030403020204" pitchFamily="49" charset="0"/>
+              </a:rPr>
+              <a:t>df</a:t>
+            </a:r>
+            <a:r>
+              <a:rPr lang="es-ES" sz="600" dirty="0">
+                <a:latin typeface="Source Code Pro Light" panose="020B0409030403020204" pitchFamily="49" charset="0"/>
+                <a:ea typeface="Source Code Pro Light" panose="020B0409030403020204" pitchFamily="49" charset="0"/>
+              </a:rPr>
+              <a:t>=10, p=0.3147</a:t>
+            </a:r>
+          </a:p>
+        </p:txBody>
+      </p:sp>
     </p:spTree>
     <p:extLst>
       <p:ext uri="{BB962C8B-B14F-4D97-AF65-F5344CB8AC3E}">
@@ -12385,4 +12769,319 @@
     </a:ext>
   </a:extLst>
 </a:theme>
+</file>
+
+<file path=ppt/theme/theme3.xml><?xml version="1.0" encoding="utf-8"?>
+<a:theme xmlns:a="http://schemas.openxmlformats.org/drawingml/2006/main" name="Tema de Office">
+  <a:themeElements>
+    <a:clrScheme name="Office">
+      <a:dk1>
+        <a:sysClr val="windowText" lastClr="000000"/>
+      </a:dk1>
+      <a:lt1>
+        <a:sysClr val="window" lastClr="FFFFFF"/>
+      </a:lt1>
+      <a:dk2>
+        <a:srgbClr val="0E2841"/>
+      </a:dk2>
+      <a:lt2>
+        <a:srgbClr val="E8E8E8"/>
+      </a:lt2>
+      <a:accent1>
+        <a:srgbClr val="156082"/>
+      </a:accent1>
+      <a:accent2>
+        <a:srgbClr val="E97132"/>
+      </a:accent2>
+      <a:accent3>
+        <a:srgbClr val="196B24"/>
+      </a:accent3>
+      <a:accent4>
+        <a:srgbClr val="0F9ED5"/>
+      </a:accent4>
+      <a:accent5>
+        <a:srgbClr val="A02B93"/>
+      </a:accent5>
+      <a:accent6>
+        <a:srgbClr val="4EA72E"/>
+      </a:accent6>
+      <a:hlink>
+        <a:srgbClr val="467886"/>
+      </a:hlink>
+      <a:folHlink>
+        <a:srgbClr val="96607D"/>
+      </a:folHlink>
+    </a:clrScheme>
+    <a:fontScheme name="Office">
+      <a:majorFont>
+        <a:latin typeface="Aptos Display" panose="02110004020202020204"/>
+        <a:ea typeface=""/>
+        <a:cs typeface=""/>
+        <a:font script="Jpan" typeface="游ゴシック Light"/>
+        <a:font script="Hang" typeface="맑은 고딕"/>
+        <a:font script="Hans" typeface="等线 Light"/>
+        <a:font script="Hant" typeface="新細明體"/>
+        <a:font script="Arab" typeface="Times New Roman"/>
+        <a:font script="Hebr" typeface="Times New Roman"/>
+        <a:font script="Thai" typeface="Angsana New"/>
+        <a:font script="Ethi" typeface="Nyala"/>
+        <a:font script="Beng" typeface="Vrinda"/>
+        <a:font script="Gujr" typeface="Shruti"/>
+        <a:font script="Khmr" typeface="MoolBoran"/>
+        <a:font script="Knda" typeface="Tunga"/>
+        <a:font script="Guru" typeface="Raavi"/>
+        <a:font script="Cans" typeface="Euphemia"/>
+        <a:font script="Cher" typeface="Plantagenet Cherokee"/>
+        <a:font script="Yiii" typeface="Microsoft Yi Baiti"/>
+        <a:font script="Tibt" typeface="Microsoft Himalaya"/>
+        <a:font script="Thaa" typeface="MV Boli"/>
+        <a:font script="Deva" typeface="Mangal"/>
+        <a:font script="Telu" typeface="Gautami"/>
+        <a:font script="Taml" typeface="Latha"/>
+        <a:font script="Syrc" typeface="Estrangelo Edessa"/>
+        <a:font script="Orya" typeface="Kalinga"/>
+        <a:font script="Mlym" typeface="Kartika"/>
+        <a:font script="Laoo" typeface="DokChampa"/>
+        <a:font script="Sinh" typeface="Iskoola Pota"/>
+        <a:font script="Mong" typeface="Mongolian Baiti"/>
+        <a:font script="Viet" typeface="Times New Roman"/>
+        <a:font script="Uigh" typeface="Microsoft Uighur"/>
+        <a:font script="Geor" typeface="Sylfaen"/>
+        <a:font script="Armn" typeface="Arial"/>
+        <a:font script="Bugi" typeface="Leelawadee UI"/>
+        <a:font script="Bopo" typeface="Microsoft JhengHei"/>
+        <a:font script="Java" typeface="Javanese Text"/>
+        <a:font script="Lisu" typeface="Segoe UI"/>
+        <a:font script="Mymr" typeface="Myanmar Text"/>
+        <a:font script="Nkoo" typeface="Ebrima"/>
+        <a:font script="Olck" typeface="Nirmala UI"/>
+        <a:font script="Osma" typeface="Ebrima"/>
+        <a:font script="Phag" typeface="Phagspa"/>
+        <a:font script="Syrn" typeface="Estrangelo Edessa"/>
+        <a:font script="Syrj" typeface="Estrangelo Edessa"/>
+        <a:font script="Syre" typeface="Estrangelo Edessa"/>
+        <a:font script="Sora" typeface="Nirmala UI"/>
+        <a:font script="Tale" typeface="Microsoft Tai Le"/>
+        <a:font script="Talu" typeface="Microsoft New Tai Lue"/>
+        <a:font script="Tfng" typeface="Ebrima"/>
+      </a:majorFont>
+      <a:minorFont>
+        <a:latin typeface="Aptos" panose="02110004020202020204"/>
+        <a:ea typeface=""/>
+        <a:cs typeface=""/>
+        <a:font script="Jpan" typeface="游ゴシック"/>
+        <a:font script="Hang" typeface="맑은 고딕"/>
+        <a:font script="Hans" typeface="等线"/>
+        <a:font script="Hant" typeface="新細明體"/>
+        <a:font script="Arab" typeface="Arial"/>
+        <a:font script="Hebr" typeface="Arial"/>
+        <a:font script="Thai" typeface="Cordia New"/>
+        <a:font script="Ethi" typeface="Nyala"/>
+        <a:font script="Beng" typeface="Vrinda"/>
+        <a:font script="Gujr" typeface="Shruti"/>
+        <a:font script="Khmr" typeface="DaunPenh"/>
+        <a:font script="Knda" typeface="Tunga"/>
+        <a:font script="Guru" typeface="Raavi"/>
+        <a:font script="Cans" typeface="Euphemia"/>
+        <a:font script="Cher" typeface="Plantagenet Cherokee"/>
+        <a:font script="Yiii" typeface="Microsoft Yi Baiti"/>
+        <a:font script="Tibt" typeface="Microsoft Himalaya"/>
+        <a:font script="Thaa" typeface="MV Boli"/>
+        <a:font script="Deva" typeface="Mangal"/>
+        <a:font script="Telu" typeface="Gautami"/>
+        <a:font script="Taml" typeface="Latha"/>
+        <a:font script="Syrc" typeface="Estrangelo Edessa"/>
+        <a:font script="Orya" typeface="Kalinga"/>
+        <a:font script="Mlym" typeface="Kartika"/>
+        <a:font script="Laoo" typeface="DokChampa"/>
+        <a:font script="Sinh" typeface="Iskoola Pota"/>
+        <a:font script="Mong" typeface="Mongolian Baiti"/>
+        <a:font script="Viet" typeface="Arial"/>
+        <a:font script="Uigh" typeface="Microsoft Uighur"/>
+        <a:font script="Geor" typeface="Sylfaen"/>
+        <a:font script="Armn" typeface="Arial"/>
+        <a:font script="Bugi" typeface="Leelawadee UI"/>
+        <a:font script="Bopo" typeface="Microsoft JhengHei"/>
+        <a:font script="Java" typeface="Javanese Text"/>
+        <a:font script="Lisu" typeface="Segoe UI"/>
+        <a:font script="Mymr" typeface="Myanmar Text"/>
+        <a:font script="Nkoo" typeface="Ebrima"/>
+        <a:font script="Olck" typeface="Nirmala UI"/>
+        <a:font script="Osma" typeface="Ebrima"/>
+        <a:font script="Phag" typeface="Phagspa"/>
+        <a:font script="Syrn" typeface="Estrangelo Edessa"/>
+        <a:font script="Syrj" typeface="Estrangelo Edessa"/>
+        <a:font script="Syre" typeface="Estrangelo Edessa"/>
+        <a:font script="Sora" typeface="Nirmala UI"/>
+        <a:font script="Tale" typeface="Microsoft Tai Le"/>
+        <a:font script="Talu" typeface="Microsoft New Tai Lue"/>
+        <a:font script="Tfng" typeface="Ebrima"/>
+      </a:minorFont>
+    </a:fontScheme>
+    <a:fmtScheme name="Office">
+      <a:fillStyleLst>
+        <a:solidFill>
+          <a:schemeClr val="phClr"/>
+        </a:solidFill>
+        <a:gradFill rotWithShape="1">
+          <a:gsLst>
+            <a:gs pos="0">
+              <a:schemeClr val="phClr">
+                <a:lumMod val="110000"/>
+                <a:satMod val="105000"/>
+                <a:tint val="67000"/>
+              </a:schemeClr>
+            </a:gs>
+            <a:gs pos="50000">
+              <a:schemeClr val="phClr">
+                <a:lumMod val="105000"/>
+                <a:satMod val="103000"/>
+                <a:tint val="73000"/>
+              </a:schemeClr>
+            </a:gs>
+            <a:gs pos="100000">
+              <a:schemeClr val="phClr">
+                <a:lumMod val="105000"/>
+                <a:satMod val="109000"/>
+                <a:tint val="81000"/>
+              </a:schemeClr>
+            </a:gs>
+          </a:gsLst>
+          <a:lin ang="5400000" scaled="0"/>
+        </a:gradFill>
+        <a:gradFill rotWithShape="1">
+          <a:gsLst>
+            <a:gs pos="0">
+              <a:schemeClr val="phClr">
+                <a:satMod val="103000"/>
+                <a:lumMod val="102000"/>
+                <a:tint val="94000"/>
+              </a:schemeClr>
+            </a:gs>
+            <a:gs pos="50000">
+              <a:schemeClr val="phClr">
+                <a:satMod val="110000"/>
+                <a:lumMod val="100000"/>
+                <a:shade val="100000"/>
+              </a:schemeClr>
+            </a:gs>
+            <a:gs pos="100000">
+              <a:schemeClr val="phClr">
+                <a:lumMod val="99000"/>
+                <a:satMod val="120000"/>
+                <a:shade val="78000"/>
+              </a:schemeClr>
+            </a:gs>
+          </a:gsLst>
+          <a:lin ang="5400000" scaled="0"/>
+        </a:gradFill>
+      </a:fillStyleLst>
+      <a:lnStyleLst>
+        <a:ln w="12700" cap="flat" cmpd="sng" algn="ctr">
+          <a:solidFill>
+            <a:schemeClr val="phClr"/>
+          </a:solidFill>
+          <a:prstDash val="solid"/>
+          <a:miter lim="800000"/>
+        </a:ln>
+        <a:ln w="19050" cap="flat" cmpd="sng" algn="ctr">
+          <a:solidFill>
+            <a:schemeClr val="phClr"/>
+          </a:solidFill>
+          <a:prstDash val="solid"/>
+          <a:miter lim="800000"/>
+        </a:ln>
+        <a:ln w="25400" cap="flat" cmpd="sng" algn="ctr">
+          <a:solidFill>
+            <a:schemeClr val="phClr"/>
+          </a:solidFill>
+          <a:prstDash val="solid"/>
+          <a:miter lim="800000"/>
+        </a:ln>
+      </a:lnStyleLst>
+      <a:effectStyleLst>
+        <a:effectStyle>
+          <a:effectLst/>
+        </a:effectStyle>
+        <a:effectStyle>
+          <a:effectLst/>
+        </a:effectStyle>
+        <a:effectStyle>
+          <a:effectLst>
+            <a:outerShdw blurRad="57150" dist="19050" dir="5400000" algn="ctr" rotWithShape="0">
+              <a:srgbClr val="000000">
+                <a:alpha val="63000"/>
+              </a:srgbClr>
+            </a:outerShdw>
+          </a:effectLst>
+        </a:effectStyle>
+      </a:effectStyleLst>
+      <a:bgFillStyleLst>
+        <a:solidFill>
+          <a:schemeClr val="phClr"/>
+        </a:solidFill>
+        <a:solidFill>
+          <a:schemeClr val="phClr">
+            <a:tint val="95000"/>
+            <a:satMod val="170000"/>
+          </a:schemeClr>
+        </a:solidFill>
+        <a:gradFill rotWithShape="1">
+          <a:gsLst>
+            <a:gs pos="0">
+              <a:schemeClr val="phClr">
+                <a:tint val="93000"/>
+                <a:satMod val="150000"/>
+                <a:shade val="98000"/>
+                <a:lumMod val="102000"/>
+              </a:schemeClr>
+            </a:gs>
+            <a:gs pos="50000">
+              <a:schemeClr val="phClr">
+                <a:tint val="98000"/>
+                <a:satMod val="130000"/>
+                <a:shade val="90000"/>
+                <a:lumMod val="103000"/>
+              </a:schemeClr>
+            </a:gs>
+            <a:gs pos="100000">
+              <a:schemeClr val="phClr">
+                <a:shade val="63000"/>
+                <a:satMod val="120000"/>
+              </a:schemeClr>
+            </a:gs>
+          </a:gsLst>
+          <a:lin ang="5400000" scaled="0"/>
+        </a:gradFill>
+      </a:bgFillStyleLst>
+    </a:fmtScheme>
+  </a:themeElements>
+  <a:objectDefaults>
+    <a:lnDef>
+      <a:spPr/>
+      <a:bodyPr/>
+      <a:lstStyle/>
+      <a:style>
+        <a:lnRef idx="2">
+          <a:schemeClr val="accent1"/>
+        </a:lnRef>
+        <a:fillRef idx="0">
+          <a:schemeClr val="accent1"/>
+        </a:fillRef>
+        <a:effectRef idx="1">
+          <a:schemeClr val="accent1"/>
+        </a:effectRef>
+        <a:fontRef idx="minor">
+          <a:schemeClr val="tx1"/>
+        </a:fontRef>
+      </a:style>
+    </a:lnDef>
+  </a:objectDefaults>
+  <a:extraClrSchemeLst/>
+  <a:extLst>
+    <a:ext uri="{05A4C25C-085E-4340-85A3-A5531E510DB2}">
+      <thm15:themeFamily xmlns:thm15="http://schemas.microsoft.com/office/thememl/2012/main" name="Office Theme" id="{2E142A2C-CD16-42D6-873A-C26D2A0506FA}" vid="{1BDDFF52-6CD6-40A5-AB3C-68EB2F1E4D0A}"/>
+    </a:ext>
+  </a:extLst>
+</a:theme>
 </file>
</xml_diff>

<commit_message>
Adding final changes to my final project presentation
This is final commit as the semester has ended, and the final project
was the final assignment to be submitted.

Signed-off-by: Abdon Morales <abdonm@cs.utexas.edu>
</commit_message>
<xml_diff>
--- a/Final Project/FinalProject.pptx
+++ b/Final Project/FinalProject.pptx
@@ -119,7 +119,7 @@
 <file path=ppt/revisionInfo.xml><?xml version="1.0" encoding="utf-8"?>
 <p1510:revInfo xmlns:a="http://schemas.openxmlformats.org/drawingml/2006/main" xmlns:r="http://schemas.openxmlformats.org/officeDocument/2006/relationships" xmlns:p1510="http://schemas.microsoft.com/office/powerpoint/2015/10/main">
   <p1510:revLst>
-    <p1510:client id="{80BA49D0-6376-CB48-B3C3-F4708D789340}" v="992" dt="2025-12-04T22:49:57.117"/>
+    <p1510:client id="{80BA49D0-6376-CB48-B3C3-F4708D789340}" v="996" dt="2025-12-09T01:48:09.323"/>
   </p1510:revLst>
 </p1510:revInfo>
 </file>
@@ -129,12 +129,12 @@
   <pc:docChgLst>
     <pc:chgData name="Morales, Abdon" userId="b8e72fca-89fa-40b2-95f0-bdb26e6d8c1d" providerId="ADAL" clId="{F77E3D6D-613B-5030-A384-37FA661628F6}"/>
     <pc:docChg chg="undo custSel modSld">
-      <pc:chgData name="Morales, Abdon" userId="b8e72fca-89fa-40b2-95f0-bdb26e6d8c1d" providerId="ADAL" clId="{F77E3D6D-613B-5030-A384-37FA661628F6}" dt="2025-12-04T22:49:57.117" v="2265" actId="313"/>
+      <pc:chgData name="Morales, Abdon" userId="b8e72fca-89fa-40b2-95f0-bdb26e6d8c1d" providerId="ADAL" clId="{F77E3D6D-613B-5030-A384-37FA661628F6}" dt="2025-12-09T02:04:01.911" v="3158" actId="1076"/>
       <pc:docMkLst>
         <pc:docMk/>
       </pc:docMkLst>
       <pc:sldChg chg="addSp delSp modSp mod">
-        <pc:chgData name="Morales, Abdon" userId="b8e72fca-89fa-40b2-95f0-bdb26e6d8c1d" providerId="ADAL" clId="{F77E3D6D-613B-5030-A384-37FA661628F6}" dt="2025-12-04T22:49:57.117" v="2265" actId="313"/>
+        <pc:chgData name="Morales, Abdon" userId="b8e72fca-89fa-40b2-95f0-bdb26e6d8c1d" providerId="ADAL" clId="{F77E3D6D-613B-5030-A384-37FA661628F6}" dt="2025-12-09T02:04:01.911" v="3158" actId="1076"/>
         <pc:sldMkLst>
           <pc:docMk/>
           <pc:sldMk cId="4152292366" sldId="268"/>
@@ -163,6 +163,22 @@
             <ac:spMk id="4" creationId="{C2642BAB-3737-CE4C-874C-5EA986C6E360}"/>
           </ac:spMkLst>
         </pc:spChg>
+        <pc:spChg chg="add">
+          <ac:chgData name="Morales, Abdon" userId="b8e72fca-89fa-40b2-95f0-bdb26e6d8c1d" providerId="ADAL" clId="{F77E3D6D-613B-5030-A384-37FA661628F6}" dt="2025-12-09T01:47:51.006" v="2267"/>
+          <ac:spMkLst>
+            <pc:docMk/>
+            <pc:sldMk cId="4152292366" sldId="268"/>
+            <ac:spMk id="6" creationId="{E9F5AE11-6BC9-3A93-8A3B-372009404BB0}"/>
+          </ac:spMkLst>
+        </pc:spChg>
+        <pc:spChg chg="add">
+          <ac:chgData name="Morales, Abdon" userId="b8e72fca-89fa-40b2-95f0-bdb26e6d8c1d" providerId="ADAL" clId="{F77E3D6D-613B-5030-A384-37FA661628F6}" dt="2025-12-09T01:48:04.923" v="2268"/>
+          <ac:spMkLst>
+            <pc:docMk/>
+            <pc:sldMk cId="4152292366" sldId="268"/>
+            <ac:spMk id="8" creationId="{B9E1747F-727B-1E0D-8B34-FE9018FFF933}"/>
+          </ac:spMkLst>
+        </pc:spChg>
         <pc:spChg chg="add mod">
           <ac:chgData name="Morales, Abdon" userId="b8e72fca-89fa-40b2-95f0-bdb26e6d8c1d" providerId="ADAL" clId="{F77E3D6D-613B-5030-A384-37FA661628F6}" dt="2025-12-04T22:48:23.119" v="2052" actId="255"/>
           <ac:spMkLst>
@@ -171,12 +187,20 @@
             <ac:spMk id="12" creationId="{F99076AB-CD48-1D9C-24C3-8E5BC7671CED}"/>
           </ac:spMkLst>
         </pc:spChg>
-        <pc:spChg chg="del">
-          <ac:chgData name="Morales, Abdon" userId="b8e72fca-89fa-40b2-95f0-bdb26e6d8c1d" providerId="ADAL" clId="{F77E3D6D-613B-5030-A384-37FA661628F6}" dt="2025-12-04T04:12:05.673" v="1083" actId="478"/>
+        <pc:spChg chg="mod">
+          <ac:chgData name="Morales, Abdon" userId="b8e72fca-89fa-40b2-95f0-bdb26e6d8c1d" providerId="ADAL" clId="{F77E3D6D-613B-5030-A384-37FA661628F6}" dt="2025-12-09T02:04:01.911" v="3158" actId="1076"/>
           <ac:spMkLst>
             <pc:docMk/>
             <pc:sldMk cId="4152292366" sldId="268"/>
-            <ac:spMk id="46" creationId="{D903B466-646C-2D4A-BD19-7AA4D5AE665B}"/>
+            <ac:spMk id="21" creationId="{74A298CE-07C7-084B-B72C-D7D120AA24D1}"/>
+          </ac:spMkLst>
+        </pc:spChg>
+        <pc:spChg chg="mod">
+          <ac:chgData name="Morales, Abdon" userId="b8e72fca-89fa-40b2-95f0-bdb26e6d8c1d" providerId="ADAL" clId="{F77E3D6D-613B-5030-A384-37FA661628F6}" dt="2025-12-09T01:50:48.278" v="2596" actId="1076"/>
+          <ac:spMkLst>
+            <pc:docMk/>
+            <pc:sldMk cId="4152292366" sldId="268"/>
+            <ac:spMk id="24" creationId="{EF233BEC-D918-0A48-8894-42A92980A8AA}"/>
           </ac:spMkLst>
         </pc:spChg>
         <pc:spChg chg="mod">
@@ -193,22 +217,6 @@
             <pc:docMk/>
             <pc:sldMk cId="4152292366" sldId="268"/>
             <ac:spMk id="51" creationId="{E1CD2C2A-F064-084C-B9FF-1CE5B53E4E32}"/>
-          </ac:spMkLst>
-        </pc:spChg>
-        <pc:spChg chg="del">
-          <ac:chgData name="Morales, Abdon" userId="b8e72fca-89fa-40b2-95f0-bdb26e6d8c1d" providerId="ADAL" clId="{F77E3D6D-613B-5030-A384-37FA661628F6}" dt="2025-12-04T22:37:34.067" v="1108" actId="478"/>
-          <ac:spMkLst>
-            <pc:docMk/>
-            <pc:sldMk cId="4152292366" sldId="268"/>
-            <ac:spMk id="55" creationId="{932F4CD2-D53A-6945-A147-AA4161801A71}"/>
-          </ac:spMkLst>
-        </pc:spChg>
-        <pc:spChg chg="del">
-          <ac:chgData name="Morales, Abdon" userId="b8e72fca-89fa-40b2-95f0-bdb26e6d8c1d" providerId="ADAL" clId="{F77E3D6D-613B-5030-A384-37FA661628F6}" dt="2025-12-04T04:12:09.898" v="1084" actId="478"/>
-          <ac:spMkLst>
-            <pc:docMk/>
-            <pc:sldMk cId="4152292366" sldId="268"/>
-            <ac:spMk id="59" creationId="{887E75FA-C034-2447-9AFA-253A4A8F5217}"/>
           </ac:spMkLst>
         </pc:spChg>
         <pc:grpChg chg="add">
@@ -235,28 +243,12 @@
             <ac:picMk id="5" creationId="{C498A840-B2C8-4383-7568-2620CE9B6494}"/>
           </ac:picMkLst>
         </pc:picChg>
-        <pc:picChg chg="add mod">
-          <ac:chgData name="Morales, Abdon" userId="b8e72fca-89fa-40b2-95f0-bdb26e6d8c1d" providerId="ADAL" clId="{F77E3D6D-613B-5030-A384-37FA661628F6}" dt="2025-12-04T04:08:01.170" v="1064"/>
-          <ac:picMkLst>
-            <pc:docMk/>
-            <pc:sldMk cId="4152292366" sldId="268"/>
-            <ac:picMk id="6" creationId="{6408B6EF-FEDB-CD66-BA45-B016490FC750}"/>
-          </ac:picMkLst>
-        </pc:picChg>
         <pc:picChg chg="mod">
           <ac:chgData name="Morales, Abdon" userId="b8e72fca-89fa-40b2-95f0-bdb26e6d8c1d" providerId="ADAL" clId="{F77E3D6D-613B-5030-A384-37FA661628F6}" dt="2025-12-04T04:04:42.913" v="1039" actId="1076"/>
           <ac:picMkLst>
             <pc:docMk/>
             <pc:sldMk cId="4152292366" sldId="268"/>
             <ac:picMk id="7" creationId="{56CDAAF2-1818-9EB6-09DE-0325CCB12502}"/>
-          </ac:picMkLst>
-        </pc:picChg>
-        <pc:picChg chg="add del mod">
-          <ac:chgData name="Morales, Abdon" userId="b8e72fca-89fa-40b2-95f0-bdb26e6d8c1d" providerId="ADAL" clId="{F77E3D6D-613B-5030-A384-37FA661628F6}" dt="2025-12-04T04:08:55.938" v="1074" actId="478"/>
-          <ac:picMkLst>
-            <pc:docMk/>
-            <pc:sldMk cId="4152292366" sldId="268"/>
-            <ac:picMk id="8" creationId="{6740F724-754B-FD30-2AC9-4F6671BEBCC8}"/>
           </ac:picMkLst>
         </pc:picChg>
         <pc:picChg chg="add mod">
@@ -355,7 +347,7 @@
           <a:p>
             <a:fld id="{D353F5E4-024D-B04C-8649-02453A372B74}" type="datetimeFigureOut">
               <a:rPr lang="es-ES" smtClean="0"/>
-              <a:t>4/12/25</a:t>
+              <a:t>5/12/25</a:t>
             </a:fld>
             <a:endParaRPr lang="es-ES"/>
           </a:p>
@@ -853,7 +845,7 @@
           <a:p>
             <a:fld id="{722949B6-FD26-4F0A-B27E-95AA34CFB7B6}" type="datetimeFigureOut">
               <a:rPr lang="en-US" smtClean="0"/>
-              <a:t>12/3/25</a:t>
+              <a:t>12/5/25</a:t>
             </a:fld>
             <a:endParaRPr lang="en-US"/>
           </a:p>
@@ -1051,7 +1043,7 @@
           <a:p>
             <a:fld id="{722949B6-FD26-4F0A-B27E-95AA34CFB7B6}" type="datetimeFigureOut">
               <a:rPr lang="en-US" smtClean="0"/>
-              <a:t>12/3/25</a:t>
+              <a:t>12/5/25</a:t>
             </a:fld>
             <a:endParaRPr lang="en-US"/>
           </a:p>
@@ -1259,7 +1251,7 @@
           <a:p>
             <a:fld id="{722949B6-FD26-4F0A-B27E-95AA34CFB7B6}" type="datetimeFigureOut">
               <a:rPr lang="en-US" smtClean="0"/>
-              <a:t>12/3/25</a:t>
+              <a:t>12/5/25</a:t>
             </a:fld>
             <a:endParaRPr lang="en-US"/>
           </a:p>
@@ -1463,7 +1455,7 @@
           <a:p>
             <a:fld id="{C764DE79-268F-4C1A-8933-263129D2AF90}" type="datetimeFigureOut">
               <a:rPr lang="en-US" dirty="0"/>
-              <a:t>12/3/25</a:t>
+              <a:t>12/5/25</a:t>
             </a:fld>
             <a:endParaRPr lang="en-US" dirty="0"/>
           </a:p>
@@ -1633,7 +1625,7 @@
           <a:p>
             <a:fld id="{C764DE79-268F-4C1A-8933-263129D2AF90}" type="datetimeFigureOut">
               <a:rPr lang="en-US" dirty="0"/>
-              <a:t>12/3/25</a:t>
+              <a:t>12/5/25</a:t>
             </a:fld>
             <a:endParaRPr lang="en-US" dirty="0"/>
           </a:p>
@@ -1877,7 +1869,7 @@
           <a:p>
             <a:fld id="{C764DE79-268F-4C1A-8933-263129D2AF90}" type="datetimeFigureOut">
               <a:rPr lang="en-US" dirty="0"/>
-              <a:t>12/3/25</a:t>
+              <a:t>12/5/25</a:t>
             </a:fld>
             <a:endParaRPr lang="en-US" dirty="0"/>
           </a:p>
@@ -2109,7 +2101,7 @@
           <a:p>
             <a:fld id="{C764DE79-268F-4C1A-8933-263129D2AF90}" type="datetimeFigureOut">
               <a:rPr lang="en-US" dirty="0"/>
-              <a:t>12/3/25</a:t>
+              <a:t>12/5/25</a:t>
             </a:fld>
             <a:endParaRPr lang="en-US" dirty="0"/>
           </a:p>
@@ -2476,7 +2468,7 @@
           <a:p>
             <a:fld id="{C764DE79-268F-4C1A-8933-263129D2AF90}" type="datetimeFigureOut">
               <a:rPr lang="en-US" dirty="0"/>
-              <a:t>12/3/25</a:t>
+              <a:t>12/5/25</a:t>
             </a:fld>
             <a:endParaRPr lang="en-US" dirty="0"/>
           </a:p>
@@ -2594,7 +2586,7 @@
           <a:p>
             <a:fld id="{C764DE79-268F-4C1A-8933-263129D2AF90}" type="datetimeFigureOut">
               <a:rPr lang="en-US" dirty="0"/>
-              <a:t>12/3/25</a:t>
+              <a:t>12/5/25</a:t>
             </a:fld>
             <a:endParaRPr lang="en-US" dirty="0"/>
           </a:p>
@@ -2689,7 +2681,7 @@
           <a:p>
             <a:fld id="{C764DE79-268F-4C1A-8933-263129D2AF90}" type="datetimeFigureOut">
               <a:rPr lang="en-US" dirty="0"/>
-              <a:t>12/3/25</a:t>
+              <a:t>12/5/25</a:t>
             </a:fld>
             <a:endParaRPr lang="en-US" dirty="0"/>
           </a:p>
@@ -2966,7 +2958,7 @@
           <a:p>
             <a:fld id="{C764DE79-268F-4C1A-8933-263129D2AF90}" type="datetimeFigureOut">
               <a:rPr lang="en-US" dirty="0"/>
-              <a:t>12/3/25</a:t>
+              <a:t>12/5/25</a:t>
             </a:fld>
             <a:endParaRPr lang="en-US" dirty="0"/>
           </a:p>
@@ -3152,7 +3144,7 @@
           <a:p>
             <a:fld id="{722949B6-FD26-4F0A-B27E-95AA34CFB7B6}" type="datetimeFigureOut">
               <a:rPr lang="en-US" smtClean="0"/>
-              <a:t>12/3/25</a:t>
+              <a:t>12/5/25</a:t>
             </a:fld>
             <a:endParaRPr lang="en-US"/>
           </a:p>
@@ -3421,7 +3413,7 @@
           <a:p>
             <a:fld id="{C764DE79-268F-4C1A-8933-263129D2AF90}" type="datetimeFigureOut">
               <a:rPr lang="en-US" dirty="0"/>
-              <a:t>12/3/25</a:t>
+              <a:t>12/5/25</a:t>
             </a:fld>
             <a:endParaRPr lang="en-US" dirty="0"/>
           </a:p>
@@ -3591,7 +3583,7 @@
           <a:p>
             <a:fld id="{C764DE79-268F-4C1A-8933-263129D2AF90}" type="datetimeFigureOut">
               <a:rPr lang="en-US" dirty="0"/>
-              <a:t>12/3/25</a:t>
+              <a:t>12/5/25</a:t>
             </a:fld>
             <a:endParaRPr lang="en-US" dirty="0"/>
           </a:p>
@@ -3771,7 +3763,7 @@
           <a:p>
             <a:fld id="{C764DE79-268F-4C1A-8933-263129D2AF90}" type="datetimeFigureOut">
               <a:rPr lang="en-US" dirty="0"/>
-              <a:t>12/3/25</a:t>
+              <a:t>12/5/25</a:t>
             </a:fld>
             <a:endParaRPr lang="en-US" dirty="0"/>
           </a:p>
@@ -4064,7 +4056,7 @@
           <a:p>
             <a:fld id="{722949B6-FD26-4F0A-B27E-95AA34CFB7B6}" type="datetimeFigureOut">
               <a:rPr lang="en-US" smtClean="0"/>
-              <a:t>12/3/25</a:t>
+              <a:t>12/5/25</a:t>
             </a:fld>
             <a:endParaRPr lang="en-US"/>
           </a:p>
@@ -4329,7 +4321,7 @@
           <a:p>
             <a:fld id="{722949B6-FD26-4F0A-B27E-95AA34CFB7B6}" type="datetimeFigureOut">
               <a:rPr lang="en-US" smtClean="0"/>
-              <a:t>12/3/25</a:t>
+              <a:t>12/5/25</a:t>
             </a:fld>
             <a:endParaRPr lang="en-US"/>
           </a:p>
@@ -4741,7 +4733,7 @@
           <a:p>
             <a:fld id="{722949B6-FD26-4F0A-B27E-95AA34CFB7B6}" type="datetimeFigureOut">
               <a:rPr lang="en-US" smtClean="0"/>
-              <a:t>12/3/25</a:t>
+              <a:t>12/5/25</a:t>
             </a:fld>
             <a:endParaRPr lang="en-US"/>
           </a:p>
@@ -4882,7 +4874,7 @@
           <a:p>
             <a:fld id="{722949B6-FD26-4F0A-B27E-95AA34CFB7B6}" type="datetimeFigureOut">
               <a:rPr lang="en-US" smtClean="0"/>
-              <a:t>12/3/25</a:t>
+              <a:t>12/5/25</a:t>
             </a:fld>
             <a:endParaRPr lang="en-US"/>
           </a:p>
@@ -4995,7 +4987,7 @@
           <a:p>
             <a:fld id="{722949B6-FD26-4F0A-B27E-95AA34CFB7B6}" type="datetimeFigureOut">
               <a:rPr lang="en-US" smtClean="0"/>
-              <a:t>12/3/25</a:t>
+              <a:t>12/5/25</a:t>
             </a:fld>
             <a:endParaRPr lang="en-US"/>
           </a:p>
@@ -5306,7 +5298,7 @@
           <a:p>
             <a:fld id="{722949B6-FD26-4F0A-B27E-95AA34CFB7B6}" type="datetimeFigureOut">
               <a:rPr lang="en-US" smtClean="0"/>
-              <a:t>12/3/25</a:t>
+              <a:t>12/5/25</a:t>
             </a:fld>
             <a:endParaRPr lang="en-US"/>
           </a:p>
@@ -5594,7 +5586,7 @@
           <a:p>
             <a:fld id="{722949B6-FD26-4F0A-B27E-95AA34CFB7B6}" type="datetimeFigureOut">
               <a:rPr lang="en-US" smtClean="0"/>
-              <a:t>12/3/25</a:t>
+              <a:t>12/5/25</a:t>
             </a:fld>
             <a:endParaRPr lang="en-US"/>
           </a:p>
@@ -5835,7 +5827,7 @@
           <a:p>
             <a:fld id="{722949B6-FD26-4F0A-B27E-95AA34CFB7B6}" type="datetimeFigureOut">
               <a:rPr lang="en-US" smtClean="0"/>
-              <a:t>12/3/25</a:t>
+              <a:t>12/5/25</a:t>
             </a:fld>
             <a:endParaRPr lang="en-US"/>
           </a:p>
@@ -6387,7 +6379,7 @@
           <a:p>
             <a:fld id="{C764DE79-268F-4C1A-8933-263129D2AF90}" type="datetimeFigureOut">
               <a:rPr lang="en-US" dirty="0"/>
-              <a:t>12/3/25</a:t>
+              <a:t>12/5/25</a:t>
             </a:fld>
             <a:endParaRPr lang="en-US" dirty="0"/>
           </a:p>
@@ -6973,8 +6965,8 @@
         </p:nvSpPr>
         <p:spPr>
           <a:xfrm>
-            <a:off x="7873433" y="4521783"/>
-            <a:ext cx="2592548" cy="620554"/>
+            <a:off x="7845698" y="4476916"/>
+            <a:ext cx="2592548" cy="708592"/>
           </a:xfrm>
           <a:prstGeom prst="rect">
             <a:avLst/>
@@ -6988,16 +6980,6 @@
           <a:lstStyle/>
           <a:p>
             <a:pPr defTabSz="780653"/>
-            <a:r>
-              <a:rPr lang="en-US" sz="572" dirty="0" err="1">
-                <a:solidFill>
-                  <a:prstClr val="black"/>
-                </a:solidFill>
-                <a:latin typeface="Arial" panose="020B0604020202020204" pitchFamily="34" charset="0"/>
-                <a:cs typeface="Arial" panose="020B0604020202020204" pitchFamily="34" charset="0"/>
-              </a:rPr>
-              <a:t>Vitam</a:t>
-            </a:r>
             <a:r>
               <a:rPr lang="en-US" sz="572" dirty="0">
                 <a:solidFill>
@@ -7006,967 +6988,7 @@
                 <a:latin typeface="Arial" panose="020B0604020202020204" pitchFamily="34" charset="0"/>
                 <a:cs typeface="Arial" panose="020B0604020202020204" pitchFamily="34" charset="0"/>
               </a:rPr>
-              <a:t> </a:t>
-            </a:r>
-            <a:r>
-              <a:rPr lang="en-US" sz="572" dirty="0" err="1">
-                <a:solidFill>
-                  <a:prstClr val="black"/>
-                </a:solidFill>
-                <a:latin typeface="Arial" panose="020B0604020202020204" pitchFamily="34" charset="0"/>
-                <a:cs typeface="Arial" panose="020B0604020202020204" pitchFamily="34" charset="0"/>
-              </a:rPr>
-              <a:t>voloria</a:t>
-            </a:r>
-            <a:r>
-              <a:rPr lang="en-US" sz="572" dirty="0">
-                <a:solidFill>
-                  <a:prstClr val="black"/>
-                </a:solidFill>
-                <a:latin typeface="Arial" panose="020B0604020202020204" pitchFamily="34" charset="0"/>
-                <a:cs typeface="Arial" panose="020B0604020202020204" pitchFamily="34" charset="0"/>
-              </a:rPr>
-              <a:t> con et, cum </a:t>
-            </a:r>
-            <a:r>
-              <a:rPr lang="en-US" sz="572" dirty="0" err="1">
-                <a:solidFill>
-                  <a:prstClr val="black"/>
-                </a:solidFill>
-                <a:latin typeface="Arial" panose="020B0604020202020204" pitchFamily="34" charset="0"/>
-                <a:cs typeface="Arial" panose="020B0604020202020204" pitchFamily="34" charset="0"/>
-              </a:rPr>
-              <a:t>laboreium</a:t>
-            </a:r>
-            <a:r>
-              <a:rPr lang="en-US" sz="572" dirty="0">
-                <a:solidFill>
-                  <a:prstClr val="black"/>
-                </a:solidFill>
-                <a:latin typeface="Arial" panose="020B0604020202020204" pitchFamily="34" charset="0"/>
-                <a:cs typeface="Arial" panose="020B0604020202020204" pitchFamily="34" charset="0"/>
-              </a:rPr>
-              <a:t>, </a:t>
-            </a:r>
-            <a:r>
-              <a:rPr lang="en-US" sz="572" dirty="0" err="1">
-                <a:solidFill>
-                  <a:prstClr val="black"/>
-                </a:solidFill>
-                <a:latin typeface="Arial" panose="020B0604020202020204" pitchFamily="34" charset="0"/>
-                <a:cs typeface="Arial" panose="020B0604020202020204" pitchFamily="34" charset="0"/>
-              </a:rPr>
-              <a:t>nam</a:t>
-            </a:r>
-            <a:r>
-              <a:rPr lang="en-US" sz="572" dirty="0">
-                <a:solidFill>
-                  <a:prstClr val="black"/>
-                </a:solidFill>
-                <a:latin typeface="Arial" panose="020B0604020202020204" pitchFamily="34" charset="0"/>
-                <a:cs typeface="Arial" panose="020B0604020202020204" pitchFamily="34" charset="0"/>
-              </a:rPr>
-              <a:t> cum, </a:t>
-            </a:r>
-            <a:r>
-              <a:rPr lang="en-US" sz="572" dirty="0" err="1">
-                <a:solidFill>
-                  <a:prstClr val="black"/>
-                </a:solidFill>
-                <a:latin typeface="Arial" panose="020B0604020202020204" pitchFamily="34" charset="0"/>
-                <a:cs typeface="Arial" panose="020B0604020202020204" pitchFamily="34" charset="0"/>
-              </a:rPr>
-              <a:t>quat</a:t>
-            </a:r>
-            <a:r>
-              <a:rPr lang="en-US" sz="572" dirty="0">
-                <a:solidFill>
-                  <a:prstClr val="black"/>
-                </a:solidFill>
-                <a:latin typeface="Arial" panose="020B0604020202020204" pitchFamily="34" charset="0"/>
-                <a:cs typeface="Arial" panose="020B0604020202020204" pitchFamily="34" charset="0"/>
-              </a:rPr>
-              <a:t> </a:t>
-            </a:r>
-            <a:r>
-              <a:rPr lang="en-US" sz="572" dirty="0" err="1">
-                <a:solidFill>
-                  <a:prstClr val="black"/>
-                </a:solidFill>
-                <a:latin typeface="Arial" panose="020B0604020202020204" pitchFamily="34" charset="0"/>
-                <a:cs typeface="Arial" panose="020B0604020202020204" pitchFamily="34" charset="0"/>
-              </a:rPr>
-              <a:t>paris</a:t>
-            </a:r>
-            <a:r>
-              <a:rPr lang="en-US" sz="572" dirty="0">
-                <a:solidFill>
-                  <a:prstClr val="black"/>
-                </a:solidFill>
-                <a:latin typeface="Arial" panose="020B0604020202020204" pitchFamily="34" charset="0"/>
-                <a:cs typeface="Arial" panose="020B0604020202020204" pitchFamily="34" charset="0"/>
-              </a:rPr>
-              <a:t> as core </a:t>
-            </a:r>
-            <a:r>
-              <a:rPr lang="en-US" sz="572" dirty="0" err="1">
-                <a:solidFill>
-                  <a:prstClr val="black"/>
-                </a:solidFill>
-                <a:latin typeface="Arial" panose="020B0604020202020204" pitchFamily="34" charset="0"/>
-                <a:cs typeface="Arial" panose="020B0604020202020204" pitchFamily="34" charset="0"/>
-              </a:rPr>
-              <a:t>volorest</a:t>
-            </a:r>
-            <a:r>
-              <a:rPr lang="en-US" sz="572" dirty="0">
-                <a:solidFill>
-                  <a:prstClr val="black"/>
-                </a:solidFill>
-                <a:latin typeface="Arial" panose="020B0604020202020204" pitchFamily="34" charset="0"/>
-                <a:cs typeface="Arial" panose="020B0604020202020204" pitchFamily="34" charset="0"/>
-              </a:rPr>
-              <a:t>, </a:t>
-            </a:r>
-            <a:r>
-              <a:rPr lang="en-US" sz="572" dirty="0" err="1">
-                <a:solidFill>
-                  <a:prstClr val="black"/>
-                </a:solidFill>
-                <a:latin typeface="Arial" panose="020B0604020202020204" pitchFamily="34" charset="0"/>
-                <a:cs typeface="Arial" panose="020B0604020202020204" pitchFamily="34" charset="0"/>
-              </a:rPr>
-              <a:t>sust</a:t>
-            </a:r>
-            <a:r>
-              <a:rPr lang="en-US" sz="572" dirty="0">
-                <a:solidFill>
-                  <a:prstClr val="black"/>
-                </a:solidFill>
-                <a:latin typeface="Arial" panose="020B0604020202020204" pitchFamily="34" charset="0"/>
-                <a:cs typeface="Arial" panose="020B0604020202020204" pitchFamily="34" charset="0"/>
-              </a:rPr>
-              <a:t> </a:t>
-            </a:r>
-            <a:r>
-              <a:rPr lang="en-US" sz="572" dirty="0" err="1">
-                <a:solidFill>
-                  <a:prstClr val="black"/>
-                </a:solidFill>
-                <a:latin typeface="Arial" panose="020B0604020202020204" pitchFamily="34" charset="0"/>
-                <a:cs typeface="Arial" panose="020B0604020202020204" pitchFamily="34" charset="0"/>
-              </a:rPr>
-              <a:t>exceatur</a:t>
-            </a:r>
-            <a:r>
-              <a:rPr lang="en-US" sz="572" dirty="0">
-                <a:solidFill>
-                  <a:prstClr val="black"/>
-                </a:solidFill>
-                <a:latin typeface="Arial" panose="020B0604020202020204" pitchFamily="34" charset="0"/>
-                <a:cs typeface="Arial" panose="020B0604020202020204" pitchFamily="34" charset="0"/>
-              </a:rPr>
-              <a:t> </a:t>
-            </a:r>
-            <a:r>
-              <a:rPr lang="en-US" sz="572" dirty="0" err="1">
-                <a:solidFill>
-                  <a:prstClr val="black"/>
-                </a:solidFill>
-                <a:latin typeface="Arial" panose="020B0604020202020204" pitchFamily="34" charset="0"/>
-                <a:cs typeface="Arial" panose="020B0604020202020204" pitchFamily="34" charset="0"/>
-              </a:rPr>
-              <a:t>antio</a:t>
-            </a:r>
-            <a:r>
-              <a:rPr lang="en-US" sz="572" dirty="0">
-                <a:solidFill>
-                  <a:prstClr val="black"/>
-                </a:solidFill>
-                <a:latin typeface="Arial" panose="020B0604020202020204" pitchFamily="34" charset="0"/>
-                <a:cs typeface="Arial" panose="020B0604020202020204" pitchFamily="34" charset="0"/>
-              </a:rPr>
-              <a:t> </a:t>
-            </a:r>
-            <a:r>
-              <a:rPr lang="en-US" sz="572" dirty="0" err="1">
-                <a:solidFill>
-                  <a:prstClr val="black"/>
-                </a:solidFill>
-                <a:latin typeface="Arial" panose="020B0604020202020204" pitchFamily="34" charset="0"/>
-                <a:cs typeface="Arial" panose="020B0604020202020204" pitchFamily="34" charset="0"/>
-              </a:rPr>
-              <a:t>ea</a:t>
-            </a:r>
-            <a:r>
-              <a:rPr lang="en-US" sz="572" dirty="0">
-                <a:solidFill>
-                  <a:prstClr val="black"/>
-                </a:solidFill>
-                <a:latin typeface="Arial" panose="020B0604020202020204" pitchFamily="34" charset="0"/>
-                <a:cs typeface="Arial" panose="020B0604020202020204" pitchFamily="34" charset="0"/>
-              </a:rPr>
-              <a:t> </a:t>
-            </a:r>
-            <a:r>
-              <a:rPr lang="en-US" sz="572" dirty="0" err="1">
-                <a:solidFill>
-                  <a:prstClr val="black"/>
-                </a:solidFill>
-                <a:latin typeface="Arial" panose="020B0604020202020204" pitchFamily="34" charset="0"/>
-                <a:cs typeface="Arial" panose="020B0604020202020204" pitchFamily="34" charset="0"/>
-              </a:rPr>
-              <a:t>voluptas</a:t>
-            </a:r>
-            <a:r>
-              <a:rPr lang="en-US" sz="572" dirty="0">
-                <a:solidFill>
-                  <a:prstClr val="black"/>
-                </a:solidFill>
-                <a:latin typeface="Arial" panose="020B0604020202020204" pitchFamily="34" charset="0"/>
-                <a:cs typeface="Arial" panose="020B0604020202020204" pitchFamily="34" charset="0"/>
-              </a:rPr>
-              <a:t> </a:t>
-            </a:r>
-            <a:r>
-              <a:rPr lang="en-US" sz="572" dirty="0" err="1">
-                <a:solidFill>
-                  <a:prstClr val="black"/>
-                </a:solidFill>
-                <a:latin typeface="Arial" panose="020B0604020202020204" pitchFamily="34" charset="0"/>
-                <a:cs typeface="Arial" panose="020B0604020202020204" pitchFamily="34" charset="0"/>
-              </a:rPr>
-              <a:t>eumquatendit</a:t>
-            </a:r>
-            <a:r>
-              <a:rPr lang="en-US" sz="572" dirty="0">
-                <a:solidFill>
-                  <a:prstClr val="black"/>
-                </a:solidFill>
-                <a:latin typeface="Arial" panose="020B0604020202020204" pitchFamily="34" charset="0"/>
-                <a:cs typeface="Arial" panose="020B0604020202020204" pitchFamily="34" charset="0"/>
-              </a:rPr>
-              <a:t> </a:t>
-            </a:r>
-            <a:r>
-              <a:rPr lang="en-US" sz="572" dirty="0" err="1">
-                <a:solidFill>
-                  <a:prstClr val="black"/>
-                </a:solidFill>
-                <a:latin typeface="Arial" panose="020B0604020202020204" pitchFamily="34" charset="0"/>
-                <a:cs typeface="Arial" panose="020B0604020202020204" pitchFamily="34" charset="0"/>
-              </a:rPr>
-              <a:t>quas</a:t>
-            </a:r>
-            <a:r>
-              <a:rPr lang="en-US" sz="572" dirty="0">
-                <a:solidFill>
-                  <a:prstClr val="black"/>
-                </a:solidFill>
-                <a:latin typeface="Arial" panose="020B0604020202020204" pitchFamily="34" charset="0"/>
-                <a:cs typeface="Arial" panose="020B0604020202020204" pitchFamily="34" charset="0"/>
-              </a:rPr>
-              <a:t> </a:t>
-            </a:r>
-            <a:r>
-              <a:rPr lang="en-US" sz="572" dirty="0" err="1">
-                <a:solidFill>
-                  <a:prstClr val="black"/>
-                </a:solidFill>
-                <a:latin typeface="Arial" panose="020B0604020202020204" pitchFamily="34" charset="0"/>
-                <a:cs typeface="Arial" panose="020B0604020202020204" pitchFamily="34" charset="0"/>
-              </a:rPr>
-              <a:t>doluptatet</a:t>
-            </a:r>
-            <a:r>
-              <a:rPr lang="en-US" sz="572" dirty="0">
-                <a:solidFill>
-                  <a:prstClr val="black"/>
-                </a:solidFill>
-                <a:latin typeface="Arial" panose="020B0604020202020204" pitchFamily="34" charset="0"/>
-                <a:cs typeface="Arial" panose="020B0604020202020204" pitchFamily="34" charset="0"/>
-              </a:rPr>
-              <a:t> </a:t>
-            </a:r>
-            <a:r>
-              <a:rPr lang="en-US" sz="572" dirty="0" err="1">
-                <a:solidFill>
-                  <a:prstClr val="black"/>
-                </a:solidFill>
-                <a:latin typeface="Arial" panose="020B0604020202020204" pitchFamily="34" charset="0"/>
-                <a:cs typeface="Arial" panose="020B0604020202020204" pitchFamily="34" charset="0"/>
-              </a:rPr>
-              <a:t>aut</a:t>
-            </a:r>
-            <a:r>
-              <a:rPr lang="en-US" sz="572" dirty="0">
-                <a:solidFill>
-                  <a:prstClr val="black"/>
-                </a:solidFill>
-                <a:latin typeface="Arial" panose="020B0604020202020204" pitchFamily="34" charset="0"/>
-                <a:cs typeface="Arial" panose="020B0604020202020204" pitchFamily="34" charset="0"/>
-              </a:rPr>
-              <a:t> </a:t>
-            </a:r>
-            <a:r>
-              <a:rPr lang="en-US" sz="572" dirty="0" err="1">
-                <a:solidFill>
-                  <a:prstClr val="black"/>
-                </a:solidFill>
-                <a:latin typeface="Arial" panose="020B0604020202020204" pitchFamily="34" charset="0"/>
-                <a:cs typeface="Arial" panose="020B0604020202020204" pitchFamily="34" charset="0"/>
-              </a:rPr>
-              <a:t>landignam</a:t>
-            </a:r>
-            <a:r>
-              <a:rPr lang="en-US" sz="572" dirty="0">
-                <a:solidFill>
-                  <a:prstClr val="black"/>
-                </a:solidFill>
-                <a:latin typeface="Arial" panose="020B0604020202020204" pitchFamily="34" charset="0"/>
-                <a:cs typeface="Arial" panose="020B0604020202020204" pitchFamily="34" charset="0"/>
-              </a:rPr>
-              <a:t> que </a:t>
-            </a:r>
-            <a:r>
-              <a:rPr lang="en-US" sz="572" dirty="0" err="1">
-                <a:solidFill>
-                  <a:prstClr val="black"/>
-                </a:solidFill>
-                <a:latin typeface="Arial" panose="020B0604020202020204" pitchFamily="34" charset="0"/>
-                <a:cs typeface="Arial" panose="020B0604020202020204" pitchFamily="34" charset="0"/>
-              </a:rPr>
-              <a:t>lantur</a:t>
-            </a:r>
-            <a:r>
-              <a:rPr lang="en-US" sz="572" dirty="0">
-                <a:solidFill>
-                  <a:prstClr val="black"/>
-                </a:solidFill>
-                <a:latin typeface="Arial" panose="020B0604020202020204" pitchFamily="34" charset="0"/>
-                <a:cs typeface="Arial" panose="020B0604020202020204" pitchFamily="34" charset="0"/>
-              </a:rPr>
-              <a:t> </a:t>
-            </a:r>
-            <a:r>
-              <a:rPr lang="en-US" sz="572" dirty="0" err="1">
-                <a:solidFill>
-                  <a:prstClr val="black"/>
-                </a:solidFill>
-                <a:latin typeface="Arial" panose="020B0604020202020204" pitchFamily="34" charset="0"/>
-                <a:cs typeface="Arial" panose="020B0604020202020204" pitchFamily="34" charset="0"/>
-              </a:rPr>
-              <a:t>sania</a:t>
-            </a:r>
-            <a:r>
-              <a:rPr lang="en-US" sz="572" dirty="0">
-                <a:solidFill>
-                  <a:prstClr val="black"/>
-                </a:solidFill>
-                <a:latin typeface="Arial" panose="020B0604020202020204" pitchFamily="34" charset="0"/>
-                <a:cs typeface="Arial" panose="020B0604020202020204" pitchFamily="34" charset="0"/>
-              </a:rPr>
-              <a:t> </a:t>
-            </a:r>
-            <a:r>
-              <a:rPr lang="en-US" sz="572" dirty="0" err="1">
-                <a:solidFill>
-                  <a:prstClr val="black"/>
-                </a:solidFill>
-                <a:latin typeface="Arial" panose="020B0604020202020204" pitchFamily="34" charset="0"/>
-                <a:cs typeface="Arial" panose="020B0604020202020204" pitchFamily="34" charset="0"/>
-              </a:rPr>
-              <a:t>dem</a:t>
-            </a:r>
-            <a:r>
-              <a:rPr lang="en-US" sz="572" dirty="0">
-                <a:solidFill>
-                  <a:prstClr val="black"/>
-                </a:solidFill>
-                <a:latin typeface="Arial" panose="020B0604020202020204" pitchFamily="34" charset="0"/>
-                <a:cs typeface="Arial" panose="020B0604020202020204" pitchFamily="34" charset="0"/>
-              </a:rPr>
-              <a:t> </a:t>
-            </a:r>
-            <a:r>
-              <a:rPr lang="en-US" sz="572" dirty="0" err="1">
-                <a:solidFill>
-                  <a:prstClr val="black"/>
-                </a:solidFill>
-                <a:latin typeface="Arial" panose="020B0604020202020204" pitchFamily="34" charset="0"/>
-                <a:cs typeface="Arial" panose="020B0604020202020204" pitchFamily="34" charset="0"/>
-              </a:rPr>
-              <a:t>escidit</a:t>
-            </a:r>
-            <a:r>
-              <a:rPr lang="en-US" sz="572" dirty="0">
-                <a:solidFill>
-                  <a:prstClr val="black"/>
-                </a:solidFill>
-                <a:latin typeface="Arial" panose="020B0604020202020204" pitchFamily="34" charset="0"/>
-                <a:cs typeface="Arial" panose="020B0604020202020204" pitchFamily="34" charset="0"/>
-              </a:rPr>
-              <a:t> min </a:t>
-            </a:r>
-            <a:r>
-              <a:rPr lang="en-US" sz="572" dirty="0" err="1">
-                <a:solidFill>
-                  <a:prstClr val="black"/>
-                </a:solidFill>
-                <a:latin typeface="Arial" panose="020B0604020202020204" pitchFamily="34" charset="0"/>
-                <a:cs typeface="Arial" panose="020B0604020202020204" pitchFamily="34" charset="0"/>
-              </a:rPr>
-              <a:t>reruptiaero</a:t>
-            </a:r>
-            <a:r>
-              <a:rPr lang="en-US" sz="572" dirty="0">
-                <a:solidFill>
-                  <a:prstClr val="black"/>
-                </a:solidFill>
-                <a:latin typeface="Arial" panose="020B0604020202020204" pitchFamily="34" charset="0"/>
-                <a:cs typeface="Arial" panose="020B0604020202020204" pitchFamily="34" charset="0"/>
-              </a:rPr>
-              <a:t> </a:t>
-            </a:r>
-            <a:r>
-              <a:rPr lang="en-US" sz="572" dirty="0" err="1">
-                <a:solidFill>
-                  <a:prstClr val="black"/>
-                </a:solidFill>
-                <a:latin typeface="Arial" panose="020B0604020202020204" pitchFamily="34" charset="0"/>
-                <a:cs typeface="Arial" panose="020B0604020202020204" pitchFamily="34" charset="0"/>
-              </a:rPr>
-              <a:t>velis</a:t>
-            </a:r>
-            <a:r>
-              <a:rPr lang="en-US" sz="572" dirty="0">
-                <a:solidFill>
-                  <a:prstClr val="black"/>
-                </a:solidFill>
-                <a:latin typeface="Arial" panose="020B0604020202020204" pitchFamily="34" charset="0"/>
-                <a:cs typeface="Arial" panose="020B0604020202020204" pitchFamily="34" charset="0"/>
-              </a:rPr>
-              <a:t> maximus </a:t>
-            </a:r>
-            <a:r>
-              <a:rPr lang="en-US" sz="572" dirty="0" err="1">
-                <a:solidFill>
-                  <a:prstClr val="black"/>
-                </a:solidFill>
-                <a:latin typeface="Arial" panose="020B0604020202020204" pitchFamily="34" charset="0"/>
-                <a:cs typeface="Arial" panose="020B0604020202020204" pitchFamily="34" charset="0"/>
-              </a:rPr>
-              <a:t>aut</a:t>
-            </a:r>
-            <a:r>
-              <a:rPr lang="en-US" sz="572" dirty="0">
-                <a:solidFill>
-                  <a:prstClr val="black"/>
-                </a:solidFill>
-                <a:latin typeface="Arial" panose="020B0604020202020204" pitchFamily="34" charset="0"/>
-                <a:cs typeface="Arial" panose="020B0604020202020204" pitchFamily="34" charset="0"/>
-              </a:rPr>
-              <a:t> que </a:t>
-            </a:r>
-            <a:r>
-              <a:rPr lang="en-US" sz="572" dirty="0" err="1">
-                <a:solidFill>
-                  <a:prstClr val="black"/>
-                </a:solidFill>
-                <a:latin typeface="Arial" panose="020B0604020202020204" pitchFamily="34" charset="0"/>
-                <a:cs typeface="Arial" panose="020B0604020202020204" pitchFamily="34" charset="0"/>
-              </a:rPr>
-              <a:t>pe</a:t>
-            </a:r>
-            <a:r>
-              <a:rPr lang="en-US" sz="572" dirty="0">
-                <a:solidFill>
-                  <a:prstClr val="black"/>
-                </a:solidFill>
-                <a:latin typeface="Arial" panose="020B0604020202020204" pitchFamily="34" charset="0"/>
-                <a:cs typeface="Arial" panose="020B0604020202020204" pitchFamily="34" charset="0"/>
-              </a:rPr>
-              <a:t> </a:t>
-            </a:r>
-            <a:r>
-              <a:rPr lang="en-US" sz="572" dirty="0" err="1">
-                <a:solidFill>
-                  <a:prstClr val="black"/>
-                </a:solidFill>
-                <a:latin typeface="Arial" panose="020B0604020202020204" pitchFamily="34" charset="0"/>
-                <a:cs typeface="Arial" panose="020B0604020202020204" pitchFamily="34" charset="0"/>
-              </a:rPr>
-              <a:t>aliquas</a:t>
-            </a:r>
-            <a:r>
-              <a:rPr lang="en-US" sz="572" dirty="0">
-                <a:solidFill>
-                  <a:prstClr val="black"/>
-                </a:solidFill>
-                <a:latin typeface="Arial" panose="020B0604020202020204" pitchFamily="34" charset="0"/>
-                <a:cs typeface="Arial" panose="020B0604020202020204" pitchFamily="34" charset="0"/>
-              </a:rPr>
-              <a:t> </a:t>
-            </a:r>
-            <a:r>
-              <a:rPr lang="en-US" sz="572" dirty="0" err="1">
-                <a:solidFill>
-                  <a:prstClr val="black"/>
-                </a:solidFill>
-                <a:latin typeface="Arial" panose="020B0604020202020204" pitchFamily="34" charset="0"/>
-                <a:cs typeface="Arial" panose="020B0604020202020204" pitchFamily="34" charset="0"/>
-              </a:rPr>
-              <a:t>sequidisit</a:t>
-            </a:r>
-            <a:r>
-              <a:rPr lang="en-US" sz="572" dirty="0">
-                <a:solidFill>
-                  <a:prstClr val="black"/>
-                </a:solidFill>
-                <a:latin typeface="Arial" panose="020B0604020202020204" pitchFamily="34" charset="0"/>
-                <a:cs typeface="Arial" panose="020B0604020202020204" pitchFamily="34" charset="0"/>
-              </a:rPr>
-              <a:t>, </a:t>
-            </a:r>
-            <a:r>
-              <a:rPr lang="en-US" sz="572" dirty="0" err="1">
-                <a:solidFill>
-                  <a:prstClr val="black"/>
-                </a:solidFill>
-                <a:latin typeface="Arial" panose="020B0604020202020204" pitchFamily="34" charset="0"/>
-                <a:cs typeface="Arial" panose="020B0604020202020204" pitchFamily="34" charset="0"/>
-              </a:rPr>
-              <a:t>omnient</a:t>
-            </a:r>
-            <a:r>
-              <a:rPr lang="en-US" sz="572" dirty="0">
-                <a:solidFill>
-                  <a:prstClr val="black"/>
-                </a:solidFill>
-                <a:latin typeface="Arial" panose="020B0604020202020204" pitchFamily="34" charset="0"/>
-                <a:cs typeface="Arial" panose="020B0604020202020204" pitchFamily="34" charset="0"/>
-              </a:rPr>
-              <a:t> hit lam </a:t>
-            </a:r>
-            <a:r>
-              <a:rPr lang="en-US" sz="572" dirty="0" err="1">
-                <a:solidFill>
-                  <a:prstClr val="black"/>
-                </a:solidFill>
-                <a:latin typeface="Arial" panose="020B0604020202020204" pitchFamily="34" charset="0"/>
-                <a:cs typeface="Arial" panose="020B0604020202020204" pitchFamily="34" charset="0"/>
-              </a:rPr>
-              <a:t>eicias</a:t>
-            </a:r>
-            <a:r>
-              <a:rPr lang="en-US" sz="572" dirty="0">
-                <a:solidFill>
-                  <a:prstClr val="black"/>
-                </a:solidFill>
-                <a:latin typeface="Arial" panose="020B0604020202020204" pitchFamily="34" charset="0"/>
-                <a:cs typeface="Arial" panose="020B0604020202020204" pitchFamily="34" charset="0"/>
-              </a:rPr>
-              <a:t> </a:t>
-            </a:r>
-            <a:r>
-              <a:rPr lang="en-US" sz="572" dirty="0" err="1">
-                <a:solidFill>
-                  <a:prstClr val="black"/>
-                </a:solidFill>
-                <a:latin typeface="Arial" panose="020B0604020202020204" pitchFamily="34" charset="0"/>
-                <a:cs typeface="Arial" panose="020B0604020202020204" pitchFamily="34" charset="0"/>
-              </a:rPr>
-              <a:t>modio</a:t>
-            </a:r>
-            <a:r>
-              <a:rPr lang="en-US" sz="572" dirty="0">
-                <a:solidFill>
-                  <a:prstClr val="black"/>
-                </a:solidFill>
-                <a:latin typeface="Arial" panose="020B0604020202020204" pitchFamily="34" charset="0"/>
-                <a:cs typeface="Arial" panose="020B0604020202020204" pitchFamily="34" charset="0"/>
-              </a:rPr>
-              <a:t> con </a:t>
-            </a:r>
-            <a:r>
-              <a:rPr lang="en-US" sz="572" dirty="0" err="1">
-                <a:solidFill>
-                  <a:prstClr val="black"/>
-                </a:solidFill>
-                <a:latin typeface="Arial" panose="020B0604020202020204" pitchFamily="34" charset="0"/>
-                <a:cs typeface="Arial" panose="020B0604020202020204" pitchFamily="34" charset="0"/>
-              </a:rPr>
-              <a:t>nisin</a:t>
-            </a:r>
-            <a:r>
-              <a:rPr lang="en-US" sz="572" dirty="0">
-                <a:solidFill>
-                  <a:prstClr val="black"/>
-                </a:solidFill>
-                <a:latin typeface="Arial" panose="020B0604020202020204" pitchFamily="34" charset="0"/>
-                <a:cs typeface="Arial" panose="020B0604020202020204" pitchFamily="34" charset="0"/>
-              </a:rPr>
-              <a:t> </a:t>
-            </a:r>
-            <a:r>
-              <a:rPr lang="en-US" sz="572" dirty="0" err="1">
-                <a:solidFill>
-                  <a:prstClr val="black"/>
-                </a:solidFill>
-                <a:latin typeface="Arial" panose="020B0604020202020204" pitchFamily="34" charset="0"/>
-                <a:cs typeface="Arial" panose="020B0604020202020204" pitchFamily="34" charset="0"/>
-              </a:rPr>
-              <a:t>pediam</a:t>
-            </a:r>
-            <a:r>
-              <a:rPr lang="en-US" sz="572" dirty="0">
-                <a:solidFill>
-                  <a:prstClr val="black"/>
-                </a:solidFill>
-                <a:latin typeface="Arial" panose="020B0604020202020204" pitchFamily="34" charset="0"/>
-                <a:cs typeface="Arial" panose="020B0604020202020204" pitchFamily="34" charset="0"/>
-              </a:rPr>
-              <a:t>, </a:t>
-            </a:r>
-            <a:r>
-              <a:rPr lang="en-US" sz="572" dirty="0" err="1">
-                <a:solidFill>
-                  <a:prstClr val="black"/>
-                </a:solidFill>
-                <a:latin typeface="Arial" panose="020B0604020202020204" pitchFamily="34" charset="0"/>
-                <a:cs typeface="Arial" panose="020B0604020202020204" pitchFamily="34" charset="0"/>
-              </a:rPr>
-              <a:t>ent</a:t>
-            </a:r>
-            <a:r>
-              <a:rPr lang="en-US" sz="572" dirty="0">
-                <a:solidFill>
-                  <a:prstClr val="black"/>
-                </a:solidFill>
-                <a:latin typeface="Arial" panose="020B0604020202020204" pitchFamily="34" charset="0"/>
-                <a:cs typeface="Arial" panose="020B0604020202020204" pitchFamily="34" charset="0"/>
-              </a:rPr>
-              <a:t>, </a:t>
-            </a:r>
-            <a:r>
-              <a:rPr lang="en-US" sz="572" dirty="0" err="1">
-                <a:solidFill>
-                  <a:prstClr val="black"/>
-                </a:solidFill>
-                <a:latin typeface="Arial" panose="020B0604020202020204" pitchFamily="34" charset="0"/>
-                <a:cs typeface="Arial" panose="020B0604020202020204" pitchFamily="34" charset="0"/>
-              </a:rPr>
-              <a:t>cust</a:t>
-            </a:r>
-            <a:r>
-              <a:rPr lang="en-US" sz="572" dirty="0">
-                <a:solidFill>
-                  <a:prstClr val="black"/>
-                </a:solidFill>
-                <a:latin typeface="Arial" panose="020B0604020202020204" pitchFamily="34" charset="0"/>
-                <a:cs typeface="Arial" panose="020B0604020202020204" pitchFamily="34" charset="0"/>
-              </a:rPr>
-              <a:t> </a:t>
-            </a:r>
-            <a:r>
-              <a:rPr lang="en-US" sz="572" dirty="0" err="1">
-                <a:solidFill>
-                  <a:prstClr val="black"/>
-                </a:solidFill>
-                <a:latin typeface="Arial" panose="020B0604020202020204" pitchFamily="34" charset="0"/>
-                <a:cs typeface="Arial" panose="020B0604020202020204" pitchFamily="34" charset="0"/>
-              </a:rPr>
-              <a:t>accaborit</a:t>
-            </a:r>
-            <a:r>
-              <a:rPr lang="en-US" sz="572" dirty="0">
-                <a:solidFill>
-                  <a:prstClr val="black"/>
-                </a:solidFill>
-                <a:latin typeface="Arial" panose="020B0604020202020204" pitchFamily="34" charset="0"/>
-                <a:cs typeface="Arial" panose="020B0604020202020204" pitchFamily="34" charset="0"/>
-              </a:rPr>
-              <a:t> </a:t>
-            </a:r>
-            <a:r>
-              <a:rPr lang="en-US" sz="572" dirty="0" err="1">
-                <a:solidFill>
-                  <a:prstClr val="black"/>
-                </a:solidFill>
-                <a:latin typeface="Arial" panose="020B0604020202020204" pitchFamily="34" charset="0"/>
-                <a:cs typeface="Arial" panose="020B0604020202020204" pitchFamily="34" charset="0"/>
-              </a:rPr>
-              <a:t>odio</a:t>
-            </a:r>
-            <a:r>
-              <a:rPr lang="en-US" sz="572" dirty="0">
-                <a:solidFill>
-                  <a:prstClr val="black"/>
-                </a:solidFill>
-                <a:latin typeface="Arial" panose="020B0604020202020204" pitchFamily="34" charset="0"/>
-                <a:cs typeface="Arial" panose="020B0604020202020204" pitchFamily="34" charset="0"/>
-              </a:rPr>
-              <a:t> </a:t>
-            </a:r>
-            <a:r>
-              <a:rPr lang="en-US" sz="572" dirty="0" err="1">
-                <a:solidFill>
-                  <a:prstClr val="black"/>
-                </a:solidFill>
-                <a:latin typeface="Arial" panose="020B0604020202020204" pitchFamily="34" charset="0"/>
-                <a:cs typeface="Arial" panose="020B0604020202020204" pitchFamily="34" charset="0"/>
-              </a:rPr>
-              <a:t>corehen</a:t>
-            </a:r>
-            <a:r>
-              <a:rPr lang="en-US" sz="572" dirty="0">
-                <a:solidFill>
-                  <a:prstClr val="black"/>
-                </a:solidFill>
-                <a:latin typeface="Arial" panose="020B0604020202020204" pitchFamily="34" charset="0"/>
-                <a:cs typeface="Arial" panose="020B0604020202020204" pitchFamily="34" charset="0"/>
-              </a:rPr>
-              <a:t> </a:t>
-            </a:r>
-            <a:r>
-              <a:rPr lang="en-US" sz="572" dirty="0" err="1">
-                <a:solidFill>
-                  <a:prstClr val="black"/>
-                </a:solidFill>
-                <a:latin typeface="Arial" panose="020B0604020202020204" pitchFamily="34" charset="0"/>
-                <a:cs typeface="Arial" panose="020B0604020202020204" pitchFamily="34" charset="0"/>
-              </a:rPr>
-              <a:t>dendae</a:t>
-            </a:r>
-            <a:r>
-              <a:rPr lang="en-US" sz="572" dirty="0">
-                <a:solidFill>
-                  <a:prstClr val="black"/>
-                </a:solidFill>
-                <a:latin typeface="Arial" panose="020B0604020202020204" pitchFamily="34" charset="0"/>
-                <a:cs typeface="Arial" panose="020B0604020202020204" pitchFamily="34" charset="0"/>
-              </a:rPr>
-              <a:t> nonet </a:t>
-            </a:r>
-            <a:r>
-              <a:rPr lang="en-US" sz="572" dirty="0" err="1">
-                <a:solidFill>
-                  <a:prstClr val="black"/>
-                </a:solidFill>
-                <a:latin typeface="Arial" panose="020B0604020202020204" pitchFamily="34" charset="0"/>
-                <a:cs typeface="Arial" panose="020B0604020202020204" pitchFamily="34" charset="0"/>
-              </a:rPr>
-              <a:t>eliquam</a:t>
-            </a:r>
-            <a:r>
-              <a:rPr lang="en-US" sz="572" dirty="0">
-                <a:solidFill>
-                  <a:prstClr val="black"/>
-                </a:solidFill>
-                <a:latin typeface="Arial" panose="020B0604020202020204" pitchFamily="34" charset="0"/>
-                <a:cs typeface="Arial" panose="020B0604020202020204" pitchFamily="34" charset="0"/>
-              </a:rPr>
-              <a:t>, </a:t>
-            </a:r>
-            <a:r>
-              <a:rPr lang="en-US" sz="572" dirty="0" err="1">
-                <a:solidFill>
-                  <a:prstClr val="black"/>
-                </a:solidFill>
-                <a:latin typeface="Arial" panose="020B0604020202020204" pitchFamily="34" charset="0"/>
-                <a:cs typeface="Arial" panose="020B0604020202020204" pitchFamily="34" charset="0"/>
-              </a:rPr>
-              <a:t>aperorepe</a:t>
-            </a:r>
-            <a:r>
-              <a:rPr lang="en-US" sz="572" dirty="0">
-                <a:solidFill>
-                  <a:prstClr val="black"/>
-                </a:solidFill>
-                <a:latin typeface="Arial" panose="020B0604020202020204" pitchFamily="34" charset="0"/>
-                <a:cs typeface="Arial" panose="020B0604020202020204" pitchFamily="34" charset="0"/>
-              </a:rPr>
-              <a:t> </a:t>
-            </a:r>
-            <a:r>
-              <a:rPr lang="en-US" sz="572" dirty="0" err="1">
-                <a:solidFill>
-                  <a:prstClr val="black"/>
-                </a:solidFill>
-                <a:latin typeface="Arial" panose="020B0604020202020204" pitchFamily="34" charset="0"/>
-                <a:cs typeface="Arial" panose="020B0604020202020204" pitchFamily="34" charset="0"/>
-              </a:rPr>
-              <a:t>autatem</a:t>
-            </a:r>
-            <a:r>
-              <a:rPr lang="en-US" sz="572" dirty="0">
-                <a:solidFill>
-                  <a:prstClr val="black"/>
-                </a:solidFill>
-                <a:latin typeface="Arial" panose="020B0604020202020204" pitchFamily="34" charset="0"/>
-                <a:cs typeface="Arial" panose="020B0604020202020204" pitchFamily="34" charset="0"/>
-              </a:rPr>
-              <a:t> voles </a:t>
-            </a:r>
-            <a:r>
-              <a:rPr lang="en-US" sz="572" dirty="0" err="1">
-                <a:solidFill>
-                  <a:prstClr val="black"/>
-                </a:solidFill>
-                <a:latin typeface="Arial" panose="020B0604020202020204" pitchFamily="34" charset="0"/>
-                <a:cs typeface="Arial" panose="020B0604020202020204" pitchFamily="34" charset="0"/>
-              </a:rPr>
-              <a:t>int</a:t>
-            </a:r>
-            <a:r>
-              <a:rPr lang="en-US" sz="572" dirty="0">
-                <a:solidFill>
-                  <a:prstClr val="black"/>
-                </a:solidFill>
-                <a:latin typeface="Arial" panose="020B0604020202020204" pitchFamily="34" charset="0"/>
-                <a:cs typeface="Arial" panose="020B0604020202020204" pitchFamily="34" charset="0"/>
-              </a:rPr>
-              <a:t> </a:t>
-            </a:r>
-            <a:r>
-              <a:rPr lang="en-US" sz="572" dirty="0" err="1">
-                <a:solidFill>
-                  <a:prstClr val="black"/>
-                </a:solidFill>
-                <a:latin typeface="Arial" panose="020B0604020202020204" pitchFamily="34" charset="0"/>
-                <a:cs typeface="Arial" panose="020B0604020202020204" pitchFamily="34" charset="0"/>
-              </a:rPr>
-              <a:t>odic</a:t>
-            </a:r>
-            <a:r>
-              <a:rPr lang="en-US" sz="572" dirty="0">
-                <a:solidFill>
-                  <a:prstClr val="black"/>
-                </a:solidFill>
-                <a:latin typeface="Arial" panose="020B0604020202020204" pitchFamily="34" charset="0"/>
-                <a:cs typeface="Arial" panose="020B0604020202020204" pitchFamily="34" charset="0"/>
-              </a:rPr>
-              <a:t> </a:t>
-            </a:r>
-            <a:r>
-              <a:rPr lang="en-US" sz="572" dirty="0" err="1">
-                <a:solidFill>
-                  <a:prstClr val="black"/>
-                </a:solidFill>
-                <a:latin typeface="Arial" panose="020B0604020202020204" pitchFamily="34" charset="0"/>
-                <a:cs typeface="Arial" panose="020B0604020202020204" pitchFamily="34" charset="0"/>
-              </a:rPr>
-              <a:t>tem</a:t>
-            </a:r>
-            <a:r>
-              <a:rPr lang="en-US" sz="572" dirty="0">
-                <a:solidFill>
-                  <a:prstClr val="black"/>
-                </a:solidFill>
-                <a:latin typeface="Arial" panose="020B0604020202020204" pitchFamily="34" charset="0"/>
-                <a:cs typeface="Arial" panose="020B0604020202020204" pitchFamily="34" charset="0"/>
-              </a:rPr>
-              <a:t> </a:t>
-            </a:r>
-            <a:r>
-              <a:rPr lang="en-US" sz="572" dirty="0" err="1">
-                <a:solidFill>
-                  <a:prstClr val="black"/>
-                </a:solidFill>
-                <a:latin typeface="Arial" panose="020B0604020202020204" pitchFamily="34" charset="0"/>
-                <a:cs typeface="Arial" panose="020B0604020202020204" pitchFamily="34" charset="0"/>
-              </a:rPr>
-              <a:t>nis</a:t>
-            </a:r>
-            <a:r>
-              <a:rPr lang="en-US" sz="572" dirty="0">
-                <a:solidFill>
-                  <a:prstClr val="black"/>
-                </a:solidFill>
-                <a:latin typeface="Arial" panose="020B0604020202020204" pitchFamily="34" charset="0"/>
-                <a:cs typeface="Arial" panose="020B0604020202020204" pitchFamily="34" charset="0"/>
-              </a:rPr>
-              <a:t> </a:t>
-            </a:r>
-            <a:r>
-              <a:rPr lang="en-US" sz="572" dirty="0" err="1">
-                <a:solidFill>
-                  <a:prstClr val="black"/>
-                </a:solidFill>
-                <a:latin typeface="Arial" panose="020B0604020202020204" pitchFamily="34" charset="0"/>
-                <a:cs typeface="Arial" panose="020B0604020202020204" pitchFamily="34" charset="0"/>
-              </a:rPr>
-              <a:t>dolorrum</a:t>
-            </a:r>
-            <a:r>
-              <a:rPr lang="en-US" sz="572" dirty="0">
-                <a:solidFill>
-                  <a:prstClr val="black"/>
-                </a:solidFill>
-                <a:latin typeface="Arial" panose="020B0604020202020204" pitchFamily="34" charset="0"/>
-                <a:cs typeface="Arial" panose="020B0604020202020204" pitchFamily="34" charset="0"/>
-              </a:rPr>
-              <a:t> que cores </a:t>
-            </a:r>
-            <a:r>
-              <a:rPr lang="en-US" sz="572" dirty="0" err="1">
-                <a:solidFill>
-                  <a:prstClr val="black"/>
-                </a:solidFill>
-                <a:latin typeface="Arial" panose="020B0604020202020204" pitchFamily="34" charset="0"/>
-                <a:cs typeface="Arial" panose="020B0604020202020204" pitchFamily="34" charset="0"/>
-              </a:rPr>
-              <a:t>doluptaturi</a:t>
-            </a:r>
-            <a:r>
-              <a:rPr lang="en-US" sz="572" dirty="0">
-                <a:solidFill>
-                  <a:prstClr val="black"/>
-                </a:solidFill>
-                <a:latin typeface="Arial" panose="020B0604020202020204" pitchFamily="34" charset="0"/>
-                <a:cs typeface="Arial" panose="020B0604020202020204" pitchFamily="34" charset="0"/>
-              </a:rPr>
-              <a:t> </a:t>
-            </a:r>
-            <a:r>
-              <a:rPr lang="en-US" sz="572" dirty="0" err="1">
-                <a:solidFill>
-                  <a:prstClr val="black"/>
-                </a:solidFill>
-                <a:latin typeface="Arial" panose="020B0604020202020204" pitchFamily="34" charset="0"/>
-                <a:cs typeface="Arial" panose="020B0604020202020204" pitchFamily="34" charset="0"/>
-              </a:rPr>
-              <a:t>utemolorum</a:t>
-            </a:r>
-            <a:r>
-              <a:rPr lang="en-US" sz="572" dirty="0">
-                <a:solidFill>
-                  <a:prstClr val="black"/>
-                </a:solidFill>
-                <a:latin typeface="Arial" panose="020B0604020202020204" pitchFamily="34" charset="0"/>
-                <a:cs typeface="Arial" panose="020B0604020202020204" pitchFamily="34" charset="0"/>
-              </a:rPr>
-              <a:t> </a:t>
-            </a:r>
-            <a:r>
-              <a:rPr lang="en-US" sz="572" dirty="0" err="1">
-                <a:solidFill>
-                  <a:prstClr val="black"/>
-                </a:solidFill>
-                <a:latin typeface="Arial" panose="020B0604020202020204" pitchFamily="34" charset="0"/>
-                <a:cs typeface="Arial" panose="020B0604020202020204" pitchFamily="34" charset="0"/>
-              </a:rPr>
-              <a:t>imusam</a:t>
-            </a:r>
-            <a:r>
-              <a:rPr lang="en-US" sz="572" dirty="0">
-                <a:solidFill>
-                  <a:prstClr val="black"/>
-                </a:solidFill>
-                <a:latin typeface="Arial" panose="020B0604020202020204" pitchFamily="34" charset="0"/>
-                <a:cs typeface="Arial" panose="020B0604020202020204" pitchFamily="34" charset="0"/>
-              </a:rPr>
-              <a:t>,</a:t>
+              <a:t>I would like to express my gratitude to Professor Aaron Zimmerman for his instruction in Engineering Physics II, which provided the theoretical foundations for this research. I also thank Professor Seth Bank for his guidance on the underlying electrical engineering concepts. Finally, I would like to acknowledge my Lab TA, Tannishtha Nandi, for facilitating access to the laboratory equipment and providing the necessary statistical tools for our data analysis throughout the semester.</a:t>
             </a:r>
           </a:p>
         </p:txBody>
@@ -7985,8 +7007,8 @@
         </p:nvSpPr>
         <p:spPr>
           <a:xfrm>
-            <a:off x="7873433" y="5691997"/>
-            <a:ext cx="2592548" cy="884666"/>
+            <a:off x="7845698" y="5706033"/>
+            <a:ext cx="2592548" cy="532518"/>
           </a:xfrm>
           <a:prstGeom prst="rect">
             <a:avLst/>
@@ -8000,6 +7022,16 @@
           <a:lstStyle/>
           <a:p>
             <a:pPr defTabSz="780653"/>
+            <a:r>
+              <a:rPr lang="en-US" sz="572" dirty="0">
+                <a:solidFill>
+                  <a:prstClr val="black"/>
+                </a:solidFill>
+                <a:latin typeface="Arial" panose="020B0604020202020204" pitchFamily="34" charset="0"/>
+                <a:cs typeface="Arial" panose="020B0604020202020204" pitchFamily="34" charset="0"/>
+              </a:rPr>
+              <a:t>[1] F.T Ulaby, M.M. </a:t>
+            </a:r>
             <a:r>
               <a:rPr lang="en-US" sz="572" dirty="0" err="1">
                 <a:solidFill>
@@ -8008,7 +7040,7 @@
                 <a:latin typeface="Arial" panose="020B0604020202020204" pitchFamily="34" charset="0"/>
                 <a:cs typeface="Arial" panose="020B0604020202020204" pitchFamily="34" charset="0"/>
               </a:rPr>
-              <a:t>Vitam</a:t>
+              <a:t>Maharbiz</a:t>
             </a:r>
             <a:r>
               <a:rPr lang="en-US" sz="572" dirty="0">
@@ -8018,17 +7050,17 @@
                 <a:latin typeface="Arial" panose="020B0604020202020204" pitchFamily="34" charset="0"/>
                 <a:cs typeface="Arial" panose="020B0604020202020204" pitchFamily="34" charset="0"/>
               </a:rPr>
-              <a:t> </a:t>
-            </a:r>
-            <a:r>
-              <a:rPr lang="en-US" sz="572" dirty="0" err="1">
+              <a:t>, C.M. Furse, </a:t>
+            </a:r>
+            <a:r>
+              <a:rPr lang="en-US" sz="572" i="1" dirty="0">
                 <a:solidFill>
                   <a:prstClr val="black"/>
                 </a:solidFill>
                 <a:latin typeface="Arial" panose="020B0604020202020204" pitchFamily="34" charset="0"/>
                 <a:cs typeface="Arial" panose="020B0604020202020204" pitchFamily="34" charset="0"/>
               </a:rPr>
-              <a:t>voloria</a:t>
+              <a:t>Circuit Analysis and Design</a:t>
             </a:r>
             <a:r>
               <a:rPr lang="en-US" sz="572" dirty="0">
@@ -8038,17 +7070,17 @@
                 <a:latin typeface="Arial" panose="020B0604020202020204" pitchFamily="34" charset="0"/>
                 <a:cs typeface="Arial" panose="020B0604020202020204" pitchFamily="34" charset="0"/>
               </a:rPr>
-              <a:t> con et, cum </a:t>
-            </a:r>
-            <a:r>
-              <a:rPr lang="en-US" sz="572" dirty="0" err="1">
+              <a:t>, 2</a:t>
+            </a:r>
+            <a:r>
+              <a:rPr lang="en-US" sz="572" baseline="30000" dirty="0">
                 <a:solidFill>
                   <a:prstClr val="black"/>
                 </a:solidFill>
                 <a:latin typeface="Arial" panose="020B0604020202020204" pitchFamily="34" charset="0"/>
                 <a:cs typeface="Arial" panose="020B0604020202020204" pitchFamily="34" charset="0"/>
               </a:rPr>
-              <a:t>laboreium</a:t>
+              <a:t>nd</a:t>
             </a:r>
             <a:r>
               <a:rPr lang="en-US" sz="572" dirty="0">
@@ -8058,18 +7090,21 @@
                 <a:latin typeface="Arial" panose="020B0604020202020204" pitchFamily="34" charset="0"/>
                 <a:cs typeface="Arial" panose="020B0604020202020204" pitchFamily="34" charset="0"/>
               </a:rPr>
-              <a:t>, </a:t>
-            </a:r>
-            <a:r>
-              <a:rPr lang="en-US" sz="572" dirty="0" err="1">
-                <a:solidFill>
-                  <a:prstClr val="black"/>
-                </a:solidFill>
-                <a:latin typeface="Arial" panose="020B0604020202020204" pitchFamily="34" charset="0"/>
-                <a:cs typeface="Arial" panose="020B0604020202020204" pitchFamily="34" charset="0"/>
-              </a:rPr>
-              <a:t>nam</a:t>
-            </a:r>
+              <a:t> ed. Ann Arbor, MI, USA: Michigan Publishing, 2024</a:t>
+            </a:r>
+          </a:p>
+          <a:p>
+            <a:pPr defTabSz="780653"/>
+            <a:endParaRPr lang="en-US" sz="572" dirty="0">
+              <a:solidFill>
+                <a:prstClr val="black"/>
+              </a:solidFill>
+              <a:latin typeface="Arial" panose="020B0604020202020204" pitchFamily="34" charset="0"/>
+              <a:cs typeface="Arial" panose="020B0604020202020204" pitchFamily="34" charset="0"/>
+            </a:endParaRPr>
+          </a:p>
+          <a:p>
+            <a:pPr defTabSz="780653"/>
             <a:r>
               <a:rPr lang="en-US" sz="572" dirty="0">
                 <a:solidFill>
@@ -8078,17 +7113,17 @@
                 <a:latin typeface="Arial" panose="020B0604020202020204" pitchFamily="34" charset="0"/>
                 <a:cs typeface="Arial" panose="020B0604020202020204" pitchFamily="34" charset="0"/>
               </a:rPr>
-              <a:t> cum, </a:t>
-            </a:r>
-            <a:r>
-              <a:rPr lang="en-US" sz="572" dirty="0" err="1">
+              <a:t>[2] H.C Ohanian and J.T Markert, </a:t>
+            </a:r>
+            <a:r>
+              <a:rPr lang="en-US" sz="572" i="1" dirty="0">
                 <a:solidFill>
                   <a:prstClr val="black"/>
                 </a:solidFill>
                 <a:latin typeface="Arial" panose="020B0604020202020204" pitchFamily="34" charset="0"/>
                 <a:cs typeface="Arial" panose="020B0604020202020204" pitchFamily="34" charset="0"/>
               </a:rPr>
-              <a:t>quat</a:t>
+              <a:t>Physics for Engineers and Scientists</a:t>
             </a:r>
             <a:r>
               <a:rPr lang="en-US" sz="572" dirty="0">
@@ -8098,17 +7133,17 @@
                 <a:latin typeface="Arial" panose="020B0604020202020204" pitchFamily="34" charset="0"/>
                 <a:cs typeface="Arial" panose="020B0604020202020204" pitchFamily="34" charset="0"/>
               </a:rPr>
-              <a:t> </a:t>
-            </a:r>
-            <a:r>
-              <a:rPr lang="en-US" sz="572" dirty="0" err="1">
+              <a:t>, 3</a:t>
+            </a:r>
+            <a:r>
+              <a:rPr lang="en-US" sz="572" baseline="30000" dirty="0">
                 <a:solidFill>
                   <a:prstClr val="black"/>
                 </a:solidFill>
                 <a:latin typeface="Arial" panose="020B0604020202020204" pitchFamily="34" charset="0"/>
                 <a:cs typeface="Arial" panose="020B0604020202020204" pitchFamily="34" charset="0"/>
               </a:rPr>
-              <a:t>paris</a:t>
+              <a:t>rd</a:t>
             </a:r>
             <a:r>
               <a:rPr lang="en-US" sz="572" dirty="0">
@@ -8118,1271 +7153,15 @@
                 <a:latin typeface="Arial" panose="020B0604020202020204" pitchFamily="34" charset="0"/>
                 <a:cs typeface="Arial" panose="020B0604020202020204" pitchFamily="34" charset="0"/>
               </a:rPr>
-              <a:t> as core </a:t>
-            </a:r>
-            <a:r>
-              <a:rPr lang="en-US" sz="572" dirty="0" err="1">
-                <a:solidFill>
-                  <a:prstClr val="black"/>
-                </a:solidFill>
-                <a:latin typeface="Arial" panose="020B0604020202020204" pitchFamily="34" charset="0"/>
-                <a:cs typeface="Arial" panose="020B0604020202020204" pitchFamily="34" charset="0"/>
-              </a:rPr>
-              <a:t>volorest</a:t>
-            </a:r>
-            <a:r>
-              <a:rPr lang="en-US" sz="572" dirty="0">
-                <a:solidFill>
-                  <a:prstClr val="black"/>
-                </a:solidFill>
-                <a:latin typeface="Arial" panose="020B0604020202020204" pitchFamily="34" charset="0"/>
-                <a:cs typeface="Arial" panose="020B0604020202020204" pitchFamily="34" charset="0"/>
-              </a:rPr>
-              <a:t>, </a:t>
-            </a:r>
-            <a:r>
-              <a:rPr lang="en-US" sz="572" dirty="0" err="1">
-                <a:solidFill>
-                  <a:prstClr val="black"/>
-                </a:solidFill>
-                <a:latin typeface="Arial" panose="020B0604020202020204" pitchFamily="34" charset="0"/>
-                <a:cs typeface="Arial" panose="020B0604020202020204" pitchFamily="34" charset="0"/>
-              </a:rPr>
-              <a:t>sust</a:t>
-            </a:r>
-            <a:r>
-              <a:rPr lang="en-US" sz="572" dirty="0">
-                <a:solidFill>
-                  <a:prstClr val="black"/>
-                </a:solidFill>
-                <a:latin typeface="Arial" panose="020B0604020202020204" pitchFamily="34" charset="0"/>
-                <a:cs typeface="Arial" panose="020B0604020202020204" pitchFamily="34" charset="0"/>
-              </a:rPr>
-              <a:t> </a:t>
-            </a:r>
-            <a:r>
-              <a:rPr lang="en-US" sz="572" dirty="0" err="1">
-                <a:solidFill>
-                  <a:prstClr val="black"/>
-                </a:solidFill>
-                <a:latin typeface="Arial" panose="020B0604020202020204" pitchFamily="34" charset="0"/>
-                <a:cs typeface="Arial" panose="020B0604020202020204" pitchFamily="34" charset="0"/>
-              </a:rPr>
-              <a:t>exceatur</a:t>
-            </a:r>
-            <a:r>
-              <a:rPr lang="en-US" sz="572" dirty="0">
-                <a:solidFill>
-                  <a:prstClr val="black"/>
-                </a:solidFill>
-                <a:latin typeface="Arial" panose="020B0604020202020204" pitchFamily="34" charset="0"/>
-                <a:cs typeface="Arial" panose="020B0604020202020204" pitchFamily="34" charset="0"/>
-              </a:rPr>
-              <a:t> </a:t>
-            </a:r>
-            <a:r>
-              <a:rPr lang="en-US" sz="572" dirty="0" err="1">
-                <a:solidFill>
-                  <a:prstClr val="black"/>
-                </a:solidFill>
-                <a:latin typeface="Arial" panose="020B0604020202020204" pitchFamily="34" charset="0"/>
-                <a:cs typeface="Arial" panose="020B0604020202020204" pitchFamily="34" charset="0"/>
-              </a:rPr>
-              <a:t>antio</a:t>
-            </a:r>
-            <a:r>
-              <a:rPr lang="en-US" sz="572" dirty="0">
-                <a:solidFill>
-                  <a:prstClr val="black"/>
-                </a:solidFill>
-                <a:latin typeface="Arial" panose="020B0604020202020204" pitchFamily="34" charset="0"/>
-                <a:cs typeface="Arial" panose="020B0604020202020204" pitchFamily="34" charset="0"/>
-              </a:rPr>
-              <a:t> </a:t>
-            </a:r>
-            <a:r>
-              <a:rPr lang="en-US" sz="572" dirty="0" err="1">
-                <a:solidFill>
-                  <a:prstClr val="black"/>
-                </a:solidFill>
-                <a:latin typeface="Arial" panose="020B0604020202020204" pitchFamily="34" charset="0"/>
-                <a:cs typeface="Arial" panose="020B0604020202020204" pitchFamily="34" charset="0"/>
-              </a:rPr>
-              <a:t>ea</a:t>
-            </a:r>
-            <a:r>
-              <a:rPr lang="en-US" sz="572" dirty="0">
-                <a:solidFill>
-                  <a:prstClr val="black"/>
-                </a:solidFill>
-                <a:latin typeface="Arial" panose="020B0604020202020204" pitchFamily="34" charset="0"/>
-                <a:cs typeface="Arial" panose="020B0604020202020204" pitchFamily="34" charset="0"/>
-              </a:rPr>
-              <a:t> </a:t>
-            </a:r>
-            <a:r>
-              <a:rPr lang="en-US" sz="572" dirty="0" err="1">
-                <a:solidFill>
-                  <a:prstClr val="black"/>
-                </a:solidFill>
-                <a:latin typeface="Arial" panose="020B0604020202020204" pitchFamily="34" charset="0"/>
-                <a:cs typeface="Arial" panose="020B0604020202020204" pitchFamily="34" charset="0"/>
-              </a:rPr>
-              <a:t>voluptas</a:t>
-            </a:r>
-            <a:r>
-              <a:rPr lang="en-US" sz="572" dirty="0">
-                <a:solidFill>
-                  <a:prstClr val="black"/>
-                </a:solidFill>
-                <a:latin typeface="Arial" panose="020B0604020202020204" pitchFamily="34" charset="0"/>
-                <a:cs typeface="Arial" panose="020B0604020202020204" pitchFamily="34" charset="0"/>
-              </a:rPr>
-              <a:t> </a:t>
-            </a:r>
-            <a:r>
-              <a:rPr lang="en-US" sz="572" dirty="0" err="1">
-                <a:solidFill>
-                  <a:prstClr val="black"/>
-                </a:solidFill>
-                <a:latin typeface="Arial" panose="020B0604020202020204" pitchFamily="34" charset="0"/>
-                <a:cs typeface="Arial" panose="020B0604020202020204" pitchFamily="34" charset="0"/>
-              </a:rPr>
-              <a:t>eumquatendit</a:t>
-            </a:r>
-            <a:r>
-              <a:rPr lang="en-US" sz="572" dirty="0">
-                <a:solidFill>
-                  <a:prstClr val="black"/>
-                </a:solidFill>
-                <a:latin typeface="Arial" panose="020B0604020202020204" pitchFamily="34" charset="0"/>
-                <a:cs typeface="Arial" panose="020B0604020202020204" pitchFamily="34" charset="0"/>
-              </a:rPr>
-              <a:t> </a:t>
-            </a:r>
-            <a:r>
-              <a:rPr lang="en-US" sz="572" dirty="0" err="1">
-                <a:solidFill>
-                  <a:prstClr val="black"/>
-                </a:solidFill>
-                <a:latin typeface="Arial" panose="020B0604020202020204" pitchFamily="34" charset="0"/>
-                <a:cs typeface="Arial" panose="020B0604020202020204" pitchFamily="34" charset="0"/>
-              </a:rPr>
-              <a:t>quas</a:t>
-            </a:r>
-            <a:r>
-              <a:rPr lang="en-US" sz="572" dirty="0">
-                <a:solidFill>
-                  <a:prstClr val="black"/>
-                </a:solidFill>
-                <a:latin typeface="Arial" panose="020B0604020202020204" pitchFamily="34" charset="0"/>
-                <a:cs typeface="Arial" panose="020B0604020202020204" pitchFamily="34" charset="0"/>
-              </a:rPr>
-              <a:t> </a:t>
-            </a:r>
-            <a:r>
-              <a:rPr lang="en-US" sz="572" dirty="0" err="1">
-                <a:solidFill>
-                  <a:prstClr val="black"/>
-                </a:solidFill>
-                <a:latin typeface="Arial" panose="020B0604020202020204" pitchFamily="34" charset="0"/>
-                <a:cs typeface="Arial" panose="020B0604020202020204" pitchFamily="34" charset="0"/>
-              </a:rPr>
-              <a:t>doluptatet</a:t>
-            </a:r>
-            <a:r>
-              <a:rPr lang="en-US" sz="572" dirty="0">
-                <a:solidFill>
-                  <a:prstClr val="black"/>
-                </a:solidFill>
-                <a:latin typeface="Arial" panose="020B0604020202020204" pitchFamily="34" charset="0"/>
-                <a:cs typeface="Arial" panose="020B0604020202020204" pitchFamily="34" charset="0"/>
-              </a:rPr>
-              <a:t> </a:t>
-            </a:r>
-            <a:r>
-              <a:rPr lang="en-US" sz="572" dirty="0" err="1">
-                <a:solidFill>
-                  <a:prstClr val="black"/>
-                </a:solidFill>
-                <a:latin typeface="Arial" panose="020B0604020202020204" pitchFamily="34" charset="0"/>
-                <a:cs typeface="Arial" panose="020B0604020202020204" pitchFamily="34" charset="0"/>
-              </a:rPr>
-              <a:t>aut</a:t>
-            </a:r>
-            <a:r>
-              <a:rPr lang="en-US" sz="572" dirty="0">
-                <a:solidFill>
-                  <a:prstClr val="black"/>
-                </a:solidFill>
-                <a:latin typeface="Arial" panose="020B0604020202020204" pitchFamily="34" charset="0"/>
-                <a:cs typeface="Arial" panose="020B0604020202020204" pitchFamily="34" charset="0"/>
-              </a:rPr>
-              <a:t> </a:t>
-            </a:r>
-            <a:r>
-              <a:rPr lang="en-US" sz="572" dirty="0" err="1">
-                <a:solidFill>
-                  <a:prstClr val="black"/>
-                </a:solidFill>
-                <a:latin typeface="Arial" panose="020B0604020202020204" pitchFamily="34" charset="0"/>
-                <a:cs typeface="Arial" panose="020B0604020202020204" pitchFamily="34" charset="0"/>
-              </a:rPr>
-              <a:t>landignam</a:t>
-            </a:r>
-            <a:r>
-              <a:rPr lang="en-US" sz="572" dirty="0">
-                <a:solidFill>
-                  <a:prstClr val="black"/>
-                </a:solidFill>
-                <a:latin typeface="Arial" panose="020B0604020202020204" pitchFamily="34" charset="0"/>
-                <a:cs typeface="Arial" panose="020B0604020202020204" pitchFamily="34" charset="0"/>
-              </a:rPr>
-              <a:t> que </a:t>
-            </a:r>
-            <a:r>
-              <a:rPr lang="en-US" sz="572" dirty="0" err="1">
-                <a:solidFill>
-                  <a:prstClr val="black"/>
-                </a:solidFill>
-                <a:latin typeface="Arial" panose="020B0604020202020204" pitchFamily="34" charset="0"/>
-                <a:cs typeface="Arial" panose="020B0604020202020204" pitchFamily="34" charset="0"/>
-              </a:rPr>
-              <a:t>lantur</a:t>
-            </a:r>
-            <a:r>
-              <a:rPr lang="en-US" sz="572" dirty="0">
-                <a:solidFill>
-                  <a:prstClr val="black"/>
-                </a:solidFill>
-                <a:latin typeface="Arial" panose="020B0604020202020204" pitchFamily="34" charset="0"/>
-                <a:cs typeface="Arial" panose="020B0604020202020204" pitchFamily="34" charset="0"/>
-              </a:rPr>
-              <a:t> </a:t>
-            </a:r>
-            <a:r>
-              <a:rPr lang="en-US" sz="572" dirty="0" err="1">
-                <a:solidFill>
-                  <a:prstClr val="black"/>
-                </a:solidFill>
-                <a:latin typeface="Arial" panose="020B0604020202020204" pitchFamily="34" charset="0"/>
-                <a:cs typeface="Arial" panose="020B0604020202020204" pitchFamily="34" charset="0"/>
-              </a:rPr>
-              <a:t>sania</a:t>
-            </a:r>
-            <a:r>
-              <a:rPr lang="en-US" sz="572" dirty="0">
-                <a:solidFill>
-                  <a:prstClr val="black"/>
-                </a:solidFill>
-                <a:latin typeface="Arial" panose="020B0604020202020204" pitchFamily="34" charset="0"/>
-                <a:cs typeface="Arial" panose="020B0604020202020204" pitchFamily="34" charset="0"/>
-              </a:rPr>
-              <a:t> </a:t>
-            </a:r>
-            <a:r>
-              <a:rPr lang="en-US" sz="572" dirty="0" err="1">
-                <a:solidFill>
-                  <a:prstClr val="black"/>
-                </a:solidFill>
-                <a:latin typeface="Arial" panose="020B0604020202020204" pitchFamily="34" charset="0"/>
-                <a:cs typeface="Arial" panose="020B0604020202020204" pitchFamily="34" charset="0"/>
-              </a:rPr>
-              <a:t>dem</a:t>
-            </a:r>
-            <a:r>
-              <a:rPr lang="en-US" sz="572" dirty="0">
-                <a:solidFill>
-                  <a:prstClr val="black"/>
-                </a:solidFill>
-                <a:latin typeface="Arial" panose="020B0604020202020204" pitchFamily="34" charset="0"/>
-                <a:cs typeface="Arial" panose="020B0604020202020204" pitchFamily="34" charset="0"/>
-              </a:rPr>
-              <a:t> </a:t>
-            </a:r>
-            <a:r>
-              <a:rPr lang="en-US" sz="572" dirty="0" err="1">
-                <a:solidFill>
-                  <a:prstClr val="black"/>
-                </a:solidFill>
-                <a:latin typeface="Arial" panose="020B0604020202020204" pitchFamily="34" charset="0"/>
-                <a:cs typeface="Arial" panose="020B0604020202020204" pitchFamily="34" charset="0"/>
-              </a:rPr>
-              <a:t>escidit</a:t>
-            </a:r>
-            <a:r>
-              <a:rPr lang="en-US" sz="572" dirty="0">
-                <a:solidFill>
-                  <a:prstClr val="black"/>
-                </a:solidFill>
-                <a:latin typeface="Arial" panose="020B0604020202020204" pitchFamily="34" charset="0"/>
-                <a:cs typeface="Arial" panose="020B0604020202020204" pitchFamily="34" charset="0"/>
-              </a:rPr>
-              <a:t> min </a:t>
-            </a:r>
-            <a:r>
-              <a:rPr lang="en-US" sz="572" dirty="0" err="1">
-                <a:solidFill>
-                  <a:prstClr val="black"/>
-                </a:solidFill>
-                <a:latin typeface="Arial" panose="020B0604020202020204" pitchFamily="34" charset="0"/>
-                <a:cs typeface="Arial" panose="020B0604020202020204" pitchFamily="34" charset="0"/>
-              </a:rPr>
-              <a:t>reruptiaero</a:t>
-            </a:r>
-            <a:r>
-              <a:rPr lang="en-US" sz="572" dirty="0">
-                <a:solidFill>
-                  <a:prstClr val="black"/>
-                </a:solidFill>
-                <a:latin typeface="Arial" panose="020B0604020202020204" pitchFamily="34" charset="0"/>
-                <a:cs typeface="Arial" panose="020B0604020202020204" pitchFamily="34" charset="0"/>
-              </a:rPr>
-              <a:t> </a:t>
-            </a:r>
-            <a:r>
-              <a:rPr lang="en-US" sz="572" dirty="0" err="1">
-                <a:solidFill>
-                  <a:prstClr val="black"/>
-                </a:solidFill>
-                <a:latin typeface="Arial" panose="020B0604020202020204" pitchFamily="34" charset="0"/>
-                <a:cs typeface="Arial" panose="020B0604020202020204" pitchFamily="34" charset="0"/>
-              </a:rPr>
-              <a:t>velis</a:t>
-            </a:r>
-            <a:r>
-              <a:rPr lang="en-US" sz="572" dirty="0">
-                <a:solidFill>
-                  <a:prstClr val="black"/>
-                </a:solidFill>
-                <a:latin typeface="Arial" panose="020B0604020202020204" pitchFamily="34" charset="0"/>
-                <a:cs typeface="Arial" panose="020B0604020202020204" pitchFamily="34" charset="0"/>
-              </a:rPr>
-              <a:t> maximus </a:t>
-            </a:r>
-            <a:r>
-              <a:rPr lang="en-US" sz="572" dirty="0" err="1">
-                <a:solidFill>
-                  <a:prstClr val="black"/>
-                </a:solidFill>
-                <a:latin typeface="Arial" panose="020B0604020202020204" pitchFamily="34" charset="0"/>
-                <a:cs typeface="Arial" panose="020B0604020202020204" pitchFamily="34" charset="0"/>
-              </a:rPr>
-              <a:t>aut</a:t>
-            </a:r>
-            <a:r>
-              <a:rPr lang="en-US" sz="572" dirty="0">
-                <a:solidFill>
-                  <a:prstClr val="black"/>
-                </a:solidFill>
-                <a:latin typeface="Arial" panose="020B0604020202020204" pitchFamily="34" charset="0"/>
-                <a:cs typeface="Arial" panose="020B0604020202020204" pitchFamily="34" charset="0"/>
-              </a:rPr>
-              <a:t> que </a:t>
-            </a:r>
-            <a:r>
-              <a:rPr lang="en-US" sz="572" dirty="0" err="1">
-                <a:solidFill>
-                  <a:prstClr val="black"/>
-                </a:solidFill>
-                <a:latin typeface="Arial" panose="020B0604020202020204" pitchFamily="34" charset="0"/>
-                <a:cs typeface="Arial" panose="020B0604020202020204" pitchFamily="34" charset="0"/>
-              </a:rPr>
-              <a:t>pe</a:t>
-            </a:r>
-            <a:r>
-              <a:rPr lang="en-US" sz="572" dirty="0">
-                <a:solidFill>
-                  <a:prstClr val="black"/>
-                </a:solidFill>
-                <a:latin typeface="Arial" panose="020B0604020202020204" pitchFamily="34" charset="0"/>
-                <a:cs typeface="Arial" panose="020B0604020202020204" pitchFamily="34" charset="0"/>
-              </a:rPr>
-              <a:t> </a:t>
-            </a:r>
-            <a:r>
-              <a:rPr lang="en-US" sz="572" dirty="0" err="1">
-                <a:solidFill>
-                  <a:prstClr val="black"/>
-                </a:solidFill>
-                <a:latin typeface="Arial" panose="020B0604020202020204" pitchFamily="34" charset="0"/>
-                <a:cs typeface="Arial" panose="020B0604020202020204" pitchFamily="34" charset="0"/>
-              </a:rPr>
-              <a:t>aliquas</a:t>
-            </a:r>
-            <a:r>
-              <a:rPr lang="en-US" sz="572" dirty="0">
-                <a:solidFill>
-                  <a:prstClr val="black"/>
-                </a:solidFill>
-                <a:latin typeface="Arial" panose="020B0604020202020204" pitchFamily="34" charset="0"/>
-                <a:cs typeface="Arial" panose="020B0604020202020204" pitchFamily="34" charset="0"/>
-              </a:rPr>
-              <a:t> </a:t>
-            </a:r>
-            <a:r>
-              <a:rPr lang="en-US" sz="572" dirty="0" err="1">
-                <a:solidFill>
-                  <a:prstClr val="black"/>
-                </a:solidFill>
-                <a:latin typeface="Arial" panose="020B0604020202020204" pitchFamily="34" charset="0"/>
-                <a:cs typeface="Arial" panose="020B0604020202020204" pitchFamily="34" charset="0"/>
-              </a:rPr>
-              <a:t>sequidisit</a:t>
-            </a:r>
-            <a:r>
-              <a:rPr lang="en-US" sz="572" dirty="0">
-                <a:solidFill>
-                  <a:prstClr val="black"/>
-                </a:solidFill>
-                <a:latin typeface="Arial" panose="020B0604020202020204" pitchFamily="34" charset="0"/>
-                <a:cs typeface="Arial" panose="020B0604020202020204" pitchFamily="34" charset="0"/>
-              </a:rPr>
-              <a:t>, </a:t>
-            </a:r>
-            <a:r>
-              <a:rPr lang="en-US" sz="572" dirty="0" err="1">
-                <a:solidFill>
-                  <a:prstClr val="black"/>
-                </a:solidFill>
-                <a:latin typeface="Arial" panose="020B0604020202020204" pitchFamily="34" charset="0"/>
-                <a:cs typeface="Arial" panose="020B0604020202020204" pitchFamily="34" charset="0"/>
-              </a:rPr>
-              <a:t>omnient</a:t>
-            </a:r>
-            <a:r>
-              <a:rPr lang="en-US" sz="572" dirty="0">
-                <a:solidFill>
-                  <a:prstClr val="black"/>
-                </a:solidFill>
-                <a:latin typeface="Arial" panose="020B0604020202020204" pitchFamily="34" charset="0"/>
-                <a:cs typeface="Arial" panose="020B0604020202020204" pitchFamily="34" charset="0"/>
-              </a:rPr>
-              <a:t> hit lam </a:t>
-            </a:r>
-            <a:r>
-              <a:rPr lang="en-US" sz="572" dirty="0" err="1">
-                <a:solidFill>
-                  <a:prstClr val="black"/>
-                </a:solidFill>
-                <a:latin typeface="Arial" panose="020B0604020202020204" pitchFamily="34" charset="0"/>
-                <a:cs typeface="Arial" panose="020B0604020202020204" pitchFamily="34" charset="0"/>
-              </a:rPr>
-              <a:t>eicias</a:t>
-            </a:r>
-            <a:r>
-              <a:rPr lang="en-US" sz="572" dirty="0">
-                <a:solidFill>
-                  <a:prstClr val="black"/>
-                </a:solidFill>
-                <a:latin typeface="Arial" panose="020B0604020202020204" pitchFamily="34" charset="0"/>
-                <a:cs typeface="Arial" panose="020B0604020202020204" pitchFamily="34" charset="0"/>
-              </a:rPr>
-              <a:t> </a:t>
-            </a:r>
-            <a:r>
-              <a:rPr lang="en-US" sz="572" dirty="0" err="1">
-                <a:solidFill>
-                  <a:prstClr val="black"/>
-                </a:solidFill>
-                <a:latin typeface="Arial" panose="020B0604020202020204" pitchFamily="34" charset="0"/>
-                <a:cs typeface="Arial" panose="020B0604020202020204" pitchFamily="34" charset="0"/>
-              </a:rPr>
-              <a:t>modio</a:t>
-            </a:r>
-            <a:r>
-              <a:rPr lang="en-US" sz="572" dirty="0">
-                <a:solidFill>
-                  <a:prstClr val="black"/>
-                </a:solidFill>
-                <a:latin typeface="Arial" panose="020B0604020202020204" pitchFamily="34" charset="0"/>
-                <a:cs typeface="Arial" panose="020B0604020202020204" pitchFamily="34" charset="0"/>
-              </a:rPr>
-              <a:t> con </a:t>
-            </a:r>
-            <a:r>
-              <a:rPr lang="en-US" sz="572" dirty="0" err="1">
-                <a:solidFill>
-                  <a:prstClr val="black"/>
-                </a:solidFill>
-                <a:latin typeface="Arial" panose="020B0604020202020204" pitchFamily="34" charset="0"/>
-                <a:cs typeface="Arial" panose="020B0604020202020204" pitchFamily="34" charset="0"/>
-              </a:rPr>
-              <a:t>nisin</a:t>
-            </a:r>
-            <a:r>
-              <a:rPr lang="en-US" sz="572" dirty="0">
-                <a:solidFill>
-                  <a:prstClr val="black"/>
-                </a:solidFill>
-                <a:latin typeface="Arial" panose="020B0604020202020204" pitchFamily="34" charset="0"/>
-                <a:cs typeface="Arial" panose="020B0604020202020204" pitchFamily="34" charset="0"/>
-              </a:rPr>
-              <a:t> </a:t>
-            </a:r>
-            <a:r>
-              <a:rPr lang="en-US" sz="572" dirty="0" err="1">
-                <a:solidFill>
-                  <a:prstClr val="black"/>
-                </a:solidFill>
-                <a:latin typeface="Arial" panose="020B0604020202020204" pitchFamily="34" charset="0"/>
-                <a:cs typeface="Arial" panose="020B0604020202020204" pitchFamily="34" charset="0"/>
-              </a:rPr>
-              <a:t>pediam</a:t>
-            </a:r>
-            <a:r>
-              <a:rPr lang="en-US" sz="572" dirty="0">
-                <a:solidFill>
-                  <a:prstClr val="black"/>
-                </a:solidFill>
-                <a:latin typeface="Arial" panose="020B0604020202020204" pitchFamily="34" charset="0"/>
-                <a:cs typeface="Arial" panose="020B0604020202020204" pitchFamily="34" charset="0"/>
-              </a:rPr>
-              <a:t>, </a:t>
-            </a:r>
-            <a:r>
-              <a:rPr lang="en-US" sz="572" dirty="0" err="1">
-                <a:solidFill>
-                  <a:prstClr val="black"/>
-                </a:solidFill>
-                <a:latin typeface="Arial" panose="020B0604020202020204" pitchFamily="34" charset="0"/>
-                <a:cs typeface="Arial" panose="020B0604020202020204" pitchFamily="34" charset="0"/>
-              </a:rPr>
-              <a:t>ent</a:t>
-            </a:r>
-            <a:r>
-              <a:rPr lang="en-US" sz="572" dirty="0">
-                <a:solidFill>
-                  <a:prstClr val="black"/>
-                </a:solidFill>
-                <a:latin typeface="Arial" panose="020B0604020202020204" pitchFamily="34" charset="0"/>
-                <a:cs typeface="Arial" panose="020B0604020202020204" pitchFamily="34" charset="0"/>
-              </a:rPr>
-              <a:t>, </a:t>
-            </a:r>
-            <a:r>
-              <a:rPr lang="en-US" sz="572" dirty="0" err="1">
-                <a:solidFill>
-                  <a:prstClr val="black"/>
-                </a:solidFill>
-                <a:latin typeface="Arial" panose="020B0604020202020204" pitchFamily="34" charset="0"/>
-                <a:cs typeface="Arial" panose="020B0604020202020204" pitchFamily="34" charset="0"/>
-              </a:rPr>
-              <a:t>cust</a:t>
-            </a:r>
-            <a:r>
-              <a:rPr lang="en-US" sz="572" dirty="0">
-                <a:solidFill>
-                  <a:prstClr val="black"/>
-                </a:solidFill>
-                <a:latin typeface="Arial" panose="020B0604020202020204" pitchFamily="34" charset="0"/>
-                <a:cs typeface="Arial" panose="020B0604020202020204" pitchFamily="34" charset="0"/>
-              </a:rPr>
-              <a:t> </a:t>
-            </a:r>
-            <a:r>
-              <a:rPr lang="en-US" sz="572" dirty="0" err="1">
-                <a:solidFill>
-                  <a:prstClr val="black"/>
-                </a:solidFill>
-                <a:latin typeface="Arial" panose="020B0604020202020204" pitchFamily="34" charset="0"/>
-                <a:cs typeface="Arial" panose="020B0604020202020204" pitchFamily="34" charset="0"/>
-              </a:rPr>
-              <a:t>accaborit</a:t>
-            </a:r>
-            <a:r>
-              <a:rPr lang="en-US" sz="572" dirty="0">
-                <a:solidFill>
-                  <a:prstClr val="black"/>
-                </a:solidFill>
-                <a:latin typeface="Arial" panose="020B0604020202020204" pitchFamily="34" charset="0"/>
-                <a:cs typeface="Arial" panose="020B0604020202020204" pitchFamily="34" charset="0"/>
-              </a:rPr>
-              <a:t> </a:t>
-            </a:r>
-            <a:r>
-              <a:rPr lang="en-US" sz="572" dirty="0" err="1">
-                <a:solidFill>
-                  <a:prstClr val="black"/>
-                </a:solidFill>
-                <a:latin typeface="Arial" panose="020B0604020202020204" pitchFamily="34" charset="0"/>
-                <a:cs typeface="Arial" panose="020B0604020202020204" pitchFamily="34" charset="0"/>
-              </a:rPr>
-              <a:t>odio</a:t>
-            </a:r>
-            <a:r>
-              <a:rPr lang="en-US" sz="572" dirty="0">
-                <a:solidFill>
-                  <a:prstClr val="black"/>
-                </a:solidFill>
-                <a:latin typeface="Arial" panose="020B0604020202020204" pitchFamily="34" charset="0"/>
-                <a:cs typeface="Arial" panose="020B0604020202020204" pitchFamily="34" charset="0"/>
-              </a:rPr>
-              <a:t> </a:t>
-            </a:r>
-            <a:r>
-              <a:rPr lang="en-US" sz="572" dirty="0" err="1">
-                <a:solidFill>
-                  <a:prstClr val="black"/>
-                </a:solidFill>
-                <a:latin typeface="Arial" panose="020B0604020202020204" pitchFamily="34" charset="0"/>
-                <a:cs typeface="Arial" panose="020B0604020202020204" pitchFamily="34" charset="0"/>
-              </a:rPr>
-              <a:t>corehen</a:t>
-            </a:r>
-            <a:r>
-              <a:rPr lang="en-US" sz="572" dirty="0">
-                <a:solidFill>
-                  <a:prstClr val="black"/>
-                </a:solidFill>
-                <a:latin typeface="Arial" panose="020B0604020202020204" pitchFamily="34" charset="0"/>
-                <a:cs typeface="Arial" panose="020B0604020202020204" pitchFamily="34" charset="0"/>
-              </a:rPr>
-              <a:t> </a:t>
-            </a:r>
-            <a:r>
-              <a:rPr lang="en-US" sz="572" dirty="0" err="1">
-                <a:solidFill>
-                  <a:prstClr val="black"/>
-                </a:solidFill>
-                <a:latin typeface="Arial" panose="020B0604020202020204" pitchFamily="34" charset="0"/>
-                <a:cs typeface="Arial" panose="020B0604020202020204" pitchFamily="34" charset="0"/>
-              </a:rPr>
-              <a:t>dendae</a:t>
-            </a:r>
-            <a:r>
-              <a:rPr lang="en-US" sz="572" dirty="0">
-                <a:solidFill>
-                  <a:prstClr val="black"/>
-                </a:solidFill>
-                <a:latin typeface="Arial" panose="020B0604020202020204" pitchFamily="34" charset="0"/>
-                <a:cs typeface="Arial" panose="020B0604020202020204" pitchFamily="34" charset="0"/>
-              </a:rPr>
-              <a:t> nonet </a:t>
-            </a:r>
-            <a:r>
-              <a:rPr lang="en-US" sz="572" dirty="0" err="1">
-                <a:solidFill>
-                  <a:prstClr val="black"/>
-                </a:solidFill>
-                <a:latin typeface="Arial" panose="020B0604020202020204" pitchFamily="34" charset="0"/>
-                <a:cs typeface="Arial" panose="020B0604020202020204" pitchFamily="34" charset="0"/>
-              </a:rPr>
-              <a:t>eliquam</a:t>
-            </a:r>
-            <a:r>
-              <a:rPr lang="en-US" sz="572" dirty="0">
-                <a:solidFill>
-                  <a:prstClr val="black"/>
-                </a:solidFill>
-                <a:latin typeface="Arial" panose="020B0604020202020204" pitchFamily="34" charset="0"/>
-                <a:cs typeface="Arial" panose="020B0604020202020204" pitchFamily="34" charset="0"/>
-              </a:rPr>
-              <a:t>, </a:t>
-            </a:r>
-            <a:r>
-              <a:rPr lang="en-US" sz="572" dirty="0" err="1">
-                <a:solidFill>
-                  <a:prstClr val="black"/>
-                </a:solidFill>
-                <a:latin typeface="Arial" panose="020B0604020202020204" pitchFamily="34" charset="0"/>
-                <a:cs typeface="Arial" panose="020B0604020202020204" pitchFamily="34" charset="0"/>
-              </a:rPr>
-              <a:t>aperorepe</a:t>
-            </a:r>
-            <a:r>
-              <a:rPr lang="en-US" sz="572" dirty="0">
-                <a:solidFill>
-                  <a:prstClr val="black"/>
-                </a:solidFill>
-                <a:latin typeface="Arial" panose="020B0604020202020204" pitchFamily="34" charset="0"/>
-                <a:cs typeface="Arial" panose="020B0604020202020204" pitchFamily="34" charset="0"/>
-              </a:rPr>
-              <a:t> </a:t>
-            </a:r>
-            <a:r>
-              <a:rPr lang="en-US" sz="572" dirty="0" err="1">
-                <a:solidFill>
-                  <a:prstClr val="black"/>
-                </a:solidFill>
-                <a:latin typeface="Arial" panose="020B0604020202020204" pitchFamily="34" charset="0"/>
-                <a:cs typeface="Arial" panose="020B0604020202020204" pitchFamily="34" charset="0"/>
-              </a:rPr>
-              <a:t>autatem</a:t>
-            </a:r>
-            <a:r>
-              <a:rPr lang="en-US" sz="572" dirty="0">
-                <a:solidFill>
-                  <a:prstClr val="black"/>
-                </a:solidFill>
-                <a:latin typeface="Arial" panose="020B0604020202020204" pitchFamily="34" charset="0"/>
-                <a:cs typeface="Arial" panose="020B0604020202020204" pitchFamily="34" charset="0"/>
-              </a:rPr>
-              <a:t> voles </a:t>
-            </a:r>
-            <a:r>
-              <a:rPr lang="en-US" sz="572" dirty="0" err="1">
-                <a:solidFill>
-                  <a:prstClr val="black"/>
-                </a:solidFill>
-                <a:latin typeface="Arial" panose="020B0604020202020204" pitchFamily="34" charset="0"/>
-                <a:cs typeface="Arial" panose="020B0604020202020204" pitchFamily="34" charset="0"/>
-              </a:rPr>
-              <a:t>int</a:t>
-            </a:r>
-            <a:r>
-              <a:rPr lang="en-US" sz="572" dirty="0">
-                <a:solidFill>
-                  <a:prstClr val="black"/>
-                </a:solidFill>
-                <a:latin typeface="Arial" panose="020B0604020202020204" pitchFamily="34" charset="0"/>
-                <a:cs typeface="Arial" panose="020B0604020202020204" pitchFamily="34" charset="0"/>
-              </a:rPr>
-              <a:t> </a:t>
-            </a:r>
-            <a:r>
-              <a:rPr lang="en-US" sz="572" dirty="0" err="1">
-                <a:solidFill>
-                  <a:prstClr val="black"/>
-                </a:solidFill>
-                <a:latin typeface="Arial" panose="020B0604020202020204" pitchFamily="34" charset="0"/>
-                <a:cs typeface="Arial" panose="020B0604020202020204" pitchFamily="34" charset="0"/>
-              </a:rPr>
-              <a:t>odic</a:t>
-            </a:r>
-            <a:r>
-              <a:rPr lang="en-US" sz="572" dirty="0">
-                <a:solidFill>
-                  <a:prstClr val="black"/>
-                </a:solidFill>
-                <a:latin typeface="Arial" panose="020B0604020202020204" pitchFamily="34" charset="0"/>
-                <a:cs typeface="Arial" panose="020B0604020202020204" pitchFamily="34" charset="0"/>
-              </a:rPr>
-              <a:t> </a:t>
-            </a:r>
-            <a:r>
-              <a:rPr lang="en-US" sz="572" dirty="0" err="1">
-                <a:solidFill>
-                  <a:prstClr val="black"/>
-                </a:solidFill>
-                <a:latin typeface="Arial" panose="020B0604020202020204" pitchFamily="34" charset="0"/>
-                <a:cs typeface="Arial" panose="020B0604020202020204" pitchFamily="34" charset="0"/>
-              </a:rPr>
-              <a:t>tem</a:t>
-            </a:r>
-            <a:r>
-              <a:rPr lang="en-US" sz="572" dirty="0">
-                <a:solidFill>
-                  <a:prstClr val="black"/>
-                </a:solidFill>
-                <a:latin typeface="Arial" panose="020B0604020202020204" pitchFamily="34" charset="0"/>
-                <a:cs typeface="Arial" panose="020B0604020202020204" pitchFamily="34" charset="0"/>
-              </a:rPr>
-              <a:t> </a:t>
-            </a:r>
-            <a:r>
-              <a:rPr lang="en-US" sz="572" dirty="0" err="1">
-                <a:solidFill>
-                  <a:prstClr val="black"/>
-                </a:solidFill>
-                <a:latin typeface="Arial" panose="020B0604020202020204" pitchFamily="34" charset="0"/>
-                <a:cs typeface="Arial" panose="020B0604020202020204" pitchFamily="34" charset="0"/>
-              </a:rPr>
-              <a:t>nis</a:t>
-            </a:r>
-            <a:r>
-              <a:rPr lang="en-US" sz="572" dirty="0">
-                <a:solidFill>
-                  <a:prstClr val="black"/>
-                </a:solidFill>
-                <a:latin typeface="Arial" panose="020B0604020202020204" pitchFamily="34" charset="0"/>
-                <a:cs typeface="Arial" panose="020B0604020202020204" pitchFamily="34" charset="0"/>
-              </a:rPr>
-              <a:t> </a:t>
-            </a:r>
-            <a:r>
-              <a:rPr lang="en-US" sz="572" dirty="0" err="1">
-                <a:solidFill>
-                  <a:prstClr val="black"/>
-                </a:solidFill>
-                <a:latin typeface="Arial" panose="020B0604020202020204" pitchFamily="34" charset="0"/>
-                <a:cs typeface="Arial" panose="020B0604020202020204" pitchFamily="34" charset="0"/>
-              </a:rPr>
-              <a:t>dolorrum</a:t>
-            </a:r>
-            <a:r>
-              <a:rPr lang="en-US" sz="572" dirty="0">
-                <a:solidFill>
-                  <a:prstClr val="black"/>
-                </a:solidFill>
-                <a:latin typeface="Arial" panose="020B0604020202020204" pitchFamily="34" charset="0"/>
-                <a:cs typeface="Arial" panose="020B0604020202020204" pitchFamily="34" charset="0"/>
-              </a:rPr>
-              <a:t> que cores </a:t>
-            </a:r>
-            <a:r>
-              <a:rPr lang="en-US" sz="572" dirty="0" err="1">
-                <a:solidFill>
-                  <a:prstClr val="black"/>
-                </a:solidFill>
-                <a:latin typeface="Arial" panose="020B0604020202020204" pitchFamily="34" charset="0"/>
-                <a:cs typeface="Arial" panose="020B0604020202020204" pitchFamily="34" charset="0"/>
-              </a:rPr>
-              <a:t>doluptaturi</a:t>
-            </a:r>
-            <a:r>
-              <a:rPr lang="en-US" sz="572" dirty="0">
-                <a:solidFill>
-                  <a:prstClr val="black"/>
-                </a:solidFill>
-                <a:latin typeface="Arial" panose="020B0604020202020204" pitchFamily="34" charset="0"/>
-                <a:cs typeface="Arial" panose="020B0604020202020204" pitchFamily="34" charset="0"/>
-              </a:rPr>
-              <a:t> </a:t>
-            </a:r>
-            <a:r>
-              <a:rPr lang="en-US" sz="572" dirty="0" err="1">
-                <a:solidFill>
-                  <a:prstClr val="black"/>
-                </a:solidFill>
-                <a:latin typeface="Arial" panose="020B0604020202020204" pitchFamily="34" charset="0"/>
-                <a:cs typeface="Arial" panose="020B0604020202020204" pitchFamily="34" charset="0"/>
-              </a:rPr>
-              <a:t>utemolorum</a:t>
-            </a:r>
-            <a:r>
-              <a:rPr lang="en-US" sz="572" dirty="0">
-                <a:solidFill>
-                  <a:prstClr val="black"/>
-                </a:solidFill>
-                <a:latin typeface="Arial" panose="020B0604020202020204" pitchFamily="34" charset="0"/>
-                <a:cs typeface="Arial" panose="020B0604020202020204" pitchFamily="34" charset="0"/>
-              </a:rPr>
-              <a:t> </a:t>
-            </a:r>
-            <a:r>
-              <a:rPr lang="en-US" sz="572" dirty="0" err="1">
-                <a:solidFill>
-                  <a:prstClr val="black"/>
-                </a:solidFill>
-                <a:latin typeface="Arial" panose="020B0604020202020204" pitchFamily="34" charset="0"/>
-                <a:cs typeface="Arial" panose="020B0604020202020204" pitchFamily="34" charset="0"/>
-              </a:rPr>
-              <a:t>imusam</a:t>
-            </a:r>
-            <a:r>
-              <a:rPr lang="en-US" sz="572" dirty="0">
-                <a:solidFill>
-                  <a:prstClr val="black"/>
-                </a:solidFill>
-                <a:latin typeface="Arial" panose="020B0604020202020204" pitchFamily="34" charset="0"/>
-                <a:cs typeface="Arial" panose="020B0604020202020204" pitchFamily="34" charset="0"/>
-              </a:rPr>
-              <a:t>, </a:t>
-            </a:r>
-            <a:r>
-              <a:rPr lang="en-US" sz="572" dirty="0" err="1">
-                <a:solidFill>
-                  <a:prstClr val="black"/>
-                </a:solidFill>
-                <a:latin typeface="Arial" panose="020B0604020202020204" pitchFamily="34" charset="0"/>
-                <a:cs typeface="Arial" panose="020B0604020202020204" pitchFamily="34" charset="0"/>
-              </a:rPr>
-              <a:t>idendaecabo</a:t>
-            </a:r>
-            <a:r>
-              <a:rPr lang="en-US" sz="572" dirty="0">
-                <a:solidFill>
-                  <a:prstClr val="black"/>
-                </a:solidFill>
-                <a:latin typeface="Arial" panose="020B0604020202020204" pitchFamily="34" charset="0"/>
-                <a:cs typeface="Arial" panose="020B0604020202020204" pitchFamily="34" charset="0"/>
-              </a:rPr>
-              <a:t>. Nam quo </a:t>
-            </a:r>
-            <a:r>
-              <a:rPr lang="en-US" sz="572" dirty="0" err="1">
-                <a:solidFill>
-                  <a:prstClr val="black"/>
-                </a:solidFill>
-                <a:latin typeface="Arial" panose="020B0604020202020204" pitchFamily="34" charset="0"/>
-                <a:cs typeface="Arial" panose="020B0604020202020204" pitchFamily="34" charset="0"/>
-              </a:rPr>
-              <a:t>moluptatur</a:t>
-            </a:r>
-            <a:r>
-              <a:rPr lang="en-US" sz="572" dirty="0">
-                <a:solidFill>
-                  <a:prstClr val="black"/>
-                </a:solidFill>
-                <a:latin typeface="Arial" panose="020B0604020202020204" pitchFamily="34" charset="0"/>
-                <a:cs typeface="Arial" panose="020B0604020202020204" pitchFamily="34" charset="0"/>
-              </a:rPr>
-              <a:t>?</a:t>
-            </a:r>
-          </a:p>
-          <a:p>
-            <a:pPr defTabSz="780653"/>
-            <a:r>
-              <a:rPr lang="en-US" sz="572" dirty="0" err="1">
-                <a:solidFill>
-                  <a:prstClr val="black"/>
-                </a:solidFill>
-                <a:latin typeface="Arial" panose="020B0604020202020204" pitchFamily="34" charset="0"/>
-                <a:cs typeface="Arial" panose="020B0604020202020204" pitchFamily="34" charset="0"/>
-              </a:rPr>
-              <a:t>eicias</a:t>
-            </a:r>
-            <a:r>
-              <a:rPr lang="en-US" sz="572" dirty="0">
-                <a:solidFill>
-                  <a:prstClr val="black"/>
-                </a:solidFill>
-                <a:latin typeface="Arial" panose="020B0604020202020204" pitchFamily="34" charset="0"/>
-                <a:cs typeface="Arial" panose="020B0604020202020204" pitchFamily="34" charset="0"/>
-              </a:rPr>
-              <a:t> </a:t>
-            </a:r>
-            <a:r>
-              <a:rPr lang="en-US" sz="572" dirty="0" err="1">
-                <a:solidFill>
-                  <a:prstClr val="black"/>
-                </a:solidFill>
-                <a:latin typeface="Arial" panose="020B0604020202020204" pitchFamily="34" charset="0"/>
-                <a:cs typeface="Arial" panose="020B0604020202020204" pitchFamily="34" charset="0"/>
-              </a:rPr>
-              <a:t>modio</a:t>
-            </a:r>
-            <a:r>
-              <a:rPr lang="en-US" sz="572" dirty="0">
-                <a:solidFill>
-                  <a:prstClr val="black"/>
-                </a:solidFill>
-                <a:latin typeface="Arial" panose="020B0604020202020204" pitchFamily="34" charset="0"/>
-                <a:cs typeface="Arial" panose="020B0604020202020204" pitchFamily="34" charset="0"/>
-              </a:rPr>
-              <a:t> con </a:t>
-            </a:r>
-            <a:r>
-              <a:rPr lang="en-US" sz="572" dirty="0" err="1">
-                <a:solidFill>
-                  <a:prstClr val="black"/>
-                </a:solidFill>
-                <a:latin typeface="Arial" panose="020B0604020202020204" pitchFamily="34" charset="0"/>
-                <a:cs typeface="Arial" panose="020B0604020202020204" pitchFamily="34" charset="0"/>
-              </a:rPr>
-              <a:t>nisin</a:t>
-            </a:r>
-            <a:r>
-              <a:rPr lang="en-US" sz="572" dirty="0">
-                <a:solidFill>
-                  <a:prstClr val="black"/>
-                </a:solidFill>
-                <a:latin typeface="Arial" panose="020B0604020202020204" pitchFamily="34" charset="0"/>
-                <a:cs typeface="Arial" panose="020B0604020202020204" pitchFamily="34" charset="0"/>
-              </a:rPr>
-              <a:t> </a:t>
-            </a:r>
-            <a:r>
-              <a:rPr lang="en-US" sz="572" dirty="0" err="1">
-                <a:solidFill>
-                  <a:prstClr val="black"/>
-                </a:solidFill>
-                <a:latin typeface="Arial" panose="020B0604020202020204" pitchFamily="34" charset="0"/>
-                <a:cs typeface="Arial" panose="020B0604020202020204" pitchFamily="34" charset="0"/>
-              </a:rPr>
-              <a:t>pediam</a:t>
-            </a:r>
-            <a:r>
-              <a:rPr lang="en-US" sz="572" dirty="0">
-                <a:solidFill>
-                  <a:prstClr val="black"/>
-                </a:solidFill>
-                <a:latin typeface="Arial" panose="020B0604020202020204" pitchFamily="34" charset="0"/>
-                <a:cs typeface="Arial" panose="020B0604020202020204" pitchFamily="34" charset="0"/>
-              </a:rPr>
-              <a:t>, </a:t>
-            </a:r>
-            <a:r>
-              <a:rPr lang="en-US" sz="572" dirty="0" err="1">
-                <a:solidFill>
-                  <a:prstClr val="black"/>
-                </a:solidFill>
-                <a:latin typeface="Arial" panose="020B0604020202020204" pitchFamily="34" charset="0"/>
-                <a:cs typeface="Arial" panose="020B0604020202020204" pitchFamily="34" charset="0"/>
-              </a:rPr>
-              <a:t>ent</a:t>
-            </a:r>
-            <a:r>
-              <a:rPr lang="en-US" sz="572" dirty="0">
-                <a:solidFill>
-                  <a:prstClr val="black"/>
-                </a:solidFill>
-                <a:latin typeface="Arial" panose="020B0604020202020204" pitchFamily="34" charset="0"/>
-                <a:cs typeface="Arial" panose="020B0604020202020204" pitchFamily="34" charset="0"/>
-              </a:rPr>
-              <a:t>, </a:t>
-            </a:r>
-            <a:r>
-              <a:rPr lang="en-US" sz="572" dirty="0" err="1">
-                <a:solidFill>
-                  <a:prstClr val="black"/>
-                </a:solidFill>
-                <a:latin typeface="Arial" panose="020B0604020202020204" pitchFamily="34" charset="0"/>
-                <a:cs typeface="Arial" panose="020B0604020202020204" pitchFamily="34" charset="0"/>
-              </a:rPr>
-              <a:t>cust</a:t>
-            </a:r>
-            <a:r>
-              <a:rPr lang="en-US" sz="572" dirty="0">
-                <a:solidFill>
-                  <a:prstClr val="black"/>
-                </a:solidFill>
-                <a:latin typeface="Arial" panose="020B0604020202020204" pitchFamily="34" charset="0"/>
-                <a:cs typeface="Arial" panose="020B0604020202020204" pitchFamily="34" charset="0"/>
-              </a:rPr>
-              <a:t> </a:t>
-            </a:r>
-            <a:r>
-              <a:rPr lang="en-US" sz="572" dirty="0" err="1">
-                <a:solidFill>
-                  <a:prstClr val="black"/>
-                </a:solidFill>
-                <a:latin typeface="Arial" panose="020B0604020202020204" pitchFamily="34" charset="0"/>
-                <a:cs typeface="Arial" panose="020B0604020202020204" pitchFamily="34" charset="0"/>
-              </a:rPr>
-              <a:t>accaborit</a:t>
-            </a:r>
-            <a:r>
-              <a:rPr lang="en-US" sz="572" dirty="0">
-                <a:solidFill>
-                  <a:prstClr val="black"/>
-                </a:solidFill>
-                <a:latin typeface="Arial" panose="020B0604020202020204" pitchFamily="34" charset="0"/>
-                <a:cs typeface="Arial" panose="020B0604020202020204" pitchFamily="34" charset="0"/>
-              </a:rPr>
-              <a:t> </a:t>
-            </a:r>
-            <a:r>
-              <a:rPr lang="en-US" sz="572" dirty="0" err="1">
-                <a:solidFill>
-                  <a:prstClr val="black"/>
-                </a:solidFill>
-                <a:latin typeface="Arial" panose="020B0604020202020204" pitchFamily="34" charset="0"/>
-                <a:cs typeface="Arial" panose="020B0604020202020204" pitchFamily="34" charset="0"/>
-              </a:rPr>
-              <a:t>odio</a:t>
-            </a:r>
-            <a:r>
-              <a:rPr lang="en-US" sz="572" dirty="0">
-                <a:solidFill>
-                  <a:prstClr val="black"/>
-                </a:solidFill>
-                <a:latin typeface="Arial" panose="020B0604020202020204" pitchFamily="34" charset="0"/>
-                <a:cs typeface="Arial" panose="020B0604020202020204" pitchFamily="34" charset="0"/>
-              </a:rPr>
-              <a:t> </a:t>
-            </a:r>
-            <a:r>
-              <a:rPr lang="en-US" sz="572" dirty="0" err="1">
-                <a:solidFill>
-                  <a:prstClr val="black"/>
-                </a:solidFill>
-                <a:latin typeface="Arial" panose="020B0604020202020204" pitchFamily="34" charset="0"/>
-                <a:cs typeface="Arial" panose="020B0604020202020204" pitchFamily="34" charset="0"/>
-              </a:rPr>
-              <a:t>corehen</a:t>
-            </a:r>
-            <a:r>
-              <a:rPr lang="en-US" sz="572" dirty="0">
-                <a:solidFill>
-                  <a:prstClr val="black"/>
-                </a:solidFill>
-                <a:latin typeface="Arial" panose="020B0604020202020204" pitchFamily="34" charset="0"/>
-                <a:cs typeface="Arial" panose="020B0604020202020204" pitchFamily="34" charset="0"/>
-              </a:rPr>
-              <a:t> </a:t>
-            </a:r>
-            <a:r>
-              <a:rPr lang="en-US" sz="572" dirty="0" err="1">
-                <a:solidFill>
-                  <a:prstClr val="black"/>
-                </a:solidFill>
-                <a:latin typeface="Arial" panose="020B0604020202020204" pitchFamily="34" charset="0"/>
-                <a:cs typeface="Arial" panose="020B0604020202020204" pitchFamily="34" charset="0"/>
-              </a:rPr>
-              <a:t>dendae</a:t>
-            </a:r>
-            <a:r>
-              <a:rPr lang="en-US" sz="572" dirty="0">
-                <a:solidFill>
-                  <a:prstClr val="black"/>
-                </a:solidFill>
-                <a:latin typeface="Arial" panose="020B0604020202020204" pitchFamily="34" charset="0"/>
-                <a:cs typeface="Arial" panose="020B0604020202020204" pitchFamily="34" charset="0"/>
-              </a:rPr>
-              <a:t> nonet </a:t>
-            </a:r>
-            <a:r>
-              <a:rPr lang="en-US" sz="572" dirty="0" err="1">
-                <a:solidFill>
-                  <a:prstClr val="black"/>
-                </a:solidFill>
-                <a:latin typeface="Arial" panose="020B0604020202020204" pitchFamily="34" charset="0"/>
-                <a:cs typeface="Arial" panose="020B0604020202020204" pitchFamily="34" charset="0"/>
-              </a:rPr>
-              <a:t>eliquam</a:t>
-            </a:r>
-            <a:r>
-              <a:rPr lang="en-US" sz="572" dirty="0">
-                <a:solidFill>
-                  <a:prstClr val="black"/>
-                </a:solidFill>
-                <a:latin typeface="Arial" panose="020B0604020202020204" pitchFamily="34" charset="0"/>
-                <a:cs typeface="Arial" panose="020B0604020202020204" pitchFamily="34" charset="0"/>
-              </a:rPr>
-              <a:t>, </a:t>
-            </a:r>
-            <a:r>
-              <a:rPr lang="en-US" sz="572" dirty="0" err="1">
-                <a:solidFill>
-                  <a:prstClr val="black"/>
-                </a:solidFill>
-                <a:latin typeface="Arial" panose="020B0604020202020204" pitchFamily="34" charset="0"/>
-                <a:cs typeface="Arial" panose="020B0604020202020204" pitchFamily="34" charset="0"/>
-              </a:rPr>
-              <a:t>aperorepe</a:t>
-            </a:r>
-            <a:r>
-              <a:rPr lang="en-US" sz="572" dirty="0">
-                <a:solidFill>
-                  <a:prstClr val="black"/>
-                </a:solidFill>
-                <a:latin typeface="Arial" panose="020B0604020202020204" pitchFamily="34" charset="0"/>
-                <a:cs typeface="Arial" panose="020B0604020202020204" pitchFamily="34" charset="0"/>
-              </a:rPr>
-              <a:t> </a:t>
-            </a:r>
-            <a:r>
-              <a:rPr lang="en-US" sz="572" dirty="0" err="1">
-                <a:solidFill>
-                  <a:prstClr val="black"/>
-                </a:solidFill>
-                <a:latin typeface="Arial" panose="020B0604020202020204" pitchFamily="34" charset="0"/>
-                <a:cs typeface="Arial" panose="020B0604020202020204" pitchFamily="34" charset="0"/>
-              </a:rPr>
-              <a:t>autatem</a:t>
-            </a:r>
-            <a:r>
-              <a:rPr lang="en-US" sz="572" dirty="0">
-                <a:solidFill>
-                  <a:prstClr val="black"/>
-                </a:solidFill>
-                <a:latin typeface="Arial" panose="020B0604020202020204" pitchFamily="34" charset="0"/>
-                <a:cs typeface="Arial" panose="020B0604020202020204" pitchFamily="34" charset="0"/>
-              </a:rPr>
-              <a:t> voles </a:t>
-            </a:r>
-            <a:r>
-              <a:rPr lang="en-US" sz="572" dirty="0" err="1">
-                <a:solidFill>
-                  <a:prstClr val="black"/>
-                </a:solidFill>
-                <a:latin typeface="Arial" panose="020B0604020202020204" pitchFamily="34" charset="0"/>
-                <a:cs typeface="Arial" panose="020B0604020202020204" pitchFamily="34" charset="0"/>
-              </a:rPr>
-              <a:t>int</a:t>
-            </a:r>
-            <a:r>
-              <a:rPr lang="en-US" sz="572" dirty="0">
-                <a:solidFill>
-                  <a:prstClr val="black"/>
-                </a:solidFill>
-                <a:latin typeface="Arial" panose="020B0604020202020204" pitchFamily="34" charset="0"/>
-                <a:cs typeface="Arial" panose="020B0604020202020204" pitchFamily="34" charset="0"/>
-              </a:rPr>
-              <a:t> </a:t>
-            </a:r>
-            <a:r>
-              <a:rPr lang="en-US" sz="572" dirty="0" err="1">
-                <a:solidFill>
-                  <a:prstClr val="black"/>
-                </a:solidFill>
-                <a:latin typeface="Arial" panose="020B0604020202020204" pitchFamily="34" charset="0"/>
-                <a:cs typeface="Arial" panose="020B0604020202020204" pitchFamily="34" charset="0"/>
-              </a:rPr>
-              <a:t>odic</a:t>
-            </a:r>
-            <a:r>
-              <a:rPr lang="en-US" sz="572" dirty="0">
-                <a:solidFill>
-                  <a:prstClr val="black"/>
-                </a:solidFill>
-                <a:latin typeface="Arial" panose="020B0604020202020204" pitchFamily="34" charset="0"/>
-                <a:cs typeface="Arial" panose="020B0604020202020204" pitchFamily="34" charset="0"/>
-              </a:rPr>
-              <a:t> </a:t>
-            </a:r>
-            <a:r>
-              <a:rPr lang="en-US" sz="572" dirty="0" err="1">
-                <a:solidFill>
-                  <a:prstClr val="black"/>
-                </a:solidFill>
-                <a:latin typeface="Arial" panose="020B0604020202020204" pitchFamily="34" charset="0"/>
-                <a:cs typeface="Arial" panose="020B0604020202020204" pitchFamily="34" charset="0"/>
-              </a:rPr>
-              <a:t>tem</a:t>
-            </a:r>
-            <a:r>
-              <a:rPr lang="en-US" sz="572" dirty="0">
-                <a:solidFill>
-                  <a:prstClr val="black"/>
-                </a:solidFill>
-                <a:latin typeface="Arial" panose="020B0604020202020204" pitchFamily="34" charset="0"/>
-                <a:cs typeface="Arial" panose="020B0604020202020204" pitchFamily="34" charset="0"/>
-              </a:rPr>
-              <a:t> </a:t>
-            </a:r>
-            <a:r>
-              <a:rPr lang="en-US" sz="572" dirty="0" err="1">
-                <a:solidFill>
-                  <a:prstClr val="black"/>
-                </a:solidFill>
-                <a:latin typeface="Arial" panose="020B0604020202020204" pitchFamily="34" charset="0"/>
-                <a:cs typeface="Arial" panose="020B0604020202020204" pitchFamily="34" charset="0"/>
-              </a:rPr>
-              <a:t>nis</a:t>
-            </a:r>
-            <a:r>
-              <a:rPr lang="en-US" sz="572" dirty="0">
-                <a:solidFill>
-                  <a:prstClr val="black"/>
-                </a:solidFill>
-                <a:latin typeface="Arial" panose="020B0604020202020204" pitchFamily="34" charset="0"/>
-                <a:cs typeface="Arial" panose="020B0604020202020204" pitchFamily="34" charset="0"/>
-              </a:rPr>
-              <a:t> </a:t>
-            </a:r>
-            <a:r>
-              <a:rPr lang="en-US" sz="572" dirty="0" err="1">
-                <a:solidFill>
-                  <a:prstClr val="black"/>
-                </a:solidFill>
-                <a:latin typeface="Arial" panose="020B0604020202020204" pitchFamily="34" charset="0"/>
-                <a:cs typeface="Arial" panose="020B0604020202020204" pitchFamily="34" charset="0"/>
-              </a:rPr>
-              <a:t>dolorrum</a:t>
-            </a:r>
-            <a:r>
-              <a:rPr lang="en-US" sz="572" dirty="0">
-                <a:solidFill>
-                  <a:prstClr val="black"/>
-                </a:solidFill>
-                <a:latin typeface="Arial" panose="020B0604020202020204" pitchFamily="34" charset="0"/>
-                <a:cs typeface="Arial" panose="020B0604020202020204" pitchFamily="34" charset="0"/>
-              </a:rPr>
-              <a:t> que</a:t>
-            </a:r>
+              <a:t> ed., vol. 2. New York, NY, USA: W.W. Norton &amp; Company, 2007.</a:t>
+            </a:r>
+            <a:endParaRPr lang="en-US" sz="572" i="1" dirty="0">
+              <a:solidFill>
+                <a:prstClr val="black"/>
+              </a:solidFill>
+              <a:latin typeface="Arial" panose="020B0604020202020204" pitchFamily="34" charset="0"/>
+              <a:cs typeface="Arial" panose="020B0604020202020204" pitchFamily="34" charset="0"/>
+            </a:endParaRPr>
           </a:p>
         </p:txBody>
       </p:sp>
@@ -11015,8 +8794,8 @@
           </p:sp>
         </mc:Fallback>
       </mc:AlternateContent>
-      <mc:AlternateContent xmlns:mc="http://schemas.openxmlformats.org/markup-compatibility/2006">
-        <mc:Choice xmlns:a14="http://schemas.microsoft.com/office/drawing/2010/main" Requires="a14">
+      <mc:AlternateContent xmlns:mc="http://schemas.openxmlformats.org/markup-compatibility/2006" xmlns:a14="http://schemas.microsoft.com/office/drawing/2010/main">
+        <mc:Choice Requires="a14">
           <p:sp>
             <p:nvSpPr>
               <p:cNvPr id="50" name="TextBox 49">
@@ -11310,7 +9089,7 @@
             </p:txBody>
           </p:sp>
         </mc:Choice>
-        <mc:Fallback>
+        <mc:Fallback xmlns="">
           <p:sp>
             <p:nvSpPr>
               <p:cNvPr id="50" name="TextBox 49">
@@ -11355,8 +9134,8 @@
           </p:sp>
         </mc:Fallback>
       </mc:AlternateContent>
-      <mc:AlternateContent xmlns:mc="http://schemas.openxmlformats.org/markup-compatibility/2006">
-        <mc:Choice xmlns:a14="http://schemas.microsoft.com/office/drawing/2010/main" Requires="a14">
+      <mc:AlternateContent xmlns:mc="http://schemas.openxmlformats.org/markup-compatibility/2006" xmlns:a14="http://schemas.microsoft.com/office/drawing/2010/main">
+        <mc:Choice Requires="a14">
           <p:sp>
             <p:nvSpPr>
               <p:cNvPr id="51" name="TextBox 50">
@@ -11555,7 +9334,7 @@
             </p:txBody>
           </p:sp>
         </mc:Choice>
-        <mc:Fallback>
+        <mc:Fallback xmlns="">
           <p:sp>
             <p:nvSpPr>
               <p:cNvPr id="51" name="TextBox 50">

</xml_diff>